<commit_message>
First-step slide asks for a driver, the budget owner and dates
Co-Authored-By: Claude Opus 5.5 <noreply@anthropic.com>
Claude-Session: https://claude.ai/code/session_01DptoPaaj14X3TGztKApoPN
</commit_message>
<xml_diff>
--- a/docs/presentation/KAOP_Customer_Pitch.pptx
+++ b/docs/presentation/KAOP_Customer_Pitch.pptx
@@ -7720,7 +7720,7 @@
                 </a:solidFill>
                 <a:latin typeface="Arial"/>
               </a:rPr>
-              <a:t>•  An owner who drives it day to day</a:t>
+              <a:t>•  A driver who owns it day to day</a:t>
             </a:r>
           </a:p>
           <a:p>
@@ -7736,7 +7736,23 @@
                 </a:solidFill>
                 <a:latin typeface="Arial"/>
               </a:rPr>
-              <a:t>•  A sponsor who decides when to expand</a:t>
+              <a:t>•  The budget owner, who decides when to expand</a:t>
+            </a:r>
+          </a:p>
+          <a:p>
+            <a:pPr algn="l">
+              <a:lnSpc>
+                <a:spcPct val="110000"/>
+              </a:lnSpc>
+            </a:pPr>
+            <a:r>
+              <a:rPr sz="1500" b="0">
+                <a:solidFill>
+                  <a:srgbClr val="0F172A"/>
+                </a:solidFill>
+                <a:latin typeface="Arial"/>
+              </a:rPr>
+              <a:t>•  Two or three dates for the scoping session</a:t>
             </a:r>
           </a:p>
         </p:txBody>
@@ -7962,7 +7978,7 @@
                 </a:solidFill>
                 <a:latin typeface="Arial"/>
               </a:rPr>
-              <a:t>A scoping session with your workflow owner.</a:t>
+              <a:t>Pick a date for the scoping session with your driver and budget owner.</a:t>
             </a:r>
           </a:p>
         </p:txBody>
@@ -9299,7 +9315,7 @@
                 </a:solidFill>
                 <a:latin typeface="Arial"/>
               </a:rPr>
-              <a:t>A scoping session with your workflow owner.</a:t>
+              <a:t>A scoping session with your driver and budget owner.</a:t>
             </a:r>
           </a:p>
         </p:txBody>

</xml_diff>

<commit_message>
Deck: the live preview on slide 3 as a flow
Co-Authored-By: Claude Opus 5.5 <noreply@anthropic.com>
Claude-Session: https://claude.ai/code/session_01DptoPaaj14X3TGztKApoPN
</commit_message>
<xml_diff>
--- a/docs/presentation/KAOP_Customer_Pitch.pptx
+++ b/docs/presentation/KAOP_Customer_Pitch.pptx
@@ -16521,7 +16521,7 @@
         </p:nvSpPr>
         <p:spPr>
           <a:xfrm>
-            <a:off x="7955279" y="2212848"/>
+            <a:off x="7955279" y="2176272"/>
             <a:ext cx="3474720" cy="274320"/>
           </a:xfrm>
           <a:prstGeom prst="rect">
@@ -16554,14 +16554,119 @@
       </p:sp>
       <p:sp>
         <p:nvSpPr>
-          <p:cNvPr id="28" name="TextBox 27"/>
+          <p:cNvPr id="28" name="Rounded Rectangle 27"/>
+          <p:cNvSpPr/>
+          <p:nvPr/>
+        </p:nvSpPr>
+        <p:spPr>
+          <a:xfrm>
+            <a:off x="7909560" y="2523744"/>
+            <a:ext cx="3520440" cy="402336"/>
+          </a:xfrm>
+          <a:prstGeom prst="roundRect">
+            <a:avLst>
+              <a:gd name="adj" fmla="val 20000"/>
+            </a:avLst>
+          </a:prstGeom>
+          <a:solidFill>
+            <a:srgbClr val="1E293B"/>
+          </a:solidFill>
+          <a:ln>
+            <a:noFill/>
+          </a:ln>
+          <a:effectLst/>
+        </p:spPr>
+        <p:style>
+          <a:lnRef idx="1">
+            <a:schemeClr val="accent1"/>
+          </a:lnRef>
+          <a:fillRef idx="3">
+            <a:schemeClr val="accent1"/>
+          </a:fillRef>
+          <a:effectRef idx="2">
+            <a:schemeClr val="accent1"/>
+          </a:effectRef>
+          <a:fontRef idx="minor">
+            <a:schemeClr val="lt1"/>
+          </a:fontRef>
+        </p:style>
+        <p:txBody>
+          <a:bodyPr rtlCol="0" anchor="ctr"/>
+          <a:lstStyle/>
+          <a:p>
+            <a:pPr algn="ctr"/>
+          </a:p>
+        </p:txBody>
+      </p:sp>
+      <p:sp>
+        <p:nvSpPr>
+          <p:cNvPr id="29" name="Rounded Rectangle 28"/>
+          <p:cNvSpPr/>
+          <p:nvPr/>
+        </p:nvSpPr>
+        <p:spPr>
+          <a:xfrm>
+            <a:off x="8001000" y="2587751"/>
+            <a:ext cx="292608" cy="292608"/>
+          </a:xfrm>
+          <a:prstGeom prst="roundRect">
+            <a:avLst>
+              <a:gd name="adj" fmla="val 50000"/>
+            </a:avLst>
+          </a:prstGeom>
+          <a:solidFill>
+            <a:srgbClr val="4F46E5"/>
+          </a:solidFill>
+          <a:ln>
+            <a:noFill/>
+          </a:ln>
+          <a:effectLst/>
+        </p:spPr>
+        <p:style>
+          <a:lnRef idx="1">
+            <a:schemeClr val="accent1"/>
+          </a:lnRef>
+          <a:fillRef idx="3">
+            <a:schemeClr val="accent1"/>
+          </a:fillRef>
+          <a:effectRef idx="2">
+            <a:schemeClr val="accent1"/>
+          </a:effectRef>
+          <a:fontRef idx="minor">
+            <a:schemeClr val="lt1"/>
+          </a:fontRef>
+        </p:style>
+        <p:txBody>
+          <a:bodyPr rtlCol="0" anchor="ctr" wrap="square" lIns="73152" rIns="73152" tIns="36576" bIns="36576"/>
+          <a:lstStyle/>
+          <a:p>
+            <a:pPr algn="ctr">
+              <a:lnSpc>
+                <a:spcPct val="110000"/>
+              </a:lnSpc>
+            </a:pPr>
+            <a:r>
+              <a:rPr sz="1100" b="1">
+                <a:solidFill>
+                  <a:srgbClr val="FFFFFF"/>
+                </a:solidFill>
+                <a:latin typeface="Arial"/>
+              </a:rPr>
+              <a:t>1</a:t>
+            </a:r>
+          </a:p>
+        </p:txBody>
+      </p:sp>
+      <p:sp>
+        <p:nvSpPr>
+          <p:cNvPr id="30" name="TextBox 29"/>
           <p:cNvSpPr txBox="1"/>
           <p:nvPr/>
         </p:nvSpPr>
         <p:spPr>
           <a:xfrm>
-            <a:off x="7955279" y="2606040"/>
-            <a:ext cx="3520440" cy="2926080"/>
+            <a:off x="8366760" y="2551175"/>
+            <a:ext cx="3017520" cy="365760"/>
           </a:xfrm>
           <a:prstGeom prst="rect">
             <a:avLst/>
@@ -16569,133 +16674,776 @@
           <a:noFill/>
         </p:spPr>
         <p:txBody>
-          <a:bodyPr wrap="square" lIns="73152" rIns="73152" tIns="36576" bIns="36576" anchor="t">
+          <a:bodyPr wrap="square" lIns="73152" rIns="73152" tIns="36576" bIns="36576" anchor="ctr">
             <a:spAutoFit/>
           </a:bodyPr>
           <a:lstStyle/>
           <a:p>
             <a:pPr algn="l">
               <a:lnSpc>
-                <a:spcPct val="115000"/>
-              </a:lnSpc>
-            </a:pPr>
-            <a:r>
-              <a:rPr sz="1600" b="1">
-                <a:solidFill>
-                  <a:srgbClr val="5EEAD4"/>
-                </a:solidFill>
-                <a:latin typeface="Arial"/>
-              </a:rPr>
-              <a:t>✓  </a:t>
-            </a:r>
-            <a:r>
-              <a:rPr sz="1600" b="0">
+                <a:spcPct val="110000"/>
+              </a:lnSpc>
+            </a:pPr>
+            <a:r>
+              <a:rPr sz="1400" b="0">
                 <a:solidFill>
                   <a:srgbClr val="FFFFFF"/>
                 </a:solidFill>
                 <a:latin typeface="Arial"/>
               </a:rPr>
-              <a:t>A real alert from Grafana Cloud</a:t>
-            </a:r>
-          </a:p>
+              <a:t>Grafana Cloud fires a real alert</a:t>
+            </a:r>
+          </a:p>
+        </p:txBody>
+      </p:sp>
+      <p:sp>
+        <p:nvSpPr>
+          <p:cNvPr id="31" name="Down Arrow 30"/>
+          <p:cNvSpPr/>
+          <p:nvPr/>
+        </p:nvSpPr>
+        <p:spPr>
+          <a:xfrm>
+            <a:off x="8074152" y="2962656"/>
+            <a:ext cx="219456" cy="155448"/>
+          </a:xfrm>
+          <a:prstGeom prst="downArrow">
+            <a:avLst/>
+          </a:prstGeom>
+          <a:solidFill>
+            <a:srgbClr val="CBD5E1"/>
+          </a:solidFill>
+          <a:ln>
+            <a:noFill/>
+          </a:ln>
+          <a:effectLst/>
+        </p:spPr>
+        <p:style>
+          <a:lnRef idx="1">
+            <a:schemeClr val="accent1"/>
+          </a:lnRef>
+          <a:fillRef idx="3">
+            <a:schemeClr val="accent1"/>
+          </a:fillRef>
+          <a:effectRef idx="2">
+            <a:schemeClr val="accent1"/>
+          </a:effectRef>
+          <a:fontRef idx="minor">
+            <a:schemeClr val="lt1"/>
+          </a:fontRef>
+        </p:style>
+        <p:txBody>
+          <a:bodyPr rtlCol="0" anchor="ctr"/>
+          <a:lstStyle/>
+          <a:p>
+            <a:pPr algn="ctr"/>
+          </a:p>
+        </p:txBody>
+      </p:sp>
+      <p:sp>
+        <p:nvSpPr>
+          <p:cNvPr id="32" name="Rounded Rectangle 31"/>
+          <p:cNvSpPr/>
+          <p:nvPr/>
+        </p:nvSpPr>
+        <p:spPr>
+          <a:xfrm>
+            <a:off x="7909560" y="3145536"/>
+            <a:ext cx="3520440" cy="402336"/>
+          </a:xfrm>
+          <a:prstGeom prst="roundRect">
+            <a:avLst>
+              <a:gd name="adj" fmla="val 20000"/>
+            </a:avLst>
+          </a:prstGeom>
+          <a:solidFill>
+            <a:srgbClr val="1E293B"/>
+          </a:solidFill>
+          <a:ln>
+            <a:noFill/>
+          </a:ln>
+          <a:effectLst/>
+        </p:spPr>
+        <p:style>
+          <a:lnRef idx="1">
+            <a:schemeClr val="accent1"/>
+          </a:lnRef>
+          <a:fillRef idx="3">
+            <a:schemeClr val="accent1"/>
+          </a:fillRef>
+          <a:effectRef idx="2">
+            <a:schemeClr val="accent1"/>
+          </a:effectRef>
+          <a:fontRef idx="minor">
+            <a:schemeClr val="lt1"/>
+          </a:fontRef>
+        </p:style>
+        <p:txBody>
+          <a:bodyPr rtlCol="0" anchor="ctr"/>
+          <a:lstStyle/>
+          <a:p>
+            <a:pPr algn="ctr"/>
+          </a:p>
+        </p:txBody>
+      </p:sp>
+      <p:sp>
+        <p:nvSpPr>
+          <p:cNvPr id="33" name="Rounded Rectangle 32"/>
+          <p:cNvSpPr/>
+          <p:nvPr/>
+        </p:nvSpPr>
+        <p:spPr>
+          <a:xfrm>
+            <a:off x="8001000" y="3209544"/>
+            <a:ext cx="292608" cy="292608"/>
+          </a:xfrm>
+          <a:prstGeom prst="roundRect">
+            <a:avLst>
+              <a:gd name="adj" fmla="val 50000"/>
+            </a:avLst>
+          </a:prstGeom>
+          <a:solidFill>
+            <a:srgbClr val="4F46E5"/>
+          </a:solidFill>
+          <a:ln>
+            <a:noFill/>
+          </a:ln>
+          <a:effectLst/>
+        </p:spPr>
+        <p:style>
+          <a:lnRef idx="1">
+            <a:schemeClr val="accent1"/>
+          </a:lnRef>
+          <a:fillRef idx="3">
+            <a:schemeClr val="accent1"/>
+          </a:fillRef>
+          <a:effectRef idx="2">
+            <a:schemeClr val="accent1"/>
+          </a:effectRef>
+          <a:fontRef idx="minor">
+            <a:schemeClr val="lt1"/>
+          </a:fontRef>
+        </p:style>
+        <p:txBody>
+          <a:bodyPr rtlCol="0" anchor="ctr" wrap="square" lIns="73152" rIns="73152" tIns="36576" bIns="36576"/>
+          <a:lstStyle/>
+          <a:p>
+            <a:pPr algn="ctr">
+              <a:lnSpc>
+                <a:spcPct val="110000"/>
+              </a:lnSpc>
+            </a:pPr>
+            <a:r>
+              <a:rPr sz="1100" b="1">
+                <a:solidFill>
+                  <a:srgbClr val="FFFFFF"/>
+                </a:solidFill>
+                <a:latin typeface="Arial"/>
+              </a:rPr>
+              <a:t>2</a:t>
+            </a:r>
+          </a:p>
+        </p:txBody>
+      </p:sp>
+      <p:sp>
+        <p:nvSpPr>
+          <p:cNvPr id="34" name="TextBox 33"/>
+          <p:cNvSpPr txBox="1"/>
+          <p:nvPr/>
+        </p:nvSpPr>
+        <p:spPr>
+          <a:xfrm>
+            <a:off x="8366760" y="3172968"/>
+            <a:ext cx="3017520" cy="365760"/>
+          </a:xfrm>
+          <a:prstGeom prst="rect">
+            <a:avLst/>
+          </a:prstGeom>
+          <a:noFill/>
+        </p:spPr>
+        <p:txBody>
+          <a:bodyPr wrap="square" lIns="73152" rIns="73152" tIns="36576" bIns="36576" anchor="ctr">
+            <a:spAutoFit/>
+          </a:bodyPr>
+          <a:lstStyle/>
           <a:p>
             <a:pPr algn="l">
               <a:lnSpc>
-                <a:spcPct val="115000"/>
-              </a:lnSpc>
-            </a:pPr>
-            <a:r>
-              <a:rPr sz="1600" b="1">
-                <a:solidFill>
-                  <a:srgbClr val="5EEAD4"/>
-                </a:solidFill>
-                <a:latin typeface="Arial"/>
-              </a:rPr>
-              <a:t>✓  </a:t>
-            </a:r>
-            <a:r>
-              <a:rPr sz="1600" b="0">
+                <a:spcPct val="110000"/>
+              </a:lnSpc>
+            </a:pPr>
+            <a:r>
+              <a:rPr sz="1400" b="0">
                 <a:solidFill>
                   <a:srgbClr val="FFFFFF"/>
                 </a:solidFill>
                 <a:latin typeface="Arial"/>
               </a:rPr>
-              <a:t>Two agents investigating at once</a:t>
-            </a:r>
-          </a:p>
+              <a:t>Two agents investigate at once</a:t>
+            </a:r>
+          </a:p>
+        </p:txBody>
+      </p:sp>
+      <p:sp>
+        <p:nvSpPr>
+          <p:cNvPr id="35" name="Down Arrow 34"/>
+          <p:cNvSpPr/>
+          <p:nvPr/>
+        </p:nvSpPr>
+        <p:spPr>
+          <a:xfrm>
+            <a:off x="8074152" y="3584448"/>
+            <a:ext cx="219456" cy="155448"/>
+          </a:xfrm>
+          <a:prstGeom prst="downArrow">
+            <a:avLst/>
+          </a:prstGeom>
+          <a:solidFill>
+            <a:srgbClr val="CBD5E1"/>
+          </a:solidFill>
+          <a:ln>
+            <a:noFill/>
+          </a:ln>
+          <a:effectLst/>
+        </p:spPr>
+        <p:style>
+          <a:lnRef idx="1">
+            <a:schemeClr val="accent1"/>
+          </a:lnRef>
+          <a:fillRef idx="3">
+            <a:schemeClr val="accent1"/>
+          </a:fillRef>
+          <a:effectRef idx="2">
+            <a:schemeClr val="accent1"/>
+          </a:effectRef>
+          <a:fontRef idx="minor">
+            <a:schemeClr val="lt1"/>
+          </a:fontRef>
+        </p:style>
+        <p:txBody>
+          <a:bodyPr rtlCol="0" anchor="ctr"/>
+          <a:lstStyle/>
+          <a:p>
+            <a:pPr algn="ctr"/>
+          </a:p>
+        </p:txBody>
+      </p:sp>
+      <p:sp>
+        <p:nvSpPr>
+          <p:cNvPr id="36" name="Rounded Rectangle 35"/>
+          <p:cNvSpPr/>
+          <p:nvPr/>
+        </p:nvSpPr>
+        <p:spPr>
+          <a:xfrm>
+            <a:off x="7909560" y="3767328"/>
+            <a:ext cx="3520440" cy="402336"/>
+          </a:xfrm>
+          <a:prstGeom prst="roundRect">
+            <a:avLst>
+              <a:gd name="adj" fmla="val 20000"/>
+            </a:avLst>
+          </a:prstGeom>
+          <a:solidFill>
+            <a:srgbClr val="1E293B"/>
+          </a:solidFill>
+          <a:ln>
+            <a:noFill/>
+          </a:ln>
+          <a:effectLst/>
+        </p:spPr>
+        <p:style>
+          <a:lnRef idx="1">
+            <a:schemeClr val="accent1"/>
+          </a:lnRef>
+          <a:fillRef idx="3">
+            <a:schemeClr val="accent1"/>
+          </a:fillRef>
+          <a:effectRef idx="2">
+            <a:schemeClr val="accent1"/>
+          </a:effectRef>
+          <a:fontRef idx="minor">
+            <a:schemeClr val="lt1"/>
+          </a:fontRef>
+        </p:style>
+        <p:txBody>
+          <a:bodyPr rtlCol="0" anchor="ctr"/>
+          <a:lstStyle/>
+          <a:p>
+            <a:pPr algn="ctr"/>
+          </a:p>
+        </p:txBody>
+      </p:sp>
+      <p:sp>
+        <p:nvSpPr>
+          <p:cNvPr id="37" name="Rounded Rectangle 36"/>
+          <p:cNvSpPr/>
+          <p:nvPr/>
+        </p:nvSpPr>
+        <p:spPr>
+          <a:xfrm>
+            <a:off x="8001000" y="3831336"/>
+            <a:ext cx="292608" cy="292608"/>
+          </a:xfrm>
+          <a:prstGeom prst="roundRect">
+            <a:avLst>
+              <a:gd name="adj" fmla="val 50000"/>
+            </a:avLst>
+          </a:prstGeom>
+          <a:solidFill>
+            <a:srgbClr val="B91C1C"/>
+          </a:solidFill>
+          <a:ln>
+            <a:noFill/>
+          </a:ln>
+          <a:effectLst/>
+        </p:spPr>
+        <p:style>
+          <a:lnRef idx="1">
+            <a:schemeClr val="accent1"/>
+          </a:lnRef>
+          <a:fillRef idx="3">
+            <a:schemeClr val="accent1"/>
+          </a:fillRef>
+          <a:effectRef idx="2">
+            <a:schemeClr val="accent1"/>
+          </a:effectRef>
+          <a:fontRef idx="minor">
+            <a:schemeClr val="lt1"/>
+          </a:fontRef>
+        </p:style>
+        <p:txBody>
+          <a:bodyPr rtlCol="0" anchor="ctr" wrap="square" lIns="73152" rIns="73152" tIns="36576" bIns="36576"/>
+          <a:lstStyle/>
+          <a:p>
+            <a:pPr algn="ctr">
+              <a:lnSpc>
+                <a:spcPct val="110000"/>
+              </a:lnSpc>
+            </a:pPr>
+            <a:r>
+              <a:rPr sz="1100" b="1">
+                <a:solidFill>
+                  <a:srgbClr val="FFFFFF"/>
+                </a:solidFill>
+                <a:latin typeface="Arial"/>
+              </a:rPr>
+              <a:t>3</a:t>
+            </a:r>
+          </a:p>
+        </p:txBody>
+      </p:sp>
+      <p:sp>
+        <p:nvSpPr>
+          <p:cNvPr id="38" name="TextBox 37"/>
+          <p:cNvSpPr txBox="1"/>
+          <p:nvPr/>
+        </p:nvSpPr>
+        <p:spPr>
+          <a:xfrm>
+            <a:off x="8366760" y="3794760"/>
+            <a:ext cx="3017520" cy="365760"/>
+          </a:xfrm>
+          <a:prstGeom prst="rect">
+            <a:avLst/>
+          </a:prstGeom>
+          <a:noFill/>
+        </p:spPr>
+        <p:txBody>
+          <a:bodyPr wrap="square" lIns="73152" rIns="73152" tIns="36576" bIns="36576" anchor="ctr">
+            <a:spAutoFit/>
+          </a:bodyPr>
+          <a:lstStyle/>
           <a:p>
             <a:pPr algn="l">
               <a:lnSpc>
-                <a:spcPct val="115000"/>
-              </a:lnSpc>
-            </a:pPr>
-            <a:r>
-              <a:rPr sz="1600" b="1">
-                <a:solidFill>
-                  <a:srgbClr val="5EEAD4"/>
-                </a:solidFill>
-                <a:latin typeface="Arial"/>
-              </a:rPr>
-              <a:t>✓  </a:t>
-            </a:r>
-            <a:r>
-              <a:rPr sz="1600" b="0">
+                <a:spcPct val="110000"/>
+              </a:lnSpc>
+            </a:pPr>
+            <a:r>
+              <a:rPr sz="1400" b="0">
                 <a:solidFill>
                   <a:srgbClr val="FFFFFF"/>
                 </a:solidFill>
                 <a:latin typeface="Arial"/>
               </a:rPr>
-              <a:t>A person approving the fix</a:t>
-            </a:r>
-          </a:p>
+              <a:t>A person approves the fix</a:t>
+            </a:r>
+          </a:p>
+        </p:txBody>
+      </p:sp>
+      <p:sp>
+        <p:nvSpPr>
+          <p:cNvPr id="39" name="Down Arrow 38"/>
+          <p:cNvSpPr/>
+          <p:nvPr/>
+        </p:nvSpPr>
+        <p:spPr>
+          <a:xfrm>
+            <a:off x="8074152" y="4206240"/>
+            <a:ext cx="219456" cy="155448"/>
+          </a:xfrm>
+          <a:prstGeom prst="downArrow">
+            <a:avLst/>
+          </a:prstGeom>
+          <a:solidFill>
+            <a:srgbClr val="CBD5E1"/>
+          </a:solidFill>
+          <a:ln>
+            <a:noFill/>
+          </a:ln>
+          <a:effectLst/>
+        </p:spPr>
+        <p:style>
+          <a:lnRef idx="1">
+            <a:schemeClr val="accent1"/>
+          </a:lnRef>
+          <a:fillRef idx="3">
+            <a:schemeClr val="accent1"/>
+          </a:fillRef>
+          <a:effectRef idx="2">
+            <a:schemeClr val="accent1"/>
+          </a:effectRef>
+          <a:fontRef idx="minor">
+            <a:schemeClr val="lt1"/>
+          </a:fontRef>
+        </p:style>
+        <p:txBody>
+          <a:bodyPr rtlCol="0" anchor="ctr"/>
+          <a:lstStyle/>
+          <a:p>
+            <a:pPr algn="ctr"/>
+          </a:p>
+        </p:txBody>
+      </p:sp>
+      <p:sp>
+        <p:nvSpPr>
+          <p:cNvPr id="40" name="Rounded Rectangle 39"/>
+          <p:cNvSpPr/>
+          <p:nvPr/>
+        </p:nvSpPr>
+        <p:spPr>
+          <a:xfrm>
+            <a:off x="7909560" y="4389120"/>
+            <a:ext cx="3520440" cy="402336"/>
+          </a:xfrm>
+          <a:prstGeom prst="roundRect">
+            <a:avLst>
+              <a:gd name="adj" fmla="val 20000"/>
+            </a:avLst>
+          </a:prstGeom>
+          <a:solidFill>
+            <a:srgbClr val="1E293B"/>
+          </a:solidFill>
+          <a:ln>
+            <a:noFill/>
+          </a:ln>
+          <a:effectLst/>
+        </p:spPr>
+        <p:style>
+          <a:lnRef idx="1">
+            <a:schemeClr val="accent1"/>
+          </a:lnRef>
+          <a:fillRef idx="3">
+            <a:schemeClr val="accent1"/>
+          </a:fillRef>
+          <a:effectRef idx="2">
+            <a:schemeClr val="accent1"/>
+          </a:effectRef>
+          <a:fontRef idx="minor">
+            <a:schemeClr val="lt1"/>
+          </a:fontRef>
+        </p:style>
+        <p:txBody>
+          <a:bodyPr rtlCol="0" anchor="ctr"/>
+          <a:lstStyle/>
+          <a:p>
+            <a:pPr algn="ctr"/>
+          </a:p>
+        </p:txBody>
+      </p:sp>
+      <p:sp>
+        <p:nvSpPr>
+          <p:cNvPr id="41" name="Rounded Rectangle 40"/>
+          <p:cNvSpPr/>
+          <p:nvPr/>
+        </p:nvSpPr>
+        <p:spPr>
+          <a:xfrm>
+            <a:off x="8001000" y="4453128"/>
+            <a:ext cx="292608" cy="292608"/>
+          </a:xfrm>
+          <a:prstGeom prst="roundRect">
+            <a:avLst>
+              <a:gd name="adj" fmla="val 50000"/>
+            </a:avLst>
+          </a:prstGeom>
+          <a:solidFill>
+            <a:srgbClr val="0F766E"/>
+          </a:solidFill>
+          <a:ln>
+            <a:noFill/>
+          </a:ln>
+          <a:effectLst/>
+        </p:spPr>
+        <p:style>
+          <a:lnRef idx="1">
+            <a:schemeClr val="accent1"/>
+          </a:lnRef>
+          <a:fillRef idx="3">
+            <a:schemeClr val="accent1"/>
+          </a:fillRef>
+          <a:effectRef idx="2">
+            <a:schemeClr val="accent1"/>
+          </a:effectRef>
+          <a:fontRef idx="minor">
+            <a:schemeClr val="lt1"/>
+          </a:fontRef>
+        </p:style>
+        <p:txBody>
+          <a:bodyPr rtlCol="0" anchor="ctr" wrap="square" lIns="73152" rIns="73152" tIns="36576" bIns="36576"/>
+          <a:lstStyle/>
+          <a:p>
+            <a:pPr algn="ctr">
+              <a:lnSpc>
+                <a:spcPct val="110000"/>
+              </a:lnSpc>
+            </a:pPr>
+            <a:r>
+              <a:rPr sz="1100" b="1">
+                <a:solidFill>
+                  <a:srgbClr val="FFFFFF"/>
+                </a:solidFill>
+                <a:latin typeface="Arial"/>
+              </a:rPr>
+              <a:t>4</a:t>
+            </a:r>
+          </a:p>
+        </p:txBody>
+      </p:sp>
+      <p:sp>
+        <p:nvSpPr>
+          <p:cNvPr id="42" name="TextBox 41"/>
+          <p:cNvSpPr txBox="1"/>
+          <p:nvPr/>
+        </p:nvSpPr>
+        <p:spPr>
+          <a:xfrm>
+            <a:off x="8366760" y="4416552"/>
+            <a:ext cx="3017520" cy="365760"/>
+          </a:xfrm>
+          <a:prstGeom prst="rect">
+            <a:avLst/>
+          </a:prstGeom>
+          <a:noFill/>
+        </p:spPr>
+        <p:txBody>
+          <a:bodyPr wrap="square" lIns="73152" rIns="73152" tIns="36576" bIns="36576" anchor="ctr">
+            <a:spAutoFit/>
+          </a:bodyPr>
+          <a:lstStyle/>
           <a:p>
             <a:pPr algn="l">
               <a:lnSpc>
-                <a:spcPct val="115000"/>
-              </a:lnSpc>
-            </a:pPr>
-            <a:r>
-              <a:rPr sz="1600" b="1">
-                <a:solidFill>
-                  <a:srgbClr val="5EEAD4"/>
-                </a:solidFill>
-                <a:latin typeface="Arial"/>
-              </a:rPr>
-              <a:t>✓  </a:t>
-            </a:r>
-            <a:r>
-              <a:rPr sz="1600" b="0">
+                <a:spcPct val="110000"/>
+              </a:lnSpc>
+            </a:pPr>
+            <a:r>
+              <a:rPr sz="1400" b="0">
                 <a:solidFill>
                   <a:srgbClr val="FFFFFF"/>
                 </a:solidFill>
                 <a:latin typeface="Arial"/>
               </a:rPr>
-              <a:t>An AI review of a real pull request</a:t>
-            </a:r>
-          </a:p>
+              <a:t>An agent reviews the fix PR</a:t>
+            </a:r>
+          </a:p>
+        </p:txBody>
+      </p:sp>
+      <p:sp>
+        <p:nvSpPr>
+          <p:cNvPr id="43" name="Down Arrow 42"/>
+          <p:cNvSpPr/>
+          <p:nvPr/>
+        </p:nvSpPr>
+        <p:spPr>
+          <a:xfrm>
+            <a:off x="8074152" y="4828031"/>
+            <a:ext cx="219456" cy="155448"/>
+          </a:xfrm>
+          <a:prstGeom prst="downArrow">
+            <a:avLst/>
+          </a:prstGeom>
+          <a:solidFill>
+            <a:srgbClr val="CBD5E1"/>
+          </a:solidFill>
+          <a:ln>
+            <a:noFill/>
+          </a:ln>
+          <a:effectLst/>
+        </p:spPr>
+        <p:style>
+          <a:lnRef idx="1">
+            <a:schemeClr val="accent1"/>
+          </a:lnRef>
+          <a:fillRef idx="3">
+            <a:schemeClr val="accent1"/>
+          </a:fillRef>
+          <a:effectRef idx="2">
+            <a:schemeClr val="accent1"/>
+          </a:effectRef>
+          <a:fontRef idx="minor">
+            <a:schemeClr val="lt1"/>
+          </a:fontRef>
+        </p:style>
+        <p:txBody>
+          <a:bodyPr rtlCol="0" anchor="ctr"/>
+          <a:lstStyle/>
+          <a:p>
+            <a:pPr algn="ctr"/>
+          </a:p>
+        </p:txBody>
+      </p:sp>
+      <p:sp>
+        <p:nvSpPr>
+          <p:cNvPr id="44" name="Rounded Rectangle 43"/>
+          <p:cNvSpPr/>
+          <p:nvPr/>
+        </p:nvSpPr>
+        <p:spPr>
+          <a:xfrm>
+            <a:off x="7909560" y="5010912"/>
+            <a:ext cx="3520440" cy="402336"/>
+          </a:xfrm>
+          <a:prstGeom prst="roundRect">
+            <a:avLst>
+              <a:gd name="adj" fmla="val 20000"/>
+            </a:avLst>
+          </a:prstGeom>
+          <a:solidFill>
+            <a:srgbClr val="1E293B"/>
+          </a:solidFill>
+          <a:ln>
+            <a:noFill/>
+          </a:ln>
+          <a:effectLst/>
+        </p:spPr>
+        <p:style>
+          <a:lnRef idx="1">
+            <a:schemeClr val="accent1"/>
+          </a:lnRef>
+          <a:fillRef idx="3">
+            <a:schemeClr val="accent1"/>
+          </a:fillRef>
+          <a:effectRef idx="2">
+            <a:schemeClr val="accent1"/>
+          </a:effectRef>
+          <a:fontRef idx="minor">
+            <a:schemeClr val="lt1"/>
+          </a:fontRef>
+        </p:style>
+        <p:txBody>
+          <a:bodyPr rtlCol="0" anchor="ctr"/>
+          <a:lstStyle/>
+          <a:p>
+            <a:pPr algn="ctr"/>
+          </a:p>
+        </p:txBody>
+      </p:sp>
+      <p:sp>
+        <p:nvSpPr>
+          <p:cNvPr id="45" name="Rounded Rectangle 44"/>
+          <p:cNvSpPr/>
+          <p:nvPr/>
+        </p:nvSpPr>
+        <p:spPr>
+          <a:xfrm>
+            <a:off x="8001000" y="5074920"/>
+            <a:ext cx="292608" cy="292608"/>
+          </a:xfrm>
+          <a:prstGeom prst="roundRect">
+            <a:avLst>
+              <a:gd name="adj" fmla="val 50000"/>
+            </a:avLst>
+          </a:prstGeom>
+          <a:solidFill>
+            <a:srgbClr val="0F766E"/>
+          </a:solidFill>
+          <a:ln>
+            <a:noFill/>
+          </a:ln>
+          <a:effectLst/>
+        </p:spPr>
+        <p:style>
+          <a:lnRef idx="1">
+            <a:schemeClr val="accent1"/>
+          </a:lnRef>
+          <a:fillRef idx="3">
+            <a:schemeClr val="accent1"/>
+          </a:fillRef>
+          <a:effectRef idx="2">
+            <a:schemeClr val="accent1"/>
+          </a:effectRef>
+          <a:fontRef idx="minor">
+            <a:schemeClr val="lt1"/>
+          </a:fontRef>
+        </p:style>
+        <p:txBody>
+          <a:bodyPr rtlCol="0" anchor="ctr" wrap="square" lIns="73152" rIns="73152" tIns="36576" bIns="36576"/>
+          <a:lstStyle/>
+          <a:p>
+            <a:pPr algn="ctr">
+              <a:lnSpc>
+                <a:spcPct val="110000"/>
+              </a:lnSpc>
+            </a:pPr>
+            <a:r>
+              <a:rPr sz="1100" b="1">
+                <a:solidFill>
+                  <a:srgbClr val="FFFFFF"/>
+                </a:solidFill>
+                <a:latin typeface="Arial"/>
+              </a:rPr>
+              <a:t>5</a:t>
+            </a:r>
+          </a:p>
+        </p:txBody>
+      </p:sp>
+      <p:sp>
+        <p:nvSpPr>
+          <p:cNvPr id="46" name="TextBox 45"/>
+          <p:cNvSpPr txBox="1"/>
+          <p:nvPr/>
+        </p:nvSpPr>
+        <p:spPr>
+          <a:xfrm>
+            <a:off x="8366760" y="5038344"/>
+            <a:ext cx="3017520" cy="365760"/>
+          </a:xfrm>
+          <a:prstGeom prst="rect">
+            <a:avLst/>
+          </a:prstGeom>
+          <a:noFill/>
+        </p:spPr>
+        <p:txBody>
+          <a:bodyPr wrap="square" lIns="73152" rIns="73152" tIns="36576" bIns="36576" anchor="ctr">
+            <a:spAutoFit/>
+          </a:bodyPr>
+          <a:lstStyle/>
           <a:p>
             <a:pPr algn="l">
               <a:lnSpc>
-                <a:spcPct val="115000"/>
-              </a:lnSpc>
-            </a:pPr>
-            <a:r>
-              <a:rPr sz="1600" b="1">
-                <a:solidFill>
-                  <a:srgbClr val="5EEAD4"/>
-                </a:solidFill>
-                <a:latin typeface="Arial"/>
-              </a:rPr>
-              <a:t>✓  </a:t>
-            </a:r>
-            <a:r>
-              <a:rPr sz="1600" b="0">
+                <a:spcPct val="110000"/>
+              </a:lnSpc>
+            </a:pPr>
+            <a:r>
+              <a:rPr sz="1400" b="0">
                 <a:solidFill>
                   <a:srgbClr val="FFFFFF"/>
                 </a:solidFill>
                 <a:latin typeface="Arial"/>
               </a:rPr>
-              <a:t>The full record of every step</a:t>
+              <a:t>Every step on one record</a:t>
             </a:r>
           </a:p>
         </p:txBody>

</xml_diff>

<commit_message>
Deck: slide 5 shows all four parts at once
Co-Authored-By: Claude Opus 5.5 <noreply@anthropic.com>
Claude-Session: https://claude.ai/code/session_01DptoPaaj14X3TGztKApoPN
</commit_message>
<xml_diff>
--- a/docs/presentation/KAOP_Customer_Pitch.pptx
+++ b/docs/presentation/KAOP_Customer_Pitch.pptx
@@ -20107,716 +20107,6 @@
   <p:clrMapOvr>
     <a:masterClrMapping/>
   </p:clrMapOvr>
-  <p:timing>
-    <p:tnLst>
-      <p:par>
-        <p:cTn id="1" dur="indefinite" restart="never" nodeType="tmRoot">
-          <p:childTnLst>
-            <p:seq concurrent="1" nextAc="seek">
-              <p:cTn id="2" dur="indefinite" nodeType="mainSeq">
-                <p:childTnLst>
-                  <p:par>
-                    <p:cTn id="13" fill="hold">
-                      <p:stCondLst>
-                        <p:cond delay="indefinite"/>
-                      </p:stCondLst>
-                      <p:childTnLst>
-                        <p:par>
-                          <p:cTn id="14" fill="hold">
-                            <p:stCondLst>
-                              <p:cond delay="0"/>
-                            </p:stCondLst>
-                            <p:childTnLst>
-                              <p:par>
-                                <p:cTn id="3" presetID="1" presetClass="entr" presetSubtype="0" fill="hold" nodeType="clickEffect">
-                                  <p:stCondLst>
-                                    <p:cond delay="0"/>
-                                  </p:stCondLst>
-                                  <p:childTnLst>
-                                    <p:set>
-                                      <p:cBhvr>
-                                        <p:cTn id="4" dur="1" fill="hold">
-                                          <p:stCondLst>
-                                            <p:cond delay="0"/>
-                                          </p:stCondLst>
-                                        </p:cTn>
-                                        <p:tgtEl>
-                                          <p:spTgt spid="6"/>
-                                        </p:tgtEl>
-                                        <p:attrNameLst>
-                                          <p:attrName>style.visibility</p:attrName>
-                                        </p:attrNameLst>
-                                      </p:cBhvr>
-                                      <p:to>
-                                        <p:strVal val="visible"/>
-                                      </p:to>
-                                    </p:set>
-                                  </p:childTnLst>
-                                </p:cTn>
-                              </p:par>
-                              <p:par>
-                                <p:cTn id="5" presetID="1" presetClass="entr" presetSubtype="0" fill="hold" nodeType="withEffect">
-                                  <p:stCondLst>
-                                    <p:cond delay="0"/>
-                                  </p:stCondLst>
-                                  <p:childTnLst>
-                                    <p:set>
-                                      <p:cBhvr>
-                                        <p:cTn id="6" dur="1" fill="hold">
-                                          <p:stCondLst>
-                                            <p:cond delay="0"/>
-                                          </p:stCondLst>
-                                        </p:cTn>
-                                        <p:tgtEl>
-                                          <p:spTgt spid="7"/>
-                                        </p:tgtEl>
-                                        <p:attrNameLst>
-                                          <p:attrName>style.visibility</p:attrName>
-                                        </p:attrNameLst>
-                                      </p:cBhvr>
-                                      <p:to>
-                                        <p:strVal val="visible"/>
-                                      </p:to>
-                                    </p:set>
-                                  </p:childTnLst>
-                                </p:cTn>
-                              </p:par>
-                              <p:par>
-                                <p:cTn id="7" presetID="1" presetClass="entr" presetSubtype="0" fill="hold" nodeType="withEffect">
-                                  <p:stCondLst>
-                                    <p:cond delay="0"/>
-                                  </p:stCondLst>
-                                  <p:childTnLst>
-                                    <p:set>
-                                      <p:cBhvr>
-                                        <p:cTn id="8" dur="1" fill="hold">
-                                          <p:stCondLst>
-                                            <p:cond delay="0"/>
-                                          </p:stCondLst>
-                                        </p:cTn>
-                                        <p:tgtEl>
-                                          <p:spTgt spid="8"/>
-                                        </p:tgtEl>
-                                        <p:attrNameLst>
-                                          <p:attrName>style.visibility</p:attrName>
-                                        </p:attrNameLst>
-                                      </p:cBhvr>
-                                      <p:to>
-                                        <p:strVal val="visible"/>
-                                      </p:to>
-                                    </p:set>
-                                  </p:childTnLst>
-                                </p:cTn>
-                              </p:par>
-                              <p:par>
-                                <p:cTn id="9" presetID="1" presetClass="entr" presetSubtype="0" fill="hold" nodeType="withEffect">
-                                  <p:stCondLst>
-                                    <p:cond delay="0"/>
-                                  </p:stCondLst>
-                                  <p:childTnLst>
-                                    <p:set>
-                                      <p:cBhvr>
-                                        <p:cTn id="10" dur="1" fill="hold">
-                                          <p:stCondLst>
-                                            <p:cond delay="0"/>
-                                          </p:stCondLst>
-                                        </p:cTn>
-                                        <p:tgtEl>
-                                          <p:spTgt spid="9"/>
-                                        </p:tgtEl>
-                                        <p:attrNameLst>
-                                          <p:attrName>style.visibility</p:attrName>
-                                        </p:attrNameLst>
-                                      </p:cBhvr>
-                                      <p:to>
-                                        <p:strVal val="visible"/>
-                                      </p:to>
-                                    </p:set>
-                                  </p:childTnLst>
-                                </p:cTn>
-                              </p:par>
-                              <p:par>
-                                <p:cTn id="11" presetID="1" presetClass="entr" presetSubtype="0" fill="hold" nodeType="withEffect">
-                                  <p:stCondLst>
-                                    <p:cond delay="0"/>
-                                  </p:stCondLst>
-                                  <p:childTnLst>
-                                    <p:set>
-                                      <p:cBhvr>
-                                        <p:cTn id="12" dur="1" fill="hold">
-                                          <p:stCondLst>
-                                            <p:cond delay="0"/>
-                                          </p:stCondLst>
-                                        </p:cTn>
-                                        <p:tgtEl>
-                                          <p:spTgt spid="10"/>
-                                        </p:tgtEl>
-                                        <p:attrNameLst>
-                                          <p:attrName>style.visibility</p:attrName>
-                                        </p:attrNameLst>
-                                      </p:cBhvr>
-                                      <p:to>
-                                        <p:strVal val="visible"/>
-                                      </p:to>
-                                    </p:set>
-                                  </p:childTnLst>
-                                </p:cTn>
-                              </p:par>
-                            </p:childTnLst>
-                          </p:cTn>
-                        </p:par>
-                      </p:childTnLst>
-                    </p:cTn>
-                  </p:par>
-                  <p:par>
-                    <p:cTn id="25" fill="hold">
-                      <p:stCondLst>
-                        <p:cond delay="indefinite"/>
-                      </p:stCondLst>
-                      <p:childTnLst>
-                        <p:par>
-                          <p:cTn id="26" fill="hold">
-                            <p:stCondLst>
-                              <p:cond delay="0"/>
-                            </p:stCondLst>
-                            <p:childTnLst>
-                              <p:par>
-                                <p:cTn id="15" presetID="1" presetClass="entr" presetSubtype="0" fill="hold" nodeType="clickEffect">
-                                  <p:stCondLst>
-                                    <p:cond delay="0"/>
-                                  </p:stCondLst>
-                                  <p:childTnLst>
-                                    <p:set>
-                                      <p:cBhvr>
-                                        <p:cTn id="16" dur="1" fill="hold">
-                                          <p:stCondLst>
-                                            <p:cond delay="0"/>
-                                          </p:stCondLst>
-                                        </p:cTn>
-                                        <p:tgtEl>
-                                          <p:spTgt spid="11"/>
-                                        </p:tgtEl>
-                                        <p:attrNameLst>
-                                          <p:attrName>style.visibility</p:attrName>
-                                        </p:attrNameLst>
-                                      </p:cBhvr>
-                                      <p:to>
-                                        <p:strVal val="visible"/>
-                                      </p:to>
-                                    </p:set>
-                                  </p:childTnLst>
-                                </p:cTn>
-                              </p:par>
-                              <p:par>
-                                <p:cTn id="17" presetID="1" presetClass="entr" presetSubtype="0" fill="hold" nodeType="withEffect">
-                                  <p:stCondLst>
-                                    <p:cond delay="0"/>
-                                  </p:stCondLst>
-                                  <p:childTnLst>
-                                    <p:set>
-                                      <p:cBhvr>
-                                        <p:cTn id="18" dur="1" fill="hold">
-                                          <p:stCondLst>
-                                            <p:cond delay="0"/>
-                                          </p:stCondLst>
-                                        </p:cTn>
-                                        <p:tgtEl>
-                                          <p:spTgt spid="12"/>
-                                        </p:tgtEl>
-                                        <p:attrNameLst>
-                                          <p:attrName>style.visibility</p:attrName>
-                                        </p:attrNameLst>
-                                      </p:cBhvr>
-                                      <p:to>
-                                        <p:strVal val="visible"/>
-                                      </p:to>
-                                    </p:set>
-                                  </p:childTnLst>
-                                </p:cTn>
-                              </p:par>
-                              <p:par>
-                                <p:cTn id="19" presetID="1" presetClass="entr" presetSubtype="0" fill="hold" nodeType="withEffect">
-                                  <p:stCondLst>
-                                    <p:cond delay="0"/>
-                                  </p:stCondLst>
-                                  <p:childTnLst>
-                                    <p:set>
-                                      <p:cBhvr>
-                                        <p:cTn id="20" dur="1" fill="hold">
-                                          <p:stCondLst>
-                                            <p:cond delay="0"/>
-                                          </p:stCondLst>
-                                        </p:cTn>
-                                        <p:tgtEl>
-                                          <p:spTgt spid="13"/>
-                                        </p:tgtEl>
-                                        <p:attrNameLst>
-                                          <p:attrName>style.visibility</p:attrName>
-                                        </p:attrNameLst>
-                                      </p:cBhvr>
-                                      <p:to>
-                                        <p:strVal val="visible"/>
-                                      </p:to>
-                                    </p:set>
-                                  </p:childTnLst>
-                                </p:cTn>
-                              </p:par>
-                              <p:par>
-                                <p:cTn id="21" presetID="1" presetClass="entr" presetSubtype="0" fill="hold" nodeType="withEffect">
-                                  <p:stCondLst>
-                                    <p:cond delay="0"/>
-                                  </p:stCondLst>
-                                  <p:childTnLst>
-                                    <p:set>
-                                      <p:cBhvr>
-                                        <p:cTn id="22" dur="1" fill="hold">
-                                          <p:stCondLst>
-                                            <p:cond delay="0"/>
-                                          </p:stCondLst>
-                                        </p:cTn>
-                                        <p:tgtEl>
-                                          <p:spTgt spid="14"/>
-                                        </p:tgtEl>
-                                        <p:attrNameLst>
-                                          <p:attrName>style.visibility</p:attrName>
-                                        </p:attrNameLst>
-                                      </p:cBhvr>
-                                      <p:to>
-                                        <p:strVal val="visible"/>
-                                      </p:to>
-                                    </p:set>
-                                  </p:childTnLst>
-                                </p:cTn>
-                              </p:par>
-                              <p:par>
-                                <p:cTn id="23" presetID="1" presetClass="entr" presetSubtype="0" fill="hold" nodeType="withEffect">
-                                  <p:stCondLst>
-                                    <p:cond delay="0"/>
-                                  </p:stCondLst>
-                                  <p:childTnLst>
-                                    <p:set>
-                                      <p:cBhvr>
-                                        <p:cTn id="24" dur="1" fill="hold">
-                                          <p:stCondLst>
-                                            <p:cond delay="0"/>
-                                          </p:stCondLst>
-                                        </p:cTn>
-                                        <p:tgtEl>
-                                          <p:spTgt spid="15"/>
-                                        </p:tgtEl>
-                                        <p:attrNameLst>
-                                          <p:attrName>style.visibility</p:attrName>
-                                        </p:attrNameLst>
-                                      </p:cBhvr>
-                                      <p:to>
-                                        <p:strVal val="visible"/>
-                                      </p:to>
-                                    </p:set>
-                                  </p:childTnLst>
-                                </p:cTn>
-                              </p:par>
-                            </p:childTnLst>
-                          </p:cTn>
-                        </p:par>
-                      </p:childTnLst>
-                    </p:cTn>
-                  </p:par>
-                  <p:par>
-                    <p:cTn id="37" fill="hold">
-                      <p:stCondLst>
-                        <p:cond delay="indefinite"/>
-                      </p:stCondLst>
-                      <p:childTnLst>
-                        <p:par>
-                          <p:cTn id="38" fill="hold">
-                            <p:stCondLst>
-                              <p:cond delay="0"/>
-                            </p:stCondLst>
-                            <p:childTnLst>
-                              <p:par>
-                                <p:cTn id="27" presetID="1" presetClass="entr" presetSubtype="0" fill="hold" nodeType="clickEffect">
-                                  <p:stCondLst>
-                                    <p:cond delay="0"/>
-                                  </p:stCondLst>
-                                  <p:childTnLst>
-                                    <p:set>
-                                      <p:cBhvr>
-                                        <p:cTn id="28" dur="1" fill="hold">
-                                          <p:stCondLst>
-                                            <p:cond delay="0"/>
-                                          </p:stCondLst>
-                                        </p:cTn>
-                                        <p:tgtEl>
-                                          <p:spTgt spid="16"/>
-                                        </p:tgtEl>
-                                        <p:attrNameLst>
-                                          <p:attrName>style.visibility</p:attrName>
-                                        </p:attrNameLst>
-                                      </p:cBhvr>
-                                      <p:to>
-                                        <p:strVal val="visible"/>
-                                      </p:to>
-                                    </p:set>
-                                  </p:childTnLst>
-                                </p:cTn>
-                              </p:par>
-                              <p:par>
-                                <p:cTn id="29" presetID="1" presetClass="entr" presetSubtype="0" fill="hold" nodeType="withEffect">
-                                  <p:stCondLst>
-                                    <p:cond delay="0"/>
-                                  </p:stCondLst>
-                                  <p:childTnLst>
-                                    <p:set>
-                                      <p:cBhvr>
-                                        <p:cTn id="30" dur="1" fill="hold">
-                                          <p:stCondLst>
-                                            <p:cond delay="0"/>
-                                          </p:stCondLst>
-                                        </p:cTn>
-                                        <p:tgtEl>
-                                          <p:spTgt spid="17"/>
-                                        </p:tgtEl>
-                                        <p:attrNameLst>
-                                          <p:attrName>style.visibility</p:attrName>
-                                        </p:attrNameLst>
-                                      </p:cBhvr>
-                                      <p:to>
-                                        <p:strVal val="visible"/>
-                                      </p:to>
-                                    </p:set>
-                                  </p:childTnLst>
-                                </p:cTn>
-                              </p:par>
-                              <p:par>
-                                <p:cTn id="31" presetID="1" presetClass="entr" presetSubtype="0" fill="hold" nodeType="withEffect">
-                                  <p:stCondLst>
-                                    <p:cond delay="0"/>
-                                  </p:stCondLst>
-                                  <p:childTnLst>
-                                    <p:set>
-                                      <p:cBhvr>
-                                        <p:cTn id="32" dur="1" fill="hold">
-                                          <p:stCondLst>
-                                            <p:cond delay="0"/>
-                                          </p:stCondLst>
-                                        </p:cTn>
-                                        <p:tgtEl>
-                                          <p:spTgt spid="18"/>
-                                        </p:tgtEl>
-                                        <p:attrNameLst>
-                                          <p:attrName>style.visibility</p:attrName>
-                                        </p:attrNameLst>
-                                      </p:cBhvr>
-                                      <p:to>
-                                        <p:strVal val="visible"/>
-                                      </p:to>
-                                    </p:set>
-                                  </p:childTnLst>
-                                </p:cTn>
-                              </p:par>
-                              <p:par>
-                                <p:cTn id="33" presetID="1" presetClass="entr" presetSubtype="0" fill="hold" nodeType="withEffect">
-                                  <p:stCondLst>
-                                    <p:cond delay="0"/>
-                                  </p:stCondLst>
-                                  <p:childTnLst>
-                                    <p:set>
-                                      <p:cBhvr>
-                                        <p:cTn id="34" dur="1" fill="hold">
-                                          <p:stCondLst>
-                                            <p:cond delay="0"/>
-                                          </p:stCondLst>
-                                        </p:cTn>
-                                        <p:tgtEl>
-                                          <p:spTgt spid="19"/>
-                                        </p:tgtEl>
-                                        <p:attrNameLst>
-                                          <p:attrName>style.visibility</p:attrName>
-                                        </p:attrNameLst>
-                                      </p:cBhvr>
-                                      <p:to>
-                                        <p:strVal val="visible"/>
-                                      </p:to>
-                                    </p:set>
-                                  </p:childTnLst>
-                                </p:cTn>
-                              </p:par>
-                              <p:par>
-                                <p:cTn id="35" presetID="1" presetClass="entr" presetSubtype="0" fill="hold" nodeType="withEffect">
-                                  <p:stCondLst>
-                                    <p:cond delay="0"/>
-                                  </p:stCondLst>
-                                  <p:childTnLst>
-                                    <p:set>
-                                      <p:cBhvr>
-                                        <p:cTn id="36" dur="1" fill="hold">
-                                          <p:stCondLst>
-                                            <p:cond delay="0"/>
-                                          </p:stCondLst>
-                                        </p:cTn>
-                                        <p:tgtEl>
-                                          <p:spTgt spid="20"/>
-                                        </p:tgtEl>
-                                        <p:attrNameLst>
-                                          <p:attrName>style.visibility</p:attrName>
-                                        </p:attrNameLst>
-                                      </p:cBhvr>
-                                      <p:to>
-                                        <p:strVal val="visible"/>
-                                      </p:to>
-                                    </p:set>
-                                  </p:childTnLst>
-                                </p:cTn>
-                              </p:par>
-                            </p:childTnLst>
-                          </p:cTn>
-                        </p:par>
-                      </p:childTnLst>
-                    </p:cTn>
-                  </p:par>
-                  <p:par>
-                    <p:cTn id="49" fill="hold">
-                      <p:stCondLst>
-                        <p:cond delay="indefinite"/>
-                      </p:stCondLst>
-                      <p:childTnLst>
-                        <p:par>
-                          <p:cTn id="50" fill="hold">
-                            <p:stCondLst>
-                              <p:cond delay="0"/>
-                            </p:stCondLst>
-                            <p:childTnLst>
-                              <p:par>
-                                <p:cTn id="39" presetID="1" presetClass="entr" presetSubtype="0" fill="hold" nodeType="clickEffect">
-                                  <p:stCondLst>
-                                    <p:cond delay="0"/>
-                                  </p:stCondLst>
-                                  <p:childTnLst>
-                                    <p:set>
-                                      <p:cBhvr>
-                                        <p:cTn id="40" dur="1" fill="hold">
-                                          <p:stCondLst>
-                                            <p:cond delay="0"/>
-                                          </p:stCondLst>
-                                        </p:cTn>
-                                        <p:tgtEl>
-                                          <p:spTgt spid="21"/>
-                                        </p:tgtEl>
-                                        <p:attrNameLst>
-                                          <p:attrName>style.visibility</p:attrName>
-                                        </p:attrNameLst>
-                                      </p:cBhvr>
-                                      <p:to>
-                                        <p:strVal val="visible"/>
-                                      </p:to>
-                                    </p:set>
-                                  </p:childTnLst>
-                                </p:cTn>
-                              </p:par>
-                              <p:par>
-                                <p:cTn id="41" presetID="1" presetClass="entr" presetSubtype="0" fill="hold" nodeType="withEffect">
-                                  <p:stCondLst>
-                                    <p:cond delay="0"/>
-                                  </p:stCondLst>
-                                  <p:childTnLst>
-                                    <p:set>
-                                      <p:cBhvr>
-                                        <p:cTn id="42" dur="1" fill="hold">
-                                          <p:stCondLst>
-                                            <p:cond delay="0"/>
-                                          </p:stCondLst>
-                                        </p:cTn>
-                                        <p:tgtEl>
-                                          <p:spTgt spid="22"/>
-                                        </p:tgtEl>
-                                        <p:attrNameLst>
-                                          <p:attrName>style.visibility</p:attrName>
-                                        </p:attrNameLst>
-                                      </p:cBhvr>
-                                      <p:to>
-                                        <p:strVal val="visible"/>
-                                      </p:to>
-                                    </p:set>
-                                  </p:childTnLst>
-                                </p:cTn>
-                              </p:par>
-                              <p:par>
-                                <p:cTn id="43" presetID="1" presetClass="entr" presetSubtype="0" fill="hold" nodeType="withEffect">
-                                  <p:stCondLst>
-                                    <p:cond delay="0"/>
-                                  </p:stCondLst>
-                                  <p:childTnLst>
-                                    <p:set>
-                                      <p:cBhvr>
-                                        <p:cTn id="44" dur="1" fill="hold">
-                                          <p:stCondLst>
-                                            <p:cond delay="0"/>
-                                          </p:stCondLst>
-                                        </p:cTn>
-                                        <p:tgtEl>
-                                          <p:spTgt spid="23"/>
-                                        </p:tgtEl>
-                                        <p:attrNameLst>
-                                          <p:attrName>style.visibility</p:attrName>
-                                        </p:attrNameLst>
-                                      </p:cBhvr>
-                                      <p:to>
-                                        <p:strVal val="visible"/>
-                                      </p:to>
-                                    </p:set>
-                                  </p:childTnLst>
-                                </p:cTn>
-                              </p:par>
-                              <p:par>
-                                <p:cTn id="45" presetID="1" presetClass="entr" presetSubtype="0" fill="hold" nodeType="withEffect">
-                                  <p:stCondLst>
-                                    <p:cond delay="0"/>
-                                  </p:stCondLst>
-                                  <p:childTnLst>
-                                    <p:set>
-                                      <p:cBhvr>
-                                        <p:cTn id="46" dur="1" fill="hold">
-                                          <p:stCondLst>
-                                            <p:cond delay="0"/>
-                                          </p:stCondLst>
-                                        </p:cTn>
-                                        <p:tgtEl>
-                                          <p:spTgt spid="24"/>
-                                        </p:tgtEl>
-                                        <p:attrNameLst>
-                                          <p:attrName>style.visibility</p:attrName>
-                                        </p:attrNameLst>
-                                      </p:cBhvr>
-                                      <p:to>
-                                        <p:strVal val="visible"/>
-                                      </p:to>
-                                    </p:set>
-                                  </p:childTnLst>
-                                </p:cTn>
-                              </p:par>
-                              <p:par>
-                                <p:cTn id="47" presetID="1" presetClass="entr" presetSubtype="0" fill="hold" nodeType="withEffect">
-                                  <p:stCondLst>
-                                    <p:cond delay="0"/>
-                                  </p:stCondLst>
-                                  <p:childTnLst>
-                                    <p:set>
-                                      <p:cBhvr>
-                                        <p:cTn id="48" dur="1" fill="hold">
-                                          <p:stCondLst>
-                                            <p:cond delay="0"/>
-                                          </p:stCondLst>
-                                        </p:cTn>
-                                        <p:tgtEl>
-                                          <p:spTgt spid="25"/>
-                                        </p:tgtEl>
-                                        <p:attrNameLst>
-                                          <p:attrName>style.visibility</p:attrName>
-                                        </p:attrNameLst>
-                                      </p:cBhvr>
-                                      <p:to>
-                                        <p:strVal val="visible"/>
-                                      </p:to>
-                                    </p:set>
-                                  </p:childTnLst>
-                                </p:cTn>
-                              </p:par>
-                            </p:childTnLst>
-                          </p:cTn>
-                        </p:par>
-                      </p:childTnLst>
-                    </p:cTn>
-                  </p:par>
-                  <p:par>
-                    <p:cTn id="53" fill="hold">
-                      <p:stCondLst>
-                        <p:cond delay="indefinite"/>
-                      </p:stCondLst>
-                      <p:childTnLst>
-                        <p:par>
-                          <p:cTn id="54" fill="hold">
-                            <p:stCondLst>
-                              <p:cond delay="0"/>
-                            </p:stCondLst>
-                            <p:childTnLst>
-                              <p:par>
-                                <p:cTn id="51" presetID="1" presetClass="entr" presetSubtype="0" fill="hold" nodeType="clickEffect">
-                                  <p:stCondLst>
-                                    <p:cond delay="0"/>
-                                  </p:stCondLst>
-                                  <p:childTnLst>
-                                    <p:set>
-                                      <p:cBhvr>
-                                        <p:cTn id="52" dur="1" fill="hold">
-                                          <p:stCondLst>
-                                            <p:cond delay="0"/>
-                                          </p:stCondLst>
-                                        </p:cTn>
-                                        <p:tgtEl>
-                                          <p:spTgt spid="26"/>
-                                        </p:tgtEl>
-                                        <p:attrNameLst>
-                                          <p:attrName>style.visibility</p:attrName>
-                                        </p:attrNameLst>
-                                      </p:cBhvr>
-                                      <p:to>
-                                        <p:strVal val="visible"/>
-                                      </p:to>
-                                    </p:set>
-                                  </p:childTnLst>
-                                </p:cTn>
-                              </p:par>
-                            </p:childTnLst>
-                          </p:cTn>
-                        </p:par>
-                      </p:childTnLst>
-                    </p:cTn>
-                  </p:par>
-                </p:childTnLst>
-              </p:cTn>
-              <p:prevCondLst>
-                <p:cond evt="onPrev" delay="0">
-                  <p:tgtEl>
-                    <p:sldTgt/>
-                  </p:tgtEl>
-                </p:cond>
-              </p:prevCondLst>
-              <p:nextCondLst>
-                <p:cond evt="onNext" delay="0">
-                  <p:tgtEl>
-                    <p:sldTgt/>
-                  </p:tgtEl>
-                </p:cond>
-              </p:nextCondLst>
-            </p:seq>
-          </p:childTnLst>
-        </p:cTn>
-      </p:par>
-    </p:tnLst>
-    <p:bldLst>
-      <p:bldP spid="6" grpId="0" animBg="1"/>
-      <p:bldP spid="7" grpId="0" animBg="1"/>
-      <p:bldP spid="8" grpId="0" animBg="1"/>
-      <p:bldP spid="9" grpId="0" animBg="1"/>
-      <p:bldP spid="10" grpId="0" animBg="1"/>
-      <p:bldP spid="11" grpId="0" animBg="1"/>
-      <p:bldP spid="12" grpId="0" animBg="1"/>
-      <p:bldP spid="13" grpId="0" animBg="1"/>
-      <p:bldP spid="14" grpId="0" animBg="1"/>
-      <p:bldP spid="15" grpId="0" animBg="1"/>
-      <p:bldP spid="16" grpId="0" animBg="1"/>
-      <p:bldP spid="17" grpId="0" animBg="1"/>
-      <p:bldP spid="18" grpId="0" animBg="1"/>
-      <p:bldP spid="19" grpId="0" animBg="1"/>
-      <p:bldP spid="20" grpId="0" animBg="1"/>
-      <p:bldP spid="21" grpId="0" animBg="1"/>
-      <p:bldP spid="22" grpId="0" animBg="1"/>
-      <p:bldP spid="23" grpId="0" animBg="1"/>
-      <p:bldP spid="24" grpId="0" animBg="1"/>
-      <p:bldP spid="25" grpId="0" animBg="1"/>
-      <p:bldP spid="26" grpId="0" animBg="1"/>
-    </p:bldLst>
-  </p:timing>
 </p:sld>
 </file>
 

</xml_diff>

<commit_message>
Deck: shorter value lines on slides 5, 6 and 11
Co-Authored-By: Claude Opus 5.5 <noreply@anthropic.com>
Claude-Session: https://claude.ai/code/session_01DptoPaaj14X3TGztKApoPN
</commit_message>
<xml_diff>
--- a/docs/presentation/KAOP_Customer_Pitch.pptx
+++ b/docs/presentation/KAOP_Customer_Pitch.pptx
@@ -7102,7 +7102,7 @@
                 </a:solidFill>
                 <a:latin typeface="Arial"/>
               </a:rPr>
-              <a:t>Root cause, confidence and evidence, minutes after the alert.</a:t>
+              <a:t>Root cause and evidence, minutes after the alert.</a:t>
             </a:r>
           </a:p>
         </p:txBody>
@@ -7324,7 +7324,7 @@
                 </a:solidFill>
                 <a:latin typeface="Arial"/>
               </a:rPr>
-              <a:t>The fix, with the command, an undo plan and a check that it worked.</a:t>
+              <a:t>The fix, with undo and a check.</a:t>
             </a:r>
           </a:p>
         </p:txBody>
@@ -7546,7 +7546,7 @@
                 </a:solidFill>
                 <a:latin typeface="Arial"/>
               </a:rPr>
-              <a:t>A person approves; an agent applies it under its own identity.</a:t>
+              <a:t>A person approves. An agent applies.</a:t>
             </a:r>
           </a:p>
         </p:txBody>
@@ -7768,7 +7768,7 @@
                 </a:solidFill>
                 <a:latin typeface="Arial"/>
               </a:rPr>
-              <a:t>Low-risk, reversible fixes run inside guardrails. People review the record.</a:t>
+              <a:t>Low-risk fixes run on their own. People review.</a:t>
             </a:r>
           </a:p>
         </p:txBody>
@@ -19375,7 +19375,7 @@
                 </a:solidFill>
                 <a:latin typeface="Arial"/>
               </a:rPr>
-              <a:t>Pre-built workflows for AI SRE, software ops and cost. 50+ Komodor agents. Or import yours.</a:t>
+              <a:t>50+ ready agents and workflows. Yours get the same controls.</a:t>
             </a:r>
           </a:p>
         </p:txBody>
@@ -19584,7 +19584,7 @@
                 </a:solidFill>
                 <a:latin typeface="Arial"/>
               </a:rPr>
-              <a:t>Alerts, schedules and Slack start runs. Workflows route to specialists.</a:t>
+              <a:t>Alerts start the work. Specialists hand off. One record.</a:t>
             </a:r>
           </a:p>
         </p:txBody>
@@ -19793,7 +19793,7 @@
                 </a:solidFill>
                 <a:latin typeface="Arial"/>
               </a:rPr>
-              <a:t>Identity, default-deny permissions, guardrails, approvals and audit.</a:t>
+              <a:t>Identity, permissions, approvals and audit, on every run.</a:t>
             </a:r>
           </a:p>
         </p:txBody>
@@ -20002,7 +20002,7 @@
                 </a:solidFill>
                 <a:latin typeface="Arial"/>
               </a:rPr>
-              <a:t>Every run's evidence and cost. Evaluations and budgets.</a:t>
+              <a:t>Cost and quality per run. Budgets stop overspend.</a:t>
             </a:r>
           </a:p>
         </p:txBody>
@@ -20331,8 +20331,8 @@
         </p:nvSpPr>
         <p:spPr>
           <a:xfrm>
-            <a:off x="2697480" y="1965960"/>
-            <a:ext cx="2651760" cy="274320"/>
+            <a:off x="3017520" y="1965960"/>
+            <a:ext cx="4572000" cy="274320"/>
           </a:xfrm>
           <a:prstGeom prst="rect">
             <a:avLst/>
@@ -20357,53 +20357,14 @@
                 </a:solidFill>
                 <a:latin typeface="Arial"/>
               </a:rPr>
-              <a:t>ASKS</a:t>
-            </a:r>
-          </a:p>
-        </p:txBody>
-      </p:sp>
-      <p:sp>
-        <p:nvSpPr>
-          <p:cNvPr id="8" name="TextBox 7"/>
-          <p:cNvSpPr txBox="1"/>
-          <p:nvPr/>
-        </p:nvSpPr>
-        <p:spPr>
-          <a:xfrm>
-            <a:off x="5349240" y="1965960"/>
-            <a:ext cx="2743200" cy="274320"/>
-          </a:xfrm>
-          <a:prstGeom prst="rect">
-            <a:avLst/>
-          </a:prstGeom>
-          <a:noFill/>
-        </p:spPr>
-        <p:txBody>
-          <a:bodyPr wrap="square" lIns="73152" rIns="73152" tIns="36576" bIns="36576" anchor="t">
-            <a:spAutoFit/>
-          </a:bodyPr>
-          <a:lstStyle/>
-          <a:p>
-            <a:pPr algn="l">
-              <a:lnSpc>
-                <a:spcPct val="110000"/>
-              </a:lnSpc>
-            </a:pPr>
-            <a:r>
-              <a:rPr sz="1100" b="1">
-                <a:solidFill>
-                  <a:srgbClr val="94A3B8"/>
-                </a:solidFill>
-                <a:latin typeface="Arial"/>
-              </a:rPr>
-              <a:t>STOPS</a:t>
-            </a:r>
-          </a:p>
-        </p:txBody>
-      </p:sp>
-      <p:sp>
-        <p:nvSpPr>
-          <p:cNvPr id="9" name="Rounded Rectangle 8"/>
+              <a:t>WHAT YOU GET</a:t>
+            </a:r>
+          </a:p>
+        </p:txBody>
+      </p:sp>
+      <p:sp>
+        <p:nvSpPr>
+          <p:cNvPr id="8" name="Rounded Rectangle 7"/>
           <p:cNvSpPr/>
           <p:nvPr/>
         </p:nvSpPr>
@@ -20451,7 +20412,7 @@
       </p:sp>
       <p:sp>
         <p:nvSpPr>
-          <p:cNvPr id="10" name="Rounded Rectangle 9"/>
+          <p:cNvPr id="9" name="Rounded Rectangle 8"/>
           <p:cNvSpPr/>
           <p:nvPr/>
         </p:nvSpPr>
@@ -20510,14 +20471,14 @@
       </p:sp>
       <p:sp>
         <p:nvSpPr>
-          <p:cNvPr id="11" name="TextBox 10"/>
+          <p:cNvPr id="10" name="TextBox 9"/>
           <p:cNvSpPr txBox="1"/>
           <p:nvPr/>
         </p:nvSpPr>
         <p:spPr>
           <a:xfrm>
             <a:off x="1024128" y="2322576"/>
-            <a:ext cx="1645920" cy="384048"/>
+            <a:ext cx="1920240" cy="384048"/>
           </a:xfrm>
           <a:prstGeom prst="rect">
             <a:avLst/>
@@ -20549,14 +20510,14 @@
       </p:sp>
       <p:sp>
         <p:nvSpPr>
-          <p:cNvPr id="12" name="TextBox 11"/>
+          <p:cNvPr id="11" name="TextBox 10"/>
           <p:cNvSpPr txBox="1"/>
           <p:nvPr/>
         </p:nvSpPr>
         <p:spPr>
           <a:xfrm>
-            <a:off x="2697480" y="2322576"/>
-            <a:ext cx="2651760" cy="384048"/>
+            <a:off x="3017520" y="2322576"/>
+            <a:ext cx="4983480" cy="384048"/>
           </a:xfrm>
           <a:prstGeom prst="rect">
             <a:avLst/>
@@ -20575,59 +20536,20 @@
               </a:lnSpc>
             </a:pPr>
             <a:r>
-              <a:rPr sz="1450" b="0">
+              <a:rPr sz="1550" b="0">
                 <a:solidFill>
                   <a:srgbClr val="475569"/>
                 </a:solidFill>
                 <a:latin typeface="Arial"/>
               </a:rPr>
-              <a:t>Who is acting?</a:t>
-            </a:r>
-          </a:p>
-        </p:txBody>
-      </p:sp>
-      <p:sp>
-        <p:nvSpPr>
-          <p:cNvPr id="13" name="TextBox 12"/>
-          <p:cNvSpPr txBox="1"/>
-          <p:nvPr/>
-        </p:nvSpPr>
-        <p:spPr>
-          <a:xfrm>
-            <a:off x="5349240" y="2322576"/>
-            <a:ext cx="2697480" cy="384048"/>
-          </a:xfrm>
-          <a:prstGeom prst="rect">
-            <a:avLst/>
-          </a:prstGeom>
-          <a:noFill/>
-        </p:spPr>
-        <p:txBody>
-          <a:bodyPr wrap="square" lIns="73152" rIns="73152" tIns="36576" bIns="36576" anchor="ctr">
-            <a:spAutoFit/>
-          </a:bodyPr>
-          <a:lstStyle/>
-          <a:p>
-            <a:pPr algn="l">
-              <a:lnSpc>
-                <a:spcPct val="110000"/>
-              </a:lnSpc>
-            </a:pPr>
-            <a:r>
-              <a:rPr sz="1450" b="0">
-                <a:solidFill>
-                  <a:srgbClr val="475569"/>
-                </a:solidFill>
-                <a:latin typeface="Arial"/>
-              </a:rPr>
-              <a:t>Unaccountable actions</a:t>
-            </a:r>
-          </a:p>
-        </p:txBody>
-      </p:sp>
-      <p:sp>
-        <p:nvSpPr>
-          <p:cNvPr id="14" name="Rounded Rectangle 13"/>
+              <a:t>Every action has a name on it</a:t>
+            </a:r>
+          </a:p>
+        </p:txBody>
+      </p:sp>
+      <p:sp>
+        <p:nvSpPr>
+          <p:cNvPr id="12" name="Rounded Rectangle 11"/>
           <p:cNvSpPr/>
           <p:nvPr/>
         </p:nvSpPr>
@@ -20675,7 +20597,7 @@
       </p:sp>
       <p:sp>
         <p:nvSpPr>
-          <p:cNvPr id="15" name="Rounded Rectangle 14"/>
+          <p:cNvPr id="13" name="Rounded Rectangle 12"/>
           <p:cNvSpPr/>
           <p:nvPr/>
         </p:nvSpPr>
@@ -20734,14 +20656,14 @@
       </p:sp>
       <p:sp>
         <p:nvSpPr>
-          <p:cNvPr id="16" name="TextBox 15"/>
+          <p:cNvPr id="14" name="TextBox 13"/>
           <p:cNvSpPr txBox="1"/>
           <p:nvPr/>
         </p:nvSpPr>
         <p:spPr>
           <a:xfrm>
             <a:off x="1024128" y="2889504"/>
-            <a:ext cx="1645920" cy="384048"/>
+            <a:ext cx="1920240" cy="384048"/>
           </a:xfrm>
           <a:prstGeom prst="rect">
             <a:avLst/>
@@ -20773,14 +20695,14 @@
       </p:sp>
       <p:sp>
         <p:nvSpPr>
-          <p:cNvPr id="17" name="TextBox 16"/>
+          <p:cNvPr id="15" name="TextBox 14"/>
           <p:cNvSpPr txBox="1"/>
           <p:nvPr/>
         </p:nvSpPr>
         <p:spPr>
           <a:xfrm>
-            <a:off x="2697480" y="2889504"/>
-            <a:ext cx="2651760" cy="384048"/>
+            <a:off x="3017520" y="2889504"/>
+            <a:ext cx="4983480" cy="384048"/>
           </a:xfrm>
           <a:prstGeom prst="rect">
             <a:avLst/>
@@ -20799,59 +20721,20 @@
               </a:lnSpc>
             </a:pPr>
             <a:r>
-              <a:rPr sz="1450" b="0">
+              <a:rPr sz="1550" b="0">
                 <a:solidFill>
                   <a:srgbClr val="475569"/>
                 </a:solidFill>
                 <a:latin typeface="Arial"/>
               </a:rPr>
-              <a:t>Allowed on this?</a:t>
-            </a:r>
-          </a:p>
-        </p:txBody>
-      </p:sp>
-      <p:sp>
-        <p:nvSpPr>
-          <p:cNvPr id="18" name="TextBox 17"/>
-          <p:cNvSpPr txBox="1"/>
-          <p:nvPr/>
-        </p:nvSpPr>
-        <p:spPr>
-          <a:xfrm>
-            <a:off x="5349240" y="2889504"/>
-            <a:ext cx="2697480" cy="384048"/>
-          </a:xfrm>
-          <a:prstGeom prst="rect">
-            <a:avLst/>
-          </a:prstGeom>
-          <a:noFill/>
-        </p:spPr>
-        <p:txBody>
-          <a:bodyPr wrap="square" lIns="73152" rIns="73152" tIns="36576" bIns="36576" anchor="ctr">
-            <a:spAutoFit/>
-          </a:bodyPr>
-          <a:lstStyle/>
-          <a:p>
-            <a:pPr algn="l">
-              <a:lnSpc>
-                <a:spcPct val="110000"/>
-              </a:lnSpc>
-            </a:pPr>
-            <a:r>
-              <a:rPr sz="1450" b="0">
-                <a:solidFill>
-                  <a:srgbClr val="475569"/>
-                </a:solidFill>
-                <a:latin typeface="Arial"/>
-              </a:rPr>
-              <a:t>Reaching beyond the job</a:t>
-            </a:r>
-          </a:p>
-        </p:txBody>
-      </p:sp>
-      <p:sp>
-        <p:nvSpPr>
-          <p:cNvPr id="19" name="Rounded Rectangle 18"/>
+              <a:t>Only the access the job needs</a:t>
+            </a:r>
+          </a:p>
+        </p:txBody>
+      </p:sp>
+      <p:sp>
+        <p:nvSpPr>
+          <p:cNvPr id="16" name="Rounded Rectangle 15"/>
           <p:cNvSpPr/>
           <p:nvPr/>
         </p:nvSpPr>
@@ -20899,7 +20782,7 @@
       </p:sp>
       <p:sp>
         <p:nvSpPr>
-          <p:cNvPr id="20" name="Rounded Rectangle 19"/>
+          <p:cNvPr id="17" name="Rounded Rectangle 16"/>
           <p:cNvSpPr/>
           <p:nvPr/>
         </p:nvSpPr>
@@ -20958,14 +20841,14 @@
       </p:sp>
       <p:sp>
         <p:nvSpPr>
-          <p:cNvPr id="21" name="TextBox 20"/>
+          <p:cNvPr id="18" name="TextBox 17"/>
           <p:cNvSpPr txBox="1"/>
           <p:nvPr/>
         </p:nvSpPr>
         <p:spPr>
           <a:xfrm>
             <a:off x="1024128" y="3456432"/>
-            <a:ext cx="1645920" cy="384048"/>
+            <a:ext cx="1920240" cy="384048"/>
           </a:xfrm>
           <a:prstGeom prst="rect">
             <a:avLst/>
@@ -20997,14 +20880,14 @@
       </p:sp>
       <p:sp>
         <p:nvSpPr>
-          <p:cNvPr id="22" name="TextBox 21"/>
+          <p:cNvPr id="19" name="TextBox 18"/>
           <p:cNvSpPr txBox="1"/>
           <p:nvPr/>
         </p:nvSpPr>
         <p:spPr>
           <a:xfrm>
-            <a:off x="2697480" y="3456432"/>
-            <a:ext cx="2651760" cy="384048"/>
+            <a:off x="3017520" y="3456432"/>
+            <a:ext cx="4983480" cy="384048"/>
           </a:xfrm>
           <a:prstGeom prst="rect">
             <a:avLst/>
@@ -21023,59 +20906,20 @@
               </a:lnSpc>
             </a:pPr>
             <a:r>
-              <a:rPr sz="1450" b="0">
+              <a:rPr sz="1550" b="0">
                 <a:solidFill>
                   <a:srgbClr val="475569"/>
                 </a:solidFill>
                 <a:latin typeface="Arial"/>
               </a:rPr>
-              <a:t>Built to our rules?</a:t>
-            </a:r>
-          </a:p>
-        </p:txBody>
-      </p:sp>
-      <p:sp>
-        <p:nvSpPr>
-          <p:cNvPr id="23" name="TextBox 22"/>
-          <p:cNvSpPr txBox="1"/>
-          <p:nvPr/>
-        </p:nvSpPr>
-        <p:spPr>
-          <a:xfrm>
-            <a:off x="5349240" y="3456432"/>
-            <a:ext cx="2697480" cy="384048"/>
-          </a:xfrm>
-          <a:prstGeom prst="rect">
-            <a:avLst/>
-          </a:prstGeom>
-          <a:noFill/>
-        </p:spPr>
-        <p:txBody>
-          <a:bodyPr wrap="square" lIns="73152" rIns="73152" tIns="36576" bIns="36576" anchor="ctr">
-            <a:spAutoFit/>
-          </a:bodyPr>
-          <a:lstStyle/>
-          <a:p>
-            <a:pPr algn="l">
-              <a:lnSpc>
-                <a:spcPct val="110000"/>
-              </a:lnSpc>
-            </a:pPr>
-            <a:r>
-              <a:rPr sz="1450" b="0">
-                <a:solidFill>
-                  <a:srgbClr val="475569"/>
-                </a:solidFill>
-                <a:latin typeface="Arial"/>
-              </a:rPr>
-              <a:t>Agents with no owner or budget</a:t>
-            </a:r>
-          </a:p>
-        </p:txBody>
-      </p:sp>
-      <p:sp>
-        <p:nvSpPr>
-          <p:cNvPr id="24" name="Rounded Rectangle 23"/>
+              <a:t>No agent ships without an owner</a:t>
+            </a:r>
+          </a:p>
+        </p:txBody>
+      </p:sp>
+      <p:sp>
+        <p:nvSpPr>
+          <p:cNvPr id="20" name="Rounded Rectangle 19"/>
           <p:cNvSpPr/>
           <p:nvPr/>
         </p:nvSpPr>
@@ -21123,7 +20967,7 @@
       </p:sp>
       <p:sp>
         <p:nvSpPr>
-          <p:cNvPr id="25" name="Rounded Rectangle 24"/>
+          <p:cNvPr id="21" name="Rounded Rectangle 20"/>
           <p:cNvSpPr/>
           <p:nvPr/>
         </p:nvSpPr>
@@ -21182,14 +21026,14 @@
       </p:sp>
       <p:sp>
         <p:nvSpPr>
-          <p:cNvPr id="26" name="TextBox 25"/>
+          <p:cNvPr id="22" name="TextBox 21"/>
           <p:cNvSpPr txBox="1"/>
           <p:nvPr/>
         </p:nvSpPr>
         <p:spPr>
           <a:xfrm>
             <a:off x="1024128" y="4023359"/>
-            <a:ext cx="1645920" cy="384048"/>
+            <a:ext cx="1920240" cy="384048"/>
           </a:xfrm>
           <a:prstGeom prst="rect">
             <a:avLst/>
@@ -21221,14 +21065,14 @@
       </p:sp>
       <p:sp>
         <p:nvSpPr>
-          <p:cNvPr id="27" name="TextBox 26"/>
+          <p:cNvPr id="23" name="TextBox 22"/>
           <p:cNvSpPr txBox="1"/>
           <p:nvPr/>
         </p:nvSpPr>
         <p:spPr>
           <a:xfrm>
-            <a:off x="2697480" y="4023359"/>
-            <a:ext cx="2651760" cy="384048"/>
+            <a:off x="3017520" y="4023359"/>
+            <a:ext cx="4983480" cy="384048"/>
           </a:xfrm>
           <a:prstGeom prst="rect">
             <a:avLst/>
@@ -21247,59 +21091,20 @@
               </a:lnSpc>
             </a:pPr>
             <a:r>
-              <a:rPr sz="1450" b="0">
+              <a:rPr sz="1550" b="0">
                 <a:solidFill>
                   <a:srgbClr val="475569"/>
                 </a:solidFill>
                 <a:latin typeface="Arial"/>
               </a:rPr>
-              <a:t>Safe right now?</a:t>
-            </a:r>
-          </a:p>
-        </p:txBody>
-      </p:sp>
-      <p:sp>
-        <p:nvSpPr>
-          <p:cNvPr id="28" name="TextBox 27"/>
-          <p:cNvSpPr txBox="1"/>
-          <p:nvPr/>
-        </p:nvSpPr>
-        <p:spPr>
-          <a:xfrm>
-            <a:off x="5349240" y="4023359"/>
-            <a:ext cx="2697480" cy="384048"/>
-          </a:xfrm>
-          <a:prstGeom prst="rect">
-            <a:avLst/>
-          </a:prstGeom>
-          <a:noFill/>
-        </p:spPr>
-        <p:txBody>
-          <a:bodyPr wrap="square" lIns="73152" rIns="73152" tIns="36576" bIns="36576" anchor="ctr">
-            <a:spAutoFit/>
-          </a:bodyPr>
-          <a:lstStyle/>
-          <a:p>
-            <a:pPr algn="l">
-              <a:lnSpc>
-                <a:spcPct val="110000"/>
-              </a:lnSpc>
-            </a:pPr>
-            <a:r>
-              <a:rPr sz="1450" b="0">
-                <a:solidFill>
-                  <a:srgbClr val="475569"/>
-                </a:solidFill>
-                <a:latin typeface="Arial"/>
-              </a:rPr>
-              <a:t>Destructive tool calls</a:t>
-            </a:r>
-          </a:p>
-        </p:txBody>
-      </p:sp>
-      <p:sp>
-        <p:nvSpPr>
-          <p:cNvPr id="29" name="Rounded Rectangle 28"/>
+              <a:t>Risky calls blocked, every run</a:t>
+            </a:r>
+          </a:p>
+        </p:txBody>
+      </p:sp>
+      <p:sp>
+        <p:nvSpPr>
+          <p:cNvPr id="24" name="Rounded Rectangle 23"/>
           <p:cNvSpPr/>
           <p:nvPr/>
         </p:nvSpPr>
@@ -21347,7 +21152,7 @@
       </p:sp>
       <p:sp>
         <p:nvSpPr>
-          <p:cNvPr id="30" name="Rounded Rectangle 29"/>
+          <p:cNvPr id="25" name="Rounded Rectangle 24"/>
           <p:cNvSpPr/>
           <p:nvPr/>
         </p:nvSpPr>
@@ -21406,14 +21211,14 @@
       </p:sp>
       <p:sp>
         <p:nvSpPr>
-          <p:cNvPr id="31" name="TextBox 30"/>
+          <p:cNvPr id="26" name="TextBox 25"/>
           <p:cNvSpPr txBox="1"/>
           <p:nvPr/>
         </p:nvSpPr>
         <p:spPr>
           <a:xfrm>
             <a:off x="1024128" y="4590288"/>
-            <a:ext cx="1645920" cy="384048"/>
+            <a:ext cx="1920240" cy="384048"/>
           </a:xfrm>
           <a:prstGeom prst="rect">
             <a:avLst/>
@@ -21445,14 +21250,14 @@
       </p:sp>
       <p:sp>
         <p:nvSpPr>
-          <p:cNvPr id="32" name="TextBox 31"/>
+          <p:cNvPr id="27" name="TextBox 26"/>
           <p:cNvSpPr txBox="1"/>
           <p:nvPr/>
         </p:nvSpPr>
         <p:spPr>
           <a:xfrm>
-            <a:off x="2697480" y="4590288"/>
-            <a:ext cx="2651760" cy="384048"/>
+            <a:off x="3017520" y="4590288"/>
+            <a:ext cx="4983480" cy="384048"/>
           </a:xfrm>
           <a:prstGeom prst="rect">
             <a:avLst/>
@@ -21471,59 +21276,20 @@
               </a:lnSpc>
             </a:pPr>
             <a:r>
-              <a:rPr sz="1450" b="0">
+              <a:rPr sz="1550" b="0">
                 <a:solidFill>
                   <a:srgbClr val="475569"/>
                 </a:solidFill>
                 <a:latin typeface="Arial"/>
               </a:rPr>
-              <a:t>Should a person decide?</a:t>
-            </a:r>
-          </a:p>
-        </p:txBody>
-      </p:sp>
-      <p:sp>
-        <p:nvSpPr>
-          <p:cNvPr id="33" name="TextBox 32"/>
-          <p:cNvSpPr txBox="1"/>
-          <p:nvPr/>
-        </p:nvSpPr>
-        <p:spPr>
-          <a:xfrm>
-            <a:off x="5349240" y="4590288"/>
-            <a:ext cx="2697480" cy="384048"/>
-          </a:xfrm>
-          <a:prstGeom prst="rect">
-            <a:avLst/>
-          </a:prstGeom>
-          <a:noFill/>
-        </p:spPr>
-        <p:txBody>
-          <a:bodyPr wrap="square" lIns="73152" rIns="73152" tIns="36576" bIns="36576" anchor="ctr">
-            <a:spAutoFit/>
-          </a:bodyPr>
-          <a:lstStyle/>
-          <a:p>
-            <a:pPr algn="l">
-              <a:lnSpc>
-                <a:spcPct val="110000"/>
-              </a:lnSpc>
-            </a:pPr>
-            <a:r>
-              <a:rPr sz="1450" b="0">
-                <a:solidFill>
-                  <a:srgbClr val="475569"/>
-                </a:solidFill>
-                <a:latin typeface="Arial"/>
-              </a:rPr>
-              <a:t>Irreversible actions alone</a:t>
-            </a:r>
-          </a:p>
-        </p:txBody>
-      </p:sp>
-      <p:sp>
-        <p:nvSpPr>
-          <p:cNvPr id="34" name="Rounded Rectangle 33"/>
+              <a:t>A person decides the irreversible</a:t>
+            </a:r>
+          </a:p>
+        </p:txBody>
+      </p:sp>
+      <p:sp>
+        <p:nvSpPr>
+          <p:cNvPr id="28" name="Rounded Rectangle 27"/>
           <p:cNvSpPr/>
           <p:nvPr/>
         </p:nvSpPr>
@@ -21571,7 +21337,7 @@
       </p:sp>
       <p:sp>
         <p:nvSpPr>
-          <p:cNvPr id="35" name="Rounded Rectangle 34"/>
+          <p:cNvPr id="29" name="Rounded Rectangle 28"/>
           <p:cNvSpPr/>
           <p:nvPr/>
         </p:nvSpPr>
@@ -21630,14 +21396,14 @@
       </p:sp>
       <p:sp>
         <p:nvSpPr>
-          <p:cNvPr id="36" name="TextBox 35"/>
+          <p:cNvPr id="30" name="TextBox 29"/>
           <p:cNvSpPr txBox="1"/>
           <p:nvPr/>
         </p:nvSpPr>
         <p:spPr>
           <a:xfrm>
             <a:off x="1024128" y="5157216"/>
-            <a:ext cx="1645920" cy="384048"/>
+            <a:ext cx="1920240" cy="384048"/>
           </a:xfrm>
           <a:prstGeom prst="rect">
             <a:avLst/>
@@ -21669,14 +21435,14 @@
       </p:sp>
       <p:sp>
         <p:nvSpPr>
-          <p:cNvPr id="37" name="TextBox 36"/>
+          <p:cNvPr id="31" name="TextBox 30"/>
           <p:cNvSpPr txBox="1"/>
           <p:nvPr/>
         </p:nvSpPr>
         <p:spPr>
           <a:xfrm>
-            <a:off x="2697480" y="5157216"/>
-            <a:ext cx="2651760" cy="384048"/>
+            <a:off x="3017520" y="5157216"/>
+            <a:ext cx="4983480" cy="384048"/>
           </a:xfrm>
           <a:prstGeom prst="rect">
             <a:avLst/>
@@ -21695,59 +21461,20 @@
               </a:lnSpc>
             </a:pPr>
             <a:r>
-              <a:rPr sz="1450" b="0">
+              <a:rPr sz="1550" b="0">
                 <a:solidFill>
                   <a:srgbClr val="475569"/>
                 </a:solidFill>
                 <a:latin typeface="Arial"/>
               </a:rPr>
-              <a:t>What happened?</a:t>
-            </a:r>
-          </a:p>
-        </p:txBody>
-      </p:sp>
-      <p:sp>
-        <p:nvSpPr>
-          <p:cNvPr id="38" name="TextBox 37"/>
-          <p:cNvSpPr txBox="1"/>
-          <p:nvPr/>
-        </p:nvSpPr>
-        <p:spPr>
-          <a:xfrm>
-            <a:off x="5349240" y="5157216"/>
-            <a:ext cx="2697480" cy="384048"/>
-          </a:xfrm>
-          <a:prstGeom prst="rect">
-            <a:avLst/>
-          </a:prstGeom>
-          <a:noFill/>
-        </p:spPr>
-        <p:txBody>
-          <a:bodyPr wrap="square" lIns="73152" rIns="73152" tIns="36576" bIns="36576" anchor="ctr">
-            <a:spAutoFit/>
-          </a:bodyPr>
-          <a:lstStyle/>
-          <a:p>
-            <a:pPr algn="l">
-              <a:lnSpc>
-                <a:spcPct val="110000"/>
-              </a:lnSpc>
-            </a:pPr>
-            <a:r>
-              <a:rPr sz="1450" b="0">
-                <a:solidFill>
-                  <a:srgbClr val="475569"/>
-                </a:solidFill>
-                <a:latin typeface="Arial"/>
-              </a:rPr>
-              <a:t>Changes nobody can explain</a:t>
-            </a:r>
-          </a:p>
-        </p:txBody>
-      </p:sp>
-      <p:sp>
-        <p:nvSpPr>
-          <p:cNvPr id="39" name="Rounded Rectangle 38"/>
+              <a:t>Every step on the record</a:t>
+            </a:r>
+          </a:p>
+        </p:txBody>
+      </p:sp>
+      <p:sp>
+        <p:nvSpPr>
+          <p:cNvPr id="32" name="Rounded Rectangle 31"/>
           <p:cNvSpPr/>
           <p:nvPr/>
         </p:nvSpPr>
@@ -21793,7 +21520,7 @@
       </p:sp>
       <p:sp>
         <p:nvSpPr>
-          <p:cNvPr id="40" name="TextBox 39"/>
+          <p:cNvPr id="33" name="TextBox 32"/>
           <p:cNvSpPr txBox="1"/>
           <p:nvPr/>
         </p:nvSpPr>
@@ -21832,7 +21559,7 @@
       </p:sp>
       <p:sp>
         <p:nvSpPr>
-          <p:cNvPr id="41" name="TextBox 40"/>
+          <p:cNvPr id="34" name="TextBox 33"/>
           <p:cNvSpPr txBox="1"/>
           <p:nvPr/>
         </p:nvSpPr>
@@ -21883,7 +21610,7 @@
                 </a:solidFill>
                 <a:latin typeface="Arial"/>
               </a:rPr>
-              <a:t>Read only. Kubernetes and the gateway enforce it.</a:t>
+              <a:t>Read only. Enforced outside the agent.</a:t>
             </a:r>
           </a:p>
           <a:p>
@@ -21957,7 +21684,7 @@
       </p:sp>
       <p:sp>
         <p:nvSpPr>
-          <p:cNvPr id="42" name="Rounded Rectangle 41"/>
+          <p:cNvPr id="35" name="Rounded Rectangle 34"/>
           <p:cNvSpPr/>
           <p:nvPr/>
         </p:nvSpPr>
@@ -22018,7 +21745,7 @@
                 </a:solidFill>
                 <a:latin typeface="Arial"/>
               </a:rPr>
-              <a:t>Enforced on every run. Prompts can drift; enforcement doesn't.</a:t>
+              <a:t>Prompts drift. Enforcement doesn't.</a:t>
             </a:r>
           </a:p>
         </p:txBody>
@@ -22062,7 +21789,7 @@
                                           </p:stCondLst>
                                         </p:cTn>
                                         <p:tgtEl>
-                                          <p:spTgt spid="39"/>
+                                          <p:spTgt spid="32"/>
                                         </p:tgtEl>
                                         <p:attrNameLst>
                                           <p:attrName>style.visibility</p:attrName>
@@ -22089,7 +21816,7 @@
                                           </p:stCondLst>
                                         </p:cTn>
                                         <p:tgtEl>
-                                          <p:spTgt spid="40"/>
+                                          <p:spTgt spid="33"/>
                                         </p:tgtEl>
                                         <p:attrNameLst>
                                           <p:attrName>style.visibility</p:attrName>
@@ -22116,7 +21843,7 @@
                                           </p:stCondLst>
                                         </p:cTn>
                                         <p:tgtEl>
-                                          <p:spTgt spid="41"/>
+                                          <p:spTgt spid="34"/>
                                         </p:tgtEl>
                                         <p:attrNameLst>
                                           <p:attrName>style.visibility</p:attrName>
@@ -22161,7 +21888,7 @@
                                           </p:stCondLst>
                                         </p:cTn>
                                         <p:tgtEl>
-                                          <p:spTgt spid="42"/>
+                                          <p:spTgt spid="35"/>
                                         </p:tgtEl>
                                         <p:attrNameLst>
                                           <p:attrName>style.visibility</p:attrName>
@@ -22202,10 +21929,10 @@
       </p:par>
     </p:tnLst>
     <p:bldLst>
-      <p:bldP spid="39" grpId="0" animBg="1"/>
-      <p:bldP spid="40" grpId="0" animBg="1"/>
-      <p:bldP spid="41" grpId="0" animBg="1"/>
-      <p:bldP spid="42" grpId="0" animBg="1"/>
+      <p:bldP spid="32" grpId="0" animBg="1"/>
+      <p:bldP spid="33" grpId="0" animBg="1"/>
+      <p:bldP spid="34" grpId="0" animBg="1"/>
+      <p:bldP spid="35" grpId="0" animBg="1"/>
     </p:bldLst>
   </p:timing>
 </p:sld>

</xml_diff>

<commit_message>
Docs and deck: ownership labels, workflow budget, read-only gateway, knowledge-base standards
Gateway now also denies the generic Grafana API tool and plugin installs (verified refused).
Workflow budget verified to block investigations at its cap. Evidence records the cost tests,
including the ones that did not save money. Slide 7 uses KAOP's screen names; slide 9 states
the gateway allows read tools only.

Co-Authored-By: Claude Opus 5.5 <noreply@anthropic.com>
Claude-Session: https://claude.ai/code/session_01DptoPaaj14X3TGztKApoPN
</commit_message>
<xml_diff>
--- a/docs/presentation/KAOP_Customer_Pitch.pptx
+++ b/docs/presentation/KAOP_Customer_Pitch.pptx
@@ -13331,7 +13331,7 @@
                 </a:solidFill>
                 <a:latin typeface="Arial"/>
               </a:rPr>
-              <a:t>It separates what it saw from what it guessed, every change needs a person, and KAOP grades runs over time.</a:t>
+              <a:t>It separates what it saw from what it guessed, every change needs a person, and KAOP can grade runs with an evaluator.</a:t>
             </a:r>
           </a:p>
         </p:txBody>
@@ -22068,7 +22068,7 @@
                 </a:solidFill>
                 <a:latin typeface="Arial"/>
               </a:rPr>
-              <a:t>One record from the alert to the merged fix</a:t>
+              <a:t>One record from the alert to the reviewed fix</a:t>
             </a:r>
           </a:p>
         </p:txBody>
@@ -22238,7 +22238,7 @@
                 </a:solidFill>
                 <a:latin typeface="Arial"/>
               </a:rPr>
-              <a:t>Fleet health</a:t>
+              <a:t>Fleet</a:t>
             </a:r>
           </a:p>
         </p:txBody>
@@ -22578,7 +22578,7 @@
                 </a:solidFill>
                 <a:latin typeface="Arial"/>
               </a:rPr>
-              <a:t>Attention</a:t>
+              <a:t>Waiting on you</a:t>
             </a:r>
           </a:p>
         </p:txBody>
@@ -22617,7 +22617,7 @@
                 </a:solidFill>
                 <a:latin typeface="Arial"/>
               </a:rPr>
-              <a:t>Decisions waiting on a person.</a:t>
+              <a:t>Decisions that need a person.</a:t>
             </a:r>
           </a:p>
         </p:txBody>
@@ -22918,7 +22918,7 @@
                 </a:solidFill>
                 <a:latin typeface="Arial"/>
               </a:rPr>
-              <a:t>Spend</a:t>
+              <a:t>Cost</a:t>
             </a:r>
           </a:p>
         </p:txBody>
@@ -22957,7 +22957,7 @@
                 </a:solidFill>
                 <a:latin typeface="Arial"/>
               </a:rPr>
-              <a:t>Cost per agent and team, with budgets.</a:t>
+              <a:t>Cost per agent, with budgets.</a:t>
             </a:r>
           </a:p>
         </p:txBody>
@@ -26204,8 +26204,8 @@
                 </a:solidFill>
                 <a:latin typeface="Arial"/>
               </a:rPr>
-              <a:t>KAOP gateway blocks
-write tools</a:t>
+              <a:t>KAOP gateway allows
+read tools only</a:t>
             </a:r>
           </a:p>
         </p:txBody>

</xml_diff>

<commit_message>
Gateway allow list for the Grafana agent; evidence of the cost and quality result
Co-Authored-By: Claude Opus 5.5 <noreply@anthropic.com>
Claude-Session: https://claude.ai/code/session_01DptoPaaj14X3TGztKApoPN
</commit_message>
<xml_diff>
--- a/docs/presentation/KAOP_Customer_Pitch.pptx
+++ b/docs/presentation/KAOP_Customer_Pitch.pptx
@@ -26165,7 +26165,8 @@
                 </a:solidFill>
                 <a:latin typeface="Arial"/>
               </a:rPr>
-              <a:t>Nothing</a:t>
+              <a:t>Nothing but links
+to its evidence</a:t>
             </a:r>
           </a:p>
         </p:txBody>
@@ -26204,8 +26205,8 @@
                 </a:solidFill>
                 <a:latin typeface="Arial"/>
               </a:rPr>
-              <a:t>KAOP gateway allows
-read tools only</a:t>
+              <a:t>KAOP gateway allow
+list: 28 read tools</a:t>
             </a:r>
           </a:p>
         </p:txBody>

</xml_diff>

<commit_message>
Deck: slide 2 says why we're here; slide 3 says why each live step matters
Co-Authored-By: Claude Opus 5.5 <noreply@anthropic.com>
Claude-Session: https://claude.ai/code/session_01DptoPaaj14X3TGztKApoPN
</commit_message>
<xml_diff>
--- a/docs/presentation/KAOP_Customer_Pitch.pptx
+++ b/docs/presentation/KAOP_Customer_Pitch.pptx
@@ -14737,7 +14737,7 @@
         </p:nvSpPr>
         <p:spPr>
           <a:xfrm>
-            <a:off x="548640" y="1600200"/>
+            <a:off x="548640" y="1737360"/>
             <a:ext cx="6766560" cy="731520"/>
           </a:xfrm>
           <a:prstGeom prst="rect">
@@ -14776,7 +14776,7 @@
         </p:nvSpPr>
         <p:spPr>
           <a:xfrm>
-            <a:off x="548640" y="2377440"/>
+            <a:off x="548640" y="2514600"/>
             <a:ext cx="6583680" cy="457200"/>
           </a:xfrm>
           <a:prstGeom prst="rect">
@@ -14809,62 +14809,14 @@
       </p:sp>
       <p:sp>
         <p:nvSpPr>
-          <p:cNvPr id="7" name="Rounded Rectangle 6"/>
+          <p:cNvPr id="7" name="Rectangle 6"/>
           <p:cNvSpPr/>
           <p:nvPr/>
         </p:nvSpPr>
         <p:spPr>
           <a:xfrm>
-            <a:off x="548640" y="3246120"/>
-            <a:ext cx="6766560" cy="749808"/>
-          </a:xfrm>
-          <a:prstGeom prst="roundRect">
-            <a:avLst>
-              <a:gd name="adj" fmla="val 6000"/>
-            </a:avLst>
-          </a:prstGeom>
-          <a:solidFill>
-            <a:srgbClr val="FFFFFF"/>
-          </a:solidFill>
-          <a:ln w="12700">
-            <a:solidFill>
-              <a:srgbClr val="E2E8F0"/>
-            </a:solidFill>
-          </a:ln>
-          <a:effectLst/>
-        </p:spPr>
-        <p:style>
-          <a:lnRef idx="1">
-            <a:schemeClr val="accent1"/>
-          </a:lnRef>
-          <a:fillRef idx="3">
-            <a:schemeClr val="accent1"/>
-          </a:fillRef>
-          <a:effectRef idx="2">
-            <a:schemeClr val="accent1"/>
-          </a:effectRef>
-          <a:fontRef idx="minor">
-            <a:schemeClr val="lt1"/>
-          </a:fontRef>
-        </p:style>
-        <p:txBody>
-          <a:bodyPr rtlCol="0" anchor="ctr"/>
-          <a:lstStyle/>
-          <a:p>
-            <a:pPr algn="ctr"/>
-          </a:p>
-        </p:txBody>
-      </p:sp>
-      <p:sp>
-        <p:nvSpPr>
-          <p:cNvPr id="8" name="Rectangle 7"/>
-          <p:cNvSpPr/>
-          <p:nvPr/>
-        </p:nvSpPr>
-        <p:spPr>
-          <a:xfrm>
-            <a:off x="777240" y="3429000"/>
-            <a:ext cx="73152" cy="384048"/>
+            <a:off x="548640" y="3429000"/>
+            <a:ext cx="73152" cy="1188720"/>
           </a:xfrm>
           <a:prstGeom prst="rect">
             <a:avLst/>
@@ -14901,14 +14853,14 @@
       </p:sp>
       <p:sp>
         <p:nvSpPr>
-          <p:cNvPr id="9" name="TextBox 8"/>
+          <p:cNvPr id="8" name="TextBox 7"/>
           <p:cNvSpPr txBox="1"/>
           <p:nvPr/>
         </p:nvSpPr>
         <p:spPr>
           <a:xfrm>
-            <a:off x="960120" y="3319272"/>
-            <a:ext cx="1645920" cy="603504"/>
+            <a:off x="868680" y="3383280"/>
+            <a:ext cx="6309360" cy="1280160"/>
           </a:xfrm>
           <a:prstGeom prst="rect">
             <a:avLst/>
@@ -14916,410 +14868,31 @@
           <a:noFill/>
         </p:spPr>
         <p:txBody>
-          <a:bodyPr wrap="square" lIns="73152" rIns="73152" tIns="36576" bIns="36576" anchor="ctr">
+          <a:bodyPr wrap="square" lIns="73152" rIns="73152" tIns="36576" bIns="36576" anchor="t">
             <a:spAutoFit/>
           </a:bodyPr>
           <a:lstStyle/>
           <a:p>
             <a:pPr algn="l">
               <a:lnSpc>
-                <a:spcPct val="110000"/>
-              </a:lnSpc>
-            </a:pPr>
-            <a:r>
-              <a:rPr sz="1500" b="1">
+                <a:spcPct val="115000"/>
+              </a:lnSpc>
+            </a:pPr>
+            <a:r>
+              <a:rPr sz="2400" b="1">
                 <a:solidFill>
                   <a:srgbClr val="0F172A"/>
                 </a:solidFill>
                 <a:latin typeface="Arial"/>
               </a:rPr>
-              <a:t>Focus</a:t>
-            </a:r>
-          </a:p>
-        </p:txBody>
-      </p:sp>
-      <p:sp>
-        <p:nvSpPr>
-          <p:cNvPr id="10" name="TextBox 9"/>
-          <p:cNvSpPr txBox="1"/>
-          <p:nvPr/>
-        </p:nvSpPr>
-        <p:spPr>
-          <a:xfrm>
-            <a:off x="2606040" y="3319272"/>
-            <a:ext cx="4572000" cy="603504"/>
-          </a:xfrm>
-          <a:prstGeom prst="rect">
-            <a:avLst/>
-          </a:prstGeom>
-          <a:noFill/>
-        </p:spPr>
-        <p:txBody>
-          <a:bodyPr wrap="square" lIns="73152" rIns="73152" tIns="36576" bIns="36576" anchor="ctr">
-            <a:spAutoFit/>
-          </a:bodyPr>
-          <a:lstStyle/>
-          <a:p>
-            <a:pPr algn="l">
-              <a:lnSpc>
-                <a:spcPct val="110000"/>
-              </a:lnSpc>
-            </a:pPr>
-            <a:r>
-              <a:rPr sz="1500" b="0">
-                <a:solidFill>
-                  <a:srgbClr val="475569"/>
-                </a:solidFill>
-                <a:latin typeface="Arial"/>
-              </a:rPr>
-              <a:t>Helping platform teams adopt AI agents safely.</a:t>
-            </a:r>
-          </a:p>
-        </p:txBody>
-      </p:sp>
-      <p:sp>
-        <p:nvSpPr>
-          <p:cNvPr id="11" name="Rounded Rectangle 10"/>
-          <p:cNvSpPr/>
-          <p:nvPr/>
-        </p:nvSpPr>
-        <p:spPr>
-          <a:xfrm>
-            <a:off x="548640" y="4114800"/>
-            <a:ext cx="6766560" cy="749808"/>
-          </a:xfrm>
-          <a:prstGeom prst="roundRect">
-            <a:avLst>
-              <a:gd name="adj" fmla="val 6000"/>
-            </a:avLst>
-          </a:prstGeom>
-          <a:solidFill>
-            <a:srgbClr val="FFFFFF"/>
-          </a:solidFill>
-          <a:ln w="12700">
-            <a:solidFill>
-              <a:srgbClr val="E2E8F0"/>
-            </a:solidFill>
-          </a:ln>
-          <a:effectLst/>
-        </p:spPr>
-        <p:style>
-          <a:lnRef idx="1">
-            <a:schemeClr val="accent1"/>
-          </a:lnRef>
-          <a:fillRef idx="3">
-            <a:schemeClr val="accent1"/>
-          </a:fillRef>
-          <a:effectRef idx="2">
-            <a:schemeClr val="accent1"/>
-          </a:effectRef>
-          <a:fontRef idx="minor">
-            <a:schemeClr val="lt1"/>
-          </a:fontRef>
-        </p:style>
-        <p:txBody>
-          <a:bodyPr rtlCol="0" anchor="ctr"/>
-          <a:lstStyle/>
-          <a:p>
-            <a:pPr algn="ctr"/>
-          </a:p>
-        </p:txBody>
-      </p:sp>
-      <p:sp>
-        <p:nvSpPr>
-          <p:cNvPr id="12" name="Rectangle 11"/>
-          <p:cNvSpPr/>
-          <p:nvPr/>
-        </p:nvSpPr>
-        <p:spPr>
-          <a:xfrm>
-            <a:off x="777240" y="4297680"/>
-            <a:ext cx="73152" cy="384048"/>
-          </a:xfrm>
-          <a:prstGeom prst="rect">
-            <a:avLst/>
-          </a:prstGeom>
-          <a:solidFill>
-            <a:srgbClr val="0F766E"/>
-          </a:solidFill>
-          <a:ln>
-            <a:noFill/>
-          </a:ln>
-          <a:effectLst/>
-        </p:spPr>
-        <p:style>
-          <a:lnRef idx="1">
-            <a:schemeClr val="accent1"/>
-          </a:lnRef>
-          <a:fillRef idx="3">
-            <a:schemeClr val="accent1"/>
-          </a:fillRef>
-          <a:effectRef idx="2">
-            <a:schemeClr val="accent1"/>
-          </a:effectRef>
-          <a:fontRef idx="minor">
-            <a:schemeClr val="lt1"/>
-          </a:fontRef>
-        </p:style>
-        <p:txBody>
-          <a:bodyPr rtlCol="0" anchor="ctr"/>
-          <a:lstStyle/>
-          <a:p>
-            <a:pPr algn="ctr"/>
-          </a:p>
-        </p:txBody>
-      </p:sp>
-      <p:sp>
-        <p:nvSpPr>
-          <p:cNvPr id="13" name="TextBox 12"/>
-          <p:cNvSpPr txBox="1"/>
-          <p:nvPr/>
-        </p:nvSpPr>
-        <p:spPr>
-          <a:xfrm>
-            <a:off x="960120" y="4187952"/>
-            <a:ext cx="1645920" cy="603504"/>
-          </a:xfrm>
-          <a:prstGeom prst="rect">
-            <a:avLst/>
-          </a:prstGeom>
-          <a:noFill/>
-        </p:spPr>
-        <p:txBody>
-          <a:bodyPr wrap="square" lIns="73152" rIns="73152" tIns="36576" bIns="36576" anchor="ctr">
-            <a:spAutoFit/>
-          </a:bodyPr>
-          <a:lstStyle/>
-          <a:p>
-            <a:pPr algn="l">
-              <a:lnSpc>
-                <a:spcPct val="110000"/>
-              </a:lnSpc>
-            </a:pPr>
-            <a:r>
-              <a:rPr sz="1500" b="1">
-                <a:solidFill>
-                  <a:srgbClr val="0F172A"/>
-                </a:solidFill>
-                <a:latin typeface="Arial"/>
-              </a:rPr>
-              <a:t>For today</a:t>
-            </a:r>
-          </a:p>
-        </p:txBody>
-      </p:sp>
-      <p:sp>
-        <p:nvSpPr>
-          <p:cNvPr id="14" name="TextBox 13"/>
-          <p:cNvSpPr txBox="1"/>
-          <p:nvPr/>
-        </p:nvSpPr>
-        <p:spPr>
-          <a:xfrm>
-            <a:off x="2606040" y="4187952"/>
-            <a:ext cx="4572000" cy="603504"/>
-          </a:xfrm>
-          <a:prstGeom prst="rect">
-            <a:avLst/>
-          </a:prstGeom>
-          <a:noFill/>
-        </p:spPr>
-        <p:txBody>
-          <a:bodyPr wrap="square" lIns="73152" rIns="73152" tIns="36576" bIns="36576" anchor="ctr">
-            <a:spAutoFit/>
-          </a:bodyPr>
-          <a:lstStyle/>
-          <a:p>
-            <a:pPr algn="l">
-              <a:lnSpc>
-                <a:spcPct val="110000"/>
-              </a:lnSpc>
-            </a:pPr>
-            <a:r>
-              <a:rPr sz="1500" b="0">
-                <a:solidFill>
-                  <a:srgbClr val="475569"/>
-                </a:solidFill>
-                <a:latin typeface="Arial"/>
-              </a:rPr>
-              <a:t>I built a production-like lab end to end: Kubernetes, Grafana Cloud and KAOP.</a:t>
-            </a:r>
-          </a:p>
-        </p:txBody>
-      </p:sp>
-      <p:sp>
-        <p:nvSpPr>
-          <p:cNvPr id="15" name="Rounded Rectangle 14"/>
-          <p:cNvSpPr/>
-          <p:nvPr/>
-        </p:nvSpPr>
-        <p:spPr>
-          <a:xfrm>
-            <a:off x="548640" y="4983479"/>
-            <a:ext cx="6766560" cy="749808"/>
-          </a:xfrm>
-          <a:prstGeom prst="roundRect">
-            <a:avLst>
-              <a:gd name="adj" fmla="val 6000"/>
-            </a:avLst>
-          </a:prstGeom>
-          <a:solidFill>
-            <a:srgbClr val="FFFFFF"/>
-          </a:solidFill>
-          <a:ln w="12700">
-            <a:solidFill>
-              <a:srgbClr val="E2E8F0"/>
-            </a:solidFill>
-          </a:ln>
-          <a:effectLst/>
-        </p:spPr>
-        <p:style>
-          <a:lnRef idx="1">
-            <a:schemeClr val="accent1"/>
-          </a:lnRef>
-          <a:fillRef idx="3">
-            <a:schemeClr val="accent1"/>
-          </a:fillRef>
-          <a:effectRef idx="2">
-            <a:schemeClr val="accent1"/>
-          </a:effectRef>
-          <a:fontRef idx="minor">
-            <a:schemeClr val="lt1"/>
-          </a:fontRef>
-        </p:style>
-        <p:txBody>
-          <a:bodyPr rtlCol="0" anchor="ctr"/>
-          <a:lstStyle/>
-          <a:p>
-            <a:pPr algn="ctr"/>
-          </a:p>
-        </p:txBody>
-      </p:sp>
-      <p:sp>
-        <p:nvSpPr>
-          <p:cNvPr id="16" name="Rectangle 15"/>
-          <p:cNvSpPr/>
-          <p:nvPr/>
-        </p:nvSpPr>
-        <p:spPr>
-          <a:xfrm>
-            <a:off x="777240" y="5166359"/>
-            <a:ext cx="73152" cy="384048"/>
-          </a:xfrm>
-          <a:prstGeom prst="rect">
-            <a:avLst/>
-          </a:prstGeom>
-          <a:solidFill>
-            <a:srgbClr val="B91C1C"/>
-          </a:solidFill>
-          <a:ln>
-            <a:noFill/>
-          </a:ln>
-          <a:effectLst/>
-        </p:spPr>
-        <p:style>
-          <a:lnRef idx="1">
-            <a:schemeClr val="accent1"/>
-          </a:lnRef>
-          <a:fillRef idx="3">
-            <a:schemeClr val="accent1"/>
-          </a:fillRef>
-          <a:effectRef idx="2">
-            <a:schemeClr val="accent1"/>
-          </a:effectRef>
-          <a:fontRef idx="minor">
-            <a:schemeClr val="lt1"/>
-          </a:fontRef>
-        </p:style>
-        <p:txBody>
-          <a:bodyPr rtlCol="0" anchor="ctr"/>
-          <a:lstStyle/>
-          <a:p>
-            <a:pPr algn="ctr"/>
-          </a:p>
-        </p:txBody>
-      </p:sp>
-      <p:sp>
-        <p:nvSpPr>
-          <p:cNvPr id="17" name="TextBox 16"/>
-          <p:cNvSpPr txBox="1"/>
-          <p:nvPr/>
-        </p:nvSpPr>
-        <p:spPr>
-          <a:xfrm>
-            <a:off x="960120" y="5056631"/>
-            <a:ext cx="1645920" cy="603504"/>
-          </a:xfrm>
-          <a:prstGeom prst="rect">
-            <a:avLst/>
-          </a:prstGeom>
-          <a:noFill/>
-        </p:spPr>
-        <p:txBody>
-          <a:bodyPr wrap="square" lIns="73152" rIns="73152" tIns="36576" bIns="36576" anchor="ctr">
-            <a:spAutoFit/>
-          </a:bodyPr>
-          <a:lstStyle/>
-          <a:p>
-            <a:pPr algn="l">
-              <a:lnSpc>
-                <a:spcPct val="110000"/>
-              </a:lnSpc>
-            </a:pPr>
-            <a:r>
-              <a:rPr sz="1500" b="1">
-                <a:solidFill>
-                  <a:srgbClr val="0F172A"/>
-                </a:solidFill>
-                <a:latin typeface="Arial"/>
-              </a:rPr>
-              <a:t>My rule</a:t>
-            </a:r>
-          </a:p>
-        </p:txBody>
-      </p:sp>
-      <p:sp>
-        <p:nvSpPr>
-          <p:cNvPr id="18" name="TextBox 17"/>
-          <p:cNvSpPr txBox="1"/>
-          <p:nvPr/>
-        </p:nvSpPr>
-        <p:spPr>
-          <a:xfrm>
-            <a:off x="2606040" y="5056631"/>
-            <a:ext cx="4572000" cy="603504"/>
-          </a:xfrm>
-          <a:prstGeom prst="rect">
-            <a:avLst/>
-          </a:prstGeom>
-          <a:noFill/>
-        </p:spPr>
-        <p:txBody>
-          <a:bodyPr wrap="square" lIns="73152" rIns="73152" tIns="36576" bIns="36576" anchor="ctr">
-            <a:spAutoFit/>
-          </a:bodyPr>
-          <a:lstStyle/>
-          <a:p>
-            <a:pPr algn="l">
-              <a:lnSpc>
-                <a:spcPct val="110000"/>
-              </a:lnSpc>
-            </a:pPr>
-            <a:r>
-              <a:rPr sz="1500" b="0">
-                <a:solidFill>
-                  <a:srgbClr val="475569"/>
-                </a:solidFill>
-                <a:latin typeface="Arial"/>
-              </a:rPr>
-              <a:t>Everything you'll see, I tested on that lab first.</a:t>
-            </a:r>
-          </a:p>
-        </p:txBody>
-      </p:sp>
-      <p:sp>
-        <p:nvSpPr>
-          <p:cNvPr id="19" name="Rounded Rectangle 18"/>
+              <a:t>I help platform teams put AI agents into production safely.</a:t>
+            </a:r>
+          </a:p>
+        </p:txBody>
+      </p:sp>
+      <p:sp>
+        <p:nvSpPr>
+          <p:cNvPr id="9" name="Rounded Rectangle 8"/>
           <p:cNvSpPr/>
           <p:nvPr/>
         </p:nvSpPr>
@@ -15365,7 +14938,7 @@
       </p:sp>
       <p:sp>
         <p:nvSpPr>
-          <p:cNvPr id="20" name="TextBox 19"/>
+          <p:cNvPr id="10" name="TextBox 9"/>
           <p:cNvSpPr txBox="1"/>
           <p:nvPr/>
         </p:nvSpPr>
@@ -15397,21 +14970,21 @@
                 </a:solidFill>
                 <a:latin typeface="Arial"/>
               </a:rPr>
-              <a:t>WHAT I CARE ABOUT</a:t>
-            </a:r>
-          </a:p>
-        </p:txBody>
-      </p:sp>
-      <p:sp>
-        <p:nvSpPr>
-          <p:cNvPr id="21" name="TextBox 20"/>
+              <a:t>WHY WE'RE HERE</a:t>
+            </a:r>
+          </a:p>
+        </p:txBody>
+      </p:sp>
+      <p:sp>
+        <p:nvSpPr>
+          <p:cNvPr id="11" name="TextBox 10"/>
           <p:cNvSpPr txBox="1"/>
           <p:nvPr/>
         </p:nvSpPr>
         <p:spPr>
           <a:xfrm>
             <a:off x="7955279" y="2240280"/>
-            <a:ext cx="3474720" cy="3291840"/>
+            <a:ext cx="3474720" cy="1828800"/>
           </a:xfrm>
           <a:prstGeom prst="rect">
             <a:avLst/>
@@ -15429,7 +15002,7 @@
                 <a:spcPct val="115000"/>
               </a:lnSpc>
               <a:spcAft>
-                <a:spcPts val="1200"/>
+                <a:spcPts val="1000"/>
               </a:spcAft>
             </a:pPr>
             <a:r>
@@ -15439,7 +15012,7 @@
                 </a:solidFill>
                 <a:latin typeface="Arial"/>
               </a:rPr>
-              <a:t>Platform teams saying yes to AI agents</a:t>
+              <a:t>Your teams want more AI agents.</a:t>
             </a:r>
           </a:p>
           <a:p>
@@ -15449,13 +15022,96 @@
               </a:lnSpc>
             </a:pPr>
             <a:r>
-              <a:rPr sz="1600" b="0">
+              <a:rPr sz="2000" b="1">
+                <a:solidFill>
+                  <a:srgbClr val="FFFFFF"/>
+                </a:solidFill>
+                <a:latin typeface="Arial"/>
+              </a:rPr>
+              <a:t>You need to stay in control of them.</a:t>
+            </a:r>
+          </a:p>
+        </p:txBody>
+      </p:sp>
+      <p:sp>
+        <p:nvSpPr>
+          <p:cNvPr id="12" name="Rectangle 11"/>
+          <p:cNvSpPr/>
+          <p:nvPr/>
+        </p:nvSpPr>
+        <p:spPr>
+          <a:xfrm>
+            <a:off x="7955279" y="4160520"/>
+            <a:ext cx="3383280" cy="18288"/>
+          </a:xfrm>
+          <a:prstGeom prst="rect">
+            <a:avLst/>
+          </a:prstGeom>
+          <a:solidFill>
+            <a:srgbClr val="CBD5E1"/>
+          </a:solidFill>
+          <a:ln>
+            <a:noFill/>
+          </a:ln>
+          <a:effectLst/>
+        </p:spPr>
+        <p:style>
+          <a:lnRef idx="1">
+            <a:schemeClr val="accent1"/>
+          </a:lnRef>
+          <a:fillRef idx="3">
+            <a:schemeClr val="accent1"/>
+          </a:fillRef>
+          <a:effectRef idx="2">
+            <a:schemeClr val="accent1"/>
+          </a:effectRef>
+          <a:fontRef idx="minor">
+            <a:schemeClr val="lt1"/>
+          </a:fontRef>
+        </p:style>
+        <p:txBody>
+          <a:bodyPr rtlCol="0" anchor="ctr"/>
+          <a:lstStyle/>
+          <a:p>
+            <a:pPr algn="ctr"/>
+          </a:p>
+        </p:txBody>
+      </p:sp>
+      <p:sp>
+        <p:nvSpPr>
+          <p:cNvPr id="13" name="TextBox 12"/>
+          <p:cNvSpPr txBox="1"/>
+          <p:nvPr/>
+        </p:nvSpPr>
+        <p:spPr>
+          <a:xfrm>
+            <a:off x="7955279" y="4343400"/>
+            <a:ext cx="3474720" cy="1188720"/>
+          </a:xfrm>
+          <a:prstGeom prst="rect">
+            <a:avLst/>
+          </a:prstGeom>
+          <a:noFill/>
+        </p:spPr>
+        <p:txBody>
+          <a:bodyPr wrap="square" lIns="73152" rIns="73152" tIns="36576" bIns="36576" anchor="t">
+            <a:spAutoFit/>
+          </a:bodyPr>
+          <a:lstStyle/>
+          <a:p>
+            <a:pPr algn="l">
+              <a:lnSpc>
+                <a:spcPct val="115000"/>
+              </a:lnSpc>
+            </a:pPr>
+            <a:r>
+              <a:rPr sz="1700" b="0">
                 <a:solidFill>
                   <a:srgbClr val="CBD5E1"/>
                 </a:solidFill>
                 <a:latin typeface="Arial"/>
               </a:rPr>
-              <a:t>without losing control of what those agents can touch, or the record of what they did.</a:t>
+              <a:t>Today: KAOP doing both, on a live incident.</a:t>
             </a:r>
           </a:p>
         </p:txBody>
@@ -15928,7 +15584,7 @@
                 </a:solidFill>
                 <a:latin typeface="Arial"/>
               </a:rPr>
-              <a:t>How KAOP addresses them</a:t>
+              <a:t>How KAOP solves them</a:t>
             </a:r>
           </a:p>
         </p:txBody>
@@ -15967,7 +15623,7 @@
                 </a:solidFill>
                 <a:latin typeface="Arial"/>
               </a:rPr>
-              <a:t>Operating model, governance, visibility.</a:t>
+              <a:t>Owners, limits and a record.</a:t>
             </a:r>
           </a:p>
         </p:txBody>
@@ -16560,12 +16216,12 @@
         </p:nvSpPr>
         <p:spPr>
           <a:xfrm>
-            <a:off x="7909560" y="2523744"/>
-            <a:ext cx="3520440" cy="402336"/>
+            <a:off x="7909560" y="2487168"/>
+            <a:ext cx="3520440" cy="530352"/>
           </a:xfrm>
           <a:prstGeom prst="roundRect">
             <a:avLst>
-              <a:gd name="adj" fmla="val 20000"/>
+              <a:gd name="adj" fmla="val 15000"/>
             </a:avLst>
           </a:prstGeom>
           <a:solidFill>
@@ -16606,7 +16262,7 @@
         </p:nvSpPr>
         <p:spPr>
           <a:xfrm>
-            <a:off x="8001000" y="2587751"/>
+            <a:off x="8001000" y="2606040"/>
             <a:ext cx="292608" cy="292608"/>
           </a:xfrm>
           <a:prstGeom prst="roundRect">
@@ -16665,8 +16321,8 @@
         </p:nvSpPr>
         <p:spPr>
           <a:xfrm>
-            <a:off x="8366760" y="2551175"/>
-            <a:ext cx="3017520" cy="365760"/>
+            <a:off x="8366760" y="2505456"/>
+            <a:ext cx="3017520" cy="493776"/>
           </a:xfrm>
           <a:prstGeom prst="rect">
             <a:avLst/>
@@ -16681,79 +16337,51 @@
           <a:p>
             <a:pPr algn="l">
               <a:lnSpc>
-                <a:spcPct val="110000"/>
-              </a:lnSpc>
-            </a:pPr>
-            <a:r>
-              <a:rPr sz="1400" b="0">
+                <a:spcPct val="100000"/>
+              </a:lnSpc>
+            </a:pPr>
+            <a:r>
+              <a:rPr sz="1300" b="1">
                 <a:solidFill>
                   <a:srgbClr val="FFFFFF"/>
                 </a:solidFill>
                 <a:latin typeface="Arial"/>
               </a:rPr>
-              <a:t>Grafana Cloud fires a real alert</a:t>
-            </a:r>
-          </a:p>
-        </p:txBody>
-      </p:sp>
-      <p:sp>
-        <p:nvSpPr>
-          <p:cNvPr id="31" name="Down Arrow 30"/>
+              <a:t>A real alert fires in Grafana</a:t>
+            </a:r>
+          </a:p>
+          <a:p>
+            <a:pPr algn="l">
+              <a:lnSpc>
+                <a:spcPct val="100000"/>
+              </a:lnSpc>
+            </a:pPr>
+            <a:r>
+              <a:rPr sz="1100" b="0">
+                <a:solidFill>
+                  <a:srgbClr val="CBD5E1"/>
+                </a:solidFill>
+                <a:latin typeface="Arial"/>
+              </a:rPr>
+              <a:t>KAOP starts work on its own</a:t>
+            </a:r>
+          </a:p>
+        </p:txBody>
+      </p:sp>
+      <p:sp>
+        <p:nvSpPr>
+          <p:cNvPr id="31" name="Rounded Rectangle 30"/>
           <p:cNvSpPr/>
           <p:nvPr/>
         </p:nvSpPr>
         <p:spPr>
           <a:xfrm>
-            <a:off x="8074152" y="2962656"/>
-            <a:ext cx="219456" cy="155448"/>
-          </a:xfrm>
-          <a:prstGeom prst="downArrow">
-            <a:avLst/>
-          </a:prstGeom>
-          <a:solidFill>
-            <a:srgbClr val="CBD5E1"/>
-          </a:solidFill>
-          <a:ln>
-            <a:noFill/>
-          </a:ln>
-          <a:effectLst/>
-        </p:spPr>
-        <p:style>
-          <a:lnRef idx="1">
-            <a:schemeClr val="accent1"/>
-          </a:lnRef>
-          <a:fillRef idx="3">
-            <a:schemeClr val="accent1"/>
-          </a:fillRef>
-          <a:effectRef idx="2">
-            <a:schemeClr val="accent1"/>
-          </a:effectRef>
-          <a:fontRef idx="minor">
-            <a:schemeClr val="lt1"/>
-          </a:fontRef>
-        </p:style>
-        <p:txBody>
-          <a:bodyPr rtlCol="0" anchor="ctr"/>
-          <a:lstStyle/>
-          <a:p>
-            <a:pPr algn="ctr"/>
-          </a:p>
-        </p:txBody>
-      </p:sp>
-      <p:sp>
-        <p:nvSpPr>
-          <p:cNvPr id="32" name="Rounded Rectangle 31"/>
-          <p:cNvSpPr/>
-          <p:nvPr/>
-        </p:nvSpPr>
-        <p:spPr>
-          <a:xfrm>
-            <a:off x="7909560" y="3145536"/>
-            <a:ext cx="3520440" cy="402336"/>
+            <a:off x="7909560" y="3099816"/>
+            <a:ext cx="3520440" cy="530352"/>
           </a:xfrm>
           <a:prstGeom prst="roundRect">
             <a:avLst>
-              <a:gd name="adj" fmla="val 20000"/>
+              <a:gd name="adj" fmla="val 15000"/>
             </a:avLst>
           </a:prstGeom>
           <a:solidFill>
@@ -16788,13 +16416,13 @@
       </p:sp>
       <p:sp>
         <p:nvSpPr>
-          <p:cNvPr id="33" name="Rounded Rectangle 32"/>
+          <p:cNvPr id="32" name="Rounded Rectangle 31"/>
           <p:cNvSpPr/>
           <p:nvPr/>
         </p:nvSpPr>
         <p:spPr>
           <a:xfrm>
-            <a:off x="8001000" y="3209544"/>
+            <a:off x="8001000" y="3218688"/>
             <a:ext cx="292608" cy="292608"/>
           </a:xfrm>
           <a:prstGeom prst="roundRect">
@@ -16847,14 +16475,14 @@
       </p:sp>
       <p:sp>
         <p:nvSpPr>
-          <p:cNvPr id="34" name="TextBox 33"/>
+          <p:cNvPr id="33" name="TextBox 32"/>
           <p:cNvSpPr txBox="1"/>
           <p:nvPr/>
         </p:nvSpPr>
         <p:spPr>
           <a:xfrm>
-            <a:off x="8366760" y="3172968"/>
-            <a:ext cx="3017520" cy="365760"/>
+            <a:off x="8366760" y="3118104"/>
+            <a:ext cx="3017520" cy="493776"/>
           </a:xfrm>
           <a:prstGeom prst="rect">
             <a:avLst/>
@@ -16869,79 +16497,51 @@
           <a:p>
             <a:pPr algn="l">
               <a:lnSpc>
-                <a:spcPct val="110000"/>
-              </a:lnSpc>
-            </a:pPr>
-            <a:r>
-              <a:rPr sz="1400" b="0">
+                <a:spcPct val="100000"/>
+              </a:lnSpc>
+            </a:pPr>
+            <a:r>
+              <a:rPr sz="1300" b="1">
                 <a:solidFill>
                   <a:srgbClr val="FFFFFF"/>
                 </a:solidFill>
                 <a:latin typeface="Arial"/>
               </a:rPr>
-              <a:t>Two agents investigate at once</a:t>
-            </a:r>
-          </a:p>
-        </p:txBody>
-      </p:sp>
-      <p:sp>
-        <p:nvSpPr>
-          <p:cNvPr id="35" name="Down Arrow 34"/>
+              <a:t>Two agents investigate</a:t>
+            </a:r>
+          </a:p>
+          <a:p>
+            <a:pPr algn="l">
+              <a:lnSpc>
+                <a:spcPct val="100000"/>
+              </a:lnSpc>
+            </a:pPr>
+            <a:r>
+              <a:rPr sz="1100" b="0">
+                <a:solidFill>
+                  <a:srgbClr val="CBD5E1"/>
+                </a:solidFill>
+                <a:latin typeface="Arial"/>
+              </a:rPr>
+              <a:t>Root cause, with the evidence</a:t>
+            </a:r>
+          </a:p>
+        </p:txBody>
+      </p:sp>
+      <p:sp>
+        <p:nvSpPr>
+          <p:cNvPr id="34" name="Rounded Rectangle 33"/>
           <p:cNvSpPr/>
           <p:nvPr/>
         </p:nvSpPr>
         <p:spPr>
           <a:xfrm>
-            <a:off x="8074152" y="3584448"/>
-            <a:ext cx="219456" cy="155448"/>
-          </a:xfrm>
-          <a:prstGeom prst="downArrow">
-            <a:avLst/>
-          </a:prstGeom>
-          <a:solidFill>
-            <a:srgbClr val="CBD5E1"/>
-          </a:solidFill>
-          <a:ln>
-            <a:noFill/>
-          </a:ln>
-          <a:effectLst/>
-        </p:spPr>
-        <p:style>
-          <a:lnRef idx="1">
-            <a:schemeClr val="accent1"/>
-          </a:lnRef>
-          <a:fillRef idx="3">
-            <a:schemeClr val="accent1"/>
-          </a:fillRef>
-          <a:effectRef idx="2">
-            <a:schemeClr val="accent1"/>
-          </a:effectRef>
-          <a:fontRef idx="minor">
-            <a:schemeClr val="lt1"/>
-          </a:fontRef>
-        </p:style>
-        <p:txBody>
-          <a:bodyPr rtlCol="0" anchor="ctr"/>
-          <a:lstStyle/>
-          <a:p>
-            <a:pPr algn="ctr"/>
-          </a:p>
-        </p:txBody>
-      </p:sp>
-      <p:sp>
-        <p:nvSpPr>
-          <p:cNvPr id="36" name="Rounded Rectangle 35"/>
-          <p:cNvSpPr/>
-          <p:nvPr/>
-        </p:nvSpPr>
-        <p:spPr>
-          <a:xfrm>
-            <a:off x="7909560" y="3767328"/>
-            <a:ext cx="3520440" cy="402336"/>
+            <a:off x="7909560" y="3712464"/>
+            <a:ext cx="3520440" cy="530352"/>
           </a:xfrm>
           <a:prstGeom prst="roundRect">
             <a:avLst>
-              <a:gd name="adj" fmla="val 20000"/>
+              <a:gd name="adj" fmla="val 15000"/>
             </a:avLst>
           </a:prstGeom>
           <a:solidFill>
@@ -16976,7 +16576,7 @@
       </p:sp>
       <p:sp>
         <p:nvSpPr>
-          <p:cNvPr id="37" name="Rounded Rectangle 36"/>
+          <p:cNvPr id="35" name="Rounded Rectangle 34"/>
           <p:cNvSpPr/>
           <p:nvPr/>
         </p:nvSpPr>
@@ -17035,14 +16635,14 @@
       </p:sp>
       <p:sp>
         <p:nvSpPr>
-          <p:cNvPr id="38" name="TextBox 37"/>
+          <p:cNvPr id="36" name="TextBox 35"/>
           <p:cNvSpPr txBox="1"/>
           <p:nvPr/>
         </p:nvSpPr>
         <p:spPr>
           <a:xfrm>
-            <a:off x="8366760" y="3794760"/>
-            <a:ext cx="3017520" cy="365760"/>
+            <a:off x="8366760" y="3730752"/>
+            <a:ext cx="3017520" cy="493776"/>
           </a:xfrm>
           <a:prstGeom prst="rect">
             <a:avLst/>
@@ -17057,79 +16657,51 @@
           <a:p>
             <a:pPr algn="l">
               <a:lnSpc>
-                <a:spcPct val="110000"/>
-              </a:lnSpc>
-            </a:pPr>
-            <a:r>
-              <a:rPr sz="1400" b="0">
+                <a:spcPct val="100000"/>
+              </a:lnSpc>
+            </a:pPr>
+            <a:r>
+              <a:rPr sz="1300" b="1">
                 <a:solidFill>
                   <a:srgbClr val="FFFFFF"/>
                 </a:solidFill>
                 <a:latin typeface="Arial"/>
               </a:rPr>
-              <a:t>A person approves the fix</a:t>
-            </a:r>
-          </a:p>
-        </p:txBody>
-      </p:sp>
-      <p:sp>
-        <p:nvSpPr>
-          <p:cNvPr id="39" name="Down Arrow 38"/>
+              <a:t>A person picks the fix</a:t>
+            </a:r>
+          </a:p>
+          <a:p>
+            <a:pPr algn="l">
+              <a:lnSpc>
+                <a:spcPct val="100000"/>
+              </a:lnSpc>
+            </a:pPr>
+            <a:r>
+              <a:rPr sz="1100" b="0">
+                <a:solidFill>
+                  <a:srgbClr val="CBD5E1"/>
+                </a:solidFill>
+                <a:latin typeface="Arial"/>
+              </a:rPr>
+              <a:t>Agents propose. People decide.</a:t>
+            </a:r>
+          </a:p>
+        </p:txBody>
+      </p:sp>
+      <p:sp>
+        <p:nvSpPr>
+          <p:cNvPr id="37" name="Rounded Rectangle 36"/>
           <p:cNvSpPr/>
           <p:nvPr/>
         </p:nvSpPr>
         <p:spPr>
           <a:xfrm>
-            <a:off x="8074152" y="4206240"/>
-            <a:ext cx="219456" cy="155448"/>
-          </a:xfrm>
-          <a:prstGeom prst="downArrow">
-            <a:avLst/>
-          </a:prstGeom>
-          <a:solidFill>
-            <a:srgbClr val="CBD5E1"/>
-          </a:solidFill>
-          <a:ln>
-            <a:noFill/>
-          </a:ln>
-          <a:effectLst/>
-        </p:spPr>
-        <p:style>
-          <a:lnRef idx="1">
-            <a:schemeClr val="accent1"/>
-          </a:lnRef>
-          <a:fillRef idx="3">
-            <a:schemeClr val="accent1"/>
-          </a:fillRef>
-          <a:effectRef idx="2">
-            <a:schemeClr val="accent1"/>
-          </a:effectRef>
-          <a:fontRef idx="minor">
-            <a:schemeClr val="lt1"/>
-          </a:fontRef>
-        </p:style>
-        <p:txBody>
-          <a:bodyPr rtlCol="0" anchor="ctr"/>
-          <a:lstStyle/>
-          <a:p>
-            <a:pPr algn="ctr"/>
-          </a:p>
-        </p:txBody>
-      </p:sp>
-      <p:sp>
-        <p:nvSpPr>
-          <p:cNvPr id="40" name="Rounded Rectangle 39"/>
-          <p:cNvSpPr/>
-          <p:nvPr/>
-        </p:nvSpPr>
-        <p:spPr>
-          <a:xfrm>
-            <a:off x="7909560" y="4389120"/>
-            <a:ext cx="3520440" cy="402336"/>
+            <a:off x="7909560" y="4325112"/>
+            <a:ext cx="3520440" cy="530352"/>
           </a:xfrm>
           <a:prstGeom prst="roundRect">
             <a:avLst>
-              <a:gd name="adj" fmla="val 20000"/>
+              <a:gd name="adj" fmla="val 15000"/>
             </a:avLst>
           </a:prstGeom>
           <a:solidFill>
@@ -17164,13 +16736,13 @@
       </p:sp>
       <p:sp>
         <p:nvSpPr>
-          <p:cNvPr id="41" name="Rounded Rectangle 40"/>
+          <p:cNvPr id="38" name="Rounded Rectangle 37"/>
           <p:cNvSpPr/>
           <p:nvPr/>
         </p:nvSpPr>
         <p:spPr>
           <a:xfrm>
-            <a:off x="8001000" y="4453128"/>
+            <a:off x="8001000" y="4443984"/>
             <a:ext cx="292608" cy="292608"/>
           </a:xfrm>
           <a:prstGeom prst="roundRect">
@@ -17223,14 +16795,14 @@
       </p:sp>
       <p:sp>
         <p:nvSpPr>
-          <p:cNvPr id="42" name="TextBox 41"/>
+          <p:cNvPr id="39" name="TextBox 38"/>
           <p:cNvSpPr txBox="1"/>
           <p:nvPr/>
         </p:nvSpPr>
         <p:spPr>
           <a:xfrm>
-            <a:off x="8366760" y="4416552"/>
-            <a:ext cx="3017520" cy="365760"/>
+            <a:off x="8366760" y="4343400"/>
+            <a:ext cx="3017520" cy="493776"/>
           </a:xfrm>
           <a:prstGeom prst="rect">
             <a:avLst/>
@@ -17245,79 +16817,51 @@
           <a:p>
             <a:pPr algn="l">
               <a:lnSpc>
-                <a:spcPct val="110000"/>
-              </a:lnSpc>
-            </a:pPr>
-            <a:r>
-              <a:rPr sz="1400" b="0">
+                <a:spcPct val="100000"/>
+              </a:lnSpc>
+            </a:pPr>
+            <a:r>
+              <a:rPr sz="1300" b="1">
                 <a:solidFill>
                   <a:srgbClr val="FFFFFF"/>
                 </a:solidFill>
                 <a:latin typeface="Arial"/>
               </a:rPr>
-              <a:t>An agent reviews the fix PR</a:t>
-            </a:r>
-          </a:p>
-        </p:txBody>
-      </p:sp>
-      <p:sp>
-        <p:nvSpPr>
-          <p:cNvPr id="43" name="Down Arrow 42"/>
+              <a:t>An agent reviews the fix</a:t>
+            </a:r>
+          </a:p>
+          <a:p>
+            <a:pPr algn="l">
+              <a:lnSpc>
+                <a:spcPct val="100000"/>
+              </a:lnSpc>
+            </a:pPr>
+            <a:r>
+              <a:rPr sz="1100" b="0">
+                <a:solidFill>
+                  <a:srgbClr val="CBD5E1"/>
+                </a:solidFill>
+                <a:latin typeface="Arial"/>
+              </a:rPr>
+              <a:t>Risky changes caught before merge</a:t>
+            </a:r>
+          </a:p>
+        </p:txBody>
+      </p:sp>
+      <p:sp>
+        <p:nvSpPr>
+          <p:cNvPr id="40" name="Rounded Rectangle 39"/>
           <p:cNvSpPr/>
           <p:nvPr/>
         </p:nvSpPr>
         <p:spPr>
           <a:xfrm>
-            <a:off x="8074152" y="4828031"/>
-            <a:ext cx="219456" cy="155448"/>
-          </a:xfrm>
-          <a:prstGeom prst="downArrow">
-            <a:avLst/>
-          </a:prstGeom>
-          <a:solidFill>
-            <a:srgbClr val="CBD5E1"/>
-          </a:solidFill>
-          <a:ln>
-            <a:noFill/>
-          </a:ln>
-          <a:effectLst/>
-        </p:spPr>
-        <p:style>
-          <a:lnRef idx="1">
-            <a:schemeClr val="accent1"/>
-          </a:lnRef>
-          <a:fillRef idx="3">
-            <a:schemeClr val="accent1"/>
-          </a:fillRef>
-          <a:effectRef idx="2">
-            <a:schemeClr val="accent1"/>
-          </a:effectRef>
-          <a:fontRef idx="minor">
-            <a:schemeClr val="lt1"/>
-          </a:fontRef>
-        </p:style>
-        <p:txBody>
-          <a:bodyPr rtlCol="0" anchor="ctr"/>
-          <a:lstStyle/>
-          <a:p>
-            <a:pPr algn="ctr"/>
-          </a:p>
-        </p:txBody>
-      </p:sp>
-      <p:sp>
-        <p:nvSpPr>
-          <p:cNvPr id="44" name="Rounded Rectangle 43"/>
-          <p:cNvSpPr/>
-          <p:nvPr/>
-        </p:nvSpPr>
-        <p:spPr>
-          <a:xfrm>
-            <a:off x="7909560" y="5010912"/>
-            <a:ext cx="3520440" cy="402336"/>
+            <a:off x="7909560" y="4937760"/>
+            <a:ext cx="3520440" cy="530352"/>
           </a:xfrm>
           <a:prstGeom prst="roundRect">
             <a:avLst>
-              <a:gd name="adj" fmla="val 20000"/>
+              <a:gd name="adj" fmla="val 15000"/>
             </a:avLst>
           </a:prstGeom>
           <a:solidFill>
@@ -17352,13 +16896,13 @@
       </p:sp>
       <p:sp>
         <p:nvSpPr>
-          <p:cNvPr id="45" name="Rounded Rectangle 44"/>
+          <p:cNvPr id="41" name="Rounded Rectangle 40"/>
           <p:cNvSpPr/>
           <p:nvPr/>
         </p:nvSpPr>
         <p:spPr>
           <a:xfrm>
-            <a:off x="8001000" y="5074920"/>
+            <a:off x="8001000" y="5056632"/>
             <a:ext cx="292608" cy="292608"/>
           </a:xfrm>
           <a:prstGeom prst="roundRect">
@@ -17411,14 +16955,14 @@
       </p:sp>
       <p:sp>
         <p:nvSpPr>
-          <p:cNvPr id="46" name="TextBox 45"/>
+          <p:cNvPr id="42" name="TextBox 41"/>
           <p:cNvSpPr txBox="1"/>
           <p:nvPr/>
         </p:nvSpPr>
         <p:spPr>
           <a:xfrm>
-            <a:off x="8366760" y="5038344"/>
-            <a:ext cx="3017520" cy="365760"/>
+            <a:off x="8366760" y="4956048"/>
+            <a:ext cx="3017520" cy="493776"/>
           </a:xfrm>
           <a:prstGeom prst="rect">
             <a:avLst/>
@@ -17433,17 +16977,33 @@
           <a:p>
             <a:pPr algn="l">
               <a:lnSpc>
-                <a:spcPct val="110000"/>
-              </a:lnSpc>
-            </a:pPr>
-            <a:r>
-              <a:rPr sz="1400" b="0">
+                <a:spcPct val="100000"/>
+              </a:lnSpc>
+            </a:pPr>
+            <a:r>
+              <a:rPr sz="1300" b="1">
                 <a:solidFill>
                   <a:srgbClr val="FFFFFF"/>
                 </a:solidFill>
                 <a:latin typeface="Arial"/>
               </a:rPr>
-              <a:t>Every step on one record</a:t>
+              <a:t>One record of every step</a:t>
+            </a:r>
+          </a:p>
+          <a:p>
+            <a:pPr algn="l">
+              <a:lnSpc>
+                <a:spcPct val="100000"/>
+              </a:lnSpc>
+            </a:pPr>
+            <a:r>
+              <a:rPr sz="1100" b="0">
+                <a:solidFill>
+                  <a:srgbClr val="CBD5E1"/>
+                </a:solidFill>
+                <a:latin typeface="Arial"/>
+              </a:rPr>
+              <a:t>Who did what, and what it cost</a:t>
             </a:r>
           </a:p>
         </p:txBody>

</xml_diff>

<commit_message>
Deck: slide 2 states the problem and KAOP's three outcomes from the brief
Co-Authored-By: Claude Opus 5.5 <noreply@anthropic.com>
Claude-Session: https://claude.ai/code/session_01DptoPaaj14X3TGztKApoPN
</commit_message>
<xml_diff>
--- a/docs/presentation/KAOP_Customer_Pitch.pptx
+++ b/docs/presentation/KAOP_Customer_Pitch.pptx
@@ -14809,14 +14809,62 @@
       </p:sp>
       <p:sp>
         <p:nvSpPr>
-          <p:cNvPr id="7" name="Rectangle 6"/>
+          <p:cNvPr id="7" name="Rounded Rectangle 6"/>
           <p:cNvSpPr/>
           <p:nvPr/>
         </p:nvSpPr>
         <p:spPr>
           <a:xfrm>
             <a:off x="548640" y="3429000"/>
-            <a:ext cx="73152" cy="1188720"/>
+            <a:ext cx="6766560" cy="777240"/>
+          </a:xfrm>
+          <a:prstGeom prst="roundRect">
+            <a:avLst>
+              <a:gd name="adj" fmla="val 6000"/>
+            </a:avLst>
+          </a:prstGeom>
+          <a:solidFill>
+            <a:srgbClr val="FFFFFF"/>
+          </a:solidFill>
+          <a:ln w="12700">
+            <a:solidFill>
+              <a:srgbClr val="E2E8F0"/>
+            </a:solidFill>
+          </a:ln>
+          <a:effectLst/>
+        </p:spPr>
+        <p:style>
+          <a:lnRef idx="1">
+            <a:schemeClr val="accent1"/>
+          </a:lnRef>
+          <a:fillRef idx="3">
+            <a:schemeClr val="accent1"/>
+          </a:fillRef>
+          <a:effectRef idx="2">
+            <a:schemeClr val="accent1"/>
+          </a:effectRef>
+          <a:fontRef idx="minor">
+            <a:schemeClr val="lt1"/>
+          </a:fontRef>
+        </p:style>
+        <p:txBody>
+          <a:bodyPr rtlCol="0" anchor="ctr"/>
+          <a:lstStyle/>
+          <a:p>
+            <a:pPr algn="ctr"/>
+          </a:p>
+        </p:txBody>
+      </p:sp>
+      <p:sp>
+        <p:nvSpPr>
+          <p:cNvPr id="8" name="Rectangle 7"/>
+          <p:cNvSpPr/>
+          <p:nvPr/>
+        </p:nvSpPr>
+        <p:spPr>
+          <a:xfrm>
+            <a:off x="777240" y="3611880"/>
+            <a:ext cx="73152" cy="411480"/>
           </a:xfrm>
           <a:prstGeom prst="rect">
             <a:avLst/>
@@ -14853,14 +14901,14 @@
       </p:sp>
       <p:sp>
         <p:nvSpPr>
-          <p:cNvPr id="8" name="TextBox 7"/>
+          <p:cNvPr id="9" name="TextBox 8"/>
           <p:cNvSpPr txBox="1"/>
           <p:nvPr/>
         </p:nvSpPr>
         <p:spPr>
           <a:xfrm>
-            <a:off x="868680" y="3383280"/>
-            <a:ext cx="6309360" cy="1280160"/>
+            <a:off x="960120" y="3502152"/>
+            <a:ext cx="2377440" cy="630936"/>
           </a:xfrm>
           <a:prstGeom prst="rect">
             <a:avLst/>
@@ -14868,38 +14916,247 @@
           <a:noFill/>
         </p:spPr>
         <p:txBody>
-          <a:bodyPr wrap="square" lIns="73152" rIns="73152" tIns="36576" bIns="36576" anchor="t">
+          <a:bodyPr wrap="square" lIns="73152" rIns="73152" tIns="36576" bIns="36576" anchor="ctr">
             <a:spAutoFit/>
           </a:bodyPr>
           <a:lstStyle/>
           <a:p>
             <a:pPr algn="l">
               <a:lnSpc>
-                <a:spcPct val="115000"/>
-              </a:lnSpc>
-            </a:pPr>
-            <a:r>
-              <a:rPr sz="2400" b="1">
+                <a:spcPct val="110000"/>
+              </a:lnSpc>
+            </a:pPr>
+            <a:r>
+              <a:rPr sz="1600" b="1">
                 <a:solidFill>
                   <a:srgbClr val="0F172A"/>
                 </a:solidFill>
                 <a:latin typeface="Arial"/>
               </a:rPr>
-              <a:t>I help platform teams put AI agents into production safely.</a:t>
-            </a:r>
-          </a:p>
-        </p:txBody>
-      </p:sp>
-      <p:sp>
-        <p:nvSpPr>
-          <p:cNvPr id="9" name="Rounded Rectangle 8"/>
+              <a:t>With your team</a:t>
+            </a:r>
+          </a:p>
+        </p:txBody>
+      </p:sp>
+      <p:sp>
+        <p:nvSpPr>
+          <p:cNvPr id="10" name="TextBox 9"/>
+          <p:cNvSpPr txBox="1"/>
+          <p:nvPr/>
+        </p:nvSpPr>
+        <p:spPr>
+          <a:xfrm>
+            <a:off x="3337560" y="3502152"/>
+            <a:ext cx="3840480" cy="630936"/>
+          </a:xfrm>
+          <a:prstGeom prst="rect">
+            <a:avLst/>
+          </a:prstGeom>
+          <a:noFill/>
+        </p:spPr>
+        <p:txBody>
+          <a:bodyPr wrap="square" lIns="73152" rIns="73152" tIns="36576" bIns="36576" anchor="ctr">
+            <a:spAutoFit/>
+          </a:bodyPr>
+          <a:lstStyle/>
+          <a:p>
+            <a:pPr algn="l">
+              <a:lnSpc>
+                <a:spcPct val="110000"/>
+              </a:lnSpc>
+            </a:pPr>
+            <a:r>
+              <a:rPr sz="1500" b="0">
+                <a:solidFill>
+                  <a:srgbClr val="475569"/>
+                </a:solidFill>
+                <a:latin typeface="Arial"/>
+              </a:rPr>
+              <a:t>From your first agent to production.</a:t>
+            </a:r>
+          </a:p>
+        </p:txBody>
+      </p:sp>
+      <p:sp>
+        <p:nvSpPr>
+          <p:cNvPr id="11" name="Rounded Rectangle 10"/>
           <p:cNvSpPr/>
           <p:nvPr/>
         </p:nvSpPr>
         <p:spPr>
           <a:xfrm>
+            <a:off x="548640" y="4343400"/>
+            <a:ext cx="6766560" cy="777240"/>
+          </a:xfrm>
+          <a:prstGeom prst="roundRect">
+            <a:avLst>
+              <a:gd name="adj" fmla="val 6000"/>
+            </a:avLst>
+          </a:prstGeom>
+          <a:solidFill>
+            <a:srgbClr val="FFFFFF"/>
+          </a:solidFill>
+          <a:ln w="12700">
+            <a:solidFill>
+              <a:srgbClr val="E2E8F0"/>
+            </a:solidFill>
+          </a:ln>
+          <a:effectLst/>
+        </p:spPr>
+        <p:style>
+          <a:lnRef idx="1">
+            <a:schemeClr val="accent1"/>
+          </a:lnRef>
+          <a:fillRef idx="3">
+            <a:schemeClr val="accent1"/>
+          </a:fillRef>
+          <a:effectRef idx="2">
+            <a:schemeClr val="accent1"/>
+          </a:effectRef>
+          <a:fontRef idx="minor">
+            <a:schemeClr val="lt1"/>
+          </a:fontRef>
+        </p:style>
+        <p:txBody>
+          <a:bodyPr rtlCol="0" anchor="ctr"/>
+          <a:lstStyle/>
+          <a:p>
+            <a:pPr algn="ctr"/>
+          </a:p>
+        </p:txBody>
+      </p:sp>
+      <p:sp>
+        <p:nvSpPr>
+          <p:cNvPr id="12" name="Rectangle 11"/>
+          <p:cNvSpPr/>
+          <p:nvPr/>
+        </p:nvSpPr>
+        <p:spPr>
+          <a:xfrm>
+            <a:off x="777240" y="4526280"/>
+            <a:ext cx="73152" cy="411480"/>
+          </a:xfrm>
+          <a:prstGeom prst="rect">
+            <a:avLst/>
+          </a:prstGeom>
+          <a:solidFill>
+            <a:srgbClr val="0F766E"/>
+          </a:solidFill>
+          <a:ln>
+            <a:noFill/>
+          </a:ln>
+          <a:effectLst/>
+        </p:spPr>
+        <p:style>
+          <a:lnRef idx="1">
+            <a:schemeClr val="accent1"/>
+          </a:lnRef>
+          <a:fillRef idx="3">
+            <a:schemeClr val="accent1"/>
+          </a:fillRef>
+          <a:effectRef idx="2">
+            <a:schemeClr val="accent1"/>
+          </a:effectRef>
+          <a:fontRef idx="minor">
+            <a:schemeClr val="lt1"/>
+          </a:fontRef>
+        </p:style>
+        <p:txBody>
+          <a:bodyPr rtlCol="0" anchor="ctr"/>
+          <a:lstStyle/>
+          <a:p>
+            <a:pPr algn="ctr"/>
+          </a:p>
+        </p:txBody>
+      </p:sp>
+      <p:sp>
+        <p:nvSpPr>
+          <p:cNvPr id="13" name="TextBox 12"/>
+          <p:cNvSpPr txBox="1"/>
+          <p:nvPr/>
+        </p:nvSpPr>
+        <p:spPr>
+          <a:xfrm>
+            <a:off x="960120" y="4416552"/>
+            <a:ext cx="2377440" cy="630936"/>
+          </a:xfrm>
+          <a:prstGeom prst="rect">
+            <a:avLst/>
+          </a:prstGeom>
+          <a:noFill/>
+        </p:spPr>
+        <p:txBody>
+          <a:bodyPr wrap="square" lIns="73152" rIns="73152" tIns="36576" bIns="36576" anchor="ctr">
+            <a:spAutoFit/>
+          </a:bodyPr>
+          <a:lstStyle/>
+          <a:p>
+            <a:pPr algn="l">
+              <a:lnSpc>
+                <a:spcPct val="110000"/>
+              </a:lnSpc>
+            </a:pPr>
+            <a:r>
+              <a:rPr sz="1600" b="1">
+                <a:solidFill>
+                  <a:srgbClr val="0F172A"/>
+                </a:solidFill>
+                <a:latin typeface="Arial"/>
+              </a:rPr>
+              <a:t>With our product team</a:t>
+            </a:r>
+          </a:p>
+        </p:txBody>
+      </p:sp>
+      <p:sp>
+        <p:nvSpPr>
+          <p:cNvPr id="14" name="TextBox 13"/>
+          <p:cNvSpPr txBox="1"/>
+          <p:nvPr/>
+        </p:nvSpPr>
+        <p:spPr>
+          <a:xfrm>
+            <a:off x="3337560" y="4416552"/>
+            <a:ext cx="3840480" cy="630936"/>
+          </a:xfrm>
+          <a:prstGeom prst="rect">
+            <a:avLst/>
+          </a:prstGeom>
+          <a:noFill/>
+        </p:spPr>
+        <p:txBody>
+          <a:bodyPr wrap="square" lIns="73152" rIns="73152" tIns="36576" bIns="36576" anchor="ctr">
+            <a:spAutoFit/>
+          </a:bodyPr>
+          <a:lstStyle/>
+          <a:p>
+            <a:pPr algn="l">
+              <a:lnSpc>
+                <a:spcPct val="110000"/>
+              </a:lnSpc>
+            </a:pPr>
+            <a:r>
+              <a:rPr sz="1500" b="0">
+                <a:solidFill>
+                  <a:srgbClr val="475569"/>
+                </a:solidFill>
+                <a:latin typeface="Arial"/>
+              </a:rPr>
+              <a:t>Your feedback shapes what we build next.</a:t>
+            </a:r>
+          </a:p>
+        </p:txBody>
+      </p:sp>
+      <p:sp>
+        <p:nvSpPr>
+          <p:cNvPr id="15" name="Rounded Rectangle 14"/>
+          <p:cNvSpPr/>
+          <p:nvPr/>
+        </p:nvSpPr>
+        <p:spPr>
+          <a:xfrm>
             <a:off x="7680960" y="1600200"/>
-            <a:ext cx="3959352" cy="4069080"/>
+            <a:ext cx="3959352" cy="4206240"/>
           </a:xfrm>
           <a:prstGeom prst="roundRect">
             <a:avLst>
@@ -14938,13 +15195,13 @@
       </p:sp>
       <p:sp>
         <p:nvSpPr>
-          <p:cNvPr id="10" name="TextBox 9"/>
+          <p:cNvPr id="16" name="TextBox 15"/>
           <p:cNvSpPr txBox="1"/>
           <p:nvPr/>
         </p:nvSpPr>
         <p:spPr>
           <a:xfrm>
-            <a:off x="7955279" y="1828800"/>
+            <a:off x="7955279" y="1810512"/>
             <a:ext cx="3474720" cy="274320"/>
           </a:xfrm>
           <a:prstGeom prst="rect">
@@ -14977,14 +15234,14 @@
       </p:sp>
       <p:sp>
         <p:nvSpPr>
-          <p:cNvPr id="11" name="TextBox 10"/>
+          <p:cNvPr id="17" name="TextBox 16"/>
           <p:cNvSpPr txBox="1"/>
           <p:nvPr/>
         </p:nvSpPr>
         <p:spPr>
           <a:xfrm>
-            <a:off x="7955279" y="2240280"/>
-            <a:ext cx="3474720" cy="1828800"/>
+            <a:off x="7955279" y="2148840"/>
+            <a:ext cx="3474720" cy="1005840"/>
           </a:xfrm>
           <a:prstGeom prst="rect">
             <a:avLst/>
@@ -15001,54 +15258,76 @@
               <a:lnSpc>
                 <a:spcPct val="115000"/>
               </a:lnSpc>
-              <a:spcAft>
-                <a:spcPts val="1000"/>
-              </a:spcAft>
-            </a:pPr>
-            <a:r>
-              <a:rPr sz="2000" b="1">
+            </a:pPr>
+            <a:r>
+              <a:rPr sz="1600" b="1">
                 <a:solidFill>
                   <a:srgbClr val="FFFFFF"/>
                 </a:solidFill>
                 <a:latin typeface="Arial"/>
               </a:rPr>
-              <a:t>Your teams want more AI agents.</a:t>
-            </a:r>
-          </a:p>
-          <a:p>
-            <a:pPr algn="l">
-              <a:lnSpc>
-                <a:spcPct val="115000"/>
-              </a:lnSpc>
-            </a:pPr>
-            <a:r>
-              <a:rPr sz="2000" b="1">
-                <a:solidFill>
-                  <a:srgbClr val="FFFFFF"/>
-                </a:solidFill>
-                <a:latin typeface="Arial"/>
-              </a:rPr>
-              <a:t>You need to stay in control of them.</a:t>
-            </a:r>
-          </a:p>
-        </p:txBody>
-      </p:sp>
-      <p:sp>
-        <p:nvSpPr>
-          <p:cNvPr id="12" name="Rectangle 11"/>
+              <a:t>Your teams launch AI agents on their own. Nobody sees them all or sets their limits.</a:t>
+            </a:r>
+          </a:p>
+        </p:txBody>
+      </p:sp>
+      <p:sp>
+        <p:nvSpPr>
+          <p:cNvPr id="18" name="TextBox 17"/>
+          <p:cNvSpPr txBox="1"/>
+          <p:nvPr/>
+        </p:nvSpPr>
+        <p:spPr>
+          <a:xfrm>
+            <a:off x="7955279" y="3291840"/>
+            <a:ext cx="3474720" cy="274320"/>
+          </a:xfrm>
+          <a:prstGeom prst="rect">
+            <a:avLst/>
+          </a:prstGeom>
+          <a:noFill/>
+        </p:spPr>
+        <p:txBody>
+          <a:bodyPr wrap="square" lIns="73152" rIns="73152" tIns="36576" bIns="36576" anchor="t">
+            <a:spAutoFit/>
+          </a:bodyPr>
+          <a:lstStyle/>
+          <a:p>
+            <a:pPr algn="l">
+              <a:lnSpc>
+                <a:spcPct val="110000"/>
+              </a:lnSpc>
+            </a:pPr>
+            <a:r>
+              <a:rPr sz="1100" b="1">
+                <a:solidFill>
+                  <a:srgbClr val="A5B4FC"/>
+                </a:solidFill>
+                <a:latin typeface="Arial"/>
+              </a:rPr>
+              <a:t>WHAT KAOP GIVES YOUR PLATFORM TEAM</a:t>
+            </a:r>
+          </a:p>
+        </p:txBody>
+      </p:sp>
+      <p:sp>
+        <p:nvSpPr>
+          <p:cNvPr id="19" name="Rounded Rectangle 18"/>
           <p:cNvSpPr/>
           <p:nvPr/>
         </p:nvSpPr>
         <p:spPr>
           <a:xfrm>
-            <a:off x="7955279" y="4160520"/>
-            <a:ext cx="3383280" cy="18288"/>
-          </a:xfrm>
-          <a:prstGeom prst="rect">
-            <a:avLst/>
+            <a:off x="7909560" y="3639312"/>
+            <a:ext cx="3520440" cy="420624"/>
+          </a:xfrm>
+          <a:prstGeom prst="roundRect">
+            <a:avLst>
+              <a:gd name="adj" fmla="val 20000"/>
+            </a:avLst>
           </a:prstGeom>
           <a:solidFill>
-            <a:srgbClr val="CBD5E1"/>
+            <a:srgbClr val="1E293B"/>
           </a:solidFill>
           <a:ln>
             <a:noFill/>
@@ -15079,14 +15358,355 @@
       </p:sp>
       <p:sp>
         <p:nvSpPr>
-          <p:cNvPr id="13" name="TextBox 12"/>
+          <p:cNvPr id="20" name="Rectangle 19"/>
+          <p:cNvSpPr/>
+          <p:nvPr/>
+        </p:nvSpPr>
+        <p:spPr>
+          <a:xfrm>
+            <a:off x="8046720" y="3749039"/>
+            <a:ext cx="64008" cy="201168"/>
+          </a:xfrm>
+          <a:prstGeom prst="rect">
+            <a:avLst/>
+          </a:prstGeom>
+          <a:solidFill>
+            <a:srgbClr val="4F46E5"/>
+          </a:solidFill>
+          <a:ln>
+            <a:noFill/>
+          </a:ln>
+          <a:effectLst/>
+        </p:spPr>
+        <p:style>
+          <a:lnRef idx="1">
+            <a:schemeClr val="accent1"/>
+          </a:lnRef>
+          <a:fillRef idx="3">
+            <a:schemeClr val="accent1"/>
+          </a:fillRef>
+          <a:effectRef idx="2">
+            <a:schemeClr val="accent1"/>
+          </a:effectRef>
+          <a:fontRef idx="minor">
+            <a:schemeClr val="lt1"/>
+          </a:fontRef>
+        </p:style>
+        <p:txBody>
+          <a:bodyPr rtlCol="0" anchor="ctr"/>
+          <a:lstStyle/>
+          <a:p>
+            <a:pPr algn="ctr"/>
+          </a:p>
+        </p:txBody>
+      </p:sp>
+      <p:sp>
+        <p:nvSpPr>
+          <p:cNvPr id="21" name="TextBox 20"/>
           <p:cNvSpPr txBox="1"/>
           <p:nvPr/>
         </p:nvSpPr>
         <p:spPr>
           <a:xfrm>
-            <a:off x="7955279" y="4343400"/>
-            <a:ext cx="3474720" cy="1188720"/>
+            <a:off x="8229600" y="3666744"/>
+            <a:ext cx="3108960" cy="365760"/>
+          </a:xfrm>
+          <a:prstGeom prst="rect">
+            <a:avLst/>
+          </a:prstGeom>
+          <a:noFill/>
+        </p:spPr>
+        <p:txBody>
+          <a:bodyPr wrap="square" lIns="73152" rIns="73152" tIns="36576" bIns="36576" anchor="ctr">
+            <a:spAutoFit/>
+          </a:bodyPr>
+          <a:lstStyle/>
+          <a:p>
+            <a:pPr algn="l">
+              <a:lnSpc>
+                <a:spcPct val="110000"/>
+              </a:lnSpc>
+            </a:pPr>
+            <a:r>
+              <a:rPr sz="1400" b="0">
+                <a:solidFill>
+                  <a:srgbClr val="FFFFFF"/>
+                </a:solidFill>
+                <a:latin typeface="Arial"/>
+              </a:rPr>
+              <a:t>One view of every agent</a:t>
+            </a:r>
+          </a:p>
+        </p:txBody>
+      </p:sp>
+      <p:sp>
+        <p:nvSpPr>
+          <p:cNvPr id="22" name="Rounded Rectangle 21"/>
+          <p:cNvSpPr/>
+          <p:nvPr/>
+        </p:nvSpPr>
+        <p:spPr>
+          <a:xfrm>
+            <a:off x="7909560" y="4151376"/>
+            <a:ext cx="3520440" cy="420624"/>
+          </a:xfrm>
+          <a:prstGeom prst="roundRect">
+            <a:avLst>
+              <a:gd name="adj" fmla="val 20000"/>
+            </a:avLst>
+          </a:prstGeom>
+          <a:solidFill>
+            <a:srgbClr val="1E293B"/>
+          </a:solidFill>
+          <a:ln>
+            <a:noFill/>
+          </a:ln>
+          <a:effectLst/>
+        </p:spPr>
+        <p:style>
+          <a:lnRef idx="1">
+            <a:schemeClr val="accent1"/>
+          </a:lnRef>
+          <a:fillRef idx="3">
+            <a:schemeClr val="accent1"/>
+          </a:fillRef>
+          <a:effectRef idx="2">
+            <a:schemeClr val="accent1"/>
+          </a:effectRef>
+          <a:fontRef idx="minor">
+            <a:schemeClr val="lt1"/>
+          </a:fontRef>
+        </p:style>
+        <p:txBody>
+          <a:bodyPr rtlCol="0" anchor="ctr"/>
+          <a:lstStyle/>
+          <a:p>
+            <a:pPr algn="ctr"/>
+          </a:p>
+        </p:txBody>
+      </p:sp>
+      <p:sp>
+        <p:nvSpPr>
+          <p:cNvPr id="23" name="Rectangle 22"/>
+          <p:cNvSpPr/>
+          <p:nvPr/>
+        </p:nvSpPr>
+        <p:spPr>
+          <a:xfrm>
+            <a:off x="8046720" y="4261104"/>
+            <a:ext cx="64008" cy="201168"/>
+          </a:xfrm>
+          <a:prstGeom prst="rect">
+            <a:avLst/>
+          </a:prstGeom>
+          <a:solidFill>
+            <a:srgbClr val="B91C1C"/>
+          </a:solidFill>
+          <a:ln>
+            <a:noFill/>
+          </a:ln>
+          <a:effectLst/>
+        </p:spPr>
+        <p:style>
+          <a:lnRef idx="1">
+            <a:schemeClr val="accent1"/>
+          </a:lnRef>
+          <a:fillRef idx="3">
+            <a:schemeClr val="accent1"/>
+          </a:fillRef>
+          <a:effectRef idx="2">
+            <a:schemeClr val="accent1"/>
+          </a:effectRef>
+          <a:fontRef idx="minor">
+            <a:schemeClr val="lt1"/>
+          </a:fontRef>
+        </p:style>
+        <p:txBody>
+          <a:bodyPr rtlCol="0" anchor="ctr"/>
+          <a:lstStyle/>
+          <a:p>
+            <a:pPr algn="ctr"/>
+          </a:p>
+        </p:txBody>
+      </p:sp>
+      <p:sp>
+        <p:nvSpPr>
+          <p:cNvPr id="24" name="TextBox 23"/>
+          <p:cNvSpPr txBox="1"/>
+          <p:nvPr/>
+        </p:nvSpPr>
+        <p:spPr>
+          <a:xfrm>
+            <a:off x="8229600" y="4178808"/>
+            <a:ext cx="3108960" cy="365760"/>
+          </a:xfrm>
+          <a:prstGeom prst="rect">
+            <a:avLst/>
+          </a:prstGeom>
+          <a:noFill/>
+        </p:spPr>
+        <p:txBody>
+          <a:bodyPr wrap="square" lIns="73152" rIns="73152" tIns="36576" bIns="36576" anchor="ctr">
+            <a:spAutoFit/>
+          </a:bodyPr>
+          <a:lstStyle/>
+          <a:p>
+            <a:pPr algn="l">
+              <a:lnSpc>
+                <a:spcPct val="110000"/>
+              </a:lnSpc>
+            </a:pPr>
+            <a:r>
+              <a:rPr sz="1400" b="0">
+                <a:solidFill>
+                  <a:srgbClr val="FFFFFF"/>
+                </a:solidFill>
+                <a:latin typeface="Arial"/>
+              </a:rPr>
+              <a:t>Limits a system enforces</a:t>
+            </a:r>
+          </a:p>
+        </p:txBody>
+      </p:sp>
+      <p:sp>
+        <p:nvSpPr>
+          <p:cNvPr id="25" name="Rounded Rectangle 24"/>
+          <p:cNvSpPr/>
+          <p:nvPr/>
+        </p:nvSpPr>
+        <p:spPr>
+          <a:xfrm>
+            <a:off x="7909560" y="4663440"/>
+            <a:ext cx="3520440" cy="420624"/>
+          </a:xfrm>
+          <a:prstGeom prst="roundRect">
+            <a:avLst>
+              <a:gd name="adj" fmla="val 20000"/>
+            </a:avLst>
+          </a:prstGeom>
+          <a:solidFill>
+            <a:srgbClr val="1E293B"/>
+          </a:solidFill>
+          <a:ln>
+            <a:noFill/>
+          </a:ln>
+          <a:effectLst/>
+        </p:spPr>
+        <p:style>
+          <a:lnRef idx="1">
+            <a:schemeClr val="accent1"/>
+          </a:lnRef>
+          <a:fillRef idx="3">
+            <a:schemeClr val="accent1"/>
+          </a:fillRef>
+          <a:effectRef idx="2">
+            <a:schemeClr val="accent1"/>
+          </a:effectRef>
+          <a:fontRef idx="minor">
+            <a:schemeClr val="lt1"/>
+          </a:fontRef>
+        </p:style>
+        <p:txBody>
+          <a:bodyPr rtlCol="0" anchor="ctr"/>
+          <a:lstStyle/>
+          <a:p>
+            <a:pPr algn="ctr"/>
+          </a:p>
+        </p:txBody>
+      </p:sp>
+      <p:sp>
+        <p:nvSpPr>
+          <p:cNvPr id="26" name="Rectangle 25"/>
+          <p:cNvSpPr/>
+          <p:nvPr/>
+        </p:nvSpPr>
+        <p:spPr>
+          <a:xfrm>
+            <a:off x="8046720" y="4773168"/>
+            <a:ext cx="64008" cy="201168"/>
+          </a:xfrm>
+          <a:prstGeom prst="rect">
+            <a:avLst/>
+          </a:prstGeom>
+          <a:solidFill>
+            <a:srgbClr val="0F766E"/>
+          </a:solidFill>
+          <a:ln>
+            <a:noFill/>
+          </a:ln>
+          <a:effectLst/>
+        </p:spPr>
+        <p:style>
+          <a:lnRef idx="1">
+            <a:schemeClr val="accent1"/>
+          </a:lnRef>
+          <a:fillRef idx="3">
+            <a:schemeClr val="accent1"/>
+          </a:fillRef>
+          <a:effectRef idx="2">
+            <a:schemeClr val="accent1"/>
+          </a:effectRef>
+          <a:fontRef idx="minor">
+            <a:schemeClr val="lt1"/>
+          </a:fontRef>
+        </p:style>
+        <p:txBody>
+          <a:bodyPr rtlCol="0" anchor="ctr"/>
+          <a:lstStyle/>
+          <a:p>
+            <a:pPr algn="ctr"/>
+          </a:p>
+        </p:txBody>
+      </p:sp>
+      <p:sp>
+        <p:nvSpPr>
+          <p:cNvPr id="27" name="TextBox 26"/>
+          <p:cNvSpPr txBox="1"/>
+          <p:nvPr/>
+        </p:nvSpPr>
+        <p:spPr>
+          <a:xfrm>
+            <a:off x="8229600" y="4690872"/>
+            <a:ext cx="3108960" cy="365760"/>
+          </a:xfrm>
+          <a:prstGeom prst="rect">
+            <a:avLst/>
+          </a:prstGeom>
+          <a:noFill/>
+        </p:spPr>
+        <p:txBody>
+          <a:bodyPr wrap="square" lIns="73152" rIns="73152" tIns="36576" bIns="36576" anchor="ctr">
+            <a:spAutoFit/>
+          </a:bodyPr>
+          <a:lstStyle/>
+          <a:p>
+            <a:pPr algn="l">
+              <a:lnSpc>
+                <a:spcPct val="110000"/>
+              </a:lnSpc>
+            </a:pPr>
+            <a:r>
+              <a:rPr sz="1400" b="0">
+                <a:solidFill>
+                  <a:srgbClr val="FFFFFF"/>
+                </a:solidFill>
+                <a:latin typeface="Arial"/>
+              </a:rPr>
+              <a:t>Agents working as one workflow</a:t>
+            </a:r>
+          </a:p>
+        </p:txBody>
+      </p:sp>
+      <p:sp>
+        <p:nvSpPr>
+          <p:cNvPr id="28" name="TextBox 27"/>
+          <p:cNvSpPr txBox="1"/>
+          <p:nvPr/>
+        </p:nvSpPr>
+        <p:spPr>
+          <a:xfrm>
+            <a:off x="7955279" y="5230368"/>
+            <a:ext cx="3474720" cy="457200"/>
           </a:xfrm>
           <a:prstGeom prst="rect">
             <a:avLst/>
@@ -15101,17 +15721,17 @@
           <a:p>
             <a:pPr algn="l">
               <a:lnSpc>
-                <a:spcPct val="115000"/>
-              </a:lnSpc>
-            </a:pPr>
-            <a:r>
-              <a:rPr sz="1700" b="0">
+                <a:spcPct val="110000"/>
+              </a:lnSpc>
+            </a:pPr>
+            <a:r>
+              <a:rPr sz="1300" b="0">
                 <a:solidFill>
                   <a:srgbClr val="CBD5E1"/>
                 </a:solidFill>
                 <a:latin typeface="Arial"/>
               </a:rPr>
-              <a:t>Today: KAOP doing both, on a live incident.</a:t>
+              <a:t>Live today: a real incident and a real code review.</a:t>
             </a:r>
           </a:p>
         </p:txBody>
@@ -15623,7 +16243,7 @@
                 </a:solidFill>
                 <a:latin typeface="Arial"/>
               </a:rPr>
-              <a:t>Owners, limits and a record.</a:t>
+              <a:t>Visibility, guardrails, workflows.</a:t>
             </a:r>
           </a:p>
         </p:txBody>

</xml_diff>

<commit_message>
Deck: Grafana allow-list proof on slide 9, appendix D with cost and guardrail tests, code review owner matches KAOP labels
Co-Authored-By: Claude Opus 5.5 <noreply@anthropic.com>
Claude-Session: https://claude.ai/code/session_01DptoPaaj14X3TGztKApoPN
</commit_message>
<xml_diff>
--- a/docs/presentation/KAOP_Customer_Pitch.pptx
+++ b/docs/presentation/KAOP_Customer_Pitch.pptx
@@ -22,6 +22,7 @@
     <p:sldId id="270" r:id="rId21"/>
     <p:sldId id="271" r:id="rId22"/>
     <p:sldId id="272" r:id="rId23"/>
+    <p:sldId id="273" r:id="rId24"/>
   </p:sldIdLst>
   <p:sldSz cx="12191695" cy="6858000" type="screen4x3"/>
   <p:notesSz cx="6858000" cy="9144000"/>
@@ -11935,6 +11936,45 @@
           </a:p>
         </p:txBody>
       </p:sp>
+      <p:sp>
+        <p:nvSpPr>
+          <p:cNvPr id="8" name="TextBox 7"/>
+          <p:cNvSpPr txBox="1"/>
+          <p:nvPr/>
+        </p:nvSpPr>
+        <p:spPr>
+          <a:xfrm>
+            <a:off x="548640" y="5486400"/>
+            <a:ext cx="7315200" cy="411480"/>
+          </a:xfrm>
+          <a:prstGeom prst="rect">
+            <a:avLst/>
+          </a:prstGeom>
+          <a:noFill/>
+        </p:spPr>
+        <p:txBody>
+          <a:bodyPr wrap="square" lIns="73152" rIns="73152" tIns="36576" bIns="36576" anchor="t">
+            <a:spAutoFit/>
+          </a:bodyPr>
+          <a:lstStyle/>
+          <a:p>
+            <a:pPr algn="l">
+              <a:lnSpc>
+                <a:spcPct val="110000"/>
+              </a:lnSpc>
+            </a:pPr>
+            <a:r>
+              <a:rPr sz="1600" b="0">
+                <a:solidFill>
+                  <a:srgbClr val="CBD5E1"/>
+                </a:solidFill>
+                <a:latin typeface="Arial"/>
+              </a:rPr>
+              <a:t>D   Cost and guardrails, tested</a:t>
+            </a:r>
+          </a:p>
+        </p:txBody>
+      </p:sp>
     </p:spTree>
   </p:cSld>
   <p:clrMapOvr>
@@ -14582,6 +14622,1004 @@
                 <a:latin typeface="Arial"/>
               </a:rPr>
               <a:t>Measured on 2026-10-24 and 2026-10-25 on a single-node kind cluster. With the bad check, recovery waits on Kubernetes' restart back-off (10 s, doubling up to 5 minutes), so it depends on how long the outage lasted.</a:t>
+            </a:r>
+          </a:p>
+        </p:txBody>
+      </p:sp>
+    </p:spTree>
+  </p:cSld>
+  <p:clrMapOvr>
+    <a:masterClrMapping/>
+  </p:clrMapOvr>
+</p:sld>
+</file>
+
+<file path=ppt/slides/slide18.xml><?xml version="1.0" encoding="utf-8"?>
+<p:sld xmlns:a="http://schemas.openxmlformats.org/drawingml/2006/main" xmlns:p="http://schemas.openxmlformats.org/presentationml/2006/main" xmlns:r="http://schemas.openxmlformats.org/officeDocument/2006/relationships">
+  <p:cSld>
+    <p:bg>
+      <p:bgPr>
+        <a:solidFill>
+          <a:srgbClr val="F8FAFC"/>
+        </a:solidFill>
+        <a:effectLst/>
+      </p:bgPr>
+    </p:bg>
+    <p:spTree>
+      <p:nvGrpSpPr>
+        <p:cNvPr id="1" name=""/>
+        <p:cNvGrpSpPr/>
+        <p:nvPr/>
+      </p:nvGrpSpPr>
+      <p:grpSpPr/>
+      <p:sp>
+        <p:nvSpPr>
+          <p:cNvPr id="2" name="TextBox 1"/>
+          <p:cNvSpPr txBox="1"/>
+          <p:nvPr/>
+        </p:nvSpPr>
+        <p:spPr>
+          <a:xfrm>
+            <a:off x="548640" y="320040"/>
+            <a:ext cx="7315200" cy="274320"/>
+          </a:xfrm>
+          <a:prstGeom prst="rect">
+            <a:avLst/>
+          </a:prstGeom>
+          <a:noFill/>
+        </p:spPr>
+        <p:txBody>
+          <a:bodyPr wrap="square" lIns="73152" rIns="73152" tIns="36576" bIns="36576" anchor="t">
+            <a:spAutoFit/>
+          </a:bodyPr>
+          <a:lstStyle/>
+          <a:p>
+            <a:pPr algn="l">
+              <a:lnSpc>
+                <a:spcPct val="110000"/>
+              </a:lnSpc>
+            </a:pPr>
+            <a:r>
+              <a:rPr sz="1000" b="1">
+                <a:solidFill>
+                  <a:srgbClr val="4F46E5"/>
+                </a:solidFill>
+                <a:latin typeface="Arial"/>
+              </a:rPr>
+              <a:t>APPENDIX</a:t>
+            </a:r>
+          </a:p>
+        </p:txBody>
+      </p:sp>
+      <p:sp>
+        <p:nvSpPr>
+          <p:cNvPr id="3" name="TextBox 2"/>
+          <p:cNvSpPr txBox="1"/>
+          <p:nvPr/>
+        </p:nvSpPr>
+        <p:spPr>
+          <a:xfrm>
+            <a:off x="9784080" y="320040"/>
+            <a:ext cx="1828800" cy="274320"/>
+          </a:xfrm>
+          <a:prstGeom prst="rect">
+            <a:avLst/>
+          </a:prstGeom>
+          <a:noFill/>
+        </p:spPr>
+        <p:txBody>
+          <a:bodyPr wrap="square" lIns="73152" rIns="73152" tIns="36576" bIns="36576" anchor="t">
+            <a:spAutoFit/>
+          </a:bodyPr>
+          <a:lstStyle/>
+          <a:p>
+            <a:pPr algn="r">
+              <a:lnSpc>
+                <a:spcPct val="110000"/>
+              </a:lnSpc>
+            </a:pPr>
+            <a:r>
+              <a:rPr sz="1000" b="0">
+                <a:solidFill>
+                  <a:srgbClr val="94A3B8"/>
+                </a:solidFill>
+                <a:latin typeface="Arial"/>
+              </a:rPr>
+              <a:t>APPENDIX D</a:t>
+            </a:r>
+          </a:p>
+        </p:txBody>
+      </p:sp>
+      <p:sp>
+        <p:nvSpPr>
+          <p:cNvPr id="4" name="TextBox 3"/>
+          <p:cNvSpPr txBox="1"/>
+          <p:nvPr/>
+        </p:nvSpPr>
+        <p:spPr>
+          <a:xfrm>
+            <a:off x="548640" y="658368"/>
+            <a:ext cx="11064240" cy="731520"/>
+          </a:xfrm>
+          <a:prstGeom prst="rect">
+            <a:avLst/>
+          </a:prstGeom>
+          <a:noFill/>
+        </p:spPr>
+        <p:txBody>
+          <a:bodyPr wrap="square" lIns="73152" rIns="73152" tIns="36576" bIns="36576" anchor="t">
+            <a:spAutoFit/>
+          </a:bodyPr>
+          <a:lstStyle/>
+          <a:p>
+            <a:pPr algn="l">
+              <a:lnSpc>
+                <a:spcPct val="110000"/>
+              </a:lnSpc>
+            </a:pPr>
+            <a:r>
+              <a:rPr sz="3200" b="1">
+                <a:solidFill>
+                  <a:srgbClr val="0F172A"/>
+                </a:solidFill>
+                <a:latin typeface="Arial"/>
+              </a:rPr>
+              <a:t>Cost and guardrails, tested</a:t>
+            </a:r>
+          </a:p>
+        </p:txBody>
+      </p:sp>
+      <p:sp>
+        <p:nvSpPr>
+          <p:cNvPr id="5" name="TextBox 4"/>
+          <p:cNvSpPr txBox="1"/>
+          <p:nvPr/>
+        </p:nvSpPr>
+        <p:spPr>
+          <a:xfrm>
+            <a:off x="548640" y="1371600"/>
+            <a:ext cx="11064240" cy="457200"/>
+          </a:xfrm>
+          <a:prstGeom prst="rect">
+            <a:avLst/>
+          </a:prstGeom>
+          <a:noFill/>
+        </p:spPr>
+        <p:txBody>
+          <a:bodyPr wrap="square" lIns="73152" rIns="73152" tIns="36576" bIns="36576" anchor="t">
+            <a:spAutoFit/>
+          </a:bodyPr>
+          <a:lstStyle/>
+          <a:p>
+            <a:pPr algn="l">
+              <a:lnSpc>
+                <a:spcPct val="110000"/>
+              </a:lnSpc>
+            </a:pPr>
+            <a:r>
+              <a:rPr sz="1700" b="0">
+                <a:solidFill>
+                  <a:srgbClr val="475569"/>
+                </a:solidFill>
+                <a:latin typeface="Arial"/>
+              </a:rPr>
+              <a:t>Each change made on this lab, then tested with real runs.</a:t>
+            </a:r>
+          </a:p>
+        </p:txBody>
+      </p:sp>
+      <p:sp>
+        <p:nvSpPr>
+          <p:cNvPr id="6" name="TextBox 5"/>
+          <p:cNvSpPr txBox="1"/>
+          <p:nvPr/>
+        </p:nvSpPr>
+        <p:spPr>
+          <a:xfrm>
+            <a:off x="777240" y="1965960"/>
+            <a:ext cx="4206240" cy="320040"/>
+          </a:xfrm>
+          <a:prstGeom prst="rect">
+            <a:avLst/>
+          </a:prstGeom>
+          <a:noFill/>
+        </p:spPr>
+        <p:txBody>
+          <a:bodyPr wrap="square" lIns="73152" rIns="73152" tIns="36576" bIns="36576" anchor="ctr">
+            <a:spAutoFit/>
+          </a:bodyPr>
+          <a:lstStyle/>
+          <a:p>
+            <a:pPr algn="l">
+              <a:lnSpc>
+                <a:spcPct val="105000"/>
+              </a:lnSpc>
+            </a:pPr>
+            <a:r>
+              <a:rPr sz="1100" b="1">
+                <a:solidFill>
+                  <a:srgbClr val="94A3B8"/>
+                </a:solidFill>
+                <a:latin typeface="Arial"/>
+              </a:rPr>
+              <a:t>Change</a:t>
+            </a:r>
+          </a:p>
+        </p:txBody>
+      </p:sp>
+      <p:sp>
+        <p:nvSpPr>
+          <p:cNvPr id="7" name="TextBox 6"/>
+          <p:cNvSpPr txBox="1"/>
+          <p:nvPr/>
+        </p:nvSpPr>
+        <p:spPr>
+          <a:xfrm>
+            <a:off x="5120640" y="1965960"/>
+            <a:ext cx="2834640" cy="320040"/>
+          </a:xfrm>
+          <a:prstGeom prst="rect">
+            <a:avLst/>
+          </a:prstGeom>
+          <a:noFill/>
+        </p:spPr>
+        <p:txBody>
+          <a:bodyPr wrap="square" lIns="73152" rIns="73152" tIns="36576" bIns="36576" anchor="ctr">
+            <a:spAutoFit/>
+          </a:bodyPr>
+          <a:lstStyle/>
+          <a:p>
+            <a:pPr algn="l">
+              <a:lnSpc>
+                <a:spcPct val="105000"/>
+              </a:lnSpc>
+            </a:pPr>
+            <a:r>
+              <a:rPr sz="1100" b="1">
+                <a:solidFill>
+                  <a:srgbClr val="94A3B8"/>
+                </a:solidFill>
+                <a:latin typeface="Arial"/>
+              </a:rPr>
+              <a:t>Test</a:t>
+            </a:r>
+          </a:p>
+        </p:txBody>
+      </p:sp>
+      <p:sp>
+        <p:nvSpPr>
+          <p:cNvPr id="8" name="TextBox 7"/>
+          <p:cNvSpPr txBox="1"/>
+          <p:nvPr/>
+        </p:nvSpPr>
+        <p:spPr>
+          <a:xfrm>
+            <a:off x="8092440" y="1965960"/>
+            <a:ext cx="3474720" cy="320040"/>
+          </a:xfrm>
+          <a:prstGeom prst="rect">
+            <a:avLst/>
+          </a:prstGeom>
+          <a:noFill/>
+        </p:spPr>
+        <p:txBody>
+          <a:bodyPr wrap="square" lIns="73152" rIns="73152" tIns="36576" bIns="36576" anchor="ctr">
+            <a:spAutoFit/>
+          </a:bodyPr>
+          <a:lstStyle/>
+          <a:p>
+            <a:pPr algn="l">
+              <a:lnSpc>
+                <a:spcPct val="105000"/>
+              </a:lnSpc>
+            </a:pPr>
+            <a:r>
+              <a:rPr sz="1100" b="1">
+                <a:solidFill>
+                  <a:srgbClr val="94A3B8"/>
+                </a:solidFill>
+                <a:latin typeface="Arial"/>
+              </a:rPr>
+              <a:t>Result</a:t>
+            </a:r>
+          </a:p>
+        </p:txBody>
+      </p:sp>
+      <p:sp>
+        <p:nvSpPr>
+          <p:cNvPr id="9" name="Rounded Rectangle 8"/>
+          <p:cNvSpPr/>
+          <p:nvPr/>
+        </p:nvSpPr>
+        <p:spPr>
+          <a:xfrm>
+            <a:off x="548640" y="2331720"/>
+            <a:ext cx="11091672" cy="713232"/>
+          </a:xfrm>
+          <a:prstGeom prst="roundRect">
+            <a:avLst>
+              <a:gd name="adj" fmla="val 6000"/>
+            </a:avLst>
+          </a:prstGeom>
+          <a:solidFill>
+            <a:srgbClr val="FFFFFF"/>
+          </a:solidFill>
+          <a:ln w="12700">
+            <a:solidFill>
+              <a:srgbClr val="E2E8F0"/>
+            </a:solidFill>
+          </a:ln>
+          <a:effectLst/>
+        </p:spPr>
+        <p:style>
+          <a:lnRef idx="1">
+            <a:schemeClr val="accent1"/>
+          </a:lnRef>
+          <a:fillRef idx="3">
+            <a:schemeClr val="accent1"/>
+          </a:fillRef>
+          <a:effectRef idx="2">
+            <a:schemeClr val="accent1"/>
+          </a:effectRef>
+          <a:fontRef idx="minor">
+            <a:schemeClr val="lt1"/>
+          </a:fontRef>
+        </p:style>
+        <p:txBody>
+          <a:bodyPr rtlCol="0" anchor="ctr"/>
+          <a:lstStyle/>
+          <a:p>
+            <a:pPr algn="ctr"/>
+          </a:p>
+        </p:txBody>
+      </p:sp>
+      <p:sp>
+        <p:nvSpPr>
+          <p:cNvPr id="10" name="TextBox 9"/>
+          <p:cNvSpPr txBox="1"/>
+          <p:nvPr/>
+        </p:nvSpPr>
+        <p:spPr>
+          <a:xfrm>
+            <a:off x="777240" y="2350008"/>
+            <a:ext cx="4206240" cy="676656"/>
+          </a:xfrm>
+          <a:prstGeom prst="rect">
+            <a:avLst/>
+          </a:prstGeom>
+          <a:noFill/>
+        </p:spPr>
+        <p:txBody>
+          <a:bodyPr wrap="square" lIns="73152" rIns="73152" tIns="36576" bIns="36576" anchor="ctr">
+            <a:spAutoFit/>
+          </a:bodyPr>
+          <a:lstStyle/>
+          <a:p>
+            <a:pPr algn="l">
+              <a:lnSpc>
+                <a:spcPct val="105000"/>
+              </a:lnSpc>
+            </a:pPr>
+            <a:r>
+              <a:rPr sz="1400" b="1">
+                <a:solidFill>
+                  <a:srgbClr val="0F172A"/>
+                </a:solidFill>
+                <a:latin typeface="Arial"/>
+              </a:rPr>
+              <a:t>Grafana agent: only the 28 read tools it needs, plus one standards doc</a:t>
+            </a:r>
+          </a:p>
+        </p:txBody>
+      </p:sp>
+      <p:sp>
+        <p:nvSpPr>
+          <p:cNvPr id="11" name="TextBox 10"/>
+          <p:cNvSpPr txBox="1"/>
+          <p:nvPr/>
+        </p:nvSpPr>
+        <p:spPr>
+          <a:xfrm>
+            <a:off x="5120640" y="2350008"/>
+            <a:ext cx="2834640" cy="676656"/>
+          </a:xfrm>
+          <a:prstGeom prst="rect">
+            <a:avLst/>
+          </a:prstGeom>
+          <a:noFill/>
+        </p:spPr>
+        <p:txBody>
+          <a:bodyPr wrap="square" lIns="73152" rIns="73152" tIns="36576" bIns="36576" anchor="ctr">
+            <a:spAutoFit/>
+          </a:bodyPr>
+          <a:lstStyle/>
+          <a:p>
+            <a:pPr algn="l">
+              <a:lnSpc>
+                <a:spcPct val="105000"/>
+              </a:lnSpc>
+            </a:pPr>
+            <a:r>
+              <a:rPr sz="1400" b="0">
+                <a:solidFill>
+                  <a:srgbClr val="475569"/>
+                </a:solidFill>
+                <a:latin typeface="Arial"/>
+              </a:rPr>
+              <a:t>Same alert, before and after</a:t>
+            </a:r>
+          </a:p>
+        </p:txBody>
+      </p:sp>
+      <p:sp>
+        <p:nvSpPr>
+          <p:cNvPr id="12" name="TextBox 11"/>
+          <p:cNvSpPr txBox="1"/>
+          <p:nvPr/>
+        </p:nvSpPr>
+        <p:spPr>
+          <a:xfrm>
+            <a:off x="8092440" y="2350008"/>
+            <a:ext cx="3474720" cy="676656"/>
+          </a:xfrm>
+          <a:prstGeom prst="rect">
+            <a:avLst/>
+          </a:prstGeom>
+          <a:noFill/>
+        </p:spPr>
+        <p:txBody>
+          <a:bodyPr wrap="square" lIns="73152" rIns="73152" tIns="36576" bIns="36576" anchor="ctr">
+            <a:spAutoFit/>
+          </a:bodyPr>
+          <a:lstStyle/>
+          <a:p>
+            <a:pPr algn="l">
+              <a:lnSpc>
+                <a:spcPct val="105000"/>
+              </a:lnSpc>
+            </a:pPr>
+            <a:r>
+              <a:rPr sz="1400" b="0">
+                <a:solidFill>
+                  <a:srgbClr val="0F766E"/>
+                </a:solidFill>
+                <a:latin typeface="Arial"/>
+              </a:rPr>
+              <a:t>$0.85 → $0.51 a run, 36 → 24 steps, and a better root cause</a:t>
+            </a:r>
+          </a:p>
+        </p:txBody>
+      </p:sp>
+      <p:sp>
+        <p:nvSpPr>
+          <p:cNvPr id="13" name="Rounded Rectangle 12"/>
+          <p:cNvSpPr/>
+          <p:nvPr/>
+        </p:nvSpPr>
+        <p:spPr>
+          <a:xfrm>
+            <a:off x="548640" y="3118103"/>
+            <a:ext cx="11091672" cy="713232"/>
+          </a:xfrm>
+          <a:prstGeom prst="roundRect">
+            <a:avLst>
+              <a:gd name="adj" fmla="val 6000"/>
+            </a:avLst>
+          </a:prstGeom>
+          <a:solidFill>
+            <a:srgbClr val="FFFFFF"/>
+          </a:solidFill>
+          <a:ln w="12700">
+            <a:solidFill>
+              <a:srgbClr val="E2E8F0"/>
+            </a:solidFill>
+          </a:ln>
+          <a:effectLst/>
+        </p:spPr>
+        <p:style>
+          <a:lnRef idx="1">
+            <a:schemeClr val="accent1"/>
+          </a:lnRef>
+          <a:fillRef idx="3">
+            <a:schemeClr val="accent1"/>
+          </a:fillRef>
+          <a:effectRef idx="2">
+            <a:schemeClr val="accent1"/>
+          </a:effectRef>
+          <a:fontRef idx="minor">
+            <a:schemeClr val="lt1"/>
+          </a:fontRef>
+        </p:style>
+        <p:txBody>
+          <a:bodyPr rtlCol="0" anchor="ctr"/>
+          <a:lstStyle/>
+          <a:p>
+            <a:pPr algn="ctr"/>
+          </a:p>
+        </p:txBody>
+      </p:sp>
+      <p:sp>
+        <p:nvSpPr>
+          <p:cNvPr id="14" name="TextBox 13"/>
+          <p:cNvSpPr txBox="1"/>
+          <p:nvPr/>
+        </p:nvSpPr>
+        <p:spPr>
+          <a:xfrm>
+            <a:off x="777240" y="3136391"/>
+            <a:ext cx="4206240" cy="676656"/>
+          </a:xfrm>
+          <a:prstGeom prst="rect">
+            <a:avLst/>
+          </a:prstGeom>
+          <a:noFill/>
+        </p:spPr>
+        <p:txBody>
+          <a:bodyPr wrap="square" lIns="73152" rIns="73152" tIns="36576" bIns="36576" anchor="ctr">
+            <a:spAutoFit/>
+          </a:bodyPr>
+          <a:lstStyle/>
+          <a:p>
+            <a:pPr algn="l">
+              <a:lnSpc>
+                <a:spcPct val="105000"/>
+              </a:lnSpc>
+            </a:pPr>
+            <a:r>
+              <a:rPr sz="1400" b="1">
+                <a:solidFill>
+                  <a:srgbClr val="0F172A"/>
+                </a:solidFill>
+                <a:latin typeface="Arial"/>
+              </a:rPr>
+              <a:t>Workflow budget: $40 a day, blocks new runs</a:t>
+            </a:r>
+          </a:p>
+        </p:txBody>
+      </p:sp>
+      <p:sp>
+        <p:nvSpPr>
+          <p:cNvPr id="15" name="TextBox 14"/>
+          <p:cNvSpPr txBox="1"/>
+          <p:nvPr/>
+        </p:nvSpPr>
+        <p:spPr>
+          <a:xfrm>
+            <a:off x="5120640" y="3136391"/>
+            <a:ext cx="2834640" cy="676656"/>
+          </a:xfrm>
+          <a:prstGeom prst="rect">
+            <a:avLst/>
+          </a:prstGeom>
+          <a:noFill/>
+        </p:spPr>
+        <p:txBody>
+          <a:bodyPr wrap="square" lIns="73152" rIns="73152" tIns="36576" bIns="36576" anchor="ctr">
+            <a:spAutoFit/>
+          </a:bodyPr>
+          <a:lstStyle/>
+          <a:p>
+            <a:pPr algn="l">
+              <a:lnSpc>
+                <a:spcPct val="105000"/>
+              </a:lnSpc>
+            </a:pPr>
+            <a:r>
+              <a:rPr sz="1400" b="0">
+                <a:solidFill>
+                  <a:srgbClr val="475569"/>
+                </a:solidFill>
+                <a:latin typeface="Arial"/>
+              </a:rPr>
+              <a:t>Cap lowered to $0.01, two alerts sent</a:t>
+            </a:r>
+          </a:p>
+        </p:txBody>
+      </p:sp>
+      <p:sp>
+        <p:nvSpPr>
+          <p:cNvPr id="16" name="TextBox 15"/>
+          <p:cNvSpPr txBox="1"/>
+          <p:nvPr/>
+        </p:nvSpPr>
+        <p:spPr>
+          <a:xfrm>
+            <a:off x="8092440" y="3136391"/>
+            <a:ext cx="3474720" cy="676656"/>
+          </a:xfrm>
+          <a:prstGeom prst="rect">
+            <a:avLst/>
+          </a:prstGeom>
+          <a:noFill/>
+        </p:spPr>
+        <p:txBody>
+          <a:bodyPr wrap="square" lIns="73152" rIns="73152" tIns="36576" bIns="36576" anchor="ctr">
+            <a:spAutoFit/>
+          </a:bodyPr>
+          <a:lstStyle/>
+          <a:p>
+            <a:pPr algn="l">
+              <a:lnSpc>
+                <a:spcPct val="105000"/>
+              </a:lnSpc>
+            </a:pPr>
+            <a:r>
+              <a:rPr sz="1400" b="0">
+                <a:solidFill>
+                  <a:srgbClr val="0F766E"/>
+                </a:solidFill>
+                <a:latin typeface="Arial"/>
+              </a:rPr>
+              <a:t>Second alert recorded but not investigated, with the reason</a:t>
+            </a:r>
+          </a:p>
+        </p:txBody>
+      </p:sp>
+      <p:sp>
+        <p:nvSpPr>
+          <p:cNvPr id="17" name="Rounded Rectangle 16"/>
+          <p:cNvSpPr/>
+          <p:nvPr/>
+        </p:nvSpPr>
+        <p:spPr>
+          <a:xfrm>
+            <a:off x="548640" y="3904487"/>
+            <a:ext cx="11091672" cy="713232"/>
+          </a:xfrm>
+          <a:prstGeom prst="roundRect">
+            <a:avLst>
+              <a:gd name="adj" fmla="val 6000"/>
+            </a:avLst>
+          </a:prstGeom>
+          <a:solidFill>
+            <a:srgbClr val="FFFFFF"/>
+          </a:solidFill>
+          <a:ln w="12700">
+            <a:solidFill>
+              <a:srgbClr val="E2E8F0"/>
+            </a:solidFill>
+          </a:ln>
+          <a:effectLst/>
+        </p:spPr>
+        <p:style>
+          <a:lnRef idx="1">
+            <a:schemeClr val="accent1"/>
+          </a:lnRef>
+          <a:fillRef idx="3">
+            <a:schemeClr val="accent1"/>
+          </a:fillRef>
+          <a:effectRef idx="2">
+            <a:schemeClr val="accent1"/>
+          </a:effectRef>
+          <a:fontRef idx="minor">
+            <a:schemeClr val="lt1"/>
+          </a:fontRef>
+        </p:style>
+        <p:txBody>
+          <a:bodyPr rtlCol="0" anchor="ctr"/>
+          <a:lstStyle/>
+          <a:p>
+            <a:pPr algn="ctr"/>
+          </a:p>
+        </p:txBody>
+      </p:sp>
+      <p:sp>
+        <p:nvSpPr>
+          <p:cNvPr id="18" name="TextBox 17"/>
+          <p:cNvSpPr txBox="1"/>
+          <p:nvPr/>
+        </p:nvSpPr>
+        <p:spPr>
+          <a:xfrm>
+            <a:off x="777240" y="3922775"/>
+            <a:ext cx="4206240" cy="676656"/>
+          </a:xfrm>
+          <a:prstGeom prst="rect">
+            <a:avLst/>
+          </a:prstGeom>
+          <a:noFill/>
+        </p:spPr>
+        <p:txBody>
+          <a:bodyPr wrap="square" lIns="73152" rIns="73152" tIns="36576" bIns="36576" anchor="ctr">
+            <a:spAutoFit/>
+          </a:bodyPr>
+          <a:lstStyle/>
+          <a:p>
+            <a:pPr algn="l">
+              <a:lnSpc>
+                <a:spcPct val="105000"/>
+              </a:lnSpc>
+            </a:pPr>
+            <a:r>
+              <a:rPr sz="1400" b="1">
+                <a:solidFill>
+                  <a:srgbClr val="0F172A"/>
+                </a:solidFill>
+                <a:latin typeface="Arial"/>
+              </a:rPr>
+              <a:t>Grafana agent: allow list instead of a deny list</a:t>
+            </a:r>
+          </a:p>
+        </p:txBody>
+      </p:sp>
+      <p:sp>
+        <p:nvSpPr>
+          <p:cNvPr id="19" name="TextBox 18"/>
+          <p:cNvSpPr txBox="1"/>
+          <p:nvPr/>
+        </p:nvSpPr>
+        <p:spPr>
+          <a:xfrm>
+            <a:off x="5120640" y="3922775"/>
+            <a:ext cx="2834640" cy="676656"/>
+          </a:xfrm>
+          <a:prstGeom prst="rect">
+            <a:avLst/>
+          </a:prstGeom>
+          <a:noFill/>
+        </p:spPr>
+        <p:txBody>
+          <a:bodyPr wrap="square" lIns="73152" rIns="73152" tIns="36576" bIns="36576" anchor="ctr">
+            <a:spAutoFit/>
+          </a:bodyPr>
+          <a:lstStyle/>
+          <a:p>
+            <a:pPr algn="l">
+              <a:lnSpc>
+                <a:spcPct val="105000"/>
+              </a:lnSpc>
+            </a:pPr>
+            <a:r>
+              <a:rPr sz="1400" b="0">
+                <a:solidFill>
+                  <a:srgbClr val="475569"/>
+                </a:solidFill>
+                <a:latin typeface="Arial"/>
+              </a:rPr>
+              <a:t>Asked for tools outside the list</a:t>
+            </a:r>
+          </a:p>
+        </p:txBody>
+      </p:sp>
+      <p:sp>
+        <p:nvSpPr>
+          <p:cNvPr id="20" name="TextBox 19"/>
+          <p:cNvSpPr txBox="1"/>
+          <p:nvPr/>
+        </p:nvSpPr>
+        <p:spPr>
+          <a:xfrm>
+            <a:off x="8092440" y="3922775"/>
+            <a:ext cx="3474720" cy="676656"/>
+          </a:xfrm>
+          <a:prstGeom prst="rect">
+            <a:avLst/>
+          </a:prstGeom>
+          <a:noFill/>
+        </p:spPr>
+        <p:txBody>
+          <a:bodyPr wrap="square" lIns="73152" rIns="73152" tIns="36576" bIns="36576" anchor="ctr">
+            <a:spAutoFit/>
+          </a:bodyPr>
+          <a:lstStyle/>
+          <a:p>
+            <a:pPr algn="l">
+              <a:lnSpc>
+                <a:spcPct val="105000"/>
+              </a:lnSpc>
+            </a:pPr>
+            <a:r>
+              <a:rPr sz="1400" b="0">
+                <a:solidFill>
+                  <a:srgbClr val="0F766E"/>
+                </a:solidFill>
+                <a:latin typeface="Arial"/>
+              </a:rPr>
+              <a:t>"Tool not found"</a:t>
+            </a:r>
+          </a:p>
+        </p:txBody>
+      </p:sp>
+      <p:sp>
+        <p:nvSpPr>
+          <p:cNvPr id="21" name="Rounded Rectangle 20"/>
+          <p:cNvSpPr/>
+          <p:nvPr/>
+        </p:nvSpPr>
+        <p:spPr>
+          <a:xfrm>
+            <a:off x="548640" y="4690872"/>
+            <a:ext cx="11091672" cy="713232"/>
+          </a:xfrm>
+          <a:prstGeom prst="roundRect">
+            <a:avLst>
+              <a:gd name="adj" fmla="val 6000"/>
+            </a:avLst>
+          </a:prstGeom>
+          <a:solidFill>
+            <a:srgbClr val="FFFFFF"/>
+          </a:solidFill>
+          <a:ln w="12700">
+            <a:solidFill>
+              <a:srgbClr val="E2E8F0"/>
+            </a:solidFill>
+          </a:ln>
+          <a:effectLst/>
+        </p:spPr>
+        <p:style>
+          <a:lnRef idx="1">
+            <a:schemeClr val="accent1"/>
+          </a:lnRef>
+          <a:fillRef idx="3">
+            <a:schemeClr val="accent1"/>
+          </a:fillRef>
+          <a:effectRef idx="2">
+            <a:schemeClr val="accent1"/>
+          </a:effectRef>
+          <a:fontRef idx="minor">
+            <a:schemeClr val="lt1"/>
+          </a:fontRef>
+        </p:style>
+        <p:txBody>
+          <a:bodyPr rtlCol="0" anchor="ctr"/>
+          <a:lstStyle/>
+          <a:p>
+            <a:pPr algn="ctr"/>
+          </a:p>
+        </p:txBody>
+      </p:sp>
+      <p:sp>
+        <p:nvSpPr>
+          <p:cNvPr id="22" name="TextBox 21"/>
+          <p:cNvSpPr txBox="1"/>
+          <p:nvPr/>
+        </p:nvSpPr>
+        <p:spPr>
+          <a:xfrm>
+            <a:off x="777240" y="4709159"/>
+            <a:ext cx="4206240" cy="676656"/>
+          </a:xfrm>
+          <a:prstGeom prst="rect">
+            <a:avLst/>
+          </a:prstGeom>
+          <a:noFill/>
+        </p:spPr>
+        <p:txBody>
+          <a:bodyPr wrap="square" lIns="73152" rIns="73152" tIns="36576" bIns="36576" anchor="ctr">
+            <a:spAutoFit/>
+          </a:bodyPr>
+          <a:lstStyle/>
+          <a:p>
+            <a:pPr algn="l">
+              <a:lnSpc>
+                <a:spcPct val="105000"/>
+              </a:lnSpc>
+            </a:pPr>
+            <a:r>
+              <a:rPr sz="1400" b="1">
+                <a:solidFill>
+                  <a:srgbClr val="0F172A"/>
+                </a:solidFill>
+                <a:latin typeface="Arial"/>
+              </a:rPr>
+              <a:t>Owner and team label on every agent</a:t>
+            </a:r>
+          </a:p>
+        </p:txBody>
+      </p:sp>
+      <p:sp>
+        <p:nvSpPr>
+          <p:cNvPr id="23" name="TextBox 22"/>
+          <p:cNvSpPr txBox="1"/>
+          <p:nvPr/>
+        </p:nvSpPr>
+        <p:spPr>
+          <a:xfrm>
+            <a:off x="5120640" y="4709159"/>
+            <a:ext cx="2834640" cy="676656"/>
+          </a:xfrm>
+          <a:prstGeom prst="rect">
+            <a:avLst/>
+          </a:prstGeom>
+          <a:noFill/>
+        </p:spPr>
+        <p:txBody>
+          <a:bodyPr wrap="square" lIns="73152" rIns="73152" tIns="36576" bIns="36576" anchor="ctr">
+            <a:spAutoFit/>
+          </a:bodyPr>
+          <a:lstStyle/>
+          <a:p>
+            <a:pPr algn="l">
+              <a:lnSpc>
+                <a:spcPct val="105000"/>
+              </a:lnSpc>
+            </a:pPr>
+            <a:r>
+              <a:rPr sz="1400" b="0">
+                <a:solidFill>
+                  <a:srgbClr val="475569"/>
+                </a:solidFill>
+                <a:latin typeface="Arial"/>
+              </a:rPr>
+              <a:t>Fleet filtered by owner</a:t>
+            </a:r>
+          </a:p>
+        </p:txBody>
+      </p:sp>
+      <p:sp>
+        <p:nvSpPr>
+          <p:cNvPr id="24" name="TextBox 23"/>
+          <p:cNvSpPr txBox="1"/>
+          <p:nvPr/>
+        </p:nvSpPr>
+        <p:spPr>
+          <a:xfrm>
+            <a:off x="8092440" y="4709159"/>
+            <a:ext cx="3474720" cy="676656"/>
+          </a:xfrm>
+          <a:prstGeom prst="rect">
+            <a:avLst/>
+          </a:prstGeom>
+          <a:noFill/>
+        </p:spPr>
+        <p:txBody>
+          <a:bodyPr wrap="square" lIns="73152" rIns="73152" tIns="36576" bIns="36576" anchor="ctr">
+            <a:spAutoFit/>
+          </a:bodyPr>
+          <a:lstStyle/>
+          <a:p>
+            <a:pPr algn="l">
+              <a:lnSpc>
+                <a:spcPct val="105000"/>
+              </a:lnSpc>
+            </a:pPr>
+            <a:r>
+              <a:rPr sz="1400" b="0">
+                <a:solidFill>
+                  <a:srgbClr val="0F766E"/>
+                </a:solidFill>
+                <a:latin typeface="Arial"/>
+              </a:rPr>
+              <a:t>Every agent has an owner to call</a:t>
+            </a:r>
+          </a:p>
+        </p:txBody>
+      </p:sp>
+      <p:sp>
+        <p:nvSpPr>
+          <p:cNvPr id="25" name="TextBox 24"/>
+          <p:cNvSpPr txBox="1"/>
+          <p:nvPr/>
+        </p:nvSpPr>
+        <p:spPr>
+          <a:xfrm>
+            <a:off x="548640" y="5897880"/>
+            <a:ext cx="11064240" cy="457200"/>
+          </a:xfrm>
+          <a:prstGeom prst="rect">
+            <a:avLst/>
+          </a:prstGeom>
+          <a:noFill/>
+        </p:spPr>
+        <p:txBody>
+          <a:bodyPr wrap="square" lIns="73152" rIns="73152" tIns="36576" bIns="36576" anchor="t">
+            <a:spAutoFit/>
+          </a:bodyPr>
+          <a:lstStyle/>
+          <a:p>
+            <a:pPr algn="l">
+              <a:lnSpc>
+                <a:spcPct val="110000"/>
+              </a:lnSpc>
+            </a:pPr>
+            <a:r>
+              <a:rPr sz="1100" b="0">
+                <a:solidFill>
+                  <a:srgbClr val="94A3B8"/>
+                </a:solidFill>
+                <a:latin typeface="Arial"/>
+              </a:rPr>
+              <a:t>Measured on 2026-10-26 (UTC). One run each, so the cost result is a direction, not a benchmark.</a:t>
             </a:r>
           </a:p>
         </p:txBody>
@@ -24285,7 +25323,7 @@
                 </a:solidFill>
                 <a:latin typeface="Arial"/>
               </a:rPr>
-              <a:t>WORKFLOW 2  ·  CODE REVIEW  ·  owned by the app team  ·  starts on any pull request</a:t>
+              <a:t>WORKFLOW 2  ·  CODE REVIEW  ·  owned by platform engineering  ·  starts on any pull request</a:t>
             </a:r>
           </a:p>
         </p:txBody>
@@ -27012,8 +28050,8 @@
         </p:nvSpPr>
         <p:spPr>
           <a:xfrm>
-            <a:off x="548640" y="5532120"/>
-            <a:ext cx="11091672" cy="868680"/>
+            <a:off x="548640" y="5468112"/>
+            <a:ext cx="11091672" cy="1024128"/>
           </a:xfrm>
           <a:prstGeom prst="roundRect">
             <a:avLst>
@@ -27058,7 +28096,7 @@
                 </a:solidFill>
                 <a:latin typeface="Arial"/>
               </a:rPr>
-              <a:t>VERIFIED ON THIS CLUSTER</a:t>
+              <a:t>VERIFIED IN THIS LAB</a:t>
             </a:r>
           </a:p>
           <a:p>
@@ -27068,13 +28106,47 @@
               </a:lnSpc>
             </a:pPr>
             <a:r>
-              <a:rPr sz="1500" b="0">
+              <a:rPr sz="1400" b="1">
                 <a:solidFill>
                   <a:srgbClr val="0F172A"/>
                 </a:solidFill>
                 <a:latin typeface="Arial"/>
               </a:rPr>
-              <a:t>KAOP's agent permissions checked with kubectl: reads pods, events, logs. Denied secrets, exec, delete, patch, scale.</a:t>
+              <a:t>Kubernetes RCA, checked with kubectl: </a:t>
+            </a:r>
+            <a:r>
+              <a:rPr sz="1400" b="0">
+                <a:solidFill>
+                  <a:srgbClr val="0F172A"/>
+                </a:solidFill>
+                <a:latin typeface="Arial"/>
+              </a:rPr>
+              <a:t>reads pods, events, logs. Denied secrets, exec, delete, patch, scale.</a:t>
+            </a:r>
+          </a:p>
+          <a:p>
+            <a:pPr algn="l">
+              <a:lnSpc>
+                <a:spcPct val="110000"/>
+              </a:lnSpc>
+            </a:pPr>
+            <a:r>
+              <a:rPr sz="1400" b="1">
+                <a:solidFill>
+                  <a:srgbClr val="0F172A"/>
+                </a:solidFill>
+                <a:latin typeface="Arial"/>
+              </a:rPr>
+              <a:t>Grafana investigator: </a:t>
+            </a:r>
+            <a:r>
+              <a:rPr sz="1400" b="0">
+                <a:solidFill>
+                  <a:srgbClr val="0F172A"/>
+                </a:solidFill>
+                <a:latin typeface="Arial"/>
+              </a:rPr>
+              <a:t>any tool outside its allow list comes back "Tool not found".</a:t>
             </a:r>
           </a:p>
         </p:txBody>

</xml_diff>

<commit_message>
Evidence and deck: repeated cost runs separate the allow list (cost) from the standards doc (answer quality)
Co-Authored-By: Claude Opus 5.5 <noreply@anthropic.com>
Claude-Session: https://claude.ai/code/session_01DptoPaaj14X3TGztKApoPN
</commit_message>
<xml_diff>
--- a/docs/presentation/KAOP_Customer_Pitch.pptx
+++ b/docs/presentation/KAOP_Customer_Pitch.pptx
@@ -14934,7 +14934,7 @@
         <p:spPr>
           <a:xfrm>
             <a:off x="548640" y="2331720"/>
-            <a:ext cx="11091672" cy="713232"/>
+            <a:ext cx="11091672" cy="621792"/>
           </a:xfrm>
           <a:prstGeom prst="roundRect">
             <a:avLst>
@@ -14982,7 +14982,7 @@
         <p:spPr>
           <a:xfrm>
             <a:off x="777240" y="2350008"/>
-            <a:ext cx="4206240" cy="676656"/>
+            <a:ext cx="4206240" cy="585216"/>
           </a:xfrm>
           <a:prstGeom prst="rect">
             <a:avLst/>
@@ -15007,7 +15007,7 @@
                 </a:solidFill>
                 <a:latin typeface="Arial"/>
               </a:rPr>
-              <a:t>Grafana agent: only the 28 read tools it needs, plus one standards doc</a:t>
+              <a:t>Grafana agent: only the 28 read tools it needs</a:t>
             </a:r>
           </a:p>
         </p:txBody>
@@ -15021,7 +15021,7 @@
         <p:spPr>
           <a:xfrm>
             <a:off x="5120640" y="2350008"/>
-            <a:ext cx="2834640" cy="676656"/>
+            <a:ext cx="2834640" cy="585216"/>
           </a:xfrm>
           <a:prstGeom prst="rect">
             <a:avLst/>
@@ -15046,7 +15046,7 @@
                 </a:solidFill>
                 <a:latin typeface="Arial"/>
               </a:rPr>
-              <a:t>Same alert, before and after</a:t>
+              <a:t>Same alert, 3–4 runs with and without</a:t>
             </a:r>
           </a:p>
         </p:txBody>
@@ -15060,7 +15060,7 @@
         <p:spPr>
           <a:xfrm>
             <a:off x="8092440" y="2350008"/>
-            <a:ext cx="3474720" cy="676656"/>
+            <a:ext cx="3474720" cy="585216"/>
           </a:xfrm>
           <a:prstGeom prst="rect">
             <a:avLst/>
@@ -15085,7 +15085,7 @@
                 </a:solidFill>
                 <a:latin typeface="Arial"/>
               </a:rPr>
-              <a:t>$0.85 → $0.51 a run, 36 → 24 steps, and a better root cause</a:t>
+              <a:t>About $0.71 → $0.53 a run. Same root cause</a:t>
             </a:r>
           </a:p>
         </p:txBody>
@@ -15098,8 +15098,8 @@
         </p:nvSpPr>
         <p:spPr>
           <a:xfrm>
-            <a:off x="548640" y="3118103"/>
-            <a:ext cx="11091672" cy="713232"/>
+            <a:off x="548640" y="3026663"/>
+            <a:ext cx="11091672" cy="621792"/>
           </a:xfrm>
           <a:prstGeom prst="roundRect">
             <a:avLst>
@@ -15146,8 +15146,8 @@
         </p:nvSpPr>
         <p:spPr>
           <a:xfrm>
-            <a:off x="777240" y="3136391"/>
-            <a:ext cx="4206240" cy="676656"/>
+            <a:off x="777240" y="3044951"/>
+            <a:ext cx="4206240" cy="585216"/>
           </a:xfrm>
           <a:prstGeom prst="rect">
             <a:avLst/>
@@ -15172,7 +15172,7 @@
                 </a:solidFill>
                 <a:latin typeface="Arial"/>
               </a:rPr>
-              <a:t>Workflow budget: $40 a day, blocks new runs</a:t>
+              <a:t>One standards doc for every incident agent</a:t>
             </a:r>
           </a:p>
         </p:txBody>
@@ -15185,8 +15185,8 @@
         </p:nvSpPr>
         <p:spPr>
           <a:xfrm>
-            <a:off x="5120640" y="3136391"/>
-            <a:ext cx="2834640" cy="676656"/>
+            <a:off x="5120640" y="3044951"/>
+            <a:ext cx="2834640" cy="585216"/>
           </a:xfrm>
           <a:prstGeom prst="rect">
             <a:avLst/>
@@ -15211,7 +15211,7 @@
                 </a:solidFill>
                 <a:latin typeface="Arial"/>
               </a:rPr>
-              <a:t>Cap lowered to $0.01, two alerts sent</a:t>
+              <a:t>Same alert, before and after the doc</a:t>
             </a:r>
           </a:p>
         </p:txBody>
@@ -15224,8 +15224,8 @@
         </p:nvSpPr>
         <p:spPr>
           <a:xfrm>
-            <a:off x="8092440" y="3136391"/>
-            <a:ext cx="3474720" cy="676656"/>
+            <a:off x="8092440" y="3044951"/>
+            <a:ext cx="3474720" cy="585216"/>
           </a:xfrm>
           <a:prstGeom prst="rect">
             <a:avLst/>
@@ -15250,7 +15250,7 @@
                 </a:solidFill>
                 <a:latin typeface="Arial"/>
               </a:rPr>
-              <a:t>Second alert recorded but not investigated, with the reason</a:t>
+              <a:t>Every run quotes our rule and runbook. Cost about the same</a:t>
             </a:r>
           </a:p>
         </p:txBody>
@@ -15263,8 +15263,8 @@
         </p:nvSpPr>
         <p:spPr>
           <a:xfrm>
-            <a:off x="548640" y="3904487"/>
-            <a:ext cx="11091672" cy="713232"/>
+            <a:off x="548640" y="3721608"/>
+            <a:ext cx="11091672" cy="621792"/>
           </a:xfrm>
           <a:prstGeom prst="roundRect">
             <a:avLst>
@@ -15311,8 +15311,8 @@
         </p:nvSpPr>
         <p:spPr>
           <a:xfrm>
-            <a:off x="777240" y="3922775"/>
-            <a:ext cx="4206240" cy="676656"/>
+            <a:off x="777240" y="3739896"/>
+            <a:ext cx="4206240" cy="585216"/>
           </a:xfrm>
           <a:prstGeom prst="rect">
             <a:avLst/>
@@ -15337,7 +15337,7 @@
                 </a:solidFill>
                 <a:latin typeface="Arial"/>
               </a:rPr>
-              <a:t>Grafana agent: allow list instead of a deny list</a:t>
+              <a:t>Workflow budget: $40 a day, blocks new runs</a:t>
             </a:r>
           </a:p>
         </p:txBody>
@@ -15350,8 +15350,8 @@
         </p:nvSpPr>
         <p:spPr>
           <a:xfrm>
-            <a:off x="5120640" y="3922775"/>
-            <a:ext cx="2834640" cy="676656"/>
+            <a:off x="5120640" y="3739896"/>
+            <a:ext cx="2834640" cy="585216"/>
           </a:xfrm>
           <a:prstGeom prst="rect">
             <a:avLst/>
@@ -15376,7 +15376,7 @@
                 </a:solidFill>
                 <a:latin typeface="Arial"/>
               </a:rPr>
-              <a:t>Asked for tools outside the list</a:t>
+              <a:t>Cap lowered to $0.01, two alerts sent</a:t>
             </a:r>
           </a:p>
         </p:txBody>
@@ -15389,8 +15389,8 @@
         </p:nvSpPr>
         <p:spPr>
           <a:xfrm>
-            <a:off x="8092440" y="3922775"/>
-            <a:ext cx="3474720" cy="676656"/>
+            <a:off x="8092440" y="3739896"/>
+            <a:ext cx="3474720" cy="585216"/>
           </a:xfrm>
           <a:prstGeom prst="rect">
             <a:avLst/>
@@ -15415,7 +15415,7 @@
                 </a:solidFill>
                 <a:latin typeface="Arial"/>
               </a:rPr>
-              <a:t>"Tool not found"</a:t>
+              <a:t>Second alert recorded but not investigated, with the reason</a:t>
             </a:r>
           </a:p>
         </p:txBody>
@@ -15428,8 +15428,8 @@
         </p:nvSpPr>
         <p:spPr>
           <a:xfrm>
-            <a:off x="548640" y="4690872"/>
-            <a:ext cx="11091672" cy="713232"/>
+            <a:off x="548640" y="4416552"/>
+            <a:ext cx="11091672" cy="621792"/>
           </a:xfrm>
           <a:prstGeom prst="roundRect">
             <a:avLst>
@@ -15476,8 +15476,8 @@
         </p:nvSpPr>
         <p:spPr>
           <a:xfrm>
-            <a:off x="777240" y="4709159"/>
-            <a:ext cx="4206240" cy="676656"/>
+            <a:off x="777240" y="4434840"/>
+            <a:ext cx="4206240" cy="585216"/>
           </a:xfrm>
           <a:prstGeom prst="rect">
             <a:avLst/>
@@ -15502,6 +15502,171 @@
                 </a:solidFill>
                 <a:latin typeface="Arial"/>
               </a:rPr>
+              <a:t>Grafana agent: allow list instead of a deny list</a:t>
+            </a:r>
+          </a:p>
+        </p:txBody>
+      </p:sp>
+      <p:sp>
+        <p:nvSpPr>
+          <p:cNvPr id="23" name="TextBox 22"/>
+          <p:cNvSpPr txBox="1"/>
+          <p:nvPr/>
+        </p:nvSpPr>
+        <p:spPr>
+          <a:xfrm>
+            <a:off x="5120640" y="4434840"/>
+            <a:ext cx="2834640" cy="585216"/>
+          </a:xfrm>
+          <a:prstGeom prst="rect">
+            <a:avLst/>
+          </a:prstGeom>
+          <a:noFill/>
+        </p:spPr>
+        <p:txBody>
+          <a:bodyPr wrap="square" lIns="73152" rIns="73152" tIns="36576" bIns="36576" anchor="ctr">
+            <a:spAutoFit/>
+          </a:bodyPr>
+          <a:lstStyle/>
+          <a:p>
+            <a:pPr algn="l">
+              <a:lnSpc>
+                <a:spcPct val="105000"/>
+              </a:lnSpc>
+            </a:pPr>
+            <a:r>
+              <a:rPr sz="1400" b="0">
+                <a:solidFill>
+                  <a:srgbClr val="475569"/>
+                </a:solidFill>
+                <a:latin typeface="Arial"/>
+              </a:rPr>
+              <a:t>Asked for tools outside the list</a:t>
+            </a:r>
+          </a:p>
+        </p:txBody>
+      </p:sp>
+      <p:sp>
+        <p:nvSpPr>
+          <p:cNvPr id="24" name="TextBox 23"/>
+          <p:cNvSpPr txBox="1"/>
+          <p:nvPr/>
+        </p:nvSpPr>
+        <p:spPr>
+          <a:xfrm>
+            <a:off x="8092440" y="4434840"/>
+            <a:ext cx="3474720" cy="585216"/>
+          </a:xfrm>
+          <a:prstGeom prst="rect">
+            <a:avLst/>
+          </a:prstGeom>
+          <a:noFill/>
+        </p:spPr>
+        <p:txBody>
+          <a:bodyPr wrap="square" lIns="73152" rIns="73152" tIns="36576" bIns="36576" anchor="ctr">
+            <a:spAutoFit/>
+          </a:bodyPr>
+          <a:lstStyle/>
+          <a:p>
+            <a:pPr algn="l">
+              <a:lnSpc>
+                <a:spcPct val="105000"/>
+              </a:lnSpc>
+            </a:pPr>
+            <a:r>
+              <a:rPr sz="1400" b="0">
+                <a:solidFill>
+                  <a:srgbClr val="0F766E"/>
+                </a:solidFill>
+                <a:latin typeface="Arial"/>
+              </a:rPr>
+              <a:t>"Not permitted" / "Tool not found"</a:t>
+            </a:r>
+          </a:p>
+        </p:txBody>
+      </p:sp>
+      <p:sp>
+        <p:nvSpPr>
+          <p:cNvPr id="25" name="Rounded Rectangle 24"/>
+          <p:cNvSpPr/>
+          <p:nvPr/>
+        </p:nvSpPr>
+        <p:spPr>
+          <a:xfrm>
+            <a:off x="548640" y="5111496"/>
+            <a:ext cx="11091672" cy="621792"/>
+          </a:xfrm>
+          <a:prstGeom prst="roundRect">
+            <a:avLst>
+              <a:gd name="adj" fmla="val 6000"/>
+            </a:avLst>
+          </a:prstGeom>
+          <a:solidFill>
+            <a:srgbClr val="FFFFFF"/>
+          </a:solidFill>
+          <a:ln w="12700">
+            <a:solidFill>
+              <a:srgbClr val="E2E8F0"/>
+            </a:solidFill>
+          </a:ln>
+          <a:effectLst/>
+        </p:spPr>
+        <p:style>
+          <a:lnRef idx="1">
+            <a:schemeClr val="accent1"/>
+          </a:lnRef>
+          <a:fillRef idx="3">
+            <a:schemeClr val="accent1"/>
+          </a:fillRef>
+          <a:effectRef idx="2">
+            <a:schemeClr val="accent1"/>
+          </a:effectRef>
+          <a:fontRef idx="minor">
+            <a:schemeClr val="lt1"/>
+          </a:fontRef>
+        </p:style>
+        <p:txBody>
+          <a:bodyPr rtlCol="0" anchor="ctr"/>
+          <a:lstStyle/>
+          <a:p>
+            <a:pPr algn="ctr"/>
+          </a:p>
+        </p:txBody>
+      </p:sp>
+      <p:sp>
+        <p:nvSpPr>
+          <p:cNvPr id="26" name="TextBox 25"/>
+          <p:cNvSpPr txBox="1"/>
+          <p:nvPr/>
+        </p:nvSpPr>
+        <p:spPr>
+          <a:xfrm>
+            <a:off x="777240" y="5129783"/>
+            <a:ext cx="4206240" cy="585216"/>
+          </a:xfrm>
+          <a:prstGeom prst="rect">
+            <a:avLst/>
+          </a:prstGeom>
+          <a:noFill/>
+        </p:spPr>
+        <p:txBody>
+          <a:bodyPr wrap="square" lIns="73152" rIns="73152" tIns="36576" bIns="36576" anchor="ctr">
+            <a:spAutoFit/>
+          </a:bodyPr>
+          <a:lstStyle/>
+          <a:p>
+            <a:pPr algn="l">
+              <a:lnSpc>
+                <a:spcPct val="105000"/>
+              </a:lnSpc>
+            </a:pPr>
+            <a:r>
+              <a:rPr sz="1400" b="1">
+                <a:solidFill>
+                  <a:srgbClr val="0F172A"/>
+                </a:solidFill>
+                <a:latin typeface="Arial"/>
+              </a:rPr>
               <a:t>Owner and team label on every agent</a:t>
             </a:r>
           </a:p>
@@ -15509,14 +15674,14 @@
       </p:sp>
       <p:sp>
         <p:nvSpPr>
-          <p:cNvPr id="23" name="TextBox 22"/>
-          <p:cNvSpPr txBox="1"/>
-          <p:nvPr/>
-        </p:nvSpPr>
-        <p:spPr>
-          <a:xfrm>
-            <a:off x="5120640" y="4709159"/>
-            <a:ext cx="2834640" cy="676656"/>
+          <p:cNvPr id="27" name="TextBox 26"/>
+          <p:cNvSpPr txBox="1"/>
+          <p:nvPr/>
+        </p:nvSpPr>
+        <p:spPr>
+          <a:xfrm>
+            <a:off x="5120640" y="5129783"/>
+            <a:ext cx="2834640" cy="585216"/>
           </a:xfrm>
           <a:prstGeom prst="rect">
             <a:avLst/>
@@ -15548,14 +15713,14 @@
       </p:sp>
       <p:sp>
         <p:nvSpPr>
-          <p:cNvPr id="24" name="TextBox 23"/>
-          <p:cNvSpPr txBox="1"/>
-          <p:nvPr/>
-        </p:nvSpPr>
-        <p:spPr>
-          <a:xfrm>
-            <a:off x="8092440" y="4709159"/>
-            <a:ext cx="3474720" cy="676656"/>
+          <p:cNvPr id="28" name="TextBox 27"/>
+          <p:cNvSpPr txBox="1"/>
+          <p:nvPr/>
+        </p:nvSpPr>
+        <p:spPr>
+          <a:xfrm>
+            <a:off x="8092440" y="5129783"/>
+            <a:ext cx="3474720" cy="585216"/>
           </a:xfrm>
           <a:prstGeom prst="rect">
             <a:avLst/>
@@ -15587,13 +15752,13 @@
       </p:sp>
       <p:sp>
         <p:nvSpPr>
-          <p:cNvPr id="25" name="TextBox 24"/>
-          <p:cNvSpPr txBox="1"/>
-          <p:nvPr/>
-        </p:nvSpPr>
-        <p:spPr>
-          <a:xfrm>
-            <a:off x="548640" y="5897880"/>
+          <p:cNvPr id="29" name="TextBox 28"/>
+          <p:cNvSpPr txBox="1"/>
+          <p:nvPr/>
+        </p:nvSpPr>
+        <p:spPr>
+          <a:xfrm>
+            <a:off x="548640" y="5943600"/>
             <a:ext cx="11064240" cy="457200"/>
           </a:xfrm>
           <a:prstGeom prst="rect">
@@ -15619,7 +15784,7 @@
                 </a:solidFill>
                 <a:latin typeface="Arial"/>
               </a:rPr>
-              <a:t>Measured on 2026-10-26 (UTC). One run each, so the cost result is a direction, not a benchmark.</a:t>
+              <a:t>Measured on 2026-10-25 and 2026-10-26 (UTC). Identical runs vary by about 20 cents, so read the cost result as a direction, not a benchmark.</a:t>
             </a:r>
           </a:p>
         </p:txBody>

</xml_diff>

<commit_message>
Deck: slide 5 pairs each customer problem with what KAOP does
Co-Authored-By: Claude Opus 5.5 <noreply@anthropic.com>
Claude-Session: https://claude.ai/code/session_01DptoPaaj14X3TGztKApoPN
</commit_message>
<xml_diff>
--- a/docs/presentation/KAOP_Customer_Pitch.pptx
+++ b/docs/presentation/KAOP_Customer_Pitch.pptx
@@ -20549,7 +20549,7 @@
                 </a:solidFill>
                 <a:latin typeface="Arial"/>
               </a:rPr>
-              <a:t>The context, memory and governance Komodor built for its own agents, ready for yours from day one.</a:t>
+              <a:t>Each problem you have today, and what KAOP does about it.</a:t>
             </a:r>
           </a:p>
         </p:txBody>
@@ -20562,8 +20562,127 @@
         </p:nvSpPr>
         <p:spPr>
           <a:xfrm>
-            <a:off x="548640" y="2057400"/>
-            <a:ext cx="2670048" cy="3291840"/>
+            <a:off x="548640" y="2011680"/>
+            <a:ext cx="2670048" cy="914400"/>
+          </a:xfrm>
+          <a:prstGeom prst="roundRect">
+            <a:avLst>
+              <a:gd name="adj" fmla="val 8000"/>
+            </a:avLst>
+          </a:prstGeom>
+          <a:solidFill>
+            <a:srgbClr val="FEF2F2"/>
+          </a:solidFill>
+          <a:ln>
+            <a:noFill/>
+          </a:ln>
+          <a:effectLst/>
+        </p:spPr>
+        <p:style>
+          <a:lnRef idx="1">
+            <a:schemeClr val="accent1"/>
+          </a:lnRef>
+          <a:fillRef idx="3">
+            <a:schemeClr val="accent1"/>
+          </a:fillRef>
+          <a:effectRef idx="2">
+            <a:schemeClr val="accent1"/>
+          </a:effectRef>
+          <a:fontRef idx="minor">
+            <a:schemeClr val="lt1"/>
+          </a:fontRef>
+        </p:style>
+        <p:txBody>
+          <a:bodyPr rtlCol="0" anchor="t" wrap="square" lIns="73152" rIns="73152" tIns="36576" bIns="36576"/>
+          <a:lstStyle/>
+          <a:p>
+            <a:pPr algn="l">
+              <a:lnSpc>
+                <a:spcPct val="105000"/>
+              </a:lnSpc>
+            </a:pPr>
+            <a:r>
+              <a:rPr sz="1000" b="1">
+                <a:solidFill>
+                  <a:srgbClr val="B91C1C"/>
+                </a:solidFill>
+                <a:latin typeface="Arial"/>
+              </a:rPr>
+              <a:t>TODAY</a:t>
+            </a:r>
+          </a:p>
+          <a:p>
+            <a:pPr algn="l">
+              <a:lnSpc>
+                <a:spcPct val="105000"/>
+              </a:lnSpc>
+            </a:pPr>
+            <a:r>
+              <a:rPr sz="1350" b="0">
+                <a:solidFill>
+                  <a:srgbClr val="0F172A"/>
+                </a:solidFill>
+                <a:latin typeface="Arial"/>
+              </a:rPr>
+              <a:t>Every team builds its agents from scratch.</a:t>
+            </a:r>
+          </a:p>
+        </p:txBody>
+      </p:sp>
+      <p:sp>
+        <p:nvSpPr>
+          <p:cNvPr id="7" name="Down Arrow 6"/>
+          <p:cNvSpPr/>
+          <p:nvPr/>
+        </p:nvSpPr>
+        <p:spPr>
+          <a:xfrm>
+            <a:off x="1737360" y="2990088"/>
+            <a:ext cx="219456" cy="274320"/>
+          </a:xfrm>
+          <a:prstGeom prst="downArrow">
+            <a:avLst/>
+          </a:prstGeom>
+          <a:solidFill>
+            <a:srgbClr val="94A3B8"/>
+          </a:solidFill>
+          <a:ln>
+            <a:noFill/>
+          </a:ln>
+          <a:effectLst/>
+        </p:spPr>
+        <p:style>
+          <a:lnRef idx="1">
+            <a:schemeClr val="accent1"/>
+          </a:lnRef>
+          <a:fillRef idx="3">
+            <a:schemeClr val="accent1"/>
+          </a:fillRef>
+          <a:effectRef idx="2">
+            <a:schemeClr val="accent1"/>
+          </a:effectRef>
+          <a:fontRef idx="minor">
+            <a:schemeClr val="lt1"/>
+          </a:fontRef>
+        </p:style>
+        <p:txBody>
+          <a:bodyPr rtlCol="0" anchor="ctr"/>
+          <a:lstStyle/>
+          <a:p>
+            <a:pPr algn="ctr"/>
+          </a:p>
+        </p:txBody>
+      </p:sp>
+      <p:sp>
+        <p:nvSpPr>
+          <p:cNvPr id="8" name="Rounded Rectangle 7"/>
+          <p:cNvSpPr/>
+          <p:nvPr/>
+        </p:nvSpPr>
+        <p:spPr>
+          <a:xfrm>
+            <a:off x="548640" y="3337560"/>
+            <a:ext cx="2670048" cy="2148840"/>
           </a:xfrm>
           <a:prstGeom prst="roundRect">
             <a:avLst>
@@ -20604,13 +20723,13 @@
       </p:sp>
       <p:sp>
         <p:nvSpPr>
-          <p:cNvPr id="7" name="Rectangle 6"/>
+          <p:cNvPr id="9" name="Rectangle 8"/>
           <p:cNvSpPr/>
           <p:nvPr/>
         </p:nvSpPr>
         <p:spPr>
           <a:xfrm>
-            <a:off x="777240" y="2331720"/>
+            <a:off x="777240" y="3611879"/>
             <a:ext cx="73152" cy="457200"/>
           </a:xfrm>
           <a:prstGeom prst="rect">
@@ -20648,13 +20767,13 @@
       </p:sp>
       <p:sp>
         <p:nvSpPr>
-          <p:cNvPr id="8" name="TextBox 7"/>
+          <p:cNvPr id="10" name="TextBox 9"/>
           <p:cNvSpPr txBox="1"/>
           <p:nvPr/>
         </p:nvSpPr>
         <p:spPr>
           <a:xfrm>
-            <a:off x="932688" y="2258568"/>
+            <a:off x="932688" y="3538728"/>
             <a:ext cx="2121408" cy="274320"/>
           </a:xfrm>
           <a:prstGeom prst="rect">
@@ -20687,13 +20806,13 @@
       </p:sp>
       <p:sp>
         <p:nvSpPr>
-          <p:cNvPr id="9" name="TextBox 8"/>
+          <p:cNvPr id="11" name="TextBox 10"/>
           <p:cNvSpPr txBox="1"/>
           <p:nvPr/>
         </p:nvSpPr>
         <p:spPr>
           <a:xfrm>
-            <a:off x="932688" y="2514600"/>
+            <a:off x="932688" y="3794760"/>
             <a:ext cx="2121408" cy="548640"/>
           </a:xfrm>
           <a:prstGeom prst="rect">
@@ -20713,27 +20832,27 @@
               </a:lnSpc>
             </a:pPr>
             <a:r>
-              <a:rPr sz="1800" b="1">
+              <a:rPr sz="1700" b="1">
                 <a:solidFill>
                   <a:srgbClr val="0F172A"/>
                 </a:solidFill>
                 <a:latin typeface="Arial"/>
               </a:rPr>
-              <a:t>Start ready, or bring your own</a:t>
-            </a:r>
-          </a:p>
-        </p:txBody>
-      </p:sp>
-      <p:sp>
-        <p:nvSpPr>
-          <p:cNvPr id="10" name="TextBox 9"/>
+              <a:t>Start from 50+ ready agents</a:t>
+            </a:r>
+          </a:p>
+        </p:txBody>
+      </p:sp>
+      <p:sp>
+        <p:nvSpPr>
+          <p:cNvPr id="12" name="TextBox 11"/>
           <p:cNvSpPr txBox="1"/>
           <p:nvPr/>
         </p:nvSpPr>
         <p:spPr>
           <a:xfrm>
-            <a:off x="777240" y="3383280"/>
-            <a:ext cx="2258568" cy="1828800"/>
+            <a:off x="777240" y="4526280"/>
+            <a:ext cx="2258568" cy="822960"/>
           </a:xfrm>
           <a:prstGeom prst="rect">
             <a:avLst/>
@@ -20752,27 +20871,146 @@
               </a:lnSpc>
             </a:pPr>
             <a:r>
-              <a:rPr sz="1550" b="0">
+              <a:rPr sz="1450" b="0">
                 <a:solidFill>
                   <a:srgbClr val="475569"/>
                 </a:solidFill>
                 <a:latin typeface="Arial"/>
               </a:rPr>
-              <a:t>50+ ready agents and workflows. Yours get the same controls.</a:t>
-            </a:r>
-          </a:p>
-        </p:txBody>
-      </p:sp>
-      <p:sp>
-        <p:nvSpPr>
-          <p:cNvPr id="11" name="Rounded Rectangle 10"/>
+              <a:t>Or bring your own. Same controls.</a:t>
+            </a:r>
+          </a:p>
+        </p:txBody>
+      </p:sp>
+      <p:sp>
+        <p:nvSpPr>
+          <p:cNvPr id="13" name="Rounded Rectangle 12"/>
           <p:cNvSpPr/>
           <p:nvPr/>
         </p:nvSpPr>
         <p:spPr>
           <a:xfrm>
-            <a:off x="3355848" y="2057400"/>
-            <a:ext cx="2670048" cy="3291840"/>
+            <a:off x="3355848" y="2011680"/>
+            <a:ext cx="2670048" cy="914400"/>
+          </a:xfrm>
+          <a:prstGeom prst="roundRect">
+            <a:avLst>
+              <a:gd name="adj" fmla="val 8000"/>
+            </a:avLst>
+          </a:prstGeom>
+          <a:solidFill>
+            <a:srgbClr val="FEF2F2"/>
+          </a:solidFill>
+          <a:ln>
+            <a:noFill/>
+          </a:ln>
+          <a:effectLst/>
+        </p:spPr>
+        <p:style>
+          <a:lnRef idx="1">
+            <a:schemeClr val="accent1"/>
+          </a:lnRef>
+          <a:fillRef idx="3">
+            <a:schemeClr val="accent1"/>
+          </a:fillRef>
+          <a:effectRef idx="2">
+            <a:schemeClr val="accent1"/>
+          </a:effectRef>
+          <a:fontRef idx="minor">
+            <a:schemeClr val="lt1"/>
+          </a:fontRef>
+        </p:style>
+        <p:txBody>
+          <a:bodyPr rtlCol="0" anchor="t" wrap="square" lIns="73152" rIns="73152" tIns="36576" bIns="36576"/>
+          <a:lstStyle/>
+          <a:p>
+            <a:pPr algn="l">
+              <a:lnSpc>
+                <a:spcPct val="105000"/>
+              </a:lnSpc>
+            </a:pPr>
+            <a:r>
+              <a:rPr sz="1000" b="1">
+                <a:solidFill>
+                  <a:srgbClr val="B91C1C"/>
+                </a:solidFill>
+                <a:latin typeface="Arial"/>
+              </a:rPr>
+              <a:t>TODAY</a:t>
+            </a:r>
+          </a:p>
+          <a:p>
+            <a:pPr algn="l">
+              <a:lnSpc>
+                <a:spcPct val="105000"/>
+              </a:lnSpc>
+            </a:pPr>
+            <a:r>
+              <a:rPr sz="1350" b="0">
+                <a:solidFill>
+                  <a:srgbClr val="0F172A"/>
+                </a:solidFill>
+                <a:latin typeface="Arial"/>
+              </a:rPr>
+              <a:t>Alert, investigation and fix sit in three tools.</a:t>
+            </a:r>
+          </a:p>
+        </p:txBody>
+      </p:sp>
+      <p:sp>
+        <p:nvSpPr>
+          <p:cNvPr id="14" name="Down Arrow 13"/>
+          <p:cNvSpPr/>
+          <p:nvPr/>
+        </p:nvSpPr>
+        <p:spPr>
+          <a:xfrm>
+            <a:off x="4544568" y="2990088"/>
+            <a:ext cx="219456" cy="274320"/>
+          </a:xfrm>
+          <a:prstGeom prst="downArrow">
+            <a:avLst/>
+          </a:prstGeom>
+          <a:solidFill>
+            <a:srgbClr val="94A3B8"/>
+          </a:solidFill>
+          <a:ln>
+            <a:noFill/>
+          </a:ln>
+          <a:effectLst/>
+        </p:spPr>
+        <p:style>
+          <a:lnRef idx="1">
+            <a:schemeClr val="accent1"/>
+          </a:lnRef>
+          <a:fillRef idx="3">
+            <a:schemeClr val="accent1"/>
+          </a:fillRef>
+          <a:effectRef idx="2">
+            <a:schemeClr val="accent1"/>
+          </a:effectRef>
+          <a:fontRef idx="minor">
+            <a:schemeClr val="lt1"/>
+          </a:fontRef>
+        </p:style>
+        <p:txBody>
+          <a:bodyPr rtlCol="0" anchor="ctr"/>
+          <a:lstStyle/>
+          <a:p>
+            <a:pPr algn="ctr"/>
+          </a:p>
+        </p:txBody>
+      </p:sp>
+      <p:sp>
+        <p:nvSpPr>
+          <p:cNvPr id="15" name="Rounded Rectangle 14"/>
+          <p:cNvSpPr/>
+          <p:nvPr/>
+        </p:nvSpPr>
+        <p:spPr>
+          <a:xfrm>
+            <a:off x="3355848" y="3337560"/>
+            <a:ext cx="2670048" cy="2148840"/>
           </a:xfrm>
           <a:prstGeom prst="roundRect">
             <a:avLst>
@@ -20813,13 +21051,13 @@
       </p:sp>
       <p:sp>
         <p:nvSpPr>
-          <p:cNvPr id="12" name="Rectangle 11"/>
+          <p:cNvPr id="16" name="Rectangle 15"/>
           <p:cNvSpPr/>
           <p:nvPr/>
         </p:nvSpPr>
         <p:spPr>
           <a:xfrm>
-            <a:off x="3584448" y="2331720"/>
+            <a:off x="3584448" y="3611879"/>
             <a:ext cx="73152" cy="457200"/>
           </a:xfrm>
           <a:prstGeom prst="rect">
@@ -20857,13 +21095,13 @@
       </p:sp>
       <p:sp>
         <p:nvSpPr>
-          <p:cNvPr id="13" name="TextBox 12"/>
+          <p:cNvPr id="17" name="TextBox 16"/>
           <p:cNvSpPr txBox="1"/>
           <p:nvPr/>
         </p:nvSpPr>
         <p:spPr>
           <a:xfrm>
-            <a:off x="3739896" y="2258568"/>
+            <a:off x="3739896" y="3538728"/>
             <a:ext cx="2121408" cy="274320"/>
           </a:xfrm>
           <a:prstGeom prst="rect">
@@ -20896,13 +21134,13 @@
       </p:sp>
       <p:sp>
         <p:nvSpPr>
-          <p:cNvPr id="14" name="TextBox 13"/>
+          <p:cNvPr id="18" name="TextBox 17"/>
           <p:cNvSpPr txBox="1"/>
           <p:nvPr/>
         </p:nvSpPr>
         <p:spPr>
           <a:xfrm>
-            <a:off x="3739896" y="2514600"/>
+            <a:off x="3739896" y="3794760"/>
             <a:ext cx="2121408" cy="548640"/>
           </a:xfrm>
           <a:prstGeom prst="rect">
@@ -20922,27 +21160,27 @@
               </a:lnSpc>
             </a:pPr>
             <a:r>
-              <a:rPr sz="1800" b="1">
+              <a:rPr sz="1700" b="1">
                 <a:solidFill>
                   <a:srgbClr val="0F172A"/>
                 </a:solidFill>
                 <a:latin typeface="Arial"/>
               </a:rPr>
-              <a:t>Real triggers, real workflows</a:t>
-            </a:r>
-          </a:p>
-        </p:txBody>
-      </p:sp>
-      <p:sp>
-        <p:nvSpPr>
-          <p:cNvPr id="15" name="TextBox 14"/>
+              <a:t>One workflow, one record</a:t>
+            </a:r>
+          </a:p>
+        </p:txBody>
+      </p:sp>
+      <p:sp>
+        <p:nvSpPr>
+          <p:cNvPr id="19" name="TextBox 18"/>
           <p:cNvSpPr txBox="1"/>
           <p:nvPr/>
         </p:nvSpPr>
         <p:spPr>
           <a:xfrm>
-            <a:off x="3584448" y="3383280"/>
-            <a:ext cx="2258568" cy="1828800"/>
+            <a:off x="3584448" y="4526280"/>
+            <a:ext cx="2258568" cy="822960"/>
           </a:xfrm>
           <a:prstGeom prst="rect">
             <a:avLst/>
@@ -20961,27 +21199,146 @@
               </a:lnSpc>
             </a:pPr>
             <a:r>
-              <a:rPr sz="1550" b="0">
+              <a:rPr sz="1450" b="0">
                 <a:solidFill>
                   <a:srgbClr val="475569"/>
                 </a:solidFill>
                 <a:latin typeface="Arial"/>
               </a:rPr>
-              <a:t>Alerts start the work. Specialists hand off. One record.</a:t>
-            </a:r>
-          </a:p>
-        </p:txBody>
-      </p:sp>
-      <p:sp>
-        <p:nvSpPr>
-          <p:cNvPr id="16" name="Rounded Rectangle 15"/>
+              <a:t>Alerts start the work. Agents hand off.</a:t>
+            </a:r>
+          </a:p>
+        </p:txBody>
+      </p:sp>
+      <p:sp>
+        <p:nvSpPr>
+          <p:cNvPr id="20" name="Rounded Rectangle 19"/>
           <p:cNvSpPr/>
           <p:nvPr/>
         </p:nvSpPr>
         <p:spPr>
           <a:xfrm>
-            <a:off x="6163055" y="2057400"/>
-            <a:ext cx="2670048" cy="3291840"/>
+            <a:off x="6163055" y="2011680"/>
+            <a:ext cx="2670048" cy="914400"/>
+          </a:xfrm>
+          <a:prstGeom prst="roundRect">
+            <a:avLst>
+              <a:gd name="adj" fmla="val 8000"/>
+            </a:avLst>
+          </a:prstGeom>
+          <a:solidFill>
+            <a:srgbClr val="FEF2F2"/>
+          </a:solidFill>
+          <a:ln>
+            <a:noFill/>
+          </a:ln>
+          <a:effectLst/>
+        </p:spPr>
+        <p:style>
+          <a:lnRef idx="1">
+            <a:schemeClr val="accent1"/>
+          </a:lnRef>
+          <a:fillRef idx="3">
+            <a:schemeClr val="accent1"/>
+          </a:fillRef>
+          <a:effectRef idx="2">
+            <a:schemeClr val="accent1"/>
+          </a:effectRef>
+          <a:fontRef idx="minor">
+            <a:schemeClr val="lt1"/>
+          </a:fontRef>
+        </p:style>
+        <p:txBody>
+          <a:bodyPr rtlCol="0" anchor="t" wrap="square" lIns="73152" rIns="73152" tIns="36576" bIns="36576"/>
+          <a:lstStyle/>
+          <a:p>
+            <a:pPr algn="l">
+              <a:lnSpc>
+                <a:spcPct val="105000"/>
+              </a:lnSpc>
+            </a:pPr>
+            <a:r>
+              <a:rPr sz="1000" b="1">
+                <a:solidFill>
+                  <a:srgbClr val="B91C1C"/>
+                </a:solidFill>
+                <a:latin typeface="Arial"/>
+              </a:rPr>
+              <a:t>TODAY</a:t>
+            </a:r>
+          </a:p>
+          <a:p>
+            <a:pPr algn="l">
+              <a:lnSpc>
+                <a:spcPct val="105000"/>
+              </a:lnSpc>
+            </a:pPr>
+            <a:r>
+              <a:rPr sz="1350" b="0">
+                <a:solidFill>
+                  <a:srgbClr val="0F172A"/>
+                </a:solidFill>
+                <a:latin typeface="Arial"/>
+              </a:rPr>
+              <a:t>An agent's limits live in its prompt.</a:t>
+            </a:r>
+          </a:p>
+        </p:txBody>
+      </p:sp>
+      <p:sp>
+        <p:nvSpPr>
+          <p:cNvPr id="21" name="Down Arrow 20"/>
+          <p:cNvSpPr/>
+          <p:nvPr/>
+        </p:nvSpPr>
+        <p:spPr>
+          <a:xfrm>
+            <a:off x="7351775" y="2990088"/>
+            <a:ext cx="219456" cy="274320"/>
+          </a:xfrm>
+          <a:prstGeom prst="downArrow">
+            <a:avLst/>
+          </a:prstGeom>
+          <a:solidFill>
+            <a:srgbClr val="94A3B8"/>
+          </a:solidFill>
+          <a:ln>
+            <a:noFill/>
+          </a:ln>
+          <a:effectLst/>
+        </p:spPr>
+        <p:style>
+          <a:lnRef idx="1">
+            <a:schemeClr val="accent1"/>
+          </a:lnRef>
+          <a:fillRef idx="3">
+            <a:schemeClr val="accent1"/>
+          </a:fillRef>
+          <a:effectRef idx="2">
+            <a:schemeClr val="accent1"/>
+          </a:effectRef>
+          <a:fontRef idx="minor">
+            <a:schemeClr val="lt1"/>
+          </a:fontRef>
+        </p:style>
+        <p:txBody>
+          <a:bodyPr rtlCol="0" anchor="ctr"/>
+          <a:lstStyle/>
+          <a:p>
+            <a:pPr algn="ctr"/>
+          </a:p>
+        </p:txBody>
+      </p:sp>
+      <p:sp>
+        <p:nvSpPr>
+          <p:cNvPr id="22" name="Rounded Rectangle 21"/>
+          <p:cNvSpPr/>
+          <p:nvPr/>
+        </p:nvSpPr>
+        <p:spPr>
+          <a:xfrm>
+            <a:off x="6163055" y="3337560"/>
+            <a:ext cx="2670048" cy="2148840"/>
           </a:xfrm>
           <a:prstGeom prst="roundRect">
             <a:avLst>
@@ -21022,13 +21379,13 @@
       </p:sp>
       <p:sp>
         <p:nvSpPr>
-          <p:cNvPr id="17" name="Rectangle 16"/>
+          <p:cNvPr id="23" name="Rectangle 22"/>
           <p:cNvSpPr/>
           <p:nvPr/>
         </p:nvSpPr>
         <p:spPr>
           <a:xfrm>
-            <a:off x="6391655" y="2331720"/>
+            <a:off x="6391655" y="3611879"/>
             <a:ext cx="73152" cy="457200"/>
           </a:xfrm>
           <a:prstGeom prst="rect">
@@ -21066,13 +21423,13 @@
       </p:sp>
       <p:sp>
         <p:nvSpPr>
-          <p:cNvPr id="18" name="TextBox 17"/>
+          <p:cNvPr id="24" name="TextBox 23"/>
           <p:cNvSpPr txBox="1"/>
           <p:nvPr/>
         </p:nvSpPr>
         <p:spPr>
           <a:xfrm>
-            <a:off x="6547103" y="2258568"/>
+            <a:off x="6547103" y="3538728"/>
             <a:ext cx="2121408" cy="274320"/>
           </a:xfrm>
           <a:prstGeom prst="rect">
@@ -21105,13 +21462,13 @@
       </p:sp>
       <p:sp>
         <p:nvSpPr>
-          <p:cNvPr id="19" name="TextBox 18"/>
+          <p:cNvPr id="25" name="TextBox 24"/>
           <p:cNvSpPr txBox="1"/>
           <p:nvPr/>
         </p:nvSpPr>
         <p:spPr>
           <a:xfrm>
-            <a:off x="6547103" y="2514600"/>
+            <a:off x="6547103" y="3794760"/>
             <a:ext cx="2121408" cy="548640"/>
           </a:xfrm>
           <a:prstGeom prst="rect">
@@ -21131,27 +21488,27 @@
               </a:lnSpc>
             </a:pPr>
             <a:r>
-              <a:rPr sz="1800" b="1">
+              <a:rPr sz="1700" b="1">
                 <a:solidFill>
                   <a:srgbClr val="0F172A"/>
                 </a:solidFill>
                 <a:latin typeface="Arial"/>
               </a:rPr>
-              <a:t>Enforced, not instructed</a:t>
-            </a:r>
-          </a:p>
-        </p:txBody>
-      </p:sp>
-      <p:sp>
-        <p:nvSpPr>
-          <p:cNvPr id="20" name="TextBox 19"/>
+              <a:t>Limits the platform enforces</a:t>
+            </a:r>
+          </a:p>
+        </p:txBody>
+      </p:sp>
+      <p:sp>
+        <p:nvSpPr>
+          <p:cNvPr id="26" name="TextBox 25"/>
           <p:cNvSpPr txBox="1"/>
           <p:nvPr/>
         </p:nvSpPr>
         <p:spPr>
           <a:xfrm>
-            <a:off x="6391655" y="3383280"/>
-            <a:ext cx="2258568" cy="1828800"/>
+            <a:off x="6391655" y="4526280"/>
+            <a:ext cx="2258568" cy="822960"/>
           </a:xfrm>
           <a:prstGeom prst="rect">
             <a:avLst/>
@@ -21170,27 +21527,146 @@
               </a:lnSpc>
             </a:pPr>
             <a:r>
-              <a:rPr sz="1550" b="0">
+              <a:rPr sz="1450" b="0">
                 <a:solidFill>
                   <a:srgbClr val="475569"/>
                 </a:solidFill>
                 <a:latin typeface="Arial"/>
               </a:rPr>
-              <a:t>Identity, permissions, approvals and audit, on every run.</a:t>
-            </a:r>
-          </a:p>
-        </p:txBody>
-      </p:sp>
-      <p:sp>
-        <p:nvSpPr>
-          <p:cNvPr id="21" name="Rounded Rectangle 20"/>
+              <a:t>Identity, permissions, approvals and audit.</a:t>
+            </a:r>
+          </a:p>
+        </p:txBody>
+      </p:sp>
+      <p:sp>
+        <p:nvSpPr>
+          <p:cNvPr id="27" name="Rounded Rectangle 26"/>
           <p:cNvSpPr/>
           <p:nvPr/>
         </p:nvSpPr>
         <p:spPr>
           <a:xfrm>
-            <a:off x="8970263" y="2057400"/>
-            <a:ext cx="2670048" cy="3291840"/>
+            <a:off x="8970263" y="2011680"/>
+            <a:ext cx="2670048" cy="914400"/>
+          </a:xfrm>
+          <a:prstGeom prst="roundRect">
+            <a:avLst>
+              <a:gd name="adj" fmla="val 8000"/>
+            </a:avLst>
+          </a:prstGeom>
+          <a:solidFill>
+            <a:srgbClr val="FEF2F2"/>
+          </a:solidFill>
+          <a:ln>
+            <a:noFill/>
+          </a:ln>
+          <a:effectLst/>
+        </p:spPr>
+        <p:style>
+          <a:lnRef idx="1">
+            <a:schemeClr val="accent1"/>
+          </a:lnRef>
+          <a:fillRef idx="3">
+            <a:schemeClr val="accent1"/>
+          </a:fillRef>
+          <a:effectRef idx="2">
+            <a:schemeClr val="accent1"/>
+          </a:effectRef>
+          <a:fontRef idx="minor">
+            <a:schemeClr val="lt1"/>
+          </a:fontRef>
+        </p:style>
+        <p:txBody>
+          <a:bodyPr rtlCol="0" anchor="t" wrap="square" lIns="73152" rIns="73152" tIns="36576" bIns="36576"/>
+          <a:lstStyle/>
+          <a:p>
+            <a:pPr algn="l">
+              <a:lnSpc>
+                <a:spcPct val="105000"/>
+              </a:lnSpc>
+            </a:pPr>
+            <a:r>
+              <a:rPr sz="1000" b="1">
+                <a:solidFill>
+                  <a:srgbClr val="B91C1C"/>
+                </a:solidFill>
+                <a:latin typeface="Arial"/>
+              </a:rPr>
+              <a:t>TODAY</a:t>
+            </a:r>
+          </a:p>
+          <a:p>
+            <a:pPr algn="l">
+              <a:lnSpc>
+                <a:spcPct val="105000"/>
+              </a:lnSpc>
+            </a:pPr>
+            <a:r>
+              <a:rPr sz="1350" b="0">
+                <a:solidFill>
+                  <a:srgbClr val="0F172A"/>
+                </a:solidFill>
+                <a:latin typeface="Arial"/>
+              </a:rPr>
+              <a:t>Nobody knows what agents cost or are worth.</a:t>
+            </a:r>
+          </a:p>
+        </p:txBody>
+      </p:sp>
+      <p:sp>
+        <p:nvSpPr>
+          <p:cNvPr id="28" name="Down Arrow 27"/>
+          <p:cNvSpPr/>
+          <p:nvPr/>
+        </p:nvSpPr>
+        <p:spPr>
+          <a:xfrm>
+            <a:off x="10158984" y="2990088"/>
+            <a:ext cx="219456" cy="274320"/>
+          </a:xfrm>
+          <a:prstGeom prst="downArrow">
+            <a:avLst/>
+          </a:prstGeom>
+          <a:solidFill>
+            <a:srgbClr val="94A3B8"/>
+          </a:solidFill>
+          <a:ln>
+            <a:noFill/>
+          </a:ln>
+          <a:effectLst/>
+        </p:spPr>
+        <p:style>
+          <a:lnRef idx="1">
+            <a:schemeClr val="accent1"/>
+          </a:lnRef>
+          <a:fillRef idx="3">
+            <a:schemeClr val="accent1"/>
+          </a:fillRef>
+          <a:effectRef idx="2">
+            <a:schemeClr val="accent1"/>
+          </a:effectRef>
+          <a:fontRef idx="minor">
+            <a:schemeClr val="lt1"/>
+          </a:fontRef>
+        </p:style>
+        <p:txBody>
+          <a:bodyPr rtlCol="0" anchor="ctr"/>
+          <a:lstStyle/>
+          <a:p>
+            <a:pPr algn="ctr"/>
+          </a:p>
+        </p:txBody>
+      </p:sp>
+      <p:sp>
+        <p:nvSpPr>
+          <p:cNvPr id="29" name="Rounded Rectangle 28"/>
+          <p:cNvSpPr/>
+          <p:nvPr/>
+        </p:nvSpPr>
+        <p:spPr>
+          <a:xfrm>
+            <a:off x="8970263" y="3337560"/>
+            <a:ext cx="2670048" cy="2148840"/>
           </a:xfrm>
           <a:prstGeom prst="roundRect">
             <a:avLst>
@@ -21231,13 +21707,13 @@
       </p:sp>
       <p:sp>
         <p:nvSpPr>
-          <p:cNvPr id="22" name="Rectangle 21"/>
+          <p:cNvPr id="30" name="Rectangle 29"/>
           <p:cNvSpPr/>
           <p:nvPr/>
         </p:nvSpPr>
         <p:spPr>
           <a:xfrm>
-            <a:off x="9198863" y="2331720"/>
+            <a:off x="9198863" y="3611879"/>
             <a:ext cx="73152" cy="457200"/>
           </a:xfrm>
           <a:prstGeom prst="rect">
@@ -21275,13 +21751,13 @@
       </p:sp>
       <p:sp>
         <p:nvSpPr>
-          <p:cNvPr id="23" name="TextBox 22"/>
+          <p:cNvPr id="31" name="TextBox 30"/>
           <p:cNvSpPr txBox="1"/>
           <p:nvPr/>
         </p:nvSpPr>
         <p:spPr>
           <a:xfrm>
-            <a:off x="9354311" y="2258568"/>
+            <a:off x="9354311" y="3538728"/>
             <a:ext cx="2121408" cy="274320"/>
           </a:xfrm>
           <a:prstGeom prst="rect">
@@ -21314,13 +21790,13 @@
       </p:sp>
       <p:sp>
         <p:nvSpPr>
-          <p:cNvPr id="24" name="TextBox 23"/>
+          <p:cNvPr id="32" name="TextBox 31"/>
           <p:cNvSpPr txBox="1"/>
           <p:nvPr/>
         </p:nvSpPr>
         <p:spPr>
           <a:xfrm>
-            <a:off x="9354311" y="2514600"/>
+            <a:off x="9354311" y="3794760"/>
             <a:ext cx="2121408" cy="548640"/>
           </a:xfrm>
           <a:prstGeom prst="rect">
@@ -21340,27 +21816,27 @@
               </a:lnSpc>
             </a:pPr>
             <a:r>
-              <a:rPr sz="1800" b="1">
+              <a:rPr sz="1700" b="1">
                 <a:solidFill>
                   <a:srgbClr val="0F172A"/>
                 </a:solidFill>
                 <a:latin typeface="Arial"/>
               </a:rPr>
-              <a:t>Keep what earns its cost</a:t>
-            </a:r>
-          </a:p>
-        </p:txBody>
-      </p:sp>
-      <p:sp>
-        <p:nvSpPr>
-          <p:cNvPr id="25" name="TextBox 24"/>
+              <a:t>Cost per run, budgets that block</a:t>
+            </a:r>
+          </a:p>
+        </p:txBody>
+      </p:sp>
+      <p:sp>
+        <p:nvSpPr>
+          <p:cNvPr id="33" name="TextBox 32"/>
           <p:cNvSpPr txBox="1"/>
           <p:nvPr/>
         </p:nvSpPr>
         <p:spPr>
           <a:xfrm>
-            <a:off x="9198863" y="3383280"/>
-            <a:ext cx="2258568" cy="1828800"/>
+            <a:off x="9198863" y="4526280"/>
+            <a:ext cx="2258568" cy="822960"/>
           </a:xfrm>
           <a:prstGeom prst="rect">
             <a:avLst/>
@@ -21379,20 +21855,20 @@
               </a:lnSpc>
             </a:pPr>
             <a:r>
-              <a:rPr sz="1550" b="0">
+              <a:rPr sz="1450" b="0">
                 <a:solidFill>
                   <a:srgbClr val="475569"/>
                 </a:solidFill>
                 <a:latin typeface="Arial"/>
               </a:rPr>
-              <a:t>Cost and quality per run. Budgets stop overspend.</a:t>
-            </a:r>
-          </a:p>
-        </p:txBody>
-      </p:sp>
-      <p:sp>
-        <p:nvSpPr>
-          <p:cNvPr id="26" name="Rounded Rectangle 25"/>
+              <a:t>Keep what earns its cost.</a:t>
+            </a:r>
+          </a:p>
+        </p:txBody>
+      </p:sp>
+      <p:sp>
+        <p:nvSpPr>
+          <p:cNvPr id="34" name="Rounded Rectangle 33"/>
           <p:cNvSpPr/>
           <p:nvPr/>
         </p:nvSpPr>

</xml_diff>

<commit_message>
Deck and docs: close recaps the three outcomes; knowledge-base doc tested, then removed
The close now repeats the promise from slide 2 (one view, enforced limits, one workflow)
with what the demo showed for each. The probe-policy doc was removed from the KAOP
workspace, so the docs record it as tested and removed, and the live investigation
works from evidence alone.

Co-Authored-By: Claude Opus 5.5 <noreply@anthropic.com>
Claude-Session: https://claude.ai/code/session_01DptoPaaj14X3TGztKApoPN
</commit_message>
<xml_diff>
--- a/docs/presentation/KAOP_Customer_Pitch.pptx
+++ b/docs/presentation/KAOP_Customer_Pitch.pptx
@@ -10747,7 +10747,7 @@
                 </a:solidFill>
                 <a:latin typeface="Arial"/>
               </a:rPr>
-              <a:t>Three things to remember</a:t>
+              <a:t>What you saw today</a:t>
             </a:r>
           </a:p>
         </p:txBody>
@@ -10839,13 +10839,29 @@
               </a:lnSpc>
             </a:pPr>
             <a:r>
-              <a:rPr sz="2000" b="0">
+              <a:rPr sz="2000" b="1">
                 <a:solidFill>
                   <a:srgbClr val="FFFFFF"/>
                 </a:solidFill>
                 <a:latin typeface="Arial"/>
               </a:rPr>
-              <a:t>Agents need identities and permissions, not just prompts.</a:t>
+              <a:t>One view of every agent</a:t>
+            </a:r>
+          </a:p>
+          <a:p>
+            <a:pPr algn="l">
+              <a:lnSpc>
+                <a:spcPct val="105000"/>
+              </a:lnSpc>
+            </a:pPr>
+            <a:r>
+              <a:rPr sz="1500" b="0">
+                <a:solidFill>
+                  <a:srgbClr val="CBD5E1"/>
+                </a:solidFill>
+                <a:latin typeface="Arial"/>
+              </a:rPr>
+              <a:t>Who owns it, what it did, what it cost.</a:t>
             </a:r>
           </a:p>
         </p:txBody>
@@ -10937,13 +10953,29 @@
               </a:lnSpc>
             </a:pPr>
             <a:r>
-              <a:rPr sz="2000" b="0">
+              <a:rPr sz="2000" b="1">
                 <a:solidFill>
                   <a:srgbClr val="FFFFFF"/>
                 </a:solidFill>
                 <a:latin typeface="Arial"/>
               </a:rPr>
-              <a:t>Every action needs a boundary and a record.</a:t>
+              <a:t>Limits a system enforces</a:t>
+            </a:r>
+          </a:p>
+          <a:p>
+            <a:pPr algn="l">
+              <a:lnSpc>
+                <a:spcPct val="105000"/>
+              </a:lnSpc>
+            </a:pPr>
+            <a:r>
+              <a:rPr sz="1500" b="0">
+                <a:solidFill>
+                  <a:srgbClr val="CBD5E1"/>
+                </a:solidFill>
+                <a:latin typeface="Arial"/>
+              </a:rPr>
+              <a:t>Kubernetes and KAOP said no. Not a prompt.</a:t>
             </a:r>
           </a:p>
         </p:txBody>
@@ -11035,13 +11067,29 @@
               </a:lnSpc>
             </a:pPr>
             <a:r>
-              <a:rPr sz="2000" b="0">
+              <a:rPr sz="2000" b="1">
                 <a:solidFill>
                   <a:srgbClr val="FFFFFF"/>
                 </a:solidFill>
                 <a:latin typeface="Arial"/>
               </a:rPr>
-              <a:t>Autonomy is earned. Start with one workflow and one owner.</a:t>
+              <a:t>Agents working as one workflow</a:t>
+            </a:r>
+          </a:p>
+          <a:p>
+            <a:pPr algn="l">
+              <a:lnSpc>
+                <a:spcPct val="105000"/>
+              </a:lnSpc>
+            </a:pPr>
+            <a:r>
+              <a:rPr sz="1500" b="0">
+                <a:solidFill>
+                  <a:srgbClr val="CBD5E1"/>
+                </a:solidFill>
+                <a:latin typeface="Arial"/>
+              </a:rPr>
+              <a:t>Alert to reviewed fix, on one record.</a:t>
             </a:r>
           </a:p>
         </p:txBody>
@@ -15172,7 +15220,7 @@
                 </a:solidFill>
                 <a:latin typeface="Arial"/>
               </a:rPr>
-              <a:t>One standards doc for every incident agent</a:t>
+              <a:t>Workflow budget: $40 a day, blocks new runs</a:t>
             </a:r>
           </a:p>
         </p:txBody>
@@ -15211,7 +15259,7 @@
                 </a:solidFill>
                 <a:latin typeface="Arial"/>
               </a:rPr>
-              <a:t>Same alert, before and after the doc</a:t>
+              <a:t>Cap lowered to $0.01, two alerts sent</a:t>
             </a:r>
           </a:p>
         </p:txBody>
@@ -15250,7 +15298,7 @@
                 </a:solidFill>
                 <a:latin typeface="Arial"/>
               </a:rPr>
-              <a:t>Every run quotes our rule and runbook. Cost about the same</a:t>
+              <a:t>Second alert recorded but not investigated, with the reason</a:t>
             </a:r>
           </a:p>
         </p:txBody>
@@ -15337,7 +15385,7 @@
                 </a:solidFill>
                 <a:latin typeface="Arial"/>
               </a:rPr>
-              <a:t>Workflow budget: $40 a day, blocks new runs</a:t>
+              <a:t>Grafana agent: allow list instead of a deny list</a:t>
             </a:r>
           </a:p>
         </p:txBody>
@@ -15376,7 +15424,7 @@
                 </a:solidFill>
                 <a:latin typeface="Arial"/>
               </a:rPr>
-              <a:t>Cap lowered to $0.01, two alerts sent</a:t>
+              <a:t>Asked for tools outside the list</a:t>
             </a:r>
           </a:p>
         </p:txBody>
@@ -15415,7 +15463,7 @@
                 </a:solidFill>
                 <a:latin typeface="Arial"/>
               </a:rPr>
-              <a:t>Second alert recorded but not investigated, with the reason</a:t>
+              <a:t>"Not permitted" / "Tool not found"</a:t>
             </a:r>
           </a:p>
         </p:txBody>
@@ -15502,7 +15550,7 @@
                 </a:solidFill>
                 <a:latin typeface="Arial"/>
               </a:rPr>
-              <a:t>Grafana agent: allow list instead of a deny list</a:t>
+              <a:t>Owner and team label on every agent</a:t>
             </a:r>
           </a:p>
         </p:txBody>
@@ -15541,7 +15589,7 @@
                 </a:solidFill>
                 <a:latin typeface="Arial"/>
               </a:rPr>
-              <a:t>Asked for tools outside the list</a:t>
+              <a:t>Fleet filtered by owner</a:t>
             </a:r>
           </a:p>
         </p:txBody>
@@ -15580,171 +15628,6 @@
                 </a:solidFill>
                 <a:latin typeface="Arial"/>
               </a:rPr>
-              <a:t>"Not permitted" / "Tool not found"</a:t>
-            </a:r>
-          </a:p>
-        </p:txBody>
-      </p:sp>
-      <p:sp>
-        <p:nvSpPr>
-          <p:cNvPr id="25" name="Rounded Rectangle 24"/>
-          <p:cNvSpPr/>
-          <p:nvPr/>
-        </p:nvSpPr>
-        <p:spPr>
-          <a:xfrm>
-            <a:off x="548640" y="5111496"/>
-            <a:ext cx="11091672" cy="621792"/>
-          </a:xfrm>
-          <a:prstGeom prst="roundRect">
-            <a:avLst>
-              <a:gd name="adj" fmla="val 6000"/>
-            </a:avLst>
-          </a:prstGeom>
-          <a:solidFill>
-            <a:srgbClr val="FFFFFF"/>
-          </a:solidFill>
-          <a:ln w="12700">
-            <a:solidFill>
-              <a:srgbClr val="E2E8F0"/>
-            </a:solidFill>
-          </a:ln>
-          <a:effectLst/>
-        </p:spPr>
-        <p:style>
-          <a:lnRef idx="1">
-            <a:schemeClr val="accent1"/>
-          </a:lnRef>
-          <a:fillRef idx="3">
-            <a:schemeClr val="accent1"/>
-          </a:fillRef>
-          <a:effectRef idx="2">
-            <a:schemeClr val="accent1"/>
-          </a:effectRef>
-          <a:fontRef idx="minor">
-            <a:schemeClr val="lt1"/>
-          </a:fontRef>
-        </p:style>
-        <p:txBody>
-          <a:bodyPr rtlCol="0" anchor="ctr"/>
-          <a:lstStyle/>
-          <a:p>
-            <a:pPr algn="ctr"/>
-          </a:p>
-        </p:txBody>
-      </p:sp>
-      <p:sp>
-        <p:nvSpPr>
-          <p:cNvPr id="26" name="TextBox 25"/>
-          <p:cNvSpPr txBox="1"/>
-          <p:nvPr/>
-        </p:nvSpPr>
-        <p:spPr>
-          <a:xfrm>
-            <a:off x="777240" y="5129783"/>
-            <a:ext cx="4206240" cy="585216"/>
-          </a:xfrm>
-          <a:prstGeom prst="rect">
-            <a:avLst/>
-          </a:prstGeom>
-          <a:noFill/>
-        </p:spPr>
-        <p:txBody>
-          <a:bodyPr wrap="square" lIns="73152" rIns="73152" tIns="36576" bIns="36576" anchor="ctr">
-            <a:spAutoFit/>
-          </a:bodyPr>
-          <a:lstStyle/>
-          <a:p>
-            <a:pPr algn="l">
-              <a:lnSpc>
-                <a:spcPct val="105000"/>
-              </a:lnSpc>
-            </a:pPr>
-            <a:r>
-              <a:rPr sz="1400" b="1">
-                <a:solidFill>
-                  <a:srgbClr val="0F172A"/>
-                </a:solidFill>
-                <a:latin typeface="Arial"/>
-              </a:rPr>
-              <a:t>Owner and team label on every agent</a:t>
-            </a:r>
-          </a:p>
-        </p:txBody>
-      </p:sp>
-      <p:sp>
-        <p:nvSpPr>
-          <p:cNvPr id="27" name="TextBox 26"/>
-          <p:cNvSpPr txBox="1"/>
-          <p:nvPr/>
-        </p:nvSpPr>
-        <p:spPr>
-          <a:xfrm>
-            <a:off x="5120640" y="5129783"/>
-            <a:ext cx="2834640" cy="585216"/>
-          </a:xfrm>
-          <a:prstGeom prst="rect">
-            <a:avLst/>
-          </a:prstGeom>
-          <a:noFill/>
-        </p:spPr>
-        <p:txBody>
-          <a:bodyPr wrap="square" lIns="73152" rIns="73152" tIns="36576" bIns="36576" anchor="ctr">
-            <a:spAutoFit/>
-          </a:bodyPr>
-          <a:lstStyle/>
-          <a:p>
-            <a:pPr algn="l">
-              <a:lnSpc>
-                <a:spcPct val="105000"/>
-              </a:lnSpc>
-            </a:pPr>
-            <a:r>
-              <a:rPr sz="1400" b="0">
-                <a:solidFill>
-                  <a:srgbClr val="475569"/>
-                </a:solidFill>
-                <a:latin typeface="Arial"/>
-              </a:rPr>
-              <a:t>Fleet filtered by owner</a:t>
-            </a:r>
-          </a:p>
-        </p:txBody>
-      </p:sp>
-      <p:sp>
-        <p:nvSpPr>
-          <p:cNvPr id="28" name="TextBox 27"/>
-          <p:cNvSpPr txBox="1"/>
-          <p:nvPr/>
-        </p:nvSpPr>
-        <p:spPr>
-          <a:xfrm>
-            <a:off x="8092440" y="5129783"/>
-            <a:ext cx="3474720" cy="585216"/>
-          </a:xfrm>
-          <a:prstGeom prst="rect">
-            <a:avLst/>
-          </a:prstGeom>
-          <a:noFill/>
-        </p:spPr>
-        <p:txBody>
-          <a:bodyPr wrap="square" lIns="73152" rIns="73152" tIns="36576" bIns="36576" anchor="ctr">
-            <a:spAutoFit/>
-          </a:bodyPr>
-          <a:lstStyle/>
-          <a:p>
-            <a:pPr algn="l">
-              <a:lnSpc>
-                <a:spcPct val="105000"/>
-              </a:lnSpc>
-            </a:pPr>
-            <a:r>
-              <a:rPr sz="1400" b="0">
-                <a:solidFill>
-                  <a:srgbClr val="0F766E"/>
-                </a:solidFill>
-                <a:latin typeface="Arial"/>
-              </a:rPr>
               <a:t>Every agent has an owner to call</a:t>
             </a:r>
           </a:p>
@@ -15752,7 +15635,7 @@
       </p:sp>
       <p:sp>
         <p:nvSpPr>
-          <p:cNvPr id="29" name="TextBox 28"/>
+          <p:cNvPr id="25" name="TextBox 24"/>
           <p:cNvSpPr txBox="1"/>
           <p:nvPr/>
         </p:nvSpPr>

</xml_diff>

<commit_message>
Evidence: knowledge-base doc test (doc off) and doc restored
Same Grafana Investigator input with the allow list on and the doc off, three runs:
none named the cause (confidence 0.55 to 0.62). With the doc, 7 of 7 did. The doc
is the reliability lever; the allow list is the cost lever.

Co-Authored-By: Claude Opus 5.5 <noreply@anthropic.com>
Claude-Session: https://claude.ai/code/session_01DptoPaaj14X3TGztKApoPN
</commit_message>
<xml_diff>
--- a/docs/presentation/KAOP_Customer_Pitch.pptx
+++ b/docs/presentation/KAOP_Customer_Pitch.pptx
@@ -15220,7 +15220,7 @@
                 </a:solidFill>
                 <a:latin typeface="Arial"/>
               </a:rPr>
-              <a:t>Workflow budget: $40 a day, blocks new runs</a:t>
+              <a:t>One standards doc for every incident agent</a:t>
             </a:r>
           </a:p>
         </p:txBody>
@@ -15259,7 +15259,7 @@
                 </a:solidFill>
                 <a:latin typeface="Arial"/>
               </a:rPr>
-              <a:t>Cap lowered to $0.01, two alerts sent</a:t>
+              <a:t>Same alert, with and without the doc</a:t>
             </a:r>
           </a:p>
         </p:txBody>
@@ -15298,7 +15298,7 @@
                 </a:solidFill>
                 <a:latin typeface="Arial"/>
               </a:rPr>
-              <a:t>Second alert recorded but not investigated, with the reason</a:t>
+              <a:t>Cause found in 7 of 7 runs, vs 2 of 5 without. Cost about the same</a:t>
             </a:r>
           </a:p>
         </p:txBody>
@@ -15385,7 +15385,7 @@
                 </a:solidFill>
                 <a:latin typeface="Arial"/>
               </a:rPr>
-              <a:t>Grafana agent: allow list instead of a deny list</a:t>
+              <a:t>Workflow budget: $40 a day, blocks new runs</a:t>
             </a:r>
           </a:p>
         </p:txBody>
@@ -15424,7 +15424,7 @@
                 </a:solidFill>
                 <a:latin typeface="Arial"/>
               </a:rPr>
-              <a:t>Asked for tools outside the list</a:t>
+              <a:t>Cap lowered to $0.01, two alerts sent</a:t>
             </a:r>
           </a:p>
         </p:txBody>
@@ -15463,7 +15463,7 @@
                 </a:solidFill>
                 <a:latin typeface="Arial"/>
               </a:rPr>
-              <a:t>"Not permitted" / "Tool not found"</a:t>
+              <a:t>Second alert recorded but not investigated, with the reason</a:t>
             </a:r>
           </a:p>
         </p:txBody>
@@ -15550,7 +15550,7 @@
                 </a:solidFill>
                 <a:latin typeface="Arial"/>
               </a:rPr>
-              <a:t>Owner and team label on every agent</a:t>
+              <a:t>Grafana agent: allow list instead of a deny list</a:t>
             </a:r>
           </a:p>
         </p:txBody>
@@ -15589,7 +15589,7 @@
                 </a:solidFill>
                 <a:latin typeface="Arial"/>
               </a:rPr>
-              <a:t>Fleet filtered by owner</a:t>
+              <a:t>Asked for tools outside the list</a:t>
             </a:r>
           </a:p>
         </p:txBody>
@@ -15628,6 +15628,171 @@
                 </a:solidFill>
                 <a:latin typeface="Arial"/>
               </a:rPr>
+              <a:t>"Not permitted" / "Tool not found"</a:t>
+            </a:r>
+          </a:p>
+        </p:txBody>
+      </p:sp>
+      <p:sp>
+        <p:nvSpPr>
+          <p:cNvPr id="25" name="Rounded Rectangle 24"/>
+          <p:cNvSpPr/>
+          <p:nvPr/>
+        </p:nvSpPr>
+        <p:spPr>
+          <a:xfrm>
+            <a:off x="548640" y="5111496"/>
+            <a:ext cx="11091672" cy="621792"/>
+          </a:xfrm>
+          <a:prstGeom prst="roundRect">
+            <a:avLst>
+              <a:gd name="adj" fmla="val 6000"/>
+            </a:avLst>
+          </a:prstGeom>
+          <a:solidFill>
+            <a:srgbClr val="FFFFFF"/>
+          </a:solidFill>
+          <a:ln w="12700">
+            <a:solidFill>
+              <a:srgbClr val="E2E8F0"/>
+            </a:solidFill>
+          </a:ln>
+          <a:effectLst/>
+        </p:spPr>
+        <p:style>
+          <a:lnRef idx="1">
+            <a:schemeClr val="accent1"/>
+          </a:lnRef>
+          <a:fillRef idx="3">
+            <a:schemeClr val="accent1"/>
+          </a:fillRef>
+          <a:effectRef idx="2">
+            <a:schemeClr val="accent1"/>
+          </a:effectRef>
+          <a:fontRef idx="minor">
+            <a:schemeClr val="lt1"/>
+          </a:fontRef>
+        </p:style>
+        <p:txBody>
+          <a:bodyPr rtlCol="0" anchor="ctr"/>
+          <a:lstStyle/>
+          <a:p>
+            <a:pPr algn="ctr"/>
+          </a:p>
+        </p:txBody>
+      </p:sp>
+      <p:sp>
+        <p:nvSpPr>
+          <p:cNvPr id="26" name="TextBox 25"/>
+          <p:cNvSpPr txBox="1"/>
+          <p:nvPr/>
+        </p:nvSpPr>
+        <p:spPr>
+          <a:xfrm>
+            <a:off x="777240" y="5129783"/>
+            <a:ext cx="4206240" cy="585216"/>
+          </a:xfrm>
+          <a:prstGeom prst="rect">
+            <a:avLst/>
+          </a:prstGeom>
+          <a:noFill/>
+        </p:spPr>
+        <p:txBody>
+          <a:bodyPr wrap="square" lIns="73152" rIns="73152" tIns="36576" bIns="36576" anchor="ctr">
+            <a:spAutoFit/>
+          </a:bodyPr>
+          <a:lstStyle/>
+          <a:p>
+            <a:pPr algn="l">
+              <a:lnSpc>
+                <a:spcPct val="105000"/>
+              </a:lnSpc>
+            </a:pPr>
+            <a:r>
+              <a:rPr sz="1400" b="1">
+                <a:solidFill>
+                  <a:srgbClr val="0F172A"/>
+                </a:solidFill>
+                <a:latin typeface="Arial"/>
+              </a:rPr>
+              <a:t>Owner and team label on every agent</a:t>
+            </a:r>
+          </a:p>
+        </p:txBody>
+      </p:sp>
+      <p:sp>
+        <p:nvSpPr>
+          <p:cNvPr id="27" name="TextBox 26"/>
+          <p:cNvSpPr txBox="1"/>
+          <p:nvPr/>
+        </p:nvSpPr>
+        <p:spPr>
+          <a:xfrm>
+            <a:off x="5120640" y="5129783"/>
+            <a:ext cx="2834640" cy="585216"/>
+          </a:xfrm>
+          <a:prstGeom prst="rect">
+            <a:avLst/>
+          </a:prstGeom>
+          <a:noFill/>
+        </p:spPr>
+        <p:txBody>
+          <a:bodyPr wrap="square" lIns="73152" rIns="73152" tIns="36576" bIns="36576" anchor="ctr">
+            <a:spAutoFit/>
+          </a:bodyPr>
+          <a:lstStyle/>
+          <a:p>
+            <a:pPr algn="l">
+              <a:lnSpc>
+                <a:spcPct val="105000"/>
+              </a:lnSpc>
+            </a:pPr>
+            <a:r>
+              <a:rPr sz="1400" b="0">
+                <a:solidFill>
+                  <a:srgbClr val="475569"/>
+                </a:solidFill>
+                <a:latin typeface="Arial"/>
+              </a:rPr>
+              <a:t>Fleet filtered by owner</a:t>
+            </a:r>
+          </a:p>
+        </p:txBody>
+      </p:sp>
+      <p:sp>
+        <p:nvSpPr>
+          <p:cNvPr id="28" name="TextBox 27"/>
+          <p:cNvSpPr txBox="1"/>
+          <p:nvPr/>
+        </p:nvSpPr>
+        <p:spPr>
+          <a:xfrm>
+            <a:off x="8092440" y="5129783"/>
+            <a:ext cx="3474720" cy="585216"/>
+          </a:xfrm>
+          <a:prstGeom prst="rect">
+            <a:avLst/>
+          </a:prstGeom>
+          <a:noFill/>
+        </p:spPr>
+        <p:txBody>
+          <a:bodyPr wrap="square" lIns="73152" rIns="73152" tIns="36576" bIns="36576" anchor="ctr">
+            <a:spAutoFit/>
+          </a:bodyPr>
+          <a:lstStyle/>
+          <a:p>
+            <a:pPr algn="l">
+              <a:lnSpc>
+                <a:spcPct val="105000"/>
+              </a:lnSpc>
+            </a:pPr>
+            <a:r>
+              <a:rPr sz="1400" b="0">
+                <a:solidFill>
+                  <a:srgbClr val="0F766E"/>
+                </a:solidFill>
+                <a:latin typeface="Arial"/>
+              </a:rPr>
               <a:t>Every agent has an owner to call</a:t>
             </a:r>
           </a:p>
@@ -15635,7 +15800,7 @@
       </p:sp>
       <p:sp>
         <p:nvSpPr>
-          <p:cNvPr id="25" name="TextBox 24"/>
+          <p:cNvPr id="29" name="TextBox 28"/>
           <p:cNvSpPr txBox="1"/>
           <p:nvPr/>
         </p:nvSpPr>

</xml_diff>

<commit_message>
Evidence: five runs per setup, latency, and the agent upgrade mid-test
With the standards doc, 10 of 10 runs named the cause; without it, 1 of 5.
The allow list takes a run from about $0.68 to $0.53 with the same answer.

Co-Authored-By: Claude Opus 5.5 <noreply@anthropic.com>
Claude-Session: https://claude.ai/code/session_01DptoPaaj14X3TGztKApoPN
</commit_message>
<xml_diff>
--- a/docs/presentation/KAOP_Customer_Pitch.pptx
+++ b/docs/presentation/KAOP_Customer_Pitch.pptx
@@ -15094,7 +15094,7 @@
                 </a:solidFill>
                 <a:latin typeface="Arial"/>
               </a:rPr>
-              <a:t>Same alert, 3–4 runs with and without</a:t>
+              <a:t>Same alert, 5 runs with and 5 without</a:t>
             </a:r>
           </a:p>
         </p:txBody>
@@ -15133,7 +15133,7 @@
                 </a:solidFill>
                 <a:latin typeface="Arial"/>
               </a:rPr>
-              <a:t>About $0.71 → $0.53 a run. Same root cause</a:t>
+              <a:t>About $0.68 → $0.53 a run. Same root cause</a:t>
             </a:r>
           </a:p>
         </p:txBody>
@@ -15259,7 +15259,7 @@
                 </a:solidFill>
                 <a:latin typeface="Arial"/>
               </a:rPr>
-              <a:t>Same alert, with and without the doc</a:t>
+              <a:t>Same alert, 5 runs without the doc</a:t>
             </a:r>
           </a:p>
         </p:txBody>
@@ -15298,7 +15298,7 @@
                 </a:solidFill>
                 <a:latin typeface="Arial"/>
               </a:rPr>
-              <a:t>Cause found in 7 of 7 runs, vs 2 of 5 without. Cost about the same</a:t>
+              <a:t>Cause found in 10 of 10 runs with it, 1 of 5 without</a:t>
             </a:r>
           </a:p>
         </p:txBody>

</xml_diff>

<commit_message>
Deck: three outcomes as the spine, docs wording, and a measured-results slide
Slides 6 to 9 carry the outcome they prove. New slide 11 shows the runbook
(1 of 5 to 10 of 10 right) and least-privilege (68 to 53 cents) results.
Wording follows the KAOP docs: Attention, standards, import, Production Alert
Investigation.

Co-Authored-By: Claude Opus 5.5 <noreply@anthropic.com>
Claude-Session: https://claude.ai/code/session_01DptoPaaj14X3TGztKApoPN
</commit_message>
<xml_diff>
--- a/docs/presentation/KAOP_Customer_Pitch.pptx
+++ b/docs/presentation/KAOP_Customer_Pitch.pptx
@@ -23,6 +23,7 @@
     <p:sldId id="271" r:id="rId22"/>
     <p:sldId id="272" r:id="rId23"/>
     <p:sldId id="273" r:id="rId24"/>
+    <p:sldId id="274" r:id="rId25"/>
   </p:sldIdLst>
   <p:sldSz cx="12191695" cy="6858000" type="screen4x3"/>
   <p:notesSz cx="6858000" cy="9144000"/>
@@ -3862,7 +3863,7 @@
                 </a:solidFill>
                 <a:latin typeface="Arial"/>
               </a:rPr>
-              <a:t>10 / 13</a:t>
+              <a:t>10 / 14</a:t>
             </a:r>
           </a:p>
         </p:txBody>
@@ -6803,7 +6804,697 @@
                 </a:solidFill>
                 <a:latin typeface="Arial"/>
               </a:rPr>
-              <a:t>11 / 13</a:t>
+              <a:t>11 / 14</a:t>
+            </a:r>
+          </a:p>
+        </p:txBody>
+      </p:sp>
+      <p:sp>
+        <p:nvSpPr>
+          <p:cNvPr id="4" name="TextBox 3"/>
+          <p:cNvSpPr txBox="1"/>
+          <p:nvPr/>
+        </p:nvSpPr>
+        <p:spPr>
+          <a:xfrm>
+            <a:off x="548640" y="658368"/>
+            <a:ext cx="11064240" cy="731520"/>
+          </a:xfrm>
+          <a:prstGeom prst="rect">
+            <a:avLst/>
+          </a:prstGeom>
+          <a:noFill/>
+        </p:spPr>
+        <p:txBody>
+          <a:bodyPr wrap="square" lIns="73152" rIns="73152" tIns="36576" bIns="36576" anchor="t">
+            <a:spAutoFit/>
+          </a:bodyPr>
+          <a:lstStyle/>
+          <a:p>
+            <a:pPr algn="l">
+              <a:lnSpc>
+                <a:spcPct val="110000"/>
+              </a:lnSpc>
+            </a:pPr>
+            <a:r>
+              <a:rPr sz="3200" b="1">
+                <a:solidFill>
+                  <a:srgbClr val="0F172A"/>
+                </a:solidFill>
+                <a:latin typeface="Arial"/>
+              </a:rPr>
+              <a:t>Succeeded isn't the same as right</a:t>
+            </a:r>
+          </a:p>
+        </p:txBody>
+      </p:sp>
+      <p:sp>
+        <p:nvSpPr>
+          <p:cNvPr id="5" name="TextBox 4"/>
+          <p:cNvSpPr txBox="1"/>
+          <p:nvPr/>
+        </p:nvSpPr>
+        <p:spPr>
+          <a:xfrm>
+            <a:off x="548640" y="1371600"/>
+            <a:ext cx="11064240" cy="457200"/>
+          </a:xfrm>
+          <a:prstGeom prst="rect">
+            <a:avLst/>
+          </a:prstGeom>
+          <a:noFill/>
+        </p:spPr>
+        <p:txBody>
+          <a:bodyPr wrap="square" lIns="73152" rIns="73152" tIns="36576" bIns="36576" anchor="t">
+            <a:spAutoFit/>
+          </a:bodyPr>
+          <a:lstStyle/>
+          <a:p>
+            <a:pPr algn="l">
+              <a:lnSpc>
+                <a:spcPct val="110000"/>
+              </a:lnSpc>
+            </a:pPr>
+            <a:r>
+              <a:rPr sz="1700" b="0">
+                <a:solidFill>
+                  <a:srgbClr val="475569"/>
+                </a:solidFill>
+                <a:latin typeface="Arial"/>
+              </a:rPr>
+              <a:t>I measured the Grafana agent on the same alert, five runs per setup, then improved it.</a:t>
+            </a:r>
+          </a:p>
+        </p:txBody>
+      </p:sp>
+      <p:sp>
+        <p:nvSpPr>
+          <p:cNvPr id="6" name="Rounded Rectangle 5"/>
+          <p:cNvSpPr/>
+          <p:nvPr/>
+        </p:nvSpPr>
+        <p:spPr>
+          <a:xfrm>
+            <a:off x="548640" y="2057400"/>
+            <a:ext cx="5486400" cy="3520440"/>
+          </a:xfrm>
+          <a:prstGeom prst="roundRect">
+            <a:avLst>
+              <a:gd name="adj" fmla="val 6000"/>
+            </a:avLst>
+          </a:prstGeom>
+          <a:solidFill>
+            <a:srgbClr val="E6F6F4"/>
+          </a:solidFill>
+          <a:ln>
+            <a:noFill/>
+          </a:ln>
+          <a:effectLst/>
+        </p:spPr>
+        <p:style>
+          <a:lnRef idx="1">
+            <a:schemeClr val="accent1"/>
+          </a:lnRef>
+          <a:fillRef idx="3">
+            <a:schemeClr val="accent1"/>
+          </a:fillRef>
+          <a:effectRef idx="2">
+            <a:schemeClr val="accent1"/>
+          </a:effectRef>
+          <a:fontRef idx="minor">
+            <a:schemeClr val="lt1"/>
+          </a:fontRef>
+        </p:style>
+        <p:txBody>
+          <a:bodyPr rtlCol="0" anchor="ctr"/>
+          <a:lstStyle/>
+          <a:p>
+            <a:pPr algn="ctr"/>
+          </a:p>
+        </p:txBody>
+      </p:sp>
+      <p:sp>
+        <p:nvSpPr>
+          <p:cNvPr id="7" name="TextBox 6"/>
+          <p:cNvSpPr txBox="1"/>
+          <p:nvPr/>
+        </p:nvSpPr>
+        <p:spPr>
+          <a:xfrm>
+            <a:off x="914400" y="2286000"/>
+            <a:ext cx="4846320" cy="274320"/>
+          </a:xfrm>
+          <a:prstGeom prst="rect">
+            <a:avLst/>
+          </a:prstGeom>
+          <a:noFill/>
+        </p:spPr>
+        <p:txBody>
+          <a:bodyPr wrap="square" lIns="73152" rIns="73152" tIns="36576" bIns="36576" anchor="t">
+            <a:spAutoFit/>
+          </a:bodyPr>
+          <a:lstStyle/>
+          <a:p>
+            <a:pPr algn="l">
+              <a:lnSpc>
+                <a:spcPct val="110000"/>
+              </a:lnSpc>
+            </a:pPr>
+            <a:r>
+              <a:rPr sz="1200" b="1">
+                <a:solidFill>
+                  <a:srgbClr val="0F766E"/>
+                </a:solidFill>
+                <a:latin typeface="Arial"/>
+              </a:rPr>
+              <a:t>OUR RUNBOOK IN KAOP'S KNOWLEDGE BASE</a:t>
+            </a:r>
+          </a:p>
+        </p:txBody>
+      </p:sp>
+      <p:sp>
+        <p:nvSpPr>
+          <p:cNvPr id="8" name="TextBox 7"/>
+          <p:cNvSpPr txBox="1"/>
+          <p:nvPr/>
+        </p:nvSpPr>
+        <p:spPr>
+          <a:xfrm>
+            <a:off x="914400" y="2788920"/>
+            <a:ext cx="4846320" cy="1005840"/>
+          </a:xfrm>
+          <a:prstGeom prst="rect">
+            <a:avLst/>
+          </a:prstGeom>
+          <a:noFill/>
+        </p:spPr>
+        <p:txBody>
+          <a:bodyPr wrap="square" lIns="73152" rIns="73152" tIns="36576" bIns="36576" anchor="ctr">
+            <a:spAutoFit/>
+          </a:bodyPr>
+          <a:lstStyle/>
+          <a:p>
+            <a:pPr algn="l">
+              <a:lnSpc>
+                <a:spcPct val="110000"/>
+              </a:lnSpc>
+            </a:pPr>
+            <a:r>
+              <a:rPr sz="3400" b="1">
+                <a:solidFill>
+                  <a:srgbClr val="475569"/>
+                </a:solidFill>
+                <a:latin typeface="Arial"/>
+              </a:rPr>
+              <a:t>1 of 5</a:t>
+            </a:r>
+            <a:r>
+              <a:rPr sz="3000" b="0">
+                <a:solidFill>
+                  <a:srgbClr val="94A3B8"/>
+                </a:solidFill>
+                <a:latin typeface="Arial"/>
+              </a:rPr>
+              <a:t>   →   </a:t>
+            </a:r>
+            <a:r>
+              <a:rPr sz="4400" b="1">
+                <a:solidFill>
+                  <a:srgbClr val="0F766E"/>
+                </a:solidFill>
+                <a:latin typeface="Arial"/>
+              </a:rPr>
+              <a:t>10 of 10</a:t>
+            </a:r>
+          </a:p>
+        </p:txBody>
+      </p:sp>
+      <p:sp>
+        <p:nvSpPr>
+          <p:cNvPr id="9" name="TextBox 8"/>
+          <p:cNvSpPr txBox="1"/>
+          <p:nvPr/>
+        </p:nvSpPr>
+        <p:spPr>
+          <a:xfrm>
+            <a:off x="914400" y="3840480"/>
+            <a:ext cx="4846320" cy="457200"/>
+          </a:xfrm>
+          <a:prstGeom prst="rect">
+            <a:avLst/>
+          </a:prstGeom>
+          <a:noFill/>
+        </p:spPr>
+        <p:txBody>
+          <a:bodyPr wrap="square" lIns="73152" rIns="73152" tIns="36576" bIns="36576" anchor="t">
+            <a:spAutoFit/>
+          </a:bodyPr>
+          <a:lstStyle/>
+          <a:p>
+            <a:pPr algn="l">
+              <a:lnSpc>
+                <a:spcPct val="110000"/>
+              </a:lnSpc>
+            </a:pPr>
+            <a:r>
+              <a:rPr sz="1800" b="1">
+                <a:solidFill>
+                  <a:srgbClr val="0F172A"/>
+                </a:solidFill>
+                <a:latin typeface="Arial"/>
+              </a:rPr>
+              <a:t>runs that named the real cause</a:t>
+            </a:r>
+          </a:p>
+        </p:txBody>
+      </p:sp>
+      <p:sp>
+        <p:nvSpPr>
+          <p:cNvPr id="10" name="TextBox 9"/>
+          <p:cNvSpPr txBox="1"/>
+          <p:nvPr/>
+        </p:nvSpPr>
+        <p:spPr>
+          <a:xfrm>
+            <a:off x="914400" y="4434840"/>
+            <a:ext cx="4846320" cy="914400"/>
+          </a:xfrm>
+          <a:prstGeom prst="rect">
+            <a:avLst/>
+          </a:prstGeom>
+          <a:noFill/>
+        </p:spPr>
+        <p:txBody>
+          <a:bodyPr wrap="square" lIns="73152" rIns="73152" tIns="36576" bIns="36576" anchor="t">
+            <a:spAutoFit/>
+          </a:bodyPr>
+          <a:lstStyle/>
+          <a:p>
+            <a:pPr algn="l">
+              <a:lnSpc>
+                <a:spcPct val="115000"/>
+              </a:lnSpc>
+            </a:pPr>
+            <a:r>
+              <a:rPr sz="1500" b="0">
+                <a:solidFill>
+                  <a:srgbClr val="475569"/>
+                </a:solidFill>
+                <a:latin typeface="Arial"/>
+              </a:rPr>
+              <a:t>Same alert. One page of our own standards.</a:t>
+            </a:r>
+          </a:p>
+        </p:txBody>
+      </p:sp>
+      <p:sp>
+        <p:nvSpPr>
+          <p:cNvPr id="11" name="Rounded Rectangle 10"/>
+          <p:cNvSpPr/>
+          <p:nvPr/>
+        </p:nvSpPr>
+        <p:spPr>
+          <a:xfrm>
+            <a:off x="6153912" y="2057400"/>
+            <a:ext cx="5486400" cy="3520440"/>
+          </a:xfrm>
+          <a:prstGeom prst="roundRect">
+            <a:avLst>
+              <a:gd name="adj" fmla="val 6000"/>
+            </a:avLst>
+          </a:prstGeom>
+          <a:solidFill>
+            <a:srgbClr val="FFF7E6"/>
+          </a:solidFill>
+          <a:ln>
+            <a:noFill/>
+          </a:ln>
+          <a:effectLst/>
+        </p:spPr>
+        <p:style>
+          <a:lnRef idx="1">
+            <a:schemeClr val="accent1"/>
+          </a:lnRef>
+          <a:fillRef idx="3">
+            <a:schemeClr val="accent1"/>
+          </a:fillRef>
+          <a:effectRef idx="2">
+            <a:schemeClr val="accent1"/>
+          </a:effectRef>
+          <a:fontRef idx="minor">
+            <a:schemeClr val="lt1"/>
+          </a:fontRef>
+        </p:style>
+        <p:txBody>
+          <a:bodyPr rtlCol="0" anchor="ctr"/>
+          <a:lstStyle/>
+          <a:p>
+            <a:pPr algn="ctr"/>
+          </a:p>
+        </p:txBody>
+      </p:sp>
+      <p:sp>
+        <p:nvSpPr>
+          <p:cNvPr id="12" name="TextBox 11"/>
+          <p:cNvSpPr txBox="1"/>
+          <p:nvPr/>
+        </p:nvSpPr>
+        <p:spPr>
+          <a:xfrm>
+            <a:off x="6519672" y="2286000"/>
+            <a:ext cx="4846320" cy="274320"/>
+          </a:xfrm>
+          <a:prstGeom prst="rect">
+            <a:avLst/>
+          </a:prstGeom>
+          <a:noFill/>
+        </p:spPr>
+        <p:txBody>
+          <a:bodyPr wrap="square" lIns="73152" rIns="73152" tIns="36576" bIns="36576" anchor="t">
+            <a:spAutoFit/>
+          </a:bodyPr>
+          <a:lstStyle/>
+          <a:p>
+            <a:pPr algn="l">
+              <a:lnSpc>
+                <a:spcPct val="110000"/>
+              </a:lnSpc>
+            </a:pPr>
+            <a:r>
+              <a:rPr sz="1200" b="1">
+                <a:solidFill>
+                  <a:srgbClr val="B45309"/>
+                </a:solidFill>
+                <a:latin typeface="Arial"/>
+              </a:rPr>
+              <a:t>ONLY THE TOOLS THE JOB NEEDS</a:t>
+            </a:r>
+          </a:p>
+        </p:txBody>
+      </p:sp>
+      <p:sp>
+        <p:nvSpPr>
+          <p:cNvPr id="13" name="TextBox 12"/>
+          <p:cNvSpPr txBox="1"/>
+          <p:nvPr/>
+        </p:nvSpPr>
+        <p:spPr>
+          <a:xfrm>
+            <a:off x="6519672" y="2788920"/>
+            <a:ext cx="4846320" cy="1005840"/>
+          </a:xfrm>
+          <a:prstGeom prst="rect">
+            <a:avLst/>
+          </a:prstGeom>
+          <a:noFill/>
+        </p:spPr>
+        <p:txBody>
+          <a:bodyPr wrap="square" lIns="73152" rIns="73152" tIns="36576" bIns="36576" anchor="ctr">
+            <a:spAutoFit/>
+          </a:bodyPr>
+          <a:lstStyle/>
+          <a:p>
+            <a:pPr algn="l">
+              <a:lnSpc>
+                <a:spcPct val="110000"/>
+              </a:lnSpc>
+            </a:pPr>
+            <a:r>
+              <a:rPr sz="3400" b="1">
+                <a:solidFill>
+                  <a:srgbClr val="475569"/>
+                </a:solidFill>
+                <a:latin typeface="Arial"/>
+              </a:rPr>
+              <a:t>$0.68</a:t>
+            </a:r>
+            <a:r>
+              <a:rPr sz="3000" b="0">
+                <a:solidFill>
+                  <a:srgbClr val="94A3B8"/>
+                </a:solidFill>
+                <a:latin typeface="Arial"/>
+              </a:rPr>
+              <a:t>   →   </a:t>
+            </a:r>
+            <a:r>
+              <a:rPr sz="4400" b="1">
+                <a:solidFill>
+                  <a:srgbClr val="B45309"/>
+                </a:solidFill>
+                <a:latin typeface="Arial"/>
+              </a:rPr>
+              <a:t>$0.53</a:t>
+            </a:r>
+          </a:p>
+        </p:txBody>
+      </p:sp>
+      <p:sp>
+        <p:nvSpPr>
+          <p:cNvPr id="14" name="TextBox 13"/>
+          <p:cNvSpPr txBox="1"/>
+          <p:nvPr/>
+        </p:nvSpPr>
+        <p:spPr>
+          <a:xfrm>
+            <a:off x="6519672" y="3840480"/>
+            <a:ext cx="4846320" cy="457200"/>
+          </a:xfrm>
+          <a:prstGeom prst="rect">
+            <a:avLst/>
+          </a:prstGeom>
+          <a:noFill/>
+        </p:spPr>
+        <p:txBody>
+          <a:bodyPr wrap="square" lIns="73152" rIns="73152" tIns="36576" bIns="36576" anchor="t">
+            <a:spAutoFit/>
+          </a:bodyPr>
+          <a:lstStyle/>
+          <a:p>
+            <a:pPr algn="l">
+              <a:lnSpc>
+                <a:spcPct val="110000"/>
+              </a:lnSpc>
+            </a:pPr>
+            <a:r>
+              <a:rPr sz="1800" b="1">
+                <a:solidFill>
+                  <a:srgbClr val="0F172A"/>
+                </a:solidFill>
+                <a:latin typeface="Arial"/>
+              </a:rPr>
+              <a:t>per run, with the same answer</a:t>
+            </a:r>
+          </a:p>
+        </p:txBody>
+      </p:sp>
+      <p:sp>
+        <p:nvSpPr>
+          <p:cNvPr id="15" name="TextBox 14"/>
+          <p:cNvSpPr txBox="1"/>
+          <p:nvPr/>
+        </p:nvSpPr>
+        <p:spPr>
+          <a:xfrm>
+            <a:off x="6519672" y="4434840"/>
+            <a:ext cx="4846320" cy="914400"/>
+          </a:xfrm>
+          <a:prstGeom prst="rect">
+            <a:avLst/>
+          </a:prstGeom>
+          <a:noFill/>
+        </p:spPr>
+        <p:txBody>
+          <a:bodyPr wrap="square" lIns="73152" rIns="73152" tIns="36576" bIns="36576" anchor="t">
+            <a:spAutoFit/>
+          </a:bodyPr>
+          <a:lstStyle/>
+          <a:p>
+            <a:pPr algn="l">
+              <a:lnSpc>
+                <a:spcPct val="115000"/>
+              </a:lnSpc>
+            </a:pPr>
+            <a:r>
+              <a:rPr sz="1500" b="0">
+                <a:solidFill>
+                  <a:srgbClr val="475569"/>
+                </a:solidFill>
+                <a:latin typeface="Arial"/>
+              </a:rPr>
+              <a:t>28 read tools instead of about 75.</a:t>
+            </a:r>
+          </a:p>
+        </p:txBody>
+      </p:sp>
+      <p:sp>
+        <p:nvSpPr>
+          <p:cNvPr id="16" name="Rounded Rectangle 15"/>
+          <p:cNvSpPr/>
+          <p:nvPr/>
+        </p:nvSpPr>
+        <p:spPr>
+          <a:xfrm>
+            <a:off x="548640" y="5852160"/>
+            <a:ext cx="11091672" cy="603504"/>
+          </a:xfrm>
+          <a:prstGeom prst="roundRect">
+            <a:avLst>
+              <a:gd name="adj" fmla="val 12000"/>
+            </a:avLst>
+          </a:prstGeom>
+          <a:solidFill>
+            <a:srgbClr val="0B1220"/>
+          </a:solidFill>
+          <a:ln>
+            <a:noFill/>
+          </a:ln>
+          <a:effectLst/>
+        </p:spPr>
+        <p:style>
+          <a:lnRef idx="1">
+            <a:schemeClr val="accent1"/>
+          </a:lnRef>
+          <a:fillRef idx="3">
+            <a:schemeClr val="accent1"/>
+          </a:fillRef>
+          <a:effectRef idx="2">
+            <a:schemeClr val="accent1"/>
+          </a:effectRef>
+          <a:fontRef idx="minor">
+            <a:schemeClr val="lt1"/>
+          </a:fontRef>
+        </p:style>
+        <p:txBody>
+          <a:bodyPr rtlCol="0" anchor="ctr" wrap="square" lIns="292608" rIns="73152" tIns="36576" bIns="36576"/>
+          <a:lstStyle/>
+          <a:p>
+            <a:pPr algn="l">
+              <a:lnSpc>
+                <a:spcPct val="110000"/>
+              </a:lnSpc>
+            </a:pPr>
+            <a:r>
+              <a:rPr sz="1200" b="1">
+                <a:solidFill>
+                  <a:srgbClr val="A5B4FC"/>
+                </a:solidFill>
+                <a:latin typeface="Arial"/>
+              </a:rPr>
+              <a:t>NOTICE   </a:t>
+            </a:r>
+            <a:r>
+              <a:rPr sz="1600" b="0">
+                <a:solidFill>
+                  <a:srgbClr val="FFFFFF"/>
+                </a:solidFill>
+                <a:latin typeface="Arial"/>
+              </a:rPr>
+              <a:t>Every run reported success, the wrong ones too. KAOP's evaluations grade the answer.</a:t>
+            </a:r>
+          </a:p>
+        </p:txBody>
+      </p:sp>
+    </p:spTree>
+  </p:cSld>
+  <p:clrMapOvr>
+    <a:masterClrMapping/>
+  </p:clrMapOvr>
+</p:sld>
+</file>
+
+<file path=ppt/slides/slide12.xml><?xml version="1.0" encoding="utf-8"?>
+<p:sld xmlns:a="http://schemas.openxmlformats.org/drawingml/2006/main" xmlns:p="http://schemas.openxmlformats.org/presentationml/2006/main" xmlns:r="http://schemas.openxmlformats.org/officeDocument/2006/relationships">
+  <p:cSld>
+    <p:bg>
+      <p:bgPr>
+        <a:solidFill>
+          <a:srgbClr val="F8FAFC"/>
+        </a:solidFill>
+        <a:effectLst/>
+      </p:bgPr>
+    </p:bg>
+    <p:spTree>
+      <p:nvGrpSpPr>
+        <p:cNvPr id="1" name=""/>
+        <p:cNvGrpSpPr/>
+        <p:nvPr/>
+      </p:nvGrpSpPr>
+      <p:grpSpPr/>
+      <p:sp>
+        <p:nvSpPr>
+          <p:cNvPr id="2" name="TextBox 1"/>
+          <p:cNvSpPr txBox="1"/>
+          <p:nvPr/>
+        </p:nvSpPr>
+        <p:spPr>
+          <a:xfrm>
+            <a:off x="548640" y="320040"/>
+            <a:ext cx="7315200" cy="274320"/>
+          </a:xfrm>
+          <a:prstGeom prst="rect">
+            <a:avLst/>
+          </a:prstGeom>
+          <a:noFill/>
+        </p:spPr>
+        <p:txBody>
+          <a:bodyPr wrap="square" lIns="73152" rIns="73152" tIns="36576" bIns="36576" anchor="t">
+            <a:spAutoFit/>
+          </a:bodyPr>
+          <a:lstStyle/>
+          <a:p>
+            <a:pPr algn="l">
+              <a:lnSpc>
+                <a:spcPct val="110000"/>
+              </a:lnSpc>
+            </a:pPr>
+            <a:r>
+              <a:rPr sz="1000" b="1">
+                <a:solidFill>
+                  <a:srgbClr val="4F46E5"/>
+                </a:solidFill>
+                <a:latin typeface="Arial"/>
+              </a:rPr>
+              <a:t>KAOP  ·  PLATFORM ENGINEERING</a:t>
+            </a:r>
+          </a:p>
+        </p:txBody>
+      </p:sp>
+      <p:sp>
+        <p:nvSpPr>
+          <p:cNvPr id="3" name="TextBox 2"/>
+          <p:cNvSpPr txBox="1"/>
+          <p:nvPr/>
+        </p:nvSpPr>
+        <p:spPr>
+          <a:xfrm>
+            <a:off x="9784080" y="320040"/>
+            <a:ext cx="1828800" cy="274320"/>
+          </a:xfrm>
+          <a:prstGeom prst="rect">
+            <a:avLst/>
+          </a:prstGeom>
+          <a:noFill/>
+        </p:spPr>
+        <p:txBody>
+          <a:bodyPr wrap="square" lIns="73152" rIns="73152" tIns="36576" bIns="36576" anchor="t">
+            <a:spAutoFit/>
+          </a:bodyPr>
+          <a:lstStyle/>
+          <a:p>
+            <a:pPr algn="r">
+              <a:lnSpc>
+                <a:spcPct val="110000"/>
+              </a:lnSpc>
+            </a:pPr>
+            <a:r>
+              <a:rPr sz="1000" b="0">
+                <a:solidFill>
+                  <a:srgbClr val="94A3B8"/>
+                </a:solidFill>
+                <a:latin typeface="Arial"/>
+              </a:rPr>
+              <a:t>12 / 14</a:t>
             </a:r>
           </a:p>
         </p:txBody>
@@ -8560,7 +9251,7 @@
 </p:sld>
 </file>
 
-<file path=ppt/slides/slide12.xml><?xml version="1.0" encoding="utf-8"?>
+<file path=ppt/slides/slide13.xml><?xml version="1.0" encoding="utf-8"?>
 <p:sld xmlns:a="http://schemas.openxmlformats.org/drawingml/2006/main" xmlns:p="http://schemas.openxmlformats.org/presentationml/2006/main" xmlns:r="http://schemas.openxmlformats.org/officeDocument/2006/relationships">
   <p:cSld>
     <p:bg>
@@ -8651,7 +9342,7 @@
                 </a:solidFill>
                 <a:latin typeface="Arial"/>
               </a:rPr>
-              <a:t>12 / 13</a:t>
+              <a:t>13 / 14</a:t>
             </a:r>
           </a:p>
         </p:txBody>
@@ -8938,7 +9629,7 @@
                 </a:solidFill>
                 <a:latin typeface="Arial"/>
               </a:rPr>
-              <a:t>Agree the workflow, the owner, how we measure success, and the guardrails.</a:t>
+              <a:t>Agree the workflow, the owner, the guardrails, and how we measure success.</a:t>
             </a:r>
           </a:p>
         </p:txBody>
@@ -9191,7 +9882,7 @@
                 </a:solidFill>
                 <a:latin typeface="Arial"/>
               </a:rPr>
-              <a:t>One cluster. Read-only. Every change approved by a person.</a:t>
+              <a:t>One cluster, read-only. Plus one agent your teams already run.</a:t>
             </a:r>
           </a:p>
         </p:txBody>
@@ -9444,7 +10135,7 @@
                 </a:solidFill>
                 <a:latin typeface="Arial"/>
               </a:rPr>
-              <a:t>More workflows, teams and autonomy, once the results hold.</a:t>
+              <a:t>More teams and autonomy, then modules like Alert Intelligence or Kubernetes Cost.</a:t>
             </a:r>
           </a:p>
         </p:txBody>
@@ -10617,7 +11308,7 @@
 </p:sld>
 </file>
 
-<file path=ppt/slides/slide13.xml><?xml version="1.0" encoding="utf-8"?>
+<file path=ppt/slides/slide14.xml><?xml version="1.0" encoding="utf-8"?>
 <p:sld xmlns:a="http://schemas.openxmlformats.org/drawingml/2006/main" xmlns:p="http://schemas.openxmlformats.org/presentationml/2006/main" xmlns:r="http://schemas.openxmlformats.org/officeDocument/2006/relationships">
   <p:cSld>
     <p:bg>
@@ -11732,7 +12423,7 @@
 </p:sld>
 </file>
 
-<file path=ppt/slides/slide14.xml><?xml version="1.0" encoding="utf-8"?>
+<file path=ppt/slides/slide15.xml><?xml version="1.0" encoding="utf-8"?>
 <p:sld xmlns:a="http://schemas.openxmlformats.org/drawingml/2006/main" xmlns:p="http://schemas.openxmlformats.org/presentationml/2006/main" xmlns:r="http://schemas.openxmlformats.org/officeDocument/2006/relationships">
   <p:cSld>
     <p:bg>
@@ -12019,886 +12710,6 @@
                 <a:latin typeface="Arial"/>
               </a:rPr>
               <a:t>D   Cost and guardrails, tested</a:t>
-            </a:r>
-          </a:p>
-        </p:txBody>
-      </p:sp>
-    </p:spTree>
-  </p:cSld>
-  <p:clrMapOvr>
-    <a:masterClrMapping/>
-  </p:clrMapOvr>
-</p:sld>
-</file>
-
-<file path=ppt/slides/slide15.xml><?xml version="1.0" encoding="utf-8"?>
-<p:sld xmlns:a="http://schemas.openxmlformats.org/drawingml/2006/main" xmlns:p="http://schemas.openxmlformats.org/presentationml/2006/main" xmlns:r="http://schemas.openxmlformats.org/officeDocument/2006/relationships">
-  <p:cSld>
-    <p:bg>
-      <p:bgPr>
-        <a:solidFill>
-          <a:srgbClr val="F8FAFC"/>
-        </a:solidFill>
-        <a:effectLst/>
-      </p:bgPr>
-    </p:bg>
-    <p:spTree>
-      <p:nvGrpSpPr>
-        <p:cNvPr id="1" name=""/>
-        <p:cNvGrpSpPr/>
-        <p:nvPr/>
-      </p:nvGrpSpPr>
-      <p:grpSpPr/>
-      <p:sp>
-        <p:nvSpPr>
-          <p:cNvPr id="2" name="TextBox 1"/>
-          <p:cNvSpPr txBox="1"/>
-          <p:nvPr/>
-        </p:nvSpPr>
-        <p:spPr>
-          <a:xfrm>
-            <a:off x="548640" y="320040"/>
-            <a:ext cx="7315200" cy="274320"/>
-          </a:xfrm>
-          <a:prstGeom prst="rect">
-            <a:avLst/>
-          </a:prstGeom>
-          <a:noFill/>
-        </p:spPr>
-        <p:txBody>
-          <a:bodyPr wrap="square" lIns="73152" rIns="73152" tIns="36576" bIns="36576" anchor="t">
-            <a:spAutoFit/>
-          </a:bodyPr>
-          <a:lstStyle/>
-          <a:p>
-            <a:pPr algn="l">
-              <a:lnSpc>
-                <a:spcPct val="110000"/>
-              </a:lnSpc>
-            </a:pPr>
-            <a:r>
-              <a:rPr sz="1000" b="1">
-                <a:solidFill>
-                  <a:srgbClr val="4F46E5"/>
-                </a:solidFill>
-                <a:latin typeface="Arial"/>
-              </a:rPr>
-              <a:t>APPENDIX</a:t>
-            </a:r>
-          </a:p>
-        </p:txBody>
-      </p:sp>
-      <p:sp>
-        <p:nvSpPr>
-          <p:cNvPr id="3" name="TextBox 2"/>
-          <p:cNvSpPr txBox="1"/>
-          <p:nvPr/>
-        </p:nvSpPr>
-        <p:spPr>
-          <a:xfrm>
-            <a:off x="9784080" y="320040"/>
-            <a:ext cx="1828800" cy="274320"/>
-          </a:xfrm>
-          <a:prstGeom prst="rect">
-            <a:avLst/>
-          </a:prstGeom>
-          <a:noFill/>
-        </p:spPr>
-        <p:txBody>
-          <a:bodyPr wrap="square" lIns="73152" rIns="73152" tIns="36576" bIns="36576" anchor="t">
-            <a:spAutoFit/>
-          </a:bodyPr>
-          <a:lstStyle/>
-          <a:p>
-            <a:pPr algn="r">
-              <a:lnSpc>
-                <a:spcPct val="110000"/>
-              </a:lnSpc>
-            </a:pPr>
-            <a:r>
-              <a:rPr sz="1000" b="0">
-                <a:solidFill>
-                  <a:srgbClr val="94A3B8"/>
-                </a:solidFill>
-                <a:latin typeface="Arial"/>
-              </a:rPr>
-              <a:t>APPENDIX A</a:t>
-            </a:r>
-          </a:p>
-        </p:txBody>
-      </p:sp>
-      <p:sp>
-        <p:nvSpPr>
-          <p:cNvPr id="4" name="TextBox 3"/>
-          <p:cNvSpPr txBox="1"/>
-          <p:nvPr/>
-        </p:nvSpPr>
-        <p:spPr>
-          <a:xfrm>
-            <a:off x="548640" y="658368"/>
-            <a:ext cx="11064240" cy="731520"/>
-          </a:xfrm>
-          <a:prstGeom prst="rect">
-            <a:avLst/>
-          </a:prstGeom>
-          <a:noFill/>
-        </p:spPr>
-        <p:txBody>
-          <a:bodyPr wrap="square" lIns="73152" rIns="73152" tIns="36576" bIns="36576" anchor="t">
-            <a:spAutoFit/>
-          </a:bodyPr>
-          <a:lstStyle/>
-          <a:p>
-            <a:pPr algn="l">
-              <a:lnSpc>
-                <a:spcPct val="110000"/>
-              </a:lnSpc>
-            </a:pPr>
-            <a:r>
-              <a:rPr sz="3200" b="1">
-                <a:solidFill>
-                  <a:srgbClr val="0F172A"/>
-                </a:solidFill>
-                <a:latin typeface="Arial"/>
-              </a:rPr>
-              <a:t>Sources for this presentation</a:t>
-            </a:r>
-          </a:p>
-        </p:txBody>
-      </p:sp>
-      <p:sp>
-        <p:nvSpPr>
-          <p:cNvPr id="5" name="TextBox 4"/>
-          <p:cNvSpPr txBox="1"/>
-          <p:nvPr/>
-        </p:nvSpPr>
-        <p:spPr>
-          <a:xfrm>
-            <a:off x="548640" y="1371600"/>
-            <a:ext cx="11064240" cy="457200"/>
-          </a:xfrm>
-          <a:prstGeom prst="rect">
-            <a:avLst/>
-          </a:prstGeom>
-          <a:noFill/>
-        </p:spPr>
-        <p:txBody>
-          <a:bodyPr wrap="square" lIns="73152" rIns="73152" tIns="36576" bIns="36576" anchor="t">
-            <a:spAutoFit/>
-          </a:bodyPr>
-          <a:lstStyle/>
-          <a:p>
-            <a:pPr algn="l">
-              <a:lnSpc>
-                <a:spcPct val="110000"/>
-              </a:lnSpc>
-            </a:pPr>
-            <a:r>
-              <a:rPr sz="1700" b="0">
-                <a:solidFill>
-                  <a:srgbClr val="475569"/>
-                </a:solidFill>
-                <a:latin typeface="Arial"/>
-              </a:rPr>
-              <a:t>Every claim traces to Komodor's material or to this lab.</a:t>
-            </a:r>
-          </a:p>
-        </p:txBody>
-      </p:sp>
-      <p:sp>
-        <p:nvSpPr>
-          <p:cNvPr id="6" name="Rounded Rectangle 5"/>
-          <p:cNvSpPr/>
-          <p:nvPr/>
-        </p:nvSpPr>
-        <p:spPr>
-          <a:xfrm>
-            <a:off x="548640" y="2011680"/>
-            <a:ext cx="11091672" cy="621792"/>
-          </a:xfrm>
-          <a:prstGeom prst="roundRect">
-            <a:avLst>
-              <a:gd name="adj" fmla="val 6000"/>
-            </a:avLst>
-          </a:prstGeom>
-          <a:solidFill>
-            <a:srgbClr val="FFFFFF"/>
-          </a:solidFill>
-          <a:ln w="12700">
-            <a:solidFill>
-              <a:srgbClr val="E2E8F0"/>
-            </a:solidFill>
-          </a:ln>
-          <a:effectLst/>
-        </p:spPr>
-        <p:style>
-          <a:lnRef idx="1">
-            <a:schemeClr val="accent1"/>
-          </a:lnRef>
-          <a:fillRef idx="3">
-            <a:schemeClr val="accent1"/>
-          </a:fillRef>
-          <a:effectRef idx="2">
-            <a:schemeClr val="accent1"/>
-          </a:effectRef>
-          <a:fontRef idx="minor">
-            <a:schemeClr val="lt1"/>
-          </a:fontRef>
-        </p:style>
-        <p:txBody>
-          <a:bodyPr rtlCol="0" anchor="ctr"/>
-          <a:lstStyle/>
-          <a:p>
-            <a:pPr algn="ctr"/>
-          </a:p>
-        </p:txBody>
-      </p:sp>
-      <p:sp>
-        <p:nvSpPr>
-          <p:cNvPr id="7" name="TextBox 6"/>
-          <p:cNvSpPr txBox="1"/>
-          <p:nvPr/>
-        </p:nvSpPr>
-        <p:spPr>
-          <a:xfrm>
-            <a:off x="777240" y="2057400"/>
-            <a:ext cx="3931920" cy="530352"/>
-          </a:xfrm>
-          <a:prstGeom prst="rect">
-            <a:avLst/>
-          </a:prstGeom>
-          <a:noFill/>
-        </p:spPr>
-        <p:txBody>
-          <a:bodyPr wrap="square" lIns="73152" rIns="73152" tIns="36576" bIns="36576" anchor="ctr">
-            <a:spAutoFit/>
-          </a:bodyPr>
-          <a:lstStyle/>
-          <a:p>
-            <a:pPr algn="l">
-              <a:lnSpc>
-                <a:spcPct val="110000"/>
-              </a:lnSpc>
-            </a:pPr>
-            <a:r>
-              <a:rPr sz="1500" b="1">
-                <a:solidFill>
-                  <a:srgbClr val="0F172A"/>
-                </a:solidFill>
-                <a:latin typeface="Arial"/>
-              </a:rPr>
-              <a:t>Komodor website and KAOP launch</a:t>
-            </a:r>
-          </a:p>
-        </p:txBody>
-      </p:sp>
-      <p:sp>
-        <p:nvSpPr>
-          <p:cNvPr id="8" name="TextBox 7"/>
-          <p:cNvSpPr txBox="1"/>
-          <p:nvPr/>
-        </p:nvSpPr>
-        <p:spPr>
-          <a:xfrm>
-            <a:off x="4754880" y="2057400"/>
-            <a:ext cx="6766560" cy="530352"/>
-          </a:xfrm>
-          <a:prstGeom prst="rect">
-            <a:avLst/>
-          </a:prstGeom>
-          <a:noFill/>
-        </p:spPr>
-        <p:txBody>
-          <a:bodyPr wrap="square" lIns="73152" rIns="73152" tIns="36576" bIns="36576" anchor="ctr">
-            <a:spAutoFit/>
-          </a:bodyPr>
-          <a:lstStyle/>
-          <a:p>
-            <a:pPr algn="l">
-              <a:lnSpc>
-                <a:spcPct val="110000"/>
-              </a:lnSpc>
-            </a:pPr>
-            <a:r>
-              <a:rPr sz="1500" b="0">
-                <a:solidFill>
-                  <a:srgbClr val="475569"/>
-                </a:solidFill>
-                <a:latin typeface="Arial"/>
-              </a:rPr>
-              <a:t>Positioning: build, run, govern, optimize. The Gartner figure.</a:t>
-            </a:r>
-          </a:p>
-        </p:txBody>
-      </p:sp>
-      <p:sp>
-        <p:nvSpPr>
-          <p:cNvPr id="9" name="Rounded Rectangle 8"/>
-          <p:cNvSpPr/>
-          <p:nvPr/>
-        </p:nvSpPr>
-        <p:spPr>
-          <a:xfrm>
-            <a:off x="548640" y="2724912"/>
-            <a:ext cx="11091672" cy="621792"/>
-          </a:xfrm>
-          <a:prstGeom prst="roundRect">
-            <a:avLst>
-              <a:gd name="adj" fmla="val 6000"/>
-            </a:avLst>
-          </a:prstGeom>
-          <a:solidFill>
-            <a:srgbClr val="FFFFFF"/>
-          </a:solidFill>
-          <a:ln w="12700">
-            <a:solidFill>
-              <a:srgbClr val="E2E8F0"/>
-            </a:solidFill>
-          </a:ln>
-          <a:effectLst/>
-        </p:spPr>
-        <p:style>
-          <a:lnRef idx="1">
-            <a:schemeClr val="accent1"/>
-          </a:lnRef>
-          <a:fillRef idx="3">
-            <a:schemeClr val="accent1"/>
-          </a:fillRef>
-          <a:effectRef idx="2">
-            <a:schemeClr val="accent1"/>
-          </a:effectRef>
-          <a:fontRef idx="minor">
-            <a:schemeClr val="lt1"/>
-          </a:fontRef>
-        </p:style>
-        <p:txBody>
-          <a:bodyPr rtlCol="0" anchor="ctr"/>
-          <a:lstStyle/>
-          <a:p>
-            <a:pPr algn="ctr"/>
-          </a:p>
-        </p:txBody>
-      </p:sp>
-      <p:sp>
-        <p:nvSpPr>
-          <p:cNvPr id="10" name="TextBox 9"/>
-          <p:cNvSpPr txBox="1"/>
-          <p:nvPr/>
-        </p:nvSpPr>
-        <p:spPr>
-          <a:xfrm>
-            <a:off x="777240" y="2770632"/>
-            <a:ext cx="3931920" cy="530352"/>
-          </a:xfrm>
-          <a:prstGeom prst="rect">
-            <a:avLst/>
-          </a:prstGeom>
-          <a:noFill/>
-        </p:spPr>
-        <p:txBody>
-          <a:bodyPr wrap="square" lIns="73152" rIns="73152" tIns="36576" bIns="36576" anchor="ctr">
-            <a:spAutoFit/>
-          </a:bodyPr>
-          <a:lstStyle/>
-          <a:p>
-            <a:pPr algn="l">
-              <a:lnSpc>
-                <a:spcPct val="110000"/>
-              </a:lnSpc>
-            </a:pPr>
-            <a:r>
-              <a:rPr sz="1500" b="1">
-                <a:solidFill>
-                  <a:srgbClr val="0F172A"/>
-                </a:solidFill>
-                <a:latin typeface="Arial"/>
-              </a:rPr>
-              <a:t>KAOP docs: security and governance</a:t>
-            </a:r>
-          </a:p>
-        </p:txBody>
-      </p:sp>
-      <p:sp>
-        <p:nvSpPr>
-          <p:cNvPr id="11" name="TextBox 10"/>
-          <p:cNvSpPr txBox="1"/>
-          <p:nvPr/>
-        </p:nvSpPr>
-        <p:spPr>
-          <a:xfrm>
-            <a:off x="4754880" y="2770632"/>
-            <a:ext cx="6766560" cy="530352"/>
-          </a:xfrm>
-          <a:prstGeom prst="rect">
-            <a:avLst/>
-          </a:prstGeom>
-          <a:noFill/>
-        </p:spPr>
-        <p:txBody>
-          <a:bodyPr wrap="square" lIns="73152" rIns="73152" tIns="36576" bIns="36576" anchor="ctr">
-            <a:spAutoFit/>
-          </a:bodyPr>
-          <a:lstStyle/>
-          <a:p>
-            <a:pPr algn="l">
-              <a:lnSpc>
-                <a:spcPct val="110000"/>
-              </a:lnSpc>
-            </a:pPr>
-            <a:r>
-              <a:rPr sz="1500" b="0">
-                <a:solidFill>
-                  <a:srgbClr val="475569"/>
-                </a:solidFill>
-                <a:latin typeface="Arial"/>
-              </a:rPr>
-              <a:t>The six layers, approvals, audit log, Access explorer.</a:t>
-            </a:r>
-          </a:p>
-        </p:txBody>
-      </p:sp>
-      <p:sp>
-        <p:nvSpPr>
-          <p:cNvPr id="12" name="Rounded Rectangle 11"/>
-          <p:cNvSpPr/>
-          <p:nvPr/>
-        </p:nvSpPr>
-        <p:spPr>
-          <a:xfrm>
-            <a:off x="548640" y="3438144"/>
-            <a:ext cx="11091672" cy="621792"/>
-          </a:xfrm>
-          <a:prstGeom prst="roundRect">
-            <a:avLst>
-              <a:gd name="adj" fmla="val 6000"/>
-            </a:avLst>
-          </a:prstGeom>
-          <a:solidFill>
-            <a:srgbClr val="FFFFFF"/>
-          </a:solidFill>
-          <a:ln w="12700">
-            <a:solidFill>
-              <a:srgbClr val="E2E8F0"/>
-            </a:solidFill>
-          </a:ln>
-          <a:effectLst/>
-        </p:spPr>
-        <p:style>
-          <a:lnRef idx="1">
-            <a:schemeClr val="accent1"/>
-          </a:lnRef>
-          <a:fillRef idx="3">
-            <a:schemeClr val="accent1"/>
-          </a:fillRef>
-          <a:effectRef idx="2">
-            <a:schemeClr val="accent1"/>
-          </a:effectRef>
-          <a:fontRef idx="minor">
-            <a:schemeClr val="lt1"/>
-          </a:fontRef>
-        </p:style>
-        <p:txBody>
-          <a:bodyPr rtlCol="0" anchor="ctr"/>
-          <a:lstStyle/>
-          <a:p>
-            <a:pPr algn="ctr"/>
-          </a:p>
-        </p:txBody>
-      </p:sp>
-      <p:sp>
-        <p:nvSpPr>
-          <p:cNvPr id="13" name="TextBox 12"/>
-          <p:cNvSpPr txBox="1"/>
-          <p:nvPr/>
-        </p:nvSpPr>
-        <p:spPr>
-          <a:xfrm>
-            <a:off x="777240" y="3483864"/>
-            <a:ext cx="3931920" cy="530352"/>
-          </a:xfrm>
-          <a:prstGeom prst="rect">
-            <a:avLst/>
-          </a:prstGeom>
-          <a:noFill/>
-        </p:spPr>
-        <p:txBody>
-          <a:bodyPr wrap="square" lIns="73152" rIns="73152" tIns="36576" bIns="36576" anchor="ctr">
-            <a:spAutoFit/>
-          </a:bodyPr>
-          <a:lstStyle/>
-          <a:p>
-            <a:pPr algn="l">
-              <a:lnSpc>
-                <a:spcPct val="110000"/>
-              </a:lnSpc>
-            </a:pPr>
-            <a:r>
-              <a:rPr sz="1500" b="1">
-                <a:solidFill>
-                  <a:srgbClr val="0F172A"/>
-                </a:solidFill>
-                <a:latin typeface="Arial"/>
-              </a:rPr>
-              <a:t>KAOP docs: agent catalog</a:t>
-            </a:r>
-          </a:p>
-        </p:txBody>
-      </p:sp>
-      <p:sp>
-        <p:nvSpPr>
-          <p:cNvPr id="14" name="TextBox 13"/>
-          <p:cNvSpPr txBox="1"/>
-          <p:nvPr/>
-        </p:nvSpPr>
-        <p:spPr>
-          <a:xfrm>
-            <a:off x="4754880" y="3483864"/>
-            <a:ext cx="6766560" cy="530352"/>
-          </a:xfrm>
-          <a:prstGeom prst="rect">
-            <a:avLst/>
-          </a:prstGeom>
-          <a:noFill/>
-        </p:spPr>
-        <p:txBody>
-          <a:bodyPr wrap="square" lIns="73152" rIns="73152" tIns="36576" bIns="36576" anchor="ctr">
-            <a:spAutoFit/>
-          </a:bodyPr>
-          <a:lstStyle/>
-          <a:p>
-            <a:pPr algn="l">
-              <a:lnSpc>
-                <a:spcPct val="110000"/>
-              </a:lnSpc>
-            </a:pPr>
-            <a:r>
-              <a:rPr sz="1500" b="0">
-                <a:solidFill>
-                  <a:srgbClr val="475569"/>
-                </a:solidFill>
-                <a:latin typeface="Arial"/>
-              </a:rPr>
-              <a:t>What each agent reads, changes, and where it stops.</a:t>
-            </a:r>
-          </a:p>
-        </p:txBody>
-      </p:sp>
-      <p:sp>
-        <p:nvSpPr>
-          <p:cNvPr id="15" name="Rounded Rectangle 14"/>
-          <p:cNvSpPr/>
-          <p:nvPr/>
-        </p:nvSpPr>
-        <p:spPr>
-          <a:xfrm>
-            <a:off x="548640" y="4151376"/>
-            <a:ext cx="11091672" cy="621792"/>
-          </a:xfrm>
-          <a:prstGeom prst="roundRect">
-            <a:avLst>
-              <a:gd name="adj" fmla="val 6000"/>
-            </a:avLst>
-          </a:prstGeom>
-          <a:solidFill>
-            <a:srgbClr val="FFFFFF"/>
-          </a:solidFill>
-          <a:ln w="12700">
-            <a:solidFill>
-              <a:srgbClr val="E2E8F0"/>
-            </a:solidFill>
-          </a:ln>
-          <a:effectLst/>
-        </p:spPr>
-        <p:style>
-          <a:lnRef idx="1">
-            <a:schemeClr val="accent1"/>
-          </a:lnRef>
-          <a:fillRef idx="3">
-            <a:schemeClr val="accent1"/>
-          </a:fillRef>
-          <a:effectRef idx="2">
-            <a:schemeClr val="accent1"/>
-          </a:effectRef>
-          <a:fontRef idx="minor">
-            <a:schemeClr val="lt1"/>
-          </a:fontRef>
-        </p:style>
-        <p:txBody>
-          <a:bodyPr rtlCol="0" anchor="ctr"/>
-          <a:lstStyle/>
-          <a:p>
-            <a:pPr algn="ctr"/>
-          </a:p>
-        </p:txBody>
-      </p:sp>
-      <p:sp>
-        <p:nvSpPr>
-          <p:cNvPr id="16" name="TextBox 15"/>
-          <p:cNvSpPr txBox="1"/>
-          <p:nvPr/>
-        </p:nvSpPr>
-        <p:spPr>
-          <a:xfrm>
-            <a:off x="777240" y="4197096"/>
-            <a:ext cx="3931920" cy="530352"/>
-          </a:xfrm>
-          <a:prstGeom prst="rect">
-            <a:avLst/>
-          </a:prstGeom>
-          <a:noFill/>
-        </p:spPr>
-        <p:txBody>
-          <a:bodyPr wrap="square" lIns="73152" rIns="73152" tIns="36576" bIns="36576" anchor="ctr">
-            <a:spAutoFit/>
-          </a:bodyPr>
-          <a:lstStyle/>
-          <a:p>
-            <a:pPr algn="l">
-              <a:lnSpc>
-                <a:spcPct val="110000"/>
-              </a:lnSpc>
-            </a:pPr>
-            <a:r>
-              <a:rPr sz="1500" b="1">
-                <a:solidFill>
-                  <a:srgbClr val="0F172A"/>
-                </a:solidFill>
-                <a:latin typeface="Arial"/>
-              </a:rPr>
-              <a:t>KAOP docs: incident module</a:t>
-            </a:r>
-          </a:p>
-        </p:txBody>
-      </p:sp>
-      <p:sp>
-        <p:nvSpPr>
-          <p:cNvPr id="17" name="TextBox 16"/>
-          <p:cNvSpPr txBox="1"/>
-          <p:nvPr/>
-        </p:nvSpPr>
-        <p:spPr>
-          <a:xfrm>
-            <a:off x="4754880" y="4197096"/>
-            <a:ext cx="6766560" cy="530352"/>
-          </a:xfrm>
-          <a:prstGeom prst="rect">
-            <a:avLst/>
-          </a:prstGeom>
-          <a:noFill/>
-        </p:spPr>
-        <p:txBody>
-          <a:bodyPr wrap="square" lIns="73152" rIns="73152" tIns="36576" bIns="36576" anchor="ctr">
-            <a:spAutoFit/>
-          </a:bodyPr>
-          <a:lstStyle/>
-          <a:p>
-            <a:pPr algn="l">
-              <a:lnSpc>
-                <a:spcPct val="110000"/>
-              </a:lnSpc>
-            </a:pPr>
-            <a:r>
-              <a:rPr sz="1500" b="0">
-                <a:solidFill>
-                  <a:srgbClr val="475569"/>
-                </a:solidFill>
-                <a:latin typeface="Arial"/>
-              </a:rPr>
-              <a:t>The alert-to-remediation workflow.</a:t>
-            </a:r>
-          </a:p>
-        </p:txBody>
-      </p:sp>
-      <p:sp>
-        <p:nvSpPr>
-          <p:cNvPr id="18" name="Rounded Rectangle 17"/>
-          <p:cNvSpPr/>
-          <p:nvPr/>
-        </p:nvSpPr>
-        <p:spPr>
-          <a:xfrm>
-            <a:off x="548640" y="4864608"/>
-            <a:ext cx="11091672" cy="621792"/>
-          </a:xfrm>
-          <a:prstGeom prst="roundRect">
-            <a:avLst>
-              <a:gd name="adj" fmla="val 6000"/>
-            </a:avLst>
-          </a:prstGeom>
-          <a:solidFill>
-            <a:srgbClr val="FFFFFF"/>
-          </a:solidFill>
-          <a:ln w="12700">
-            <a:solidFill>
-              <a:srgbClr val="E2E8F0"/>
-            </a:solidFill>
-          </a:ln>
-          <a:effectLst/>
-        </p:spPr>
-        <p:style>
-          <a:lnRef idx="1">
-            <a:schemeClr val="accent1"/>
-          </a:lnRef>
-          <a:fillRef idx="3">
-            <a:schemeClr val="accent1"/>
-          </a:fillRef>
-          <a:effectRef idx="2">
-            <a:schemeClr val="accent1"/>
-          </a:effectRef>
-          <a:fontRef idx="minor">
-            <a:schemeClr val="lt1"/>
-          </a:fontRef>
-        </p:style>
-        <p:txBody>
-          <a:bodyPr rtlCol="0" anchor="ctr"/>
-          <a:lstStyle/>
-          <a:p>
-            <a:pPr algn="ctr"/>
-          </a:p>
-        </p:txBody>
-      </p:sp>
-      <p:sp>
-        <p:nvSpPr>
-          <p:cNvPr id="19" name="TextBox 18"/>
-          <p:cNvSpPr txBox="1"/>
-          <p:nvPr/>
-        </p:nvSpPr>
-        <p:spPr>
-          <a:xfrm>
-            <a:off x="777240" y="4910328"/>
-            <a:ext cx="3931920" cy="530352"/>
-          </a:xfrm>
-          <a:prstGeom prst="rect">
-            <a:avLst/>
-          </a:prstGeom>
-          <a:noFill/>
-        </p:spPr>
-        <p:txBody>
-          <a:bodyPr wrap="square" lIns="73152" rIns="73152" tIns="36576" bIns="36576" anchor="ctr">
-            <a:spAutoFit/>
-          </a:bodyPr>
-          <a:lstStyle/>
-          <a:p>
-            <a:pPr algn="l">
-              <a:lnSpc>
-                <a:spcPct val="110000"/>
-              </a:lnSpc>
-            </a:pPr>
-            <a:r>
-              <a:rPr sz="1500" b="1">
-                <a:solidFill>
-                  <a:srgbClr val="0F172A"/>
-                </a:solidFill>
-                <a:latin typeface="Arial"/>
-              </a:rPr>
-              <a:t>This lab</a:t>
-            </a:r>
-          </a:p>
-        </p:txBody>
-      </p:sp>
-      <p:sp>
-        <p:nvSpPr>
-          <p:cNvPr id="20" name="TextBox 19"/>
-          <p:cNvSpPr txBox="1"/>
-          <p:nvPr/>
-        </p:nvSpPr>
-        <p:spPr>
-          <a:xfrm>
-            <a:off x="4754880" y="4910328"/>
-            <a:ext cx="6766560" cy="530352"/>
-          </a:xfrm>
-          <a:prstGeom prst="rect">
-            <a:avLst/>
-          </a:prstGeom>
-          <a:noFill/>
-        </p:spPr>
-        <p:txBody>
-          <a:bodyPr wrap="square" lIns="73152" rIns="73152" tIns="36576" bIns="36576" anchor="ctr">
-            <a:spAutoFit/>
-          </a:bodyPr>
-          <a:lstStyle/>
-          <a:p>
-            <a:pPr algn="l">
-              <a:lnSpc>
-                <a:spcPct val="110000"/>
-              </a:lnSpc>
-            </a:pPr>
-            <a:r>
-              <a:rPr sz="1500" b="0">
-                <a:solidFill>
-                  <a:srgbClr val="475569"/>
-                </a:solidFill>
-                <a:latin typeface="Arial"/>
-              </a:rPr>
-              <a:t>A real fault, a real alert, permissions verified, fix measured.</a:t>
-            </a:r>
-          </a:p>
-        </p:txBody>
-      </p:sp>
-      <p:sp>
-        <p:nvSpPr>
-          <p:cNvPr id="21" name="Rounded Rectangle 20"/>
-          <p:cNvSpPr/>
-          <p:nvPr/>
-        </p:nvSpPr>
-        <p:spPr>
-          <a:xfrm>
-            <a:off x="548640" y="5852160"/>
-            <a:ext cx="11091672" cy="603504"/>
-          </a:xfrm>
-          <a:prstGeom prst="roundRect">
-            <a:avLst>
-              <a:gd name="adj" fmla="val 12000"/>
-            </a:avLst>
-          </a:prstGeom>
-          <a:solidFill>
-            <a:srgbClr val="0B1220"/>
-          </a:solidFill>
-          <a:ln>
-            <a:noFill/>
-          </a:ln>
-          <a:effectLst/>
-        </p:spPr>
-        <p:style>
-          <a:lnRef idx="1">
-            <a:schemeClr val="accent1"/>
-          </a:lnRef>
-          <a:fillRef idx="3">
-            <a:schemeClr val="accent1"/>
-          </a:fillRef>
-          <a:effectRef idx="2">
-            <a:schemeClr val="accent1"/>
-          </a:effectRef>
-          <a:fontRef idx="minor">
-            <a:schemeClr val="lt1"/>
-          </a:fontRef>
-        </p:style>
-        <p:txBody>
-          <a:bodyPr rtlCol="0" anchor="ctr" wrap="square" lIns="292608" rIns="73152" tIns="36576" bIns="36576"/>
-          <a:lstStyle/>
-          <a:p>
-            <a:pPr algn="l">
-              <a:lnSpc>
-                <a:spcPct val="110000"/>
-              </a:lnSpc>
-            </a:pPr>
-            <a:r>
-              <a:rPr sz="1200" b="1">
-                <a:solidFill>
-                  <a:srgbClr val="A5B4FC"/>
-                </a:solidFill>
-                <a:latin typeface="Arial"/>
-              </a:rPr>
-              <a:t>APPROACH   </a:t>
-            </a:r>
-            <a:r>
-              <a:rPr sz="1600" b="0">
-                <a:solidFill>
-                  <a:srgbClr val="FFFFFF"/>
-                </a:solidFill>
-                <a:latin typeface="Arial"/>
-              </a:rPr>
-              <a:t>Start from your challenges, prove it on a real incident, then agree the first step together.</a:t>
             </a:r>
           </a:p>
         </p:txBody>
@@ -13002,7 +12813,7 @@
                 </a:solidFill>
                 <a:latin typeface="Arial"/>
               </a:rPr>
-              <a:t>APPENDIX B</a:t>
+              <a:t>APPENDIX A</a:t>
             </a:r>
           </a:p>
         </p:txBody>
@@ -13041,21 +12852,60 @@
                 </a:solidFill>
                 <a:latin typeface="Arial"/>
               </a:rPr>
-              <a:t>Common questions</a:t>
-            </a:r>
-          </a:p>
-        </p:txBody>
-      </p:sp>
-      <p:sp>
-        <p:nvSpPr>
-          <p:cNvPr id="5" name="Rounded Rectangle 4"/>
+              <a:t>Sources for this presentation</a:t>
+            </a:r>
+          </a:p>
+        </p:txBody>
+      </p:sp>
+      <p:sp>
+        <p:nvSpPr>
+          <p:cNvPr id="5" name="TextBox 4"/>
+          <p:cNvSpPr txBox="1"/>
+          <p:nvPr/>
+        </p:nvSpPr>
+        <p:spPr>
+          <a:xfrm>
+            <a:off x="548640" y="1371600"/>
+            <a:ext cx="11064240" cy="457200"/>
+          </a:xfrm>
+          <a:prstGeom prst="rect">
+            <a:avLst/>
+          </a:prstGeom>
+          <a:noFill/>
+        </p:spPr>
+        <p:txBody>
+          <a:bodyPr wrap="square" lIns="73152" rIns="73152" tIns="36576" bIns="36576" anchor="t">
+            <a:spAutoFit/>
+          </a:bodyPr>
+          <a:lstStyle/>
+          <a:p>
+            <a:pPr algn="l">
+              <a:lnSpc>
+                <a:spcPct val="110000"/>
+              </a:lnSpc>
+            </a:pPr>
+            <a:r>
+              <a:rPr sz="1700" b="0">
+                <a:solidFill>
+                  <a:srgbClr val="475569"/>
+                </a:solidFill>
+                <a:latin typeface="Arial"/>
+              </a:rPr>
+              <a:t>Every claim traces to Komodor's material or to this lab.</a:t>
+            </a:r>
+          </a:p>
+        </p:txBody>
+      </p:sp>
+      <p:sp>
+        <p:nvSpPr>
+          <p:cNvPr id="6" name="Rounded Rectangle 5"/>
           <p:cNvSpPr/>
           <p:nvPr/>
         </p:nvSpPr>
         <p:spPr>
           <a:xfrm>
-            <a:off x="548640" y="1463040"/>
-            <a:ext cx="11091672" cy="804672"/>
+            <a:off x="548640" y="2011680"/>
+            <a:ext cx="11091672" cy="621792"/>
           </a:xfrm>
           <a:prstGeom prst="roundRect">
             <a:avLst>
@@ -13096,14 +12946,14 @@
       </p:sp>
       <p:sp>
         <p:nvSpPr>
-          <p:cNvPr id="6" name="TextBox 5"/>
-          <p:cNvSpPr txBox="1"/>
-          <p:nvPr/>
-        </p:nvSpPr>
-        <p:spPr>
-          <a:xfrm>
-            <a:off x="777240" y="1508760"/>
-            <a:ext cx="3931920" cy="713232"/>
+          <p:cNvPr id="7" name="TextBox 6"/>
+          <p:cNvSpPr txBox="1"/>
+          <p:nvPr/>
+        </p:nvSpPr>
+        <p:spPr>
+          <a:xfrm>
+            <a:off x="777240" y="2057400"/>
+            <a:ext cx="3931920" cy="530352"/>
           </a:xfrm>
           <a:prstGeom prst="rect">
             <a:avLst/>
@@ -13128,21 +12978,21 @@
                 </a:solidFill>
                 <a:latin typeface="Arial"/>
               </a:rPr>
-              <a:t>“We'll build this ourselves.”</a:t>
-            </a:r>
-          </a:p>
-        </p:txBody>
-      </p:sp>
-      <p:sp>
-        <p:nvSpPr>
-          <p:cNvPr id="7" name="TextBox 6"/>
-          <p:cNvSpPr txBox="1"/>
-          <p:nvPr/>
-        </p:nvSpPr>
-        <p:spPr>
-          <a:xfrm>
-            <a:off x="4754880" y="1508760"/>
-            <a:ext cx="6766560" cy="713232"/>
+              <a:t>Komodor website and KAOP launch</a:t>
+            </a:r>
+          </a:p>
+        </p:txBody>
+      </p:sp>
+      <p:sp>
+        <p:nvSpPr>
+          <p:cNvPr id="8" name="TextBox 7"/>
+          <p:cNvSpPr txBox="1"/>
+          <p:nvPr/>
+        </p:nvSpPr>
+        <p:spPr>
+          <a:xfrm>
+            <a:off x="4754880" y="2057400"/>
+            <a:ext cx="6766560" cy="530352"/>
           </a:xfrm>
           <a:prstGeom prst="rect">
             <a:avLst/>
@@ -13161,27 +13011,27 @@
               </a:lnSpc>
             </a:pPr>
             <a:r>
-              <a:rPr sz="1400" b="0">
+              <a:rPr sz="1500" b="0">
                 <a:solidFill>
                   <a:srgbClr val="475569"/>
                 </a:solidFill>
                 <a:latin typeface="Arial"/>
               </a:rPr>
-              <a:t>You can build an agent. The hard part is identity, approvals, audit, budgets and evaluation around every agent, for every team. That's the platform.</a:t>
-            </a:r>
-          </a:p>
-        </p:txBody>
-      </p:sp>
-      <p:sp>
-        <p:nvSpPr>
-          <p:cNvPr id="8" name="Rounded Rectangle 7"/>
+              <a:t>Positioning: build, run, govern, optimize. The Gartner figure.</a:t>
+            </a:r>
+          </a:p>
+        </p:txBody>
+      </p:sp>
+      <p:sp>
+        <p:nvSpPr>
+          <p:cNvPr id="9" name="Rounded Rectangle 8"/>
           <p:cNvSpPr/>
           <p:nvPr/>
         </p:nvSpPr>
         <p:spPr>
           <a:xfrm>
-            <a:off x="548640" y="2359152"/>
-            <a:ext cx="11091672" cy="804672"/>
+            <a:off x="548640" y="2724912"/>
+            <a:ext cx="11091672" cy="621792"/>
           </a:xfrm>
           <a:prstGeom prst="roundRect">
             <a:avLst>
@@ -13222,14 +13072,14 @@
       </p:sp>
       <p:sp>
         <p:nvSpPr>
-          <p:cNvPr id="9" name="TextBox 8"/>
-          <p:cNvSpPr txBox="1"/>
-          <p:nvPr/>
-        </p:nvSpPr>
-        <p:spPr>
-          <a:xfrm>
-            <a:off x="777240" y="2404872"/>
-            <a:ext cx="3931920" cy="713232"/>
+          <p:cNvPr id="10" name="TextBox 9"/>
+          <p:cNvSpPr txBox="1"/>
+          <p:nvPr/>
+        </p:nvSpPr>
+        <p:spPr>
+          <a:xfrm>
+            <a:off x="777240" y="2770632"/>
+            <a:ext cx="3931920" cy="530352"/>
           </a:xfrm>
           <a:prstGeom prst="rect">
             <a:avLst/>
@@ -13254,21 +13104,21 @@
                 </a:solidFill>
                 <a:latin typeface="Arial"/>
               </a:rPr>
-              <a:t>“Komodor already has Klaudia. Why KAOP?”</a:t>
-            </a:r>
-          </a:p>
-        </p:txBody>
-      </p:sp>
-      <p:sp>
-        <p:nvSpPr>
-          <p:cNvPr id="10" name="TextBox 9"/>
-          <p:cNvSpPr txBox="1"/>
-          <p:nvPr/>
-        </p:nvSpPr>
-        <p:spPr>
-          <a:xfrm>
-            <a:off x="4754880" y="2404872"/>
-            <a:ext cx="6766560" cy="713232"/>
+              <a:t>KAOP docs: security and governance</a:t>
+            </a:r>
+          </a:p>
+        </p:txBody>
+      </p:sp>
+      <p:sp>
+        <p:nvSpPr>
+          <p:cNvPr id="11" name="TextBox 10"/>
+          <p:cNvSpPr txBox="1"/>
+          <p:nvPr/>
+        </p:nvSpPr>
+        <p:spPr>
+          <a:xfrm>
+            <a:off x="4754880" y="2770632"/>
+            <a:ext cx="6766560" cy="530352"/>
           </a:xfrm>
           <a:prstGeom prst="rect">
             <a:avLst/>
@@ -13287,27 +13137,27 @@
               </a:lnSpc>
             </a:pPr>
             <a:r>
-              <a:rPr sz="1400" b="0">
+              <a:rPr sz="1500" b="0">
                 <a:solidFill>
                   <a:srgbClr val="475569"/>
                 </a:solidFill>
                 <a:latin typeface="Arial"/>
               </a:rPr>
-              <a:t>Klaudia is Komodor's AI SRE. KAOP is the control center for all your agents: Klaudia-based, Komodor's and your own.</a:t>
-            </a:r>
-          </a:p>
-        </p:txBody>
-      </p:sp>
-      <p:sp>
-        <p:nvSpPr>
-          <p:cNvPr id="11" name="Rounded Rectangle 10"/>
+              <a:t>The six layers, approvals, audit log, Access explorer.</a:t>
+            </a:r>
+          </a:p>
+        </p:txBody>
+      </p:sp>
+      <p:sp>
+        <p:nvSpPr>
+          <p:cNvPr id="12" name="Rounded Rectangle 11"/>
           <p:cNvSpPr/>
           <p:nvPr/>
         </p:nvSpPr>
         <p:spPr>
           <a:xfrm>
-            <a:off x="548640" y="3255264"/>
-            <a:ext cx="11091672" cy="804672"/>
+            <a:off x="548640" y="3438144"/>
+            <a:ext cx="11091672" cy="621792"/>
           </a:xfrm>
           <a:prstGeom prst="roundRect">
             <a:avLst>
@@ -13348,14 +13198,14 @@
       </p:sp>
       <p:sp>
         <p:nvSpPr>
-          <p:cNvPr id="12" name="TextBox 11"/>
-          <p:cNvSpPr txBox="1"/>
-          <p:nvPr/>
-        </p:nvSpPr>
-        <p:spPr>
-          <a:xfrm>
-            <a:off x="777240" y="3300984"/>
-            <a:ext cx="3931920" cy="713232"/>
+          <p:cNvPr id="13" name="TextBox 12"/>
+          <p:cNvSpPr txBox="1"/>
+          <p:nvPr/>
+        </p:nvSpPr>
+        <p:spPr>
+          <a:xfrm>
+            <a:off x="777240" y="3483864"/>
+            <a:ext cx="3931920" cy="530352"/>
           </a:xfrm>
           <a:prstGeom prst="rect">
             <a:avLst/>
@@ -13380,21 +13230,21 @@
                 </a:solidFill>
                 <a:latin typeface="Arial"/>
               </a:rPr>
-              <a:t>“What if the agent is wrong?”</a:t>
-            </a:r>
-          </a:p>
-        </p:txBody>
-      </p:sp>
-      <p:sp>
-        <p:nvSpPr>
-          <p:cNvPr id="13" name="TextBox 12"/>
-          <p:cNvSpPr txBox="1"/>
-          <p:nvPr/>
-        </p:nvSpPr>
-        <p:spPr>
-          <a:xfrm>
-            <a:off x="4754880" y="3300984"/>
-            <a:ext cx="6766560" cy="713232"/>
+              <a:t>KAOP docs: catalog, knowledge base, evaluations</a:t>
+            </a:r>
+          </a:p>
+        </p:txBody>
+      </p:sp>
+      <p:sp>
+        <p:nvSpPr>
+          <p:cNvPr id="14" name="TextBox 13"/>
+          <p:cNvSpPr txBox="1"/>
+          <p:nvPr/>
+        </p:nvSpPr>
+        <p:spPr>
+          <a:xfrm>
+            <a:off x="4754880" y="3483864"/>
+            <a:ext cx="6766560" cy="530352"/>
           </a:xfrm>
           <a:prstGeom prst="rect">
             <a:avLst/>
@@ -13413,27 +13263,27 @@
               </a:lnSpc>
             </a:pPr>
             <a:r>
-              <a:rPr sz="1400" b="0">
+              <a:rPr sz="1500" b="0">
                 <a:solidFill>
                   <a:srgbClr val="475569"/>
                 </a:solidFill>
                 <a:latin typeface="Arial"/>
               </a:rPr>
-              <a:t>It separates what it saw from what it guessed, every change needs a person, and KAOP can grade runs with an evaluator.</a:t>
-            </a:r>
-          </a:p>
-        </p:txBody>
-      </p:sp>
-      <p:sp>
-        <p:nvSpPr>
-          <p:cNvPr id="14" name="Rounded Rectangle 13"/>
+              <a:t>What each agent does, where it stops, and how runs are graded.</a:t>
+            </a:r>
+          </a:p>
+        </p:txBody>
+      </p:sp>
+      <p:sp>
+        <p:nvSpPr>
+          <p:cNvPr id="15" name="Rounded Rectangle 14"/>
           <p:cNvSpPr/>
           <p:nvPr/>
         </p:nvSpPr>
         <p:spPr>
           <a:xfrm>
             <a:off x="548640" y="4151376"/>
-            <a:ext cx="11091672" cy="804672"/>
+            <a:ext cx="11091672" cy="621792"/>
           </a:xfrm>
           <a:prstGeom prst="roundRect">
             <a:avLst>
@@ -13474,14 +13324,14 @@
       </p:sp>
       <p:sp>
         <p:nvSpPr>
-          <p:cNvPr id="15" name="TextBox 14"/>
+          <p:cNvPr id="16" name="TextBox 15"/>
           <p:cNvSpPr txBox="1"/>
           <p:nvPr/>
         </p:nvSpPr>
         <p:spPr>
           <a:xfrm>
             <a:off x="777240" y="4197096"/>
-            <a:ext cx="3931920" cy="713232"/>
+            <a:ext cx="3931920" cy="530352"/>
           </a:xfrm>
           <a:prstGeom prst="rect">
             <a:avLst/>
@@ -13506,21 +13356,21 @@
                 </a:solidFill>
                 <a:latin typeface="Arial"/>
               </a:rPr>
-              <a:t>“How long does onboarding take?”</a:t>
-            </a:r>
-          </a:p>
-        </p:txBody>
-      </p:sp>
-      <p:sp>
-        <p:nvSpPr>
-          <p:cNvPr id="16" name="TextBox 15"/>
+              <a:t>KAOP docs: incident module</a:t>
+            </a:r>
+          </a:p>
+        </p:txBody>
+      </p:sp>
+      <p:sp>
+        <p:nvSpPr>
+          <p:cNvPr id="17" name="TextBox 16"/>
           <p:cNvSpPr txBox="1"/>
           <p:nvPr/>
         </p:nvSpPr>
         <p:spPr>
           <a:xfrm>
             <a:off x="4754880" y="4197096"/>
-            <a:ext cx="6766560" cy="713232"/>
+            <a:ext cx="6766560" cy="530352"/>
           </a:xfrm>
           <a:prstGeom prst="rect">
             <a:avLst/>
@@ -13539,27 +13389,27 @@
               </a:lnSpc>
             </a:pPr>
             <a:r>
-              <a:rPr sz="1400" b="0">
+              <a:rPr sz="1500" b="0">
                 <a:solidFill>
                   <a:srgbClr val="475569"/>
                 </a:solidFill>
                 <a:latin typeface="Arial"/>
               </a:rPr>
-              <a:t>Catalog agents deploy in minutes. The real time goes into agreeing the workflow, the owner and the guardrails, which is why I'd start with a scoping session.</a:t>
-            </a:r>
-          </a:p>
-        </p:txBody>
-      </p:sp>
-      <p:sp>
-        <p:nvSpPr>
-          <p:cNvPr id="17" name="Rounded Rectangle 16"/>
+              <a:t>The alert-to-remediation workflow.</a:t>
+            </a:r>
+          </a:p>
+        </p:txBody>
+      </p:sp>
+      <p:sp>
+        <p:nvSpPr>
+          <p:cNvPr id="18" name="Rounded Rectangle 17"/>
           <p:cNvSpPr/>
           <p:nvPr/>
         </p:nvSpPr>
         <p:spPr>
           <a:xfrm>
-            <a:off x="548640" y="5047488"/>
-            <a:ext cx="11091672" cy="804672"/>
+            <a:off x="548640" y="4864608"/>
+            <a:ext cx="11091672" cy="621792"/>
           </a:xfrm>
           <a:prstGeom prst="roundRect">
             <a:avLst>
@@ -13600,14 +13450,14 @@
       </p:sp>
       <p:sp>
         <p:nvSpPr>
-          <p:cNvPr id="18" name="TextBox 17"/>
-          <p:cNvSpPr txBox="1"/>
-          <p:nvPr/>
-        </p:nvSpPr>
-        <p:spPr>
-          <a:xfrm>
-            <a:off x="777240" y="5093207"/>
-            <a:ext cx="3931920" cy="713232"/>
+          <p:cNvPr id="19" name="TextBox 18"/>
+          <p:cNvSpPr txBox="1"/>
+          <p:nvPr/>
+        </p:nvSpPr>
+        <p:spPr>
+          <a:xfrm>
+            <a:off x="777240" y="4910328"/>
+            <a:ext cx="3931920" cy="530352"/>
           </a:xfrm>
           <a:prstGeom prst="rect">
             <a:avLst/>
@@ -13632,21 +13482,21 @@
                 </a:solidFill>
                 <a:latin typeface="Arial"/>
               </a:rPr>
-              <a:t>“What does it cost?”</a:t>
-            </a:r>
-          </a:p>
-        </p:txBody>
-      </p:sp>
-      <p:sp>
-        <p:nvSpPr>
-          <p:cNvPr id="19" name="TextBox 18"/>
-          <p:cNvSpPr txBox="1"/>
-          <p:nvPr/>
-        </p:nvSpPr>
-        <p:spPr>
-          <a:xfrm>
-            <a:off x="4754880" y="5093207"/>
-            <a:ext cx="6766560" cy="713232"/>
+              <a:t>This lab</a:t>
+            </a:r>
+          </a:p>
+        </p:txBody>
+      </p:sp>
+      <p:sp>
+        <p:nvSpPr>
+          <p:cNvPr id="20" name="TextBox 19"/>
+          <p:cNvSpPr txBox="1"/>
+          <p:nvPr/>
+        </p:nvSpPr>
+        <p:spPr>
+          <a:xfrm>
+            <a:off x="4754880" y="4910328"/>
+            <a:ext cx="6766560" cy="530352"/>
           </a:xfrm>
           <a:prstGeom prst="rect">
             <a:avLst/>
@@ -13665,13 +13515,81 @@
               </a:lnSpc>
             </a:pPr>
             <a:r>
-              <a:rPr sz="1400" b="0">
+              <a:rPr sz="1500" b="0">
                 <a:solidFill>
                   <a:srgbClr val="475569"/>
                 </a:solidFill>
                 <a:latin typeface="Arial"/>
               </a:rPr>
-              <a:t>Every run shows its cost, and budgets block new runs at a limit. We'd agree a budget in the scoping session and track cost per useful investigation.</a:t>
+              <a:t>A real fault, a real alert, permissions verified, fix measured.</a:t>
+            </a:r>
+          </a:p>
+        </p:txBody>
+      </p:sp>
+      <p:sp>
+        <p:nvSpPr>
+          <p:cNvPr id="21" name="Rounded Rectangle 20"/>
+          <p:cNvSpPr/>
+          <p:nvPr/>
+        </p:nvSpPr>
+        <p:spPr>
+          <a:xfrm>
+            <a:off x="548640" y="5852160"/>
+            <a:ext cx="11091672" cy="603504"/>
+          </a:xfrm>
+          <a:prstGeom prst="roundRect">
+            <a:avLst>
+              <a:gd name="adj" fmla="val 12000"/>
+            </a:avLst>
+          </a:prstGeom>
+          <a:solidFill>
+            <a:srgbClr val="0B1220"/>
+          </a:solidFill>
+          <a:ln>
+            <a:noFill/>
+          </a:ln>
+          <a:effectLst/>
+        </p:spPr>
+        <p:style>
+          <a:lnRef idx="1">
+            <a:schemeClr val="accent1"/>
+          </a:lnRef>
+          <a:fillRef idx="3">
+            <a:schemeClr val="accent1"/>
+          </a:fillRef>
+          <a:effectRef idx="2">
+            <a:schemeClr val="accent1"/>
+          </a:effectRef>
+          <a:fontRef idx="minor">
+            <a:schemeClr val="lt1"/>
+          </a:fontRef>
+        </p:style>
+        <p:txBody>
+          <a:bodyPr rtlCol="0" anchor="ctr" wrap="square" lIns="292608" rIns="73152" tIns="36576" bIns="36576"/>
+          <a:lstStyle/>
+          <a:p>
+            <a:pPr algn="l">
+              <a:lnSpc>
+                <a:spcPct val="110000"/>
+              </a:lnSpc>
+            </a:pPr>
+            <a:r>
+              <a:rPr sz="1200" b="1">
+                <a:solidFill>
+                  <a:srgbClr val="A5B4FC"/>
+                </a:solidFill>
+                <a:latin typeface="Arial"/>
+              </a:rPr>
+              <a:t>APPROACH   </a:t>
+            </a:r>
+            <a:r>
+              <a:rPr sz="1600" b="0">
+                <a:solidFill>
+                  <a:srgbClr val="FFFFFF"/>
+                </a:solidFill>
+                <a:latin typeface="Arial"/>
+              </a:rPr>
+              <a:t>Start from your challenges, prove it on a real incident, then agree the first step together.</a:t>
             </a:r>
           </a:p>
         </p:txBody>
@@ -13775,7 +13693,7 @@
                 </a:solidFill>
                 <a:latin typeface="Arial"/>
               </a:rPr>
-              <a:t>APPENDIX C</a:t>
+              <a:t>APPENDIX B</a:t>
             </a:r>
           </a:p>
         </p:txBody>
@@ -13814,177 +13732,21 @@
                 </a:solidFill>
                 <a:latin typeface="Arial"/>
               </a:rPr>
-              <a:t>Measured results</a:t>
-            </a:r>
-          </a:p>
-        </p:txBody>
-      </p:sp>
-      <p:sp>
-        <p:nvSpPr>
-          <p:cNvPr id="5" name="TextBox 4"/>
-          <p:cNvSpPr txBox="1"/>
-          <p:nvPr/>
-        </p:nvSpPr>
-        <p:spPr>
-          <a:xfrm>
-            <a:off x="548640" y="1371600"/>
-            <a:ext cx="11064240" cy="457200"/>
-          </a:xfrm>
-          <a:prstGeom prst="rect">
-            <a:avLst/>
-          </a:prstGeom>
-          <a:noFill/>
-        </p:spPr>
-        <p:txBody>
-          <a:bodyPr wrap="square" lIns="73152" rIns="73152" tIns="36576" bIns="36576" anchor="t">
-            <a:spAutoFit/>
-          </a:bodyPr>
-          <a:lstStyle/>
-          <a:p>
-            <a:pPr algn="l">
-              <a:lnSpc>
-                <a:spcPct val="110000"/>
-              </a:lnSpc>
-            </a:pPr>
-            <a:r>
-              <a:rPr sz="1700" b="0">
-                <a:solidFill>
-                  <a:srgbClr val="475569"/>
-                </a:solidFill>
-                <a:latin typeface="Arial"/>
-              </a:rPr>
-              <a:t>The same Redis outage, measured both ways.</a:t>
-            </a:r>
-          </a:p>
-        </p:txBody>
-      </p:sp>
-      <p:sp>
-        <p:nvSpPr>
-          <p:cNvPr id="6" name="TextBox 5"/>
-          <p:cNvSpPr txBox="1"/>
-          <p:nvPr/>
-        </p:nvSpPr>
-        <p:spPr>
-          <a:xfrm>
-            <a:off x="777240" y="1965960"/>
-            <a:ext cx="3474720" cy="320040"/>
-          </a:xfrm>
-          <a:prstGeom prst="rect">
-            <a:avLst/>
-          </a:prstGeom>
-          <a:noFill/>
-        </p:spPr>
-        <p:txBody>
-          <a:bodyPr wrap="square" lIns="73152" rIns="73152" tIns="36576" bIns="36576" anchor="ctr">
-            <a:spAutoFit/>
-          </a:bodyPr>
-          <a:lstStyle/>
-          <a:p>
-            <a:pPr algn="l">
-              <a:lnSpc>
-                <a:spcPct val="110000"/>
-              </a:lnSpc>
-            </a:pPr>
-            <a:r>
-              <a:rPr sz="1100" b="1">
-                <a:solidFill>
-                  <a:srgbClr val="94A3B8"/>
-                </a:solidFill>
-                <a:latin typeface="Arial"/>
-              </a:rPr>
-              <a:t/>
-            </a:r>
-          </a:p>
-        </p:txBody>
-      </p:sp>
-      <p:sp>
-        <p:nvSpPr>
-          <p:cNvPr id="7" name="TextBox 6"/>
-          <p:cNvSpPr txBox="1"/>
-          <p:nvPr/>
-        </p:nvSpPr>
-        <p:spPr>
-          <a:xfrm>
-            <a:off x="4343400" y="1965960"/>
-            <a:ext cx="3657600" cy="320040"/>
-          </a:xfrm>
-          <a:prstGeom prst="rect">
-            <a:avLst/>
-          </a:prstGeom>
-          <a:noFill/>
-        </p:spPr>
-        <p:txBody>
-          <a:bodyPr wrap="square" lIns="73152" rIns="73152" tIns="36576" bIns="36576" anchor="ctr">
-            <a:spAutoFit/>
-          </a:bodyPr>
-          <a:lstStyle/>
-          <a:p>
-            <a:pPr algn="l">
-              <a:lnSpc>
-                <a:spcPct val="110000"/>
-              </a:lnSpc>
-            </a:pPr>
-            <a:r>
-              <a:rPr sz="1100" b="1">
-                <a:solidFill>
-                  <a:srgbClr val="94A3B8"/>
-                </a:solidFill>
-                <a:latin typeface="Arial"/>
-              </a:rPr>
-              <a:t>Liveness checks Redis (bad)</a:t>
-            </a:r>
-          </a:p>
-        </p:txBody>
-      </p:sp>
-      <p:sp>
-        <p:nvSpPr>
-          <p:cNvPr id="8" name="TextBox 7"/>
-          <p:cNvSpPr txBox="1"/>
-          <p:nvPr/>
-        </p:nvSpPr>
-        <p:spPr>
-          <a:xfrm>
-            <a:off x="8046720" y="1965960"/>
-            <a:ext cx="3566160" cy="320040"/>
-          </a:xfrm>
-          <a:prstGeom prst="rect">
-            <a:avLst/>
-          </a:prstGeom>
-          <a:noFill/>
-        </p:spPr>
-        <p:txBody>
-          <a:bodyPr wrap="square" lIns="73152" rIns="73152" tIns="36576" bIns="36576" anchor="ctr">
-            <a:spAutoFit/>
-          </a:bodyPr>
-          <a:lstStyle/>
-          <a:p>
-            <a:pPr algn="l">
-              <a:lnSpc>
-                <a:spcPct val="110000"/>
-              </a:lnSpc>
-            </a:pPr>
-            <a:r>
-              <a:rPr sz="1100" b="1">
-                <a:solidFill>
-                  <a:srgbClr val="94A3B8"/>
-                </a:solidFill>
-                <a:latin typeface="Arial"/>
-              </a:rPr>
-              <a:t>Liveness checks the process (fix)</a:t>
-            </a:r>
-          </a:p>
-        </p:txBody>
-      </p:sp>
-      <p:sp>
-        <p:nvSpPr>
-          <p:cNvPr id="9" name="Rounded Rectangle 8"/>
+              <a:t>Common questions</a:t>
+            </a:r>
+          </a:p>
+        </p:txBody>
+      </p:sp>
+      <p:sp>
+        <p:nvSpPr>
+          <p:cNvPr id="5" name="Rounded Rectangle 4"/>
           <p:cNvSpPr/>
           <p:nvPr/>
         </p:nvSpPr>
         <p:spPr>
           <a:xfrm>
-            <a:off x="548640" y="2331720"/>
-            <a:ext cx="11091672" cy="530352"/>
+            <a:off x="548640" y="1463040"/>
+            <a:ext cx="11091672" cy="804672"/>
           </a:xfrm>
           <a:prstGeom prst="roundRect">
             <a:avLst>
@@ -14025,14 +13787,14 @@
       </p:sp>
       <p:sp>
         <p:nvSpPr>
-          <p:cNvPr id="10" name="TextBox 9"/>
-          <p:cNvSpPr txBox="1"/>
-          <p:nvPr/>
-        </p:nvSpPr>
-        <p:spPr>
-          <a:xfrm>
-            <a:off x="777240" y="2350008"/>
-            <a:ext cx="3474720" cy="493776"/>
+          <p:cNvPr id="6" name="TextBox 5"/>
+          <p:cNvSpPr txBox="1"/>
+          <p:nvPr/>
+        </p:nvSpPr>
+        <p:spPr>
+          <a:xfrm>
+            <a:off x="777240" y="1508760"/>
+            <a:ext cx="3931920" cy="713232"/>
           </a:xfrm>
           <a:prstGeom prst="rect">
             <a:avLst/>
@@ -14057,21 +13819,21 @@
                 </a:solidFill>
                 <a:latin typeface="Arial"/>
               </a:rPr>
-              <a:t>Times Kubernetes killed the healthy API</a:t>
-            </a:r>
-          </a:p>
-        </p:txBody>
-      </p:sp>
-      <p:sp>
-        <p:nvSpPr>
-          <p:cNvPr id="11" name="TextBox 10"/>
-          <p:cNvSpPr txBox="1"/>
-          <p:nvPr/>
-        </p:nvSpPr>
-        <p:spPr>
-          <a:xfrm>
-            <a:off x="4343400" y="2350008"/>
-            <a:ext cx="3657600" cy="493776"/>
+              <a:t>“We'll build this ourselves.”</a:t>
+            </a:r>
+          </a:p>
+        </p:txBody>
+      </p:sp>
+      <p:sp>
+        <p:nvSpPr>
+          <p:cNvPr id="7" name="TextBox 6"/>
+          <p:cNvSpPr txBox="1"/>
+          <p:nvPr/>
+        </p:nvSpPr>
+        <p:spPr>
+          <a:xfrm>
+            <a:off x="4754880" y="1508760"/>
+            <a:ext cx="6766560" cy="713232"/>
           </a:xfrm>
           <a:prstGeom prst="rect">
             <a:avLst/>
@@ -14090,66 +13852,27 @@
               </a:lnSpc>
             </a:pPr>
             <a:r>
-              <a:rPr sz="1500" b="0">
-                <a:solidFill>
-                  <a:srgbClr val="B91C1C"/>
-                </a:solidFill>
-                <a:latin typeface="Arial"/>
-              </a:rPr>
-              <a:t>5 in a 5-minute outage</a:t>
-            </a:r>
-          </a:p>
-        </p:txBody>
-      </p:sp>
-      <p:sp>
-        <p:nvSpPr>
-          <p:cNvPr id="12" name="TextBox 11"/>
-          <p:cNvSpPr txBox="1"/>
-          <p:nvPr/>
-        </p:nvSpPr>
-        <p:spPr>
-          <a:xfrm>
-            <a:off x="8046720" y="2350008"/>
-            <a:ext cx="3566160" cy="493776"/>
-          </a:xfrm>
-          <a:prstGeom prst="rect">
-            <a:avLst/>
-          </a:prstGeom>
-          <a:noFill/>
-        </p:spPr>
-        <p:txBody>
-          <a:bodyPr wrap="square" lIns="73152" rIns="73152" tIns="36576" bIns="36576" anchor="ctr">
-            <a:spAutoFit/>
-          </a:bodyPr>
-          <a:lstStyle/>
-          <a:p>
-            <a:pPr algn="l">
-              <a:lnSpc>
-                <a:spcPct val="110000"/>
-              </a:lnSpc>
-            </a:pPr>
-            <a:r>
-              <a:rPr sz="1500" b="0">
-                <a:solidFill>
-                  <a:srgbClr val="0F766E"/>
-                </a:solidFill>
-                <a:latin typeface="Arial"/>
-              </a:rPr>
-              <a:t>0</a:t>
-            </a:r>
-          </a:p>
-        </p:txBody>
-      </p:sp>
-      <p:sp>
-        <p:nvSpPr>
-          <p:cNvPr id="13" name="Rounded Rectangle 12"/>
+              <a:rPr sz="1400" b="0">
+                <a:solidFill>
+                  <a:srgbClr val="475569"/>
+                </a:solidFill>
+                <a:latin typeface="Arial"/>
+              </a:rPr>
+              <a:t>You can build an agent. The hard part is identity, approvals, audit, budgets and evaluation around every agent, for every team. That's the platform.</a:t>
+            </a:r>
+          </a:p>
+        </p:txBody>
+      </p:sp>
+      <p:sp>
+        <p:nvSpPr>
+          <p:cNvPr id="8" name="Rounded Rectangle 7"/>
           <p:cNvSpPr/>
           <p:nvPr/>
         </p:nvSpPr>
         <p:spPr>
           <a:xfrm>
-            <a:off x="548640" y="2935224"/>
-            <a:ext cx="11091672" cy="530352"/>
+            <a:off x="548640" y="2359152"/>
+            <a:ext cx="11091672" cy="804672"/>
           </a:xfrm>
           <a:prstGeom prst="roundRect">
             <a:avLst>
@@ -14190,14 +13913,14 @@
       </p:sp>
       <p:sp>
         <p:nvSpPr>
-          <p:cNvPr id="14" name="TextBox 13"/>
-          <p:cNvSpPr txBox="1"/>
-          <p:nvPr/>
-        </p:nvSpPr>
-        <p:spPr>
-          <a:xfrm>
-            <a:off x="777240" y="2953512"/>
-            <a:ext cx="3474720" cy="493776"/>
+          <p:cNvPr id="9" name="TextBox 8"/>
+          <p:cNvSpPr txBox="1"/>
+          <p:nvPr/>
+        </p:nvSpPr>
+        <p:spPr>
+          <a:xfrm>
+            <a:off x="777240" y="2404872"/>
+            <a:ext cx="3931920" cy="713232"/>
           </a:xfrm>
           <a:prstGeom prst="rect">
             <a:avLst/>
@@ -14222,21 +13945,21 @@
                 </a:solidFill>
                 <a:latin typeface="Arial"/>
               </a:rPr>
-              <a:t>Liveness failures</a:t>
-            </a:r>
-          </a:p>
-        </p:txBody>
-      </p:sp>
-      <p:sp>
-        <p:nvSpPr>
-          <p:cNvPr id="15" name="TextBox 14"/>
-          <p:cNvSpPr txBox="1"/>
-          <p:nvPr/>
-        </p:nvSpPr>
-        <p:spPr>
-          <a:xfrm>
-            <a:off x="4343400" y="2953512"/>
-            <a:ext cx="3657600" cy="493776"/>
+              <a:t>“Komodor already has Klaudia. Why KAOP?”</a:t>
+            </a:r>
+          </a:p>
+        </p:txBody>
+      </p:sp>
+      <p:sp>
+        <p:nvSpPr>
+          <p:cNvPr id="10" name="TextBox 9"/>
+          <p:cNvSpPr txBox="1"/>
+          <p:nvPr/>
+        </p:nvSpPr>
+        <p:spPr>
+          <a:xfrm>
+            <a:off x="4754880" y="2404872"/>
+            <a:ext cx="6766560" cy="713232"/>
           </a:xfrm>
           <a:prstGeom prst="rect">
             <a:avLst/>
@@ -14255,66 +13978,27 @@
               </a:lnSpc>
             </a:pPr>
             <a:r>
-              <a:rPr sz="1500" b="0">
-                <a:solidFill>
-                  <a:srgbClr val="B91C1C"/>
-                </a:solidFill>
-                <a:latin typeface="Arial"/>
-              </a:rPr>
-              <a:t>Yes</a:t>
-            </a:r>
-          </a:p>
-        </p:txBody>
-      </p:sp>
-      <p:sp>
-        <p:nvSpPr>
-          <p:cNvPr id="16" name="TextBox 15"/>
-          <p:cNvSpPr txBox="1"/>
-          <p:nvPr/>
-        </p:nvSpPr>
-        <p:spPr>
-          <a:xfrm>
-            <a:off x="8046720" y="2953512"/>
-            <a:ext cx="3566160" cy="493776"/>
-          </a:xfrm>
-          <a:prstGeom prst="rect">
-            <a:avLst/>
-          </a:prstGeom>
-          <a:noFill/>
-        </p:spPr>
-        <p:txBody>
-          <a:bodyPr wrap="square" lIns="73152" rIns="73152" tIns="36576" bIns="36576" anchor="ctr">
-            <a:spAutoFit/>
-          </a:bodyPr>
-          <a:lstStyle/>
-          <a:p>
-            <a:pPr algn="l">
-              <a:lnSpc>
-                <a:spcPct val="110000"/>
-              </a:lnSpc>
-            </a:pPr>
-            <a:r>
-              <a:rPr sz="1500" b="0">
-                <a:solidFill>
-                  <a:srgbClr val="0F766E"/>
-                </a:solidFill>
-                <a:latin typeface="Arial"/>
-              </a:rPr>
-              <a:t>None</a:t>
-            </a:r>
-          </a:p>
-        </p:txBody>
-      </p:sp>
-      <p:sp>
-        <p:nvSpPr>
-          <p:cNvPr id="17" name="Rounded Rectangle 16"/>
+              <a:rPr sz="1400" b="0">
+                <a:solidFill>
+                  <a:srgbClr val="475569"/>
+                </a:solidFill>
+                <a:latin typeface="Arial"/>
+              </a:rPr>
+              <a:t>Klaudia is Komodor's AI SRE. KAOP is the control center for all your agents: Klaudia-based, Komodor's and your own.</a:t>
+            </a:r>
+          </a:p>
+        </p:txBody>
+      </p:sp>
+      <p:sp>
+        <p:nvSpPr>
+          <p:cNvPr id="11" name="Rounded Rectangle 10"/>
           <p:cNvSpPr/>
           <p:nvPr/>
         </p:nvSpPr>
         <p:spPr>
           <a:xfrm>
-            <a:off x="548640" y="3538728"/>
-            <a:ext cx="11091672" cy="530352"/>
+            <a:off x="548640" y="3255264"/>
+            <a:ext cx="11091672" cy="804672"/>
           </a:xfrm>
           <a:prstGeom prst="roundRect">
             <a:avLst>
@@ -14355,14 +14039,14 @@
       </p:sp>
       <p:sp>
         <p:nvSpPr>
-          <p:cNvPr id="18" name="TextBox 17"/>
-          <p:cNvSpPr txBox="1"/>
-          <p:nvPr/>
-        </p:nvSpPr>
-        <p:spPr>
-          <a:xfrm>
-            <a:off x="777240" y="3557016"/>
-            <a:ext cx="3474720" cy="493776"/>
+          <p:cNvPr id="12" name="TextBox 11"/>
+          <p:cNvSpPr txBox="1"/>
+          <p:nvPr/>
+        </p:nvSpPr>
+        <p:spPr>
+          <a:xfrm>
+            <a:off x="777240" y="3300984"/>
+            <a:ext cx="3931920" cy="713232"/>
           </a:xfrm>
           <a:prstGeom prst="rect">
             <a:avLst/>
@@ -14387,21 +14071,21 @@
                 </a:solidFill>
                 <a:latin typeface="Arial"/>
               </a:rPr>
-              <a:t>Grafana restart alert</a:t>
-            </a:r>
-          </a:p>
-        </p:txBody>
-      </p:sp>
-      <p:sp>
-        <p:nvSpPr>
-          <p:cNvPr id="19" name="TextBox 18"/>
-          <p:cNvSpPr txBox="1"/>
-          <p:nvPr/>
-        </p:nvSpPr>
-        <p:spPr>
-          <a:xfrm>
-            <a:off x="4343400" y="3557016"/>
-            <a:ext cx="3657600" cy="493776"/>
+              <a:t>“What if the agent is wrong?”</a:t>
+            </a:r>
+          </a:p>
+        </p:txBody>
+      </p:sp>
+      <p:sp>
+        <p:nvSpPr>
+          <p:cNvPr id="13" name="TextBox 12"/>
+          <p:cNvSpPr txBox="1"/>
+          <p:nvPr/>
+        </p:nvSpPr>
+        <p:spPr>
+          <a:xfrm>
+            <a:off x="4754880" y="3300984"/>
+            <a:ext cx="6766560" cy="713232"/>
           </a:xfrm>
           <a:prstGeom prst="rect">
             <a:avLst/>
@@ -14420,66 +14104,27 @@
               </a:lnSpc>
             </a:pPr>
             <a:r>
-              <a:rPr sz="1500" b="0">
-                <a:solidFill>
-                  <a:srgbClr val="B91C1C"/>
-                </a:solidFill>
-                <a:latin typeface="Arial"/>
-              </a:rPr>
-              <a:t>Fired at +3 minutes</a:t>
-            </a:r>
-          </a:p>
-        </p:txBody>
-      </p:sp>
-      <p:sp>
-        <p:nvSpPr>
-          <p:cNvPr id="20" name="TextBox 19"/>
-          <p:cNvSpPr txBox="1"/>
-          <p:nvPr/>
-        </p:nvSpPr>
-        <p:spPr>
-          <a:xfrm>
-            <a:off x="8046720" y="3557016"/>
-            <a:ext cx="3566160" cy="493776"/>
-          </a:xfrm>
-          <a:prstGeom prst="rect">
-            <a:avLst/>
-          </a:prstGeom>
-          <a:noFill/>
-        </p:spPr>
-        <p:txBody>
-          <a:bodyPr wrap="square" lIns="73152" rIns="73152" tIns="36576" bIns="36576" anchor="ctr">
-            <a:spAutoFit/>
-          </a:bodyPr>
-          <a:lstStyle/>
-          <a:p>
-            <a:pPr algn="l">
-              <a:lnSpc>
-                <a:spcPct val="110000"/>
-              </a:lnSpc>
-            </a:pPr>
-            <a:r>
-              <a:rPr sz="1500" b="0">
-                <a:solidFill>
-                  <a:srgbClr val="0F766E"/>
-                </a:solidFill>
-                <a:latin typeface="Arial"/>
-              </a:rPr>
-              <a:t>Stayed Normal</a:t>
-            </a:r>
-          </a:p>
-        </p:txBody>
-      </p:sp>
-      <p:sp>
-        <p:nvSpPr>
-          <p:cNvPr id="21" name="Rounded Rectangle 20"/>
+              <a:rPr sz="1400" b="0">
+                <a:solidFill>
+                  <a:srgbClr val="475569"/>
+                </a:solidFill>
+                <a:latin typeface="Arial"/>
+              </a:rPr>
+              <a:t>It separates what it saw from what it guessed, every change needs a person, and KAOP can grade runs with an evaluator.</a:t>
+            </a:r>
+          </a:p>
+        </p:txBody>
+      </p:sp>
+      <p:sp>
+        <p:nvSpPr>
+          <p:cNvPr id="14" name="Rounded Rectangle 13"/>
           <p:cNvSpPr/>
           <p:nvPr/>
         </p:nvSpPr>
         <p:spPr>
           <a:xfrm>
-            <a:off x="548640" y="4142231"/>
-            <a:ext cx="11091672" cy="530352"/>
+            <a:off x="548640" y="4151376"/>
+            <a:ext cx="11091672" cy="804672"/>
           </a:xfrm>
           <a:prstGeom prst="roundRect">
             <a:avLst>
@@ -14520,14 +14165,14 @@
       </p:sp>
       <p:sp>
         <p:nvSpPr>
-          <p:cNvPr id="22" name="TextBox 21"/>
-          <p:cNvSpPr txBox="1"/>
-          <p:nvPr/>
-        </p:nvSpPr>
-        <p:spPr>
-          <a:xfrm>
-            <a:off x="777240" y="4160519"/>
-            <a:ext cx="3474720" cy="493776"/>
+          <p:cNvPr id="15" name="TextBox 14"/>
+          <p:cNvSpPr txBox="1"/>
+          <p:nvPr/>
+        </p:nvSpPr>
+        <p:spPr>
+          <a:xfrm>
+            <a:off x="777240" y="4197096"/>
+            <a:ext cx="3931920" cy="713232"/>
           </a:xfrm>
           <a:prstGeom prst="rect">
             <a:avLst/>
@@ -14552,21 +14197,21 @@
                 </a:solidFill>
                 <a:latin typeface="Arial"/>
               </a:rPr>
-              <a:t>API back after Redis returned</a:t>
-            </a:r>
-          </a:p>
-        </p:txBody>
-      </p:sp>
-      <p:sp>
-        <p:nvSpPr>
-          <p:cNvPr id="23" name="TextBox 22"/>
-          <p:cNvSpPr txBox="1"/>
-          <p:nvPr/>
-        </p:nvSpPr>
-        <p:spPr>
-          <a:xfrm>
-            <a:off x="4343400" y="4160519"/>
-            <a:ext cx="3657600" cy="493776"/>
+              <a:t>“How long does onboarding take?”</a:t>
+            </a:r>
+          </a:p>
+        </p:txBody>
+      </p:sp>
+      <p:sp>
+        <p:nvSpPr>
+          <p:cNvPr id="16" name="TextBox 15"/>
+          <p:cNvSpPr txBox="1"/>
+          <p:nvPr/>
+        </p:nvSpPr>
+        <p:spPr>
+          <a:xfrm>
+            <a:off x="4754880" y="4197096"/>
+            <a:ext cx="6766560" cy="713232"/>
           </a:xfrm>
           <a:prstGeom prst="rect">
             <a:avLst/>
@@ -14585,27 +14230,75 @@
               </a:lnSpc>
             </a:pPr>
             <a:r>
-              <a:rPr sz="1500" b="0">
-                <a:solidFill>
-                  <a:srgbClr val="B91C1C"/>
-                </a:solidFill>
-                <a:latin typeface="Arial"/>
-              </a:rPr>
-              <a:t>4.8 s to 3.6 min (restart back-off)</a:t>
-            </a:r>
-          </a:p>
-        </p:txBody>
-      </p:sp>
-      <p:sp>
-        <p:nvSpPr>
-          <p:cNvPr id="24" name="TextBox 23"/>
-          <p:cNvSpPr txBox="1"/>
-          <p:nvPr/>
-        </p:nvSpPr>
-        <p:spPr>
-          <a:xfrm>
-            <a:off x="8046720" y="4160519"/>
-            <a:ext cx="3566160" cy="493776"/>
+              <a:rPr sz="1400" b="0">
+                <a:solidFill>
+                  <a:srgbClr val="475569"/>
+                </a:solidFill>
+                <a:latin typeface="Arial"/>
+              </a:rPr>
+              <a:t>Catalog agents deploy in minutes. The real time goes into agreeing the workflow, the owner and the guardrails, which is why I'd start with a scoping session.</a:t>
+            </a:r>
+          </a:p>
+        </p:txBody>
+      </p:sp>
+      <p:sp>
+        <p:nvSpPr>
+          <p:cNvPr id="17" name="Rounded Rectangle 16"/>
+          <p:cNvSpPr/>
+          <p:nvPr/>
+        </p:nvSpPr>
+        <p:spPr>
+          <a:xfrm>
+            <a:off x="548640" y="5047488"/>
+            <a:ext cx="11091672" cy="804672"/>
+          </a:xfrm>
+          <a:prstGeom prst="roundRect">
+            <a:avLst>
+              <a:gd name="adj" fmla="val 6000"/>
+            </a:avLst>
+          </a:prstGeom>
+          <a:solidFill>
+            <a:srgbClr val="FFFFFF"/>
+          </a:solidFill>
+          <a:ln w="12700">
+            <a:solidFill>
+              <a:srgbClr val="E2E8F0"/>
+            </a:solidFill>
+          </a:ln>
+          <a:effectLst/>
+        </p:spPr>
+        <p:style>
+          <a:lnRef idx="1">
+            <a:schemeClr val="accent1"/>
+          </a:lnRef>
+          <a:fillRef idx="3">
+            <a:schemeClr val="accent1"/>
+          </a:fillRef>
+          <a:effectRef idx="2">
+            <a:schemeClr val="accent1"/>
+          </a:effectRef>
+          <a:fontRef idx="minor">
+            <a:schemeClr val="lt1"/>
+          </a:fontRef>
+        </p:style>
+        <p:txBody>
+          <a:bodyPr rtlCol="0" anchor="ctr"/>
+          <a:lstStyle/>
+          <a:p>
+            <a:pPr algn="ctr"/>
+          </a:p>
+        </p:txBody>
+      </p:sp>
+      <p:sp>
+        <p:nvSpPr>
+          <p:cNvPr id="18" name="TextBox 17"/>
+          <p:cNvSpPr txBox="1"/>
+          <p:nvPr/>
+        </p:nvSpPr>
+        <p:spPr>
+          <a:xfrm>
+            <a:off x="777240" y="5093207"/>
+            <a:ext cx="3931920" cy="713232"/>
           </a:xfrm>
           <a:prstGeom prst="rect">
             <a:avLst/>
@@ -14624,35 +14317,35 @@
               </a:lnSpc>
             </a:pPr>
             <a:r>
-              <a:rPr sz="1500" b="0">
-                <a:solidFill>
-                  <a:srgbClr val="0F766E"/>
-                </a:solidFill>
-                <a:latin typeface="Arial"/>
-              </a:rPr>
-              <a:t>6.5 s</a:t>
-            </a:r>
-          </a:p>
-        </p:txBody>
-      </p:sp>
-      <p:sp>
-        <p:nvSpPr>
-          <p:cNvPr id="25" name="TextBox 24"/>
-          <p:cNvSpPr txBox="1"/>
-          <p:nvPr/>
-        </p:nvSpPr>
-        <p:spPr>
-          <a:xfrm>
-            <a:off x="548640" y="5897880"/>
-            <a:ext cx="11064240" cy="457200"/>
-          </a:xfrm>
-          <a:prstGeom prst="rect">
-            <a:avLst/>
-          </a:prstGeom>
-          <a:noFill/>
-        </p:spPr>
-        <p:txBody>
-          <a:bodyPr wrap="square" lIns="73152" rIns="73152" tIns="36576" bIns="36576" anchor="t">
+              <a:rPr sz="1500" b="1">
+                <a:solidFill>
+                  <a:srgbClr val="0F172A"/>
+                </a:solidFill>
+                <a:latin typeface="Arial"/>
+              </a:rPr>
+              <a:t>“What does it cost?”</a:t>
+            </a:r>
+          </a:p>
+        </p:txBody>
+      </p:sp>
+      <p:sp>
+        <p:nvSpPr>
+          <p:cNvPr id="19" name="TextBox 18"/>
+          <p:cNvSpPr txBox="1"/>
+          <p:nvPr/>
+        </p:nvSpPr>
+        <p:spPr>
+          <a:xfrm>
+            <a:off x="4754880" y="5093207"/>
+            <a:ext cx="6766560" cy="713232"/>
+          </a:xfrm>
+          <a:prstGeom prst="rect">
+            <a:avLst/>
+          </a:prstGeom>
+          <a:noFill/>
+        </p:spPr>
+        <p:txBody>
+          <a:bodyPr wrap="square" lIns="73152" rIns="73152" tIns="36576" bIns="36576" anchor="ctr">
             <a:spAutoFit/>
           </a:bodyPr>
           <a:lstStyle/>
@@ -14663,13 +14356,13 @@
               </a:lnSpc>
             </a:pPr>
             <a:r>
-              <a:rPr sz="1100" b="0">
-                <a:solidFill>
-                  <a:srgbClr val="94A3B8"/>
-                </a:solidFill>
-                <a:latin typeface="Arial"/>
-              </a:rPr>
-              <a:t>Measured on 2026-10-24 and 2026-10-25 on a single-node kind cluster. With the bad check, recovery waits on Kubernetes' restart back-off (10 s, doubling up to 5 minutes), so it depends on how long the outage lasted.</a:t>
+              <a:rPr sz="1400" b="0">
+                <a:solidFill>
+                  <a:srgbClr val="475569"/>
+                </a:solidFill>
+                <a:latin typeface="Arial"/>
+              </a:rPr>
+              <a:t>Every run shows its cost, and budgets block new runs at a limit. We'd agree a budget in the scoping session and track cost per useful investigation.</a:t>
             </a:r>
           </a:p>
         </p:txBody>
@@ -14773,6 +14466,1004 @@
                 </a:solidFill>
                 <a:latin typeface="Arial"/>
               </a:rPr>
+              <a:t>APPENDIX C</a:t>
+            </a:r>
+          </a:p>
+        </p:txBody>
+      </p:sp>
+      <p:sp>
+        <p:nvSpPr>
+          <p:cNvPr id="4" name="TextBox 3"/>
+          <p:cNvSpPr txBox="1"/>
+          <p:nvPr/>
+        </p:nvSpPr>
+        <p:spPr>
+          <a:xfrm>
+            <a:off x="548640" y="658368"/>
+            <a:ext cx="11064240" cy="731520"/>
+          </a:xfrm>
+          <a:prstGeom prst="rect">
+            <a:avLst/>
+          </a:prstGeom>
+          <a:noFill/>
+        </p:spPr>
+        <p:txBody>
+          <a:bodyPr wrap="square" lIns="73152" rIns="73152" tIns="36576" bIns="36576" anchor="t">
+            <a:spAutoFit/>
+          </a:bodyPr>
+          <a:lstStyle/>
+          <a:p>
+            <a:pPr algn="l">
+              <a:lnSpc>
+                <a:spcPct val="110000"/>
+              </a:lnSpc>
+            </a:pPr>
+            <a:r>
+              <a:rPr sz="3200" b="1">
+                <a:solidFill>
+                  <a:srgbClr val="0F172A"/>
+                </a:solidFill>
+                <a:latin typeface="Arial"/>
+              </a:rPr>
+              <a:t>Measured results</a:t>
+            </a:r>
+          </a:p>
+        </p:txBody>
+      </p:sp>
+      <p:sp>
+        <p:nvSpPr>
+          <p:cNvPr id="5" name="TextBox 4"/>
+          <p:cNvSpPr txBox="1"/>
+          <p:nvPr/>
+        </p:nvSpPr>
+        <p:spPr>
+          <a:xfrm>
+            <a:off x="548640" y="1371600"/>
+            <a:ext cx="11064240" cy="457200"/>
+          </a:xfrm>
+          <a:prstGeom prst="rect">
+            <a:avLst/>
+          </a:prstGeom>
+          <a:noFill/>
+        </p:spPr>
+        <p:txBody>
+          <a:bodyPr wrap="square" lIns="73152" rIns="73152" tIns="36576" bIns="36576" anchor="t">
+            <a:spAutoFit/>
+          </a:bodyPr>
+          <a:lstStyle/>
+          <a:p>
+            <a:pPr algn="l">
+              <a:lnSpc>
+                <a:spcPct val="110000"/>
+              </a:lnSpc>
+            </a:pPr>
+            <a:r>
+              <a:rPr sz="1700" b="0">
+                <a:solidFill>
+                  <a:srgbClr val="475569"/>
+                </a:solidFill>
+                <a:latin typeface="Arial"/>
+              </a:rPr>
+              <a:t>The same Redis outage, measured both ways.</a:t>
+            </a:r>
+          </a:p>
+        </p:txBody>
+      </p:sp>
+      <p:sp>
+        <p:nvSpPr>
+          <p:cNvPr id="6" name="TextBox 5"/>
+          <p:cNvSpPr txBox="1"/>
+          <p:nvPr/>
+        </p:nvSpPr>
+        <p:spPr>
+          <a:xfrm>
+            <a:off x="777240" y="1965960"/>
+            <a:ext cx="3474720" cy="320040"/>
+          </a:xfrm>
+          <a:prstGeom prst="rect">
+            <a:avLst/>
+          </a:prstGeom>
+          <a:noFill/>
+        </p:spPr>
+        <p:txBody>
+          <a:bodyPr wrap="square" lIns="73152" rIns="73152" tIns="36576" bIns="36576" anchor="ctr">
+            <a:spAutoFit/>
+          </a:bodyPr>
+          <a:lstStyle/>
+          <a:p>
+            <a:pPr algn="l">
+              <a:lnSpc>
+                <a:spcPct val="110000"/>
+              </a:lnSpc>
+            </a:pPr>
+            <a:r>
+              <a:rPr sz="1100" b="1">
+                <a:solidFill>
+                  <a:srgbClr val="94A3B8"/>
+                </a:solidFill>
+                <a:latin typeface="Arial"/>
+              </a:rPr>
+              <a:t/>
+            </a:r>
+          </a:p>
+        </p:txBody>
+      </p:sp>
+      <p:sp>
+        <p:nvSpPr>
+          <p:cNvPr id="7" name="TextBox 6"/>
+          <p:cNvSpPr txBox="1"/>
+          <p:nvPr/>
+        </p:nvSpPr>
+        <p:spPr>
+          <a:xfrm>
+            <a:off x="4343400" y="1965960"/>
+            <a:ext cx="3657600" cy="320040"/>
+          </a:xfrm>
+          <a:prstGeom prst="rect">
+            <a:avLst/>
+          </a:prstGeom>
+          <a:noFill/>
+        </p:spPr>
+        <p:txBody>
+          <a:bodyPr wrap="square" lIns="73152" rIns="73152" tIns="36576" bIns="36576" anchor="ctr">
+            <a:spAutoFit/>
+          </a:bodyPr>
+          <a:lstStyle/>
+          <a:p>
+            <a:pPr algn="l">
+              <a:lnSpc>
+                <a:spcPct val="110000"/>
+              </a:lnSpc>
+            </a:pPr>
+            <a:r>
+              <a:rPr sz="1100" b="1">
+                <a:solidFill>
+                  <a:srgbClr val="94A3B8"/>
+                </a:solidFill>
+                <a:latin typeface="Arial"/>
+              </a:rPr>
+              <a:t>Liveness checks Redis (bad)</a:t>
+            </a:r>
+          </a:p>
+        </p:txBody>
+      </p:sp>
+      <p:sp>
+        <p:nvSpPr>
+          <p:cNvPr id="8" name="TextBox 7"/>
+          <p:cNvSpPr txBox="1"/>
+          <p:nvPr/>
+        </p:nvSpPr>
+        <p:spPr>
+          <a:xfrm>
+            <a:off x="8046720" y="1965960"/>
+            <a:ext cx="3566160" cy="320040"/>
+          </a:xfrm>
+          <a:prstGeom prst="rect">
+            <a:avLst/>
+          </a:prstGeom>
+          <a:noFill/>
+        </p:spPr>
+        <p:txBody>
+          <a:bodyPr wrap="square" lIns="73152" rIns="73152" tIns="36576" bIns="36576" anchor="ctr">
+            <a:spAutoFit/>
+          </a:bodyPr>
+          <a:lstStyle/>
+          <a:p>
+            <a:pPr algn="l">
+              <a:lnSpc>
+                <a:spcPct val="110000"/>
+              </a:lnSpc>
+            </a:pPr>
+            <a:r>
+              <a:rPr sz="1100" b="1">
+                <a:solidFill>
+                  <a:srgbClr val="94A3B8"/>
+                </a:solidFill>
+                <a:latin typeface="Arial"/>
+              </a:rPr>
+              <a:t>Liveness checks the process (fix)</a:t>
+            </a:r>
+          </a:p>
+        </p:txBody>
+      </p:sp>
+      <p:sp>
+        <p:nvSpPr>
+          <p:cNvPr id="9" name="Rounded Rectangle 8"/>
+          <p:cNvSpPr/>
+          <p:nvPr/>
+        </p:nvSpPr>
+        <p:spPr>
+          <a:xfrm>
+            <a:off x="548640" y="2331720"/>
+            <a:ext cx="11091672" cy="530352"/>
+          </a:xfrm>
+          <a:prstGeom prst="roundRect">
+            <a:avLst>
+              <a:gd name="adj" fmla="val 6000"/>
+            </a:avLst>
+          </a:prstGeom>
+          <a:solidFill>
+            <a:srgbClr val="FFFFFF"/>
+          </a:solidFill>
+          <a:ln w="12700">
+            <a:solidFill>
+              <a:srgbClr val="E2E8F0"/>
+            </a:solidFill>
+          </a:ln>
+          <a:effectLst/>
+        </p:spPr>
+        <p:style>
+          <a:lnRef idx="1">
+            <a:schemeClr val="accent1"/>
+          </a:lnRef>
+          <a:fillRef idx="3">
+            <a:schemeClr val="accent1"/>
+          </a:fillRef>
+          <a:effectRef idx="2">
+            <a:schemeClr val="accent1"/>
+          </a:effectRef>
+          <a:fontRef idx="minor">
+            <a:schemeClr val="lt1"/>
+          </a:fontRef>
+        </p:style>
+        <p:txBody>
+          <a:bodyPr rtlCol="0" anchor="ctr"/>
+          <a:lstStyle/>
+          <a:p>
+            <a:pPr algn="ctr"/>
+          </a:p>
+        </p:txBody>
+      </p:sp>
+      <p:sp>
+        <p:nvSpPr>
+          <p:cNvPr id="10" name="TextBox 9"/>
+          <p:cNvSpPr txBox="1"/>
+          <p:nvPr/>
+        </p:nvSpPr>
+        <p:spPr>
+          <a:xfrm>
+            <a:off x="777240" y="2350008"/>
+            <a:ext cx="3474720" cy="493776"/>
+          </a:xfrm>
+          <a:prstGeom prst="rect">
+            <a:avLst/>
+          </a:prstGeom>
+          <a:noFill/>
+        </p:spPr>
+        <p:txBody>
+          <a:bodyPr wrap="square" lIns="73152" rIns="73152" tIns="36576" bIns="36576" anchor="ctr">
+            <a:spAutoFit/>
+          </a:bodyPr>
+          <a:lstStyle/>
+          <a:p>
+            <a:pPr algn="l">
+              <a:lnSpc>
+                <a:spcPct val="110000"/>
+              </a:lnSpc>
+            </a:pPr>
+            <a:r>
+              <a:rPr sz="1500" b="1">
+                <a:solidFill>
+                  <a:srgbClr val="0F172A"/>
+                </a:solidFill>
+                <a:latin typeface="Arial"/>
+              </a:rPr>
+              <a:t>Times Kubernetes killed the healthy API</a:t>
+            </a:r>
+          </a:p>
+        </p:txBody>
+      </p:sp>
+      <p:sp>
+        <p:nvSpPr>
+          <p:cNvPr id="11" name="TextBox 10"/>
+          <p:cNvSpPr txBox="1"/>
+          <p:nvPr/>
+        </p:nvSpPr>
+        <p:spPr>
+          <a:xfrm>
+            <a:off x="4343400" y="2350008"/>
+            <a:ext cx="3657600" cy="493776"/>
+          </a:xfrm>
+          <a:prstGeom prst="rect">
+            <a:avLst/>
+          </a:prstGeom>
+          <a:noFill/>
+        </p:spPr>
+        <p:txBody>
+          <a:bodyPr wrap="square" lIns="73152" rIns="73152" tIns="36576" bIns="36576" anchor="ctr">
+            <a:spAutoFit/>
+          </a:bodyPr>
+          <a:lstStyle/>
+          <a:p>
+            <a:pPr algn="l">
+              <a:lnSpc>
+                <a:spcPct val="110000"/>
+              </a:lnSpc>
+            </a:pPr>
+            <a:r>
+              <a:rPr sz="1500" b="0">
+                <a:solidFill>
+                  <a:srgbClr val="B91C1C"/>
+                </a:solidFill>
+                <a:latin typeface="Arial"/>
+              </a:rPr>
+              <a:t>5 in a 5-minute outage</a:t>
+            </a:r>
+          </a:p>
+        </p:txBody>
+      </p:sp>
+      <p:sp>
+        <p:nvSpPr>
+          <p:cNvPr id="12" name="TextBox 11"/>
+          <p:cNvSpPr txBox="1"/>
+          <p:nvPr/>
+        </p:nvSpPr>
+        <p:spPr>
+          <a:xfrm>
+            <a:off x="8046720" y="2350008"/>
+            <a:ext cx="3566160" cy="493776"/>
+          </a:xfrm>
+          <a:prstGeom prst="rect">
+            <a:avLst/>
+          </a:prstGeom>
+          <a:noFill/>
+        </p:spPr>
+        <p:txBody>
+          <a:bodyPr wrap="square" lIns="73152" rIns="73152" tIns="36576" bIns="36576" anchor="ctr">
+            <a:spAutoFit/>
+          </a:bodyPr>
+          <a:lstStyle/>
+          <a:p>
+            <a:pPr algn="l">
+              <a:lnSpc>
+                <a:spcPct val="110000"/>
+              </a:lnSpc>
+            </a:pPr>
+            <a:r>
+              <a:rPr sz="1500" b="0">
+                <a:solidFill>
+                  <a:srgbClr val="0F766E"/>
+                </a:solidFill>
+                <a:latin typeface="Arial"/>
+              </a:rPr>
+              <a:t>0</a:t>
+            </a:r>
+          </a:p>
+        </p:txBody>
+      </p:sp>
+      <p:sp>
+        <p:nvSpPr>
+          <p:cNvPr id="13" name="Rounded Rectangle 12"/>
+          <p:cNvSpPr/>
+          <p:nvPr/>
+        </p:nvSpPr>
+        <p:spPr>
+          <a:xfrm>
+            <a:off x="548640" y="2935224"/>
+            <a:ext cx="11091672" cy="530352"/>
+          </a:xfrm>
+          <a:prstGeom prst="roundRect">
+            <a:avLst>
+              <a:gd name="adj" fmla="val 6000"/>
+            </a:avLst>
+          </a:prstGeom>
+          <a:solidFill>
+            <a:srgbClr val="FFFFFF"/>
+          </a:solidFill>
+          <a:ln w="12700">
+            <a:solidFill>
+              <a:srgbClr val="E2E8F0"/>
+            </a:solidFill>
+          </a:ln>
+          <a:effectLst/>
+        </p:spPr>
+        <p:style>
+          <a:lnRef idx="1">
+            <a:schemeClr val="accent1"/>
+          </a:lnRef>
+          <a:fillRef idx="3">
+            <a:schemeClr val="accent1"/>
+          </a:fillRef>
+          <a:effectRef idx="2">
+            <a:schemeClr val="accent1"/>
+          </a:effectRef>
+          <a:fontRef idx="minor">
+            <a:schemeClr val="lt1"/>
+          </a:fontRef>
+        </p:style>
+        <p:txBody>
+          <a:bodyPr rtlCol="0" anchor="ctr"/>
+          <a:lstStyle/>
+          <a:p>
+            <a:pPr algn="ctr"/>
+          </a:p>
+        </p:txBody>
+      </p:sp>
+      <p:sp>
+        <p:nvSpPr>
+          <p:cNvPr id="14" name="TextBox 13"/>
+          <p:cNvSpPr txBox="1"/>
+          <p:nvPr/>
+        </p:nvSpPr>
+        <p:spPr>
+          <a:xfrm>
+            <a:off x="777240" y="2953512"/>
+            <a:ext cx="3474720" cy="493776"/>
+          </a:xfrm>
+          <a:prstGeom prst="rect">
+            <a:avLst/>
+          </a:prstGeom>
+          <a:noFill/>
+        </p:spPr>
+        <p:txBody>
+          <a:bodyPr wrap="square" lIns="73152" rIns="73152" tIns="36576" bIns="36576" anchor="ctr">
+            <a:spAutoFit/>
+          </a:bodyPr>
+          <a:lstStyle/>
+          <a:p>
+            <a:pPr algn="l">
+              <a:lnSpc>
+                <a:spcPct val="110000"/>
+              </a:lnSpc>
+            </a:pPr>
+            <a:r>
+              <a:rPr sz="1500" b="1">
+                <a:solidFill>
+                  <a:srgbClr val="0F172A"/>
+                </a:solidFill>
+                <a:latin typeface="Arial"/>
+              </a:rPr>
+              <a:t>Liveness failures</a:t>
+            </a:r>
+          </a:p>
+        </p:txBody>
+      </p:sp>
+      <p:sp>
+        <p:nvSpPr>
+          <p:cNvPr id="15" name="TextBox 14"/>
+          <p:cNvSpPr txBox="1"/>
+          <p:nvPr/>
+        </p:nvSpPr>
+        <p:spPr>
+          <a:xfrm>
+            <a:off x="4343400" y="2953512"/>
+            <a:ext cx="3657600" cy="493776"/>
+          </a:xfrm>
+          <a:prstGeom prst="rect">
+            <a:avLst/>
+          </a:prstGeom>
+          <a:noFill/>
+        </p:spPr>
+        <p:txBody>
+          <a:bodyPr wrap="square" lIns="73152" rIns="73152" tIns="36576" bIns="36576" anchor="ctr">
+            <a:spAutoFit/>
+          </a:bodyPr>
+          <a:lstStyle/>
+          <a:p>
+            <a:pPr algn="l">
+              <a:lnSpc>
+                <a:spcPct val="110000"/>
+              </a:lnSpc>
+            </a:pPr>
+            <a:r>
+              <a:rPr sz="1500" b="0">
+                <a:solidFill>
+                  <a:srgbClr val="B91C1C"/>
+                </a:solidFill>
+                <a:latin typeface="Arial"/>
+              </a:rPr>
+              <a:t>Yes</a:t>
+            </a:r>
+          </a:p>
+        </p:txBody>
+      </p:sp>
+      <p:sp>
+        <p:nvSpPr>
+          <p:cNvPr id="16" name="TextBox 15"/>
+          <p:cNvSpPr txBox="1"/>
+          <p:nvPr/>
+        </p:nvSpPr>
+        <p:spPr>
+          <a:xfrm>
+            <a:off x="8046720" y="2953512"/>
+            <a:ext cx="3566160" cy="493776"/>
+          </a:xfrm>
+          <a:prstGeom prst="rect">
+            <a:avLst/>
+          </a:prstGeom>
+          <a:noFill/>
+        </p:spPr>
+        <p:txBody>
+          <a:bodyPr wrap="square" lIns="73152" rIns="73152" tIns="36576" bIns="36576" anchor="ctr">
+            <a:spAutoFit/>
+          </a:bodyPr>
+          <a:lstStyle/>
+          <a:p>
+            <a:pPr algn="l">
+              <a:lnSpc>
+                <a:spcPct val="110000"/>
+              </a:lnSpc>
+            </a:pPr>
+            <a:r>
+              <a:rPr sz="1500" b="0">
+                <a:solidFill>
+                  <a:srgbClr val="0F766E"/>
+                </a:solidFill>
+                <a:latin typeface="Arial"/>
+              </a:rPr>
+              <a:t>None</a:t>
+            </a:r>
+          </a:p>
+        </p:txBody>
+      </p:sp>
+      <p:sp>
+        <p:nvSpPr>
+          <p:cNvPr id="17" name="Rounded Rectangle 16"/>
+          <p:cNvSpPr/>
+          <p:nvPr/>
+        </p:nvSpPr>
+        <p:spPr>
+          <a:xfrm>
+            <a:off x="548640" y="3538728"/>
+            <a:ext cx="11091672" cy="530352"/>
+          </a:xfrm>
+          <a:prstGeom prst="roundRect">
+            <a:avLst>
+              <a:gd name="adj" fmla="val 6000"/>
+            </a:avLst>
+          </a:prstGeom>
+          <a:solidFill>
+            <a:srgbClr val="FFFFFF"/>
+          </a:solidFill>
+          <a:ln w="12700">
+            <a:solidFill>
+              <a:srgbClr val="E2E8F0"/>
+            </a:solidFill>
+          </a:ln>
+          <a:effectLst/>
+        </p:spPr>
+        <p:style>
+          <a:lnRef idx="1">
+            <a:schemeClr val="accent1"/>
+          </a:lnRef>
+          <a:fillRef idx="3">
+            <a:schemeClr val="accent1"/>
+          </a:fillRef>
+          <a:effectRef idx="2">
+            <a:schemeClr val="accent1"/>
+          </a:effectRef>
+          <a:fontRef idx="minor">
+            <a:schemeClr val="lt1"/>
+          </a:fontRef>
+        </p:style>
+        <p:txBody>
+          <a:bodyPr rtlCol="0" anchor="ctr"/>
+          <a:lstStyle/>
+          <a:p>
+            <a:pPr algn="ctr"/>
+          </a:p>
+        </p:txBody>
+      </p:sp>
+      <p:sp>
+        <p:nvSpPr>
+          <p:cNvPr id="18" name="TextBox 17"/>
+          <p:cNvSpPr txBox="1"/>
+          <p:nvPr/>
+        </p:nvSpPr>
+        <p:spPr>
+          <a:xfrm>
+            <a:off x="777240" y="3557016"/>
+            <a:ext cx="3474720" cy="493776"/>
+          </a:xfrm>
+          <a:prstGeom prst="rect">
+            <a:avLst/>
+          </a:prstGeom>
+          <a:noFill/>
+        </p:spPr>
+        <p:txBody>
+          <a:bodyPr wrap="square" lIns="73152" rIns="73152" tIns="36576" bIns="36576" anchor="ctr">
+            <a:spAutoFit/>
+          </a:bodyPr>
+          <a:lstStyle/>
+          <a:p>
+            <a:pPr algn="l">
+              <a:lnSpc>
+                <a:spcPct val="110000"/>
+              </a:lnSpc>
+            </a:pPr>
+            <a:r>
+              <a:rPr sz="1500" b="1">
+                <a:solidFill>
+                  <a:srgbClr val="0F172A"/>
+                </a:solidFill>
+                <a:latin typeface="Arial"/>
+              </a:rPr>
+              <a:t>Grafana restart alert</a:t>
+            </a:r>
+          </a:p>
+        </p:txBody>
+      </p:sp>
+      <p:sp>
+        <p:nvSpPr>
+          <p:cNvPr id="19" name="TextBox 18"/>
+          <p:cNvSpPr txBox="1"/>
+          <p:nvPr/>
+        </p:nvSpPr>
+        <p:spPr>
+          <a:xfrm>
+            <a:off x="4343400" y="3557016"/>
+            <a:ext cx="3657600" cy="493776"/>
+          </a:xfrm>
+          <a:prstGeom prst="rect">
+            <a:avLst/>
+          </a:prstGeom>
+          <a:noFill/>
+        </p:spPr>
+        <p:txBody>
+          <a:bodyPr wrap="square" lIns="73152" rIns="73152" tIns="36576" bIns="36576" anchor="ctr">
+            <a:spAutoFit/>
+          </a:bodyPr>
+          <a:lstStyle/>
+          <a:p>
+            <a:pPr algn="l">
+              <a:lnSpc>
+                <a:spcPct val="110000"/>
+              </a:lnSpc>
+            </a:pPr>
+            <a:r>
+              <a:rPr sz="1500" b="0">
+                <a:solidFill>
+                  <a:srgbClr val="B91C1C"/>
+                </a:solidFill>
+                <a:latin typeface="Arial"/>
+              </a:rPr>
+              <a:t>Fired at +3 minutes</a:t>
+            </a:r>
+          </a:p>
+        </p:txBody>
+      </p:sp>
+      <p:sp>
+        <p:nvSpPr>
+          <p:cNvPr id="20" name="TextBox 19"/>
+          <p:cNvSpPr txBox="1"/>
+          <p:nvPr/>
+        </p:nvSpPr>
+        <p:spPr>
+          <a:xfrm>
+            <a:off x="8046720" y="3557016"/>
+            <a:ext cx="3566160" cy="493776"/>
+          </a:xfrm>
+          <a:prstGeom prst="rect">
+            <a:avLst/>
+          </a:prstGeom>
+          <a:noFill/>
+        </p:spPr>
+        <p:txBody>
+          <a:bodyPr wrap="square" lIns="73152" rIns="73152" tIns="36576" bIns="36576" anchor="ctr">
+            <a:spAutoFit/>
+          </a:bodyPr>
+          <a:lstStyle/>
+          <a:p>
+            <a:pPr algn="l">
+              <a:lnSpc>
+                <a:spcPct val="110000"/>
+              </a:lnSpc>
+            </a:pPr>
+            <a:r>
+              <a:rPr sz="1500" b="0">
+                <a:solidFill>
+                  <a:srgbClr val="0F766E"/>
+                </a:solidFill>
+                <a:latin typeface="Arial"/>
+              </a:rPr>
+              <a:t>Stayed Normal</a:t>
+            </a:r>
+          </a:p>
+        </p:txBody>
+      </p:sp>
+      <p:sp>
+        <p:nvSpPr>
+          <p:cNvPr id="21" name="Rounded Rectangle 20"/>
+          <p:cNvSpPr/>
+          <p:nvPr/>
+        </p:nvSpPr>
+        <p:spPr>
+          <a:xfrm>
+            <a:off x="548640" y="4142231"/>
+            <a:ext cx="11091672" cy="530352"/>
+          </a:xfrm>
+          <a:prstGeom prst="roundRect">
+            <a:avLst>
+              <a:gd name="adj" fmla="val 6000"/>
+            </a:avLst>
+          </a:prstGeom>
+          <a:solidFill>
+            <a:srgbClr val="FFFFFF"/>
+          </a:solidFill>
+          <a:ln w="12700">
+            <a:solidFill>
+              <a:srgbClr val="E2E8F0"/>
+            </a:solidFill>
+          </a:ln>
+          <a:effectLst/>
+        </p:spPr>
+        <p:style>
+          <a:lnRef idx="1">
+            <a:schemeClr val="accent1"/>
+          </a:lnRef>
+          <a:fillRef idx="3">
+            <a:schemeClr val="accent1"/>
+          </a:fillRef>
+          <a:effectRef idx="2">
+            <a:schemeClr val="accent1"/>
+          </a:effectRef>
+          <a:fontRef idx="minor">
+            <a:schemeClr val="lt1"/>
+          </a:fontRef>
+        </p:style>
+        <p:txBody>
+          <a:bodyPr rtlCol="0" anchor="ctr"/>
+          <a:lstStyle/>
+          <a:p>
+            <a:pPr algn="ctr"/>
+          </a:p>
+        </p:txBody>
+      </p:sp>
+      <p:sp>
+        <p:nvSpPr>
+          <p:cNvPr id="22" name="TextBox 21"/>
+          <p:cNvSpPr txBox="1"/>
+          <p:nvPr/>
+        </p:nvSpPr>
+        <p:spPr>
+          <a:xfrm>
+            <a:off x="777240" y="4160519"/>
+            <a:ext cx="3474720" cy="493776"/>
+          </a:xfrm>
+          <a:prstGeom prst="rect">
+            <a:avLst/>
+          </a:prstGeom>
+          <a:noFill/>
+        </p:spPr>
+        <p:txBody>
+          <a:bodyPr wrap="square" lIns="73152" rIns="73152" tIns="36576" bIns="36576" anchor="ctr">
+            <a:spAutoFit/>
+          </a:bodyPr>
+          <a:lstStyle/>
+          <a:p>
+            <a:pPr algn="l">
+              <a:lnSpc>
+                <a:spcPct val="110000"/>
+              </a:lnSpc>
+            </a:pPr>
+            <a:r>
+              <a:rPr sz="1500" b="1">
+                <a:solidFill>
+                  <a:srgbClr val="0F172A"/>
+                </a:solidFill>
+                <a:latin typeface="Arial"/>
+              </a:rPr>
+              <a:t>API back after Redis returned</a:t>
+            </a:r>
+          </a:p>
+        </p:txBody>
+      </p:sp>
+      <p:sp>
+        <p:nvSpPr>
+          <p:cNvPr id="23" name="TextBox 22"/>
+          <p:cNvSpPr txBox="1"/>
+          <p:nvPr/>
+        </p:nvSpPr>
+        <p:spPr>
+          <a:xfrm>
+            <a:off x="4343400" y="4160519"/>
+            <a:ext cx="3657600" cy="493776"/>
+          </a:xfrm>
+          <a:prstGeom prst="rect">
+            <a:avLst/>
+          </a:prstGeom>
+          <a:noFill/>
+        </p:spPr>
+        <p:txBody>
+          <a:bodyPr wrap="square" lIns="73152" rIns="73152" tIns="36576" bIns="36576" anchor="ctr">
+            <a:spAutoFit/>
+          </a:bodyPr>
+          <a:lstStyle/>
+          <a:p>
+            <a:pPr algn="l">
+              <a:lnSpc>
+                <a:spcPct val="110000"/>
+              </a:lnSpc>
+            </a:pPr>
+            <a:r>
+              <a:rPr sz="1500" b="0">
+                <a:solidFill>
+                  <a:srgbClr val="B91C1C"/>
+                </a:solidFill>
+                <a:latin typeface="Arial"/>
+              </a:rPr>
+              <a:t>4.8 s to 3.6 min (restart back-off)</a:t>
+            </a:r>
+          </a:p>
+        </p:txBody>
+      </p:sp>
+      <p:sp>
+        <p:nvSpPr>
+          <p:cNvPr id="24" name="TextBox 23"/>
+          <p:cNvSpPr txBox="1"/>
+          <p:nvPr/>
+        </p:nvSpPr>
+        <p:spPr>
+          <a:xfrm>
+            <a:off x="8046720" y="4160519"/>
+            <a:ext cx="3566160" cy="493776"/>
+          </a:xfrm>
+          <a:prstGeom prst="rect">
+            <a:avLst/>
+          </a:prstGeom>
+          <a:noFill/>
+        </p:spPr>
+        <p:txBody>
+          <a:bodyPr wrap="square" lIns="73152" rIns="73152" tIns="36576" bIns="36576" anchor="ctr">
+            <a:spAutoFit/>
+          </a:bodyPr>
+          <a:lstStyle/>
+          <a:p>
+            <a:pPr algn="l">
+              <a:lnSpc>
+                <a:spcPct val="110000"/>
+              </a:lnSpc>
+            </a:pPr>
+            <a:r>
+              <a:rPr sz="1500" b="0">
+                <a:solidFill>
+                  <a:srgbClr val="0F766E"/>
+                </a:solidFill>
+                <a:latin typeface="Arial"/>
+              </a:rPr>
+              <a:t>6.5 s</a:t>
+            </a:r>
+          </a:p>
+        </p:txBody>
+      </p:sp>
+      <p:sp>
+        <p:nvSpPr>
+          <p:cNvPr id="25" name="TextBox 24"/>
+          <p:cNvSpPr txBox="1"/>
+          <p:nvPr/>
+        </p:nvSpPr>
+        <p:spPr>
+          <a:xfrm>
+            <a:off x="548640" y="5897880"/>
+            <a:ext cx="11064240" cy="457200"/>
+          </a:xfrm>
+          <a:prstGeom prst="rect">
+            <a:avLst/>
+          </a:prstGeom>
+          <a:noFill/>
+        </p:spPr>
+        <p:txBody>
+          <a:bodyPr wrap="square" lIns="73152" rIns="73152" tIns="36576" bIns="36576" anchor="t">
+            <a:spAutoFit/>
+          </a:bodyPr>
+          <a:lstStyle/>
+          <a:p>
+            <a:pPr algn="l">
+              <a:lnSpc>
+                <a:spcPct val="110000"/>
+              </a:lnSpc>
+            </a:pPr>
+            <a:r>
+              <a:rPr sz="1100" b="0">
+                <a:solidFill>
+                  <a:srgbClr val="94A3B8"/>
+                </a:solidFill>
+                <a:latin typeface="Arial"/>
+              </a:rPr>
+              <a:t>Measured on 2026-10-24 and 2026-10-25 on a single-node kind cluster. With the bad check, recovery waits on Kubernetes' restart back-off (10 s, doubling up to 5 minutes), so it depends on how long the outage lasted.</a:t>
+            </a:r>
+          </a:p>
+        </p:txBody>
+      </p:sp>
+    </p:spTree>
+  </p:cSld>
+  <p:clrMapOvr>
+    <a:masterClrMapping/>
+  </p:clrMapOvr>
+</p:sld>
+</file>
+
+<file path=ppt/slides/slide19.xml><?xml version="1.0" encoding="utf-8"?>
+<p:sld xmlns:a="http://schemas.openxmlformats.org/drawingml/2006/main" xmlns:p="http://schemas.openxmlformats.org/presentationml/2006/main" xmlns:r="http://schemas.openxmlformats.org/officeDocument/2006/relationships">
+  <p:cSld>
+    <p:bg>
+      <p:bgPr>
+        <a:solidFill>
+          <a:srgbClr val="F8FAFC"/>
+        </a:solidFill>
+        <a:effectLst/>
+      </p:bgPr>
+    </p:bg>
+    <p:spTree>
+      <p:nvGrpSpPr>
+        <p:cNvPr id="1" name=""/>
+        <p:cNvGrpSpPr/>
+        <p:nvPr/>
+      </p:nvGrpSpPr>
+      <p:grpSpPr/>
+      <p:sp>
+        <p:nvSpPr>
+          <p:cNvPr id="2" name="TextBox 1"/>
+          <p:cNvSpPr txBox="1"/>
+          <p:nvPr/>
+        </p:nvSpPr>
+        <p:spPr>
+          <a:xfrm>
+            <a:off x="548640" y="320040"/>
+            <a:ext cx="7315200" cy="274320"/>
+          </a:xfrm>
+          <a:prstGeom prst="rect">
+            <a:avLst/>
+          </a:prstGeom>
+          <a:noFill/>
+        </p:spPr>
+        <p:txBody>
+          <a:bodyPr wrap="square" lIns="73152" rIns="73152" tIns="36576" bIns="36576" anchor="t">
+            <a:spAutoFit/>
+          </a:bodyPr>
+          <a:lstStyle/>
+          <a:p>
+            <a:pPr algn="l">
+              <a:lnSpc>
+                <a:spcPct val="110000"/>
+              </a:lnSpc>
+            </a:pPr>
+            <a:r>
+              <a:rPr sz="1000" b="1">
+                <a:solidFill>
+                  <a:srgbClr val="4F46E5"/>
+                </a:solidFill>
+                <a:latin typeface="Arial"/>
+              </a:rPr>
+              <a:t>APPENDIX</a:t>
+            </a:r>
+          </a:p>
+        </p:txBody>
+      </p:sp>
+      <p:sp>
+        <p:nvSpPr>
+          <p:cNvPr id="3" name="TextBox 2"/>
+          <p:cNvSpPr txBox="1"/>
+          <p:nvPr/>
+        </p:nvSpPr>
+        <p:spPr>
+          <a:xfrm>
+            <a:off x="9784080" y="320040"/>
+            <a:ext cx="1828800" cy="274320"/>
+          </a:xfrm>
+          <a:prstGeom prst="rect">
+            <a:avLst/>
+          </a:prstGeom>
+          <a:noFill/>
+        </p:spPr>
+        <p:txBody>
+          <a:bodyPr wrap="square" lIns="73152" rIns="73152" tIns="36576" bIns="36576" anchor="t">
+            <a:spAutoFit/>
+          </a:bodyPr>
+          <a:lstStyle/>
+          <a:p>
+            <a:pPr algn="r">
+              <a:lnSpc>
+                <a:spcPct val="110000"/>
+              </a:lnSpc>
+            </a:pPr>
+            <a:r>
+              <a:rPr sz="1000" b="0">
+                <a:solidFill>
+                  <a:srgbClr val="94A3B8"/>
+                </a:solidFill>
+                <a:latin typeface="Arial"/>
+              </a:rPr>
               <a:t>APPENDIX D</a:t>
             </a:r>
           </a:p>
@@ -15936,7 +16627,7 @@
                 </a:solidFill>
                 <a:latin typeface="Arial"/>
               </a:rPr>
-              <a:t>02 / 13</a:t>
+              <a:t>02 / 14</a:t>
             </a:r>
           </a:p>
         </p:txBody>
@@ -17086,7 +17777,7 @@
                 </a:solidFill>
                 <a:latin typeface="Arial"/>
               </a:rPr>
-              <a:t>03 / 13</a:t>
+              <a:t>03 / 14</a:t>
             </a:r>
           </a:p>
         </p:txBody>
@@ -17746,7 +18437,7 @@
                 </a:solidFill>
                 <a:latin typeface="Arial"/>
               </a:rPr>
-              <a:t>3 min</a:t>
+              <a:t>4 min</a:t>
             </a:r>
           </a:p>
         </p:txBody>
@@ -17785,7 +18476,7 @@
                 </a:solidFill>
                 <a:latin typeface="Arial"/>
               </a:rPr>
-              <a:t>A first step</a:t>
+              <a:t>Results, then a first step</a:t>
             </a:r>
           </a:p>
         </p:txBody>
@@ -17824,7 +18515,7 @@
                 </a:solidFill>
                 <a:latin typeface="Arial"/>
               </a:rPr>
-              <a:t>Shaped around your team.</a:t>
+              <a:t>What it's worth, and how to start.</a:t>
             </a:r>
           </a:p>
         </p:txBody>
@@ -18978,7 +19669,7 @@
                 </a:solidFill>
                 <a:latin typeface="Arial"/>
               </a:rPr>
-              <a:t>04 / 13</a:t>
+              <a:t>04 / 14</a:t>
             </a:r>
           </a:p>
         </p:txBody>
@@ -20519,7 +21210,7 @@
                 </a:solidFill>
                 <a:latin typeface="Arial"/>
               </a:rPr>
-              <a:t>05 / 13</a:t>
+              <a:t>05 / 14</a:t>
             </a:r>
           </a:p>
         </p:txBody>
@@ -20886,7 +21577,7 @@
                 </a:solidFill>
                 <a:latin typeface="Arial"/>
               </a:rPr>
-              <a:t>Start from 50+ ready agents</a:t>
+              <a:t>50+ ready agents and workflows</a:t>
             </a:r>
           </a:p>
         </p:txBody>
@@ -20925,7 +21616,7 @@
                 </a:solidFill>
                 <a:latin typeface="Arial"/>
               </a:rPr>
-              <a:t>Or bring your own. Same controls.</a:t>
+              <a:t>Or import your own: any framework, same controls.</a:t>
             </a:r>
           </a:p>
         </p:txBody>
@@ -22069,7 +22760,7 @@
                 </a:solidFill>
                 <a:latin typeface="Arial"/>
               </a:rPr>
-              <a:t>KAOP  ·  PLATFORM ENGINEERING</a:t>
+              <a:t>GUARDRAILS  ·  LIMITS A SYSTEM ENFORCES</a:t>
             </a:r>
           </a:p>
         </p:txBody>
@@ -22108,7 +22799,7 @@
                 </a:solidFill>
                 <a:latin typeface="Arial"/>
               </a:rPr>
-              <a:t>06 / 13</a:t>
+              <a:t>06 / 14</a:t>
             </a:r>
           </a:p>
         </p:txBody>
@@ -22186,7 +22877,7 @@
                 </a:solidFill>
                 <a:latin typeface="Arial"/>
               </a:rPr>
-              <a:t>KAOP governs an agent the way it governs a person.</a:t>
+              <a:t>An agent is governed the way a person is, by the same machinery.</a:t>
             </a:r>
           </a:p>
         </p:txBody>
@@ -22634,7 +23325,7 @@
                 </a:solidFill>
                 <a:latin typeface="Arial"/>
               </a:rPr>
-              <a:t>Only the access the job needs</a:t>
+              <a:t>Only what the job needs. Never sees a key</a:t>
             </a:r>
           </a:p>
         </p:txBody>
@@ -22819,7 +23510,7 @@
                 </a:solidFill>
                 <a:latin typeface="Arial"/>
               </a:rPr>
-              <a:t>No agent ships without an owner</a:t>
+              <a:t>Owner, budget and grading, by default</a:t>
             </a:r>
           </a:p>
         </p:txBody>
@@ -23004,7 +23695,7 @@
                 </a:solidFill>
                 <a:latin typeface="Arial"/>
               </a:rPr>
-              <a:t>Risky calls blocked, every run</a:t>
+              <a:t>Risky calls blocked or held, every run</a:t>
             </a:r>
           </a:p>
         </p:txBody>
@@ -23897,7 +24588,7 @@
                 </a:solidFill>
                 <a:latin typeface="Arial"/>
               </a:rPr>
-              <a:t>KAOP  ·  PLATFORM ENGINEERING</a:t>
+              <a:t>VISIBILITY  ·  ONE VIEW OF EVERY AGENT</a:t>
             </a:r>
           </a:p>
         </p:txBody>
@@ -23936,7 +24627,7 @@
                 </a:solidFill>
                 <a:latin typeface="Arial"/>
               </a:rPr>
-              <a:t>07 / 13</a:t>
+              <a:t>07 / 14</a:t>
             </a:r>
           </a:p>
         </p:txBody>
@@ -24485,7 +25176,7 @@
                 </a:solidFill>
                 <a:latin typeface="Arial"/>
               </a:rPr>
-              <a:t>Waiting on you</a:t>
+              <a:t>Attention</a:t>
             </a:r>
           </a:p>
         </p:txBody>
@@ -24524,7 +25215,7 @@
                 </a:solidFill>
                 <a:latin typeface="Arial"/>
               </a:rPr>
-              <a:t>Decisions that need a person.</a:t>
+              <a:t>Every decision waiting on a person.</a:t>
             </a:r>
           </a:p>
         </p:txBody>
@@ -24864,7 +25555,7 @@
                 </a:solidFill>
                 <a:latin typeface="Arial"/>
               </a:rPr>
-              <a:t>Cost per agent, with budgets.</a:t>
+              <a:t>Per run and per agent, with budgets.</a:t>
             </a:r>
           </a:p>
         </p:txBody>
@@ -25167,7 +25858,7 @@
                 </a:solidFill>
                 <a:latin typeface="Arial"/>
               </a:rPr>
-              <a:t>KAOP  ·  PLATFORM ENGINEERING</a:t>
+              <a:t>WORKFLOWS  ·  AGENTS WORKING AS ONE WORKFLOW</a:t>
             </a:r>
           </a:p>
         </p:txBody>
@@ -25206,7 +25897,7 @@
                 </a:solidFill>
                 <a:latin typeface="Arial"/>
               </a:rPr>
-              <a:t>08 / 13</a:t>
+              <a:t>08 / 14</a:t>
             </a:r>
           </a:p>
         </p:txBody>
@@ -25284,7 +25975,7 @@
                 </a:solidFill>
                 <a:latin typeface="Arial"/>
               </a:rPr>
-              <a:t>Built from KAOP catalog agents. No custom code.</a:t>
+              <a:t>KAOP's Production Alert Investigation workflow, from catalog agents. No custom code.</a:t>
             </a:r>
           </a:p>
         </p:txBody>
@@ -27427,7 +28118,7 @@
                 </a:solidFill>
                 <a:latin typeface="Arial"/>
               </a:rPr>
-              <a:t>KAOP  ·  PLATFORM ENGINEERING</a:t>
+              <a:t>GUARDRAILS  ·  THE PROOF</a:t>
             </a:r>
           </a:p>
         </p:txBody>
@@ -27466,7 +28157,7 @@
                 </a:solidFill>
                 <a:latin typeface="Arial"/>
               </a:rPr>
-              <a:t>09 / 13</a:t>
+              <a:t>09 / 14</a:t>
             </a:r>
           </a:p>
         </p:txBody>
@@ -27544,7 +28235,7 @@
                 </a:solidFill>
                 <a:latin typeface="Arial"/>
               </a:rPr>
-              <a:t>Least privilege per agent, enforced outside the agent.</a:t>
+              <a:t>Least privilege per agent, enforced outside the agent. Credentials stay with KAOP.</a:t>
             </a:r>
           </a:p>
         </p:txBody>

</xml_diff>

<commit_message>
Deck: slide wording matches the spoken questions
Co-Authored-By: Claude Opus 5.5 <noreply@anthropic.com>
Claude-Session: https://claude.ai/code/session_01DptoPaaj14X3TGztKApoPN
</commit_message>
<xml_diff>
--- a/docs/presentation/KAOP_Customer_Pitch.pptx
+++ b/docs/presentation/KAOP_Customer_Pitch.pptx
@@ -3863,7 +3863,7 @@
                 <a:ea typeface="Aptos" pitchFamily="34" charset="-122"/>
                 <a:cs typeface="Aptos" pitchFamily="34" charset="-120"/>
               </a:rPr>
-              <a:t>Which workflow would be worth proving first?</a:t>
+              <a:t>Which workflow would you want to prove first?</a:t>
             </a:r>
             <a:endParaRPr lang="en-US" sz="2500" dirty="0"/>
           </a:p>
@@ -3904,7 +3904,7 @@
                 <a:ea typeface="Aptos" pitchFamily="34" charset="-122"/>
                 <a:cs typeface="Aptos" pitchFamily="34" charset="-120"/>
               </a:rPr>
-              <a:t>And who would lead the scoping session with us?</a:t>
+              <a:t>Who would be the right person to help us scope it?</a:t>
             </a:r>
             <a:endParaRPr lang="en-US" sz="1720" dirty="0"/>
           </a:p>
@@ -4416,7 +4416,7 @@
                 <a:ea typeface="Aptos" pitchFamily="34" charset="-122"/>
                 <a:cs typeface="Aptos" pitchFamily="34" charset="-120"/>
               </a:rPr>
-              <a:t>What would a first pilot need to show you?</a:t>
+              <a:t>What would that first pilot need to prove for you?</a:t>
             </a:r>
             <a:endParaRPr lang="en-US" sz="1700" dirty="0"/>
           </a:p>
@@ -6604,7 +6604,7 @@
                 <a:ea typeface="Aptos" pitchFamily="34" charset="-122"/>
                 <a:cs typeface="Aptos" pitchFamily="34" charset="-120"/>
               </a:rPr>
-              <a:t>Where does agent sprawl hurt your team first?</a:t>
+              <a:t>Where would agent sprawl hurt your team first?</a:t>
             </a:r>
             <a:endParaRPr lang="en-US" sz="3150" dirty="0"/>
           </a:p>
@@ -7046,7 +7046,7 @@
                 <a:ea typeface="Aptos" pitchFamily="34" charset="-122"/>
                 <a:cs typeface="Aptos" pitchFamily="34" charset="-120"/>
               </a:rPr>
-              <a:t>AUTHORITY</a:t>
+              <a:t>ACCESS</a:t>
             </a:r>
             <a:endParaRPr lang="en-US" sz="1230" dirty="0"/>
           </a:p>
@@ -7471,7 +7471,7 @@
                 <a:ea typeface="Aptos" pitchFamily="34" charset="-122"/>
                 <a:cs typeface="Aptos" pitchFamily="34" charset="-120"/>
               </a:rPr>
-              <a:t>Which of these is hardest to manage across your teams today?</a:t>
+              <a:t>Which would be hardest for your team to manage as usage grows?</a:t>
             </a:r>
             <a:endParaRPr lang="en-US" sz="2000" dirty="0"/>
           </a:p>

</xml_diff>

<commit_message>
Deck: color the three risk cards on slide 2 and fit them inside the margins
Co-Authored-By: Claude Opus 5.5 <noreply@anthropic.com>
Claude-Session: https://claude.ai/code/session_01DptoPaaj14X3TGztKApoPN
</commit_message>
<xml_diff>
--- a/docs/presentation/KAOP_Customer_Pitch.pptx
+++ b/docs/presentation/KAOP_Customer_Pitch.pptx
@@ -6687,7 +6687,7 @@
         <p:spPr>
           <a:xfrm>
             <a:off x="676656" y="1938528"/>
-            <a:ext cx="3575304" cy="2468880"/>
+            <a:ext cx="3416469" cy="2468880"/>
           </a:xfrm>
           <a:prstGeom prst="roundRect">
             <a:avLst>
@@ -6695,11 +6695,11 @@
             </a:avLst>
           </a:prstGeom>
           <a:solidFill>
-            <a:srgbClr val="FFFFFF"/>
+            <a:srgbClr val="E3F6F4"/>
           </a:solidFill>
-          <a:ln w="10160">
+          <a:ln w="19050">
             <a:solidFill>
-              <a:srgbClr val="DCE5ED"/>
+              <a:srgbClr val="06AFA5"/>
             </a:solidFill>
             <a:prstDash val="solid"/>
           </a:ln>
@@ -6812,94 +6812,94 @@
             <a:r>
               <a:rPr lang="en-US" sz="1230" b="1" spc="100" kern="0" dirty="0">
                 <a:solidFill>
+                  <a:srgbClr val="05867E"/>
+                </a:solidFill>
+                <a:latin typeface="Aptos" pitchFamily="34" charset="0"/>
+                <a:ea typeface="Aptos" pitchFamily="34" charset="-122"/>
+                <a:cs typeface="Aptos" pitchFamily="34" charset="-120"/>
+              </a:rPr>
+              <a:t>OWNERSHIP</a:t>
+            </a:r>
+            <a:endParaRPr lang="en-US" sz="1230" dirty="0"/>
+          </a:p>
+        </p:txBody>
+      </p:sp>
+      <p:sp>
+        <p:nvSpPr>
+          <p:cNvPr id="12" name="Text 10"/>
+          <p:cNvSpPr/>
+          <p:nvPr/>
+        </p:nvSpPr>
+        <p:spPr>
+          <a:xfrm>
+            <a:off x="896112" y="2788920"/>
+            <a:ext cx="3010069" cy="429768"/>
+          </a:xfrm>
+          <a:prstGeom prst="rect">
+            <a:avLst/>
+          </a:prstGeom>
+          <a:noFill/>
+          <a:ln/>
+        </p:spPr>
+        <p:txBody>
+          <a:bodyPr wrap="square" lIns="254" tIns="254" rIns="254" bIns="254" rtlCol="0" anchor="ctr">
+            <a:normAutofit/>
+          </a:bodyPr>
+          <a:lstStyle/>
+          <a:p>
+            <a:pPr algn="l" indent="0" marL="0">
+              <a:buNone/>
+            </a:pPr>
+            <a:r>
+              <a:rPr lang="en-US" sz="1820" b="1" dirty="0">
+                <a:solidFill>
+                  <a:srgbClr val="132438"/>
+                </a:solidFill>
+                <a:latin typeface="Aptos" pitchFamily="34" charset="0"/>
+                <a:ea typeface="Aptos" pitchFamily="34" charset="-122"/>
+                <a:cs typeface="Aptos" pitchFamily="34" charset="-120"/>
+              </a:rPr>
+              <a:t>WHO OWNS IT?</a:t>
+            </a:r>
+            <a:endParaRPr lang="en-US" sz="1820" dirty="0"/>
+          </a:p>
+        </p:txBody>
+      </p:sp>
+      <p:sp>
+        <p:nvSpPr>
+          <p:cNvPr id="13" name="Text 11"/>
+          <p:cNvSpPr/>
+          <p:nvPr/>
+        </p:nvSpPr>
+        <p:spPr>
+          <a:xfrm>
+            <a:off x="896112" y="3447288"/>
+            <a:ext cx="3010069" cy="530352"/>
+          </a:xfrm>
+          <a:prstGeom prst="rect">
+            <a:avLst/>
+          </a:prstGeom>
+          <a:noFill/>
+          <a:ln/>
+        </p:spPr>
+        <p:txBody>
+          <a:bodyPr wrap="square" lIns="254" tIns="254" rIns="254" bIns="254" rtlCol="0" anchor="t">
+            <a:normAutofit/>
+          </a:bodyPr>
+          <a:lstStyle/>
+          <a:p>
+            <a:pPr algn="l" indent="0" marL="0">
+              <a:buNone/>
+            </a:pPr>
+            <a:r>
+              <a:rPr lang="en-US" sz="1510" dirty="0">
+                <a:solidFill>
                   <a:srgbClr val="536579"/>
                 </a:solidFill>
                 <a:latin typeface="Aptos" pitchFamily="34" charset="0"/>
                 <a:ea typeface="Aptos" pitchFamily="34" charset="-122"/>
                 <a:cs typeface="Aptos" pitchFamily="34" charset="-120"/>
               </a:rPr>
-              <a:t>OWNERSHIP</a:t>
-            </a:r>
-            <a:endParaRPr lang="en-US" sz="1230" dirty="0"/>
-          </a:p>
-        </p:txBody>
-      </p:sp>
-      <p:sp>
-        <p:nvSpPr>
-          <p:cNvPr id="12" name="Text 10"/>
-          <p:cNvSpPr/>
-          <p:nvPr/>
-        </p:nvSpPr>
-        <p:spPr>
-          <a:xfrm>
-            <a:off x="896112" y="2788920"/>
-            <a:ext cx="3154680" cy="429768"/>
-          </a:xfrm>
-          <a:prstGeom prst="rect">
-            <a:avLst/>
-          </a:prstGeom>
-          <a:noFill/>
-          <a:ln/>
-        </p:spPr>
-        <p:txBody>
-          <a:bodyPr wrap="square" lIns="254" tIns="254" rIns="254" bIns="254" rtlCol="0" anchor="ctr">
-            <a:normAutofit/>
-          </a:bodyPr>
-          <a:lstStyle/>
-          <a:p>
-            <a:pPr algn="l" indent="0" marL="0">
-              <a:buNone/>
-            </a:pPr>
-            <a:r>
-              <a:rPr lang="en-US" sz="1820" b="1" dirty="0">
-                <a:solidFill>
-                  <a:srgbClr val="132438"/>
-                </a:solidFill>
-                <a:latin typeface="Aptos" pitchFamily="34" charset="0"/>
-                <a:ea typeface="Aptos" pitchFamily="34" charset="-122"/>
-                <a:cs typeface="Aptos" pitchFamily="34" charset="-120"/>
-              </a:rPr>
-              <a:t>WHO OWNS IT?</a:t>
-            </a:r>
-            <a:endParaRPr lang="en-US" sz="1820" dirty="0"/>
-          </a:p>
-        </p:txBody>
-      </p:sp>
-      <p:sp>
-        <p:nvSpPr>
-          <p:cNvPr id="13" name="Text 11"/>
-          <p:cNvSpPr/>
-          <p:nvPr/>
-        </p:nvSpPr>
-        <p:spPr>
-          <a:xfrm>
-            <a:off x="896112" y="3447288"/>
-            <a:ext cx="3136392" cy="530352"/>
-          </a:xfrm>
-          <a:prstGeom prst="rect">
-            <a:avLst/>
-          </a:prstGeom>
-          <a:noFill/>
-          <a:ln/>
-        </p:spPr>
-        <p:txBody>
-          <a:bodyPr wrap="square" lIns="254" tIns="254" rIns="254" bIns="254" rtlCol="0" anchor="t">
-            <a:normAutofit/>
-          </a:bodyPr>
-          <a:lstStyle/>
-          <a:p>
-            <a:pPr algn="l" indent="0" marL="0">
-              <a:buNone/>
-            </a:pPr>
-            <a:r>
-              <a:rPr lang="en-US" sz="1510" dirty="0">
-                <a:solidFill>
-                  <a:srgbClr val="536579"/>
-                </a:solidFill>
-                <a:latin typeface="Aptos" pitchFamily="34" charset="0"/>
-                <a:ea typeface="Aptos" pitchFamily="34" charset="-122"/>
-                <a:cs typeface="Aptos" pitchFamily="34" charset="-120"/>
-              </a:rPr>
               <a:t>No inventory, no clear owner</a:t>
             </a:r>
             <a:endParaRPr lang="en-US" sz="1510" dirty="0"/>
@@ -6914,8 +6914,8 @@
         </p:nvSpPr>
         <p:spPr>
           <a:xfrm>
-            <a:off x="4517136" y="1938528"/>
-            <a:ext cx="3575304" cy="2468880"/>
+            <a:off x="4372525" y="1938528"/>
+            <a:ext cx="3416469" cy="2468880"/>
           </a:xfrm>
           <a:prstGeom prst="roundRect">
             <a:avLst>
@@ -6923,11 +6923,11 @@
             </a:avLst>
           </a:prstGeom>
           <a:solidFill>
-            <a:srgbClr val="FFFFFF"/>
+            <a:srgbClr val="FDF1DE"/>
           </a:solidFill>
-          <a:ln w="10160">
+          <a:ln w="19050">
             <a:solidFill>
-              <a:srgbClr val="DCE5ED"/>
+              <a:srgbClr val="F4B860"/>
             </a:solidFill>
             <a:prstDash val="solid"/>
           </a:ln>
@@ -6945,7 +6945,7 @@
         </p:nvSpPr>
         <p:spPr>
           <a:xfrm>
-            <a:off x="4727448" y="2212848"/>
+            <a:off x="4582837" y="2212848"/>
             <a:ext cx="402336" cy="402336"/>
           </a:xfrm>
           <a:prstGeom prst="roundRect">
@@ -6978,7 +6978,7 @@
         </p:nvSpPr>
         <p:spPr>
           <a:xfrm>
-            <a:off x="4764024" y="2340864"/>
+            <a:off x="4619413" y="2340864"/>
             <a:ext cx="310896" cy="128016"/>
           </a:xfrm>
           <a:prstGeom prst="rect">
@@ -7019,7 +7019,7 @@
         </p:nvSpPr>
         <p:spPr>
           <a:xfrm>
-            <a:off x="5230368" y="2304288"/>
+            <a:off x="5085757" y="2304288"/>
             <a:ext cx="2633472" cy="201168"/>
           </a:xfrm>
           <a:prstGeom prst="rect">
@@ -7040,94 +7040,94 @@
             <a:r>
               <a:rPr lang="en-US" sz="1230" b="1" spc="100" kern="0" dirty="0">
                 <a:solidFill>
+                  <a:srgbClr val="B7791F"/>
+                </a:solidFill>
+                <a:latin typeface="Aptos" pitchFamily="34" charset="0"/>
+                <a:ea typeface="Aptos" pitchFamily="34" charset="-122"/>
+                <a:cs typeface="Aptos" pitchFamily="34" charset="-120"/>
+              </a:rPr>
+              <a:t>ACCESS</a:t>
+            </a:r>
+            <a:endParaRPr lang="en-US" sz="1230" dirty="0"/>
+          </a:p>
+        </p:txBody>
+      </p:sp>
+      <p:sp>
+        <p:nvSpPr>
+          <p:cNvPr id="18" name="Text 16"/>
+          <p:cNvSpPr/>
+          <p:nvPr/>
+        </p:nvSpPr>
+        <p:spPr>
+          <a:xfrm>
+            <a:off x="4591981" y="2788920"/>
+            <a:ext cx="3010069" cy="429768"/>
+          </a:xfrm>
+          <a:prstGeom prst="rect">
+            <a:avLst/>
+          </a:prstGeom>
+          <a:noFill/>
+          <a:ln/>
+        </p:spPr>
+        <p:txBody>
+          <a:bodyPr wrap="square" lIns="254" tIns="254" rIns="254" bIns="254" rtlCol="0" anchor="ctr">
+            <a:normAutofit/>
+          </a:bodyPr>
+          <a:lstStyle/>
+          <a:p>
+            <a:pPr algn="l" indent="0" marL="0">
+              <a:buNone/>
+            </a:pPr>
+            <a:r>
+              <a:rPr lang="en-US" sz="1820" b="1" dirty="0">
+                <a:solidFill>
+                  <a:srgbClr val="132438"/>
+                </a:solidFill>
+                <a:latin typeface="Aptos" pitchFamily="34" charset="0"/>
+                <a:ea typeface="Aptos" pitchFamily="34" charset="-122"/>
+                <a:cs typeface="Aptos" pitchFamily="34" charset="-120"/>
+              </a:rPr>
+              <a:t>WHAT CAN IT TOUCH?</a:t>
+            </a:r>
+            <a:endParaRPr lang="en-US" sz="1820" dirty="0"/>
+          </a:p>
+        </p:txBody>
+      </p:sp>
+      <p:sp>
+        <p:nvSpPr>
+          <p:cNvPr id="19" name="Text 17"/>
+          <p:cNvSpPr/>
+          <p:nvPr/>
+        </p:nvSpPr>
+        <p:spPr>
+          <a:xfrm>
+            <a:off x="4591981" y="3447288"/>
+            <a:ext cx="3010069" cy="530352"/>
+          </a:xfrm>
+          <a:prstGeom prst="rect">
+            <a:avLst/>
+          </a:prstGeom>
+          <a:noFill/>
+          <a:ln/>
+        </p:spPr>
+        <p:txBody>
+          <a:bodyPr wrap="square" lIns="254" tIns="254" rIns="254" bIns="254" rtlCol="0" anchor="t">
+            <a:normAutofit/>
+          </a:bodyPr>
+          <a:lstStyle/>
+          <a:p>
+            <a:pPr algn="l" indent="0" marL="0">
+              <a:buNone/>
+            </a:pPr>
+            <a:r>
+              <a:rPr lang="en-US" sz="1510" dirty="0">
+                <a:solidFill>
                   <a:srgbClr val="536579"/>
                 </a:solidFill>
                 <a:latin typeface="Aptos" pitchFamily="34" charset="0"/>
                 <a:ea typeface="Aptos" pitchFamily="34" charset="-122"/>
                 <a:cs typeface="Aptos" pitchFamily="34" charset="-120"/>
               </a:rPr>
-              <a:t>ACCESS</a:t>
-            </a:r>
-            <a:endParaRPr lang="en-US" sz="1230" dirty="0"/>
-          </a:p>
-        </p:txBody>
-      </p:sp>
-      <p:sp>
-        <p:nvSpPr>
-          <p:cNvPr id="18" name="Text 16"/>
-          <p:cNvSpPr/>
-          <p:nvPr/>
-        </p:nvSpPr>
-        <p:spPr>
-          <a:xfrm>
-            <a:off x="4736592" y="2788920"/>
-            <a:ext cx="3154680" cy="429768"/>
-          </a:xfrm>
-          <a:prstGeom prst="rect">
-            <a:avLst/>
-          </a:prstGeom>
-          <a:noFill/>
-          <a:ln/>
-        </p:spPr>
-        <p:txBody>
-          <a:bodyPr wrap="square" lIns="254" tIns="254" rIns="254" bIns="254" rtlCol="0" anchor="ctr">
-            <a:normAutofit/>
-          </a:bodyPr>
-          <a:lstStyle/>
-          <a:p>
-            <a:pPr algn="l" indent="0" marL="0">
-              <a:buNone/>
-            </a:pPr>
-            <a:r>
-              <a:rPr lang="en-US" sz="1820" b="1" dirty="0">
-                <a:solidFill>
-                  <a:srgbClr val="132438"/>
-                </a:solidFill>
-                <a:latin typeface="Aptos" pitchFamily="34" charset="0"/>
-                <a:ea typeface="Aptos" pitchFamily="34" charset="-122"/>
-                <a:cs typeface="Aptos" pitchFamily="34" charset="-120"/>
-              </a:rPr>
-              <a:t>WHAT CAN IT TOUCH?</a:t>
-            </a:r>
-            <a:endParaRPr lang="en-US" sz="1820" dirty="0"/>
-          </a:p>
-        </p:txBody>
-      </p:sp>
-      <p:sp>
-        <p:nvSpPr>
-          <p:cNvPr id="19" name="Text 17"/>
-          <p:cNvSpPr/>
-          <p:nvPr/>
-        </p:nvSpPr>
-        <p:spPr>
-          <a:xfrm>
-            <a:off x="4736592" y="3447288"/>
-            <a:ext cx="3136392" cy="530352"/>
-          </a:xfrm>
-          <a:prstGeom prst="rect">
-            <a:avLst/>
-          </a:prstGeom>
-          <a:noFill/>
-          <a:ln/>
-        </p:spPr>
-        <p:txBody>
-          <a:bodyPr wrap="square" lIns="254" tIns="254" rIns="254" bIns="254" rtlCol="0" anchor="t">
-            <a:normAutofit/>
-          </a:bodyPr>
-          <a:lstStyle/>
-          <a:p>
-            <a:pPr algn="l" indent="0" marL="0">
-              <a:buNone/>
-            </a:pPr>
-            <a:r>
-              <a:rPr lang="en-US" sz="1510" dirty="0">
-                <a:solidFill>
-                  <a:srgbClr val="536579"/>
-                </a:solidFill>
-                <a:latin typeface="Aptos" pitchFamily="34" charset="0"/>
-                <a:ea typeface="Aptos" pitchFamily="34" charset="-122"/>
-                <a:cs typeface="Aptos" pitchFamily="34" charset="-120"/>
-              </a:rPr>
               <a:t>Broad tokens, unclear access</a:t>
             </a:r>
             <a:endParaRPr lang="en-US" sz="1510" dirty="0"/>
@@ -7142,8 +7142,8 @@
         </p:nvSpPr>
         <p:spPr>
           <a:xfrm>
-            <a:off x="8357616" y="1938528"/>
-            <a:ext cx="3575304" cy="2468880"/>
+            <a:off x="8068394" y="1938528"/>
+            <a:ext cx="3416469" cy="2468880"/>
           </a:xfrm>
           <a:prstGeom prst="roundRect">
             <a:avLst>
@@ -7151,11 +7151,11 @@
             </a:avLst>
           </a:prstGeom>
           <a:solidFill>
-            <a:srgbClr val="FFFFFF"/>
+            <a:srgbClr val="E8EFFD"/>
           </a:solidFill>
-          <a:ln w="10160">
+          <a:ln w="19050">
             <a:solidFill>
-              <a:srgbClr val="DCE5ED"/>
+              <a:srgbClr val="3B78E7"/>
             </a:solidFill>
             <a:prstDash val="solid"/>
           </a:ln>
@@ -7173,7 +7173,7 @@
         </p:nvSpPr>
         <p:spPr>
           <a:xfrm>
-            <a:off x="8567928" y="2212848"/>
+            <a:off x="8278706" y="2212848"/>
             <a:ext cx="402336" cy="402336"/>
           </a:xfrm>
           <a:prstGeom prst="roundRect">
@@ -7182,11 +7182,11 @@
             </a:avLst>
           </a:prstGeom>
           <a:solidFill>
-            <a:srgbClr val="06AFA5"/>
+            <a:srgbClr val="3B78E7"/>
           </a:solidFill>
           <a:ln w="12700">
             <a:solidFill>
-              <a:srgbClr val="06AFA5">
+              <a:srgbClr val="3B78E7">
                 <a:alpha val="0"/>
               </a:srgbClr>
             </a:solidFill>
@@ -7206,7 +7206,7 @@
         </p:nvSpPr>
         <p:spPr>
           <a:xfrm>
-            <a:off x="8604504" y="2340864"/>
+            <a:off x="8315282" y="2340864"/>
             <a:ext cx="310896" cy="128016"/>
           </a:xfrm>
           <a:prstGeom prst="rect">
@@ -7247,7 +7247,7 @@
         </p:nvSpPr>
         <p:spPr>
           <a:xfrm>
-            <a:off x="9070848" y="2304288"/>
+            <a:off x="8781626" y="2304288"/>
             <a:ext cx="2633472" cy="201168"/>
           </a:xfrm>
           <a:prstGeom prst="rect">
@@ -7268,7 +7268,7 @@
             <a:r>
               <a:rPr lang="en-US" sz="1230" b="1" spc="100" kern="0" dirty="0">
                 <a:solidFill>
-                  <a:srgbClr val="536579"/>
+                  <a:srgbClr val="2F62C4"/>
                 </a:solidFill>
                 <a:latin typeface="Aptos" pitchFamily="34" charset="0"/>
                 <a:ea typeface="Aptos" pitchFamily="34" charset="-122"/>
@@ -7288,8 +7288,8 @@
         </p:nvSpPr>
         <p:spPr>
           <a:xfrm>
-            <a:off x="8577072" y="2788920"/>
-            <a:ext cx="3154680" cy="429768"/>
+            <a:off x="8287850" y="2788920"/>
+            <a:ext cx="3010069" cy="429768"/>
           </a:xfrm>
           <a:prstGeom prst="rect">
             <a:avLst/>
@@ -7329,8 +7329,8 @@
         </p:nvSpPr>
         <p:spPr>
           <a:xfrm>
-            <a:off x="8577072" y="3447288"/>
-            <a:ext cx="3136392" cy="530352"/>
+            <a:off x="8287850" y="3447288"/>
+            <a:ext cx="3010069" cy="530352"/>
           </a:xfrm>
           <a:prstGeom prst="rect">
             <a:avLst/>

</xml_diff>

<commit_message>
Deck: add an introduction and agenda slide after the title
Co-Authored-By: Claude Opus 5.5 <noreply@anthropic.com>
Claude-Session: https://claude.ai/code/session_01DptoPaaj14X3TGztKApoPN
</commit_message>
<xml_diff>
--- a/docs/presentation/KAOP_Customer_Pitch.pptx
+++ b/docs/presentation/KAOP_Customer_Pitch.pptx
@@ -6,6 +6,7 @@
   </p:sldMasterIdLst>
   <p:sldIdLst>
     <p:sldId id="256" r:id="rId2"/>
+    <p:sldId id="270" r:id="rId16"/>
     <p:sldId id="257" r:id="rId3"/>
     <p:sldId id="258" r:id="rId4"/>
     <p:sldId id="259" r:id="rId5"/>
@@ -1570,6 +1571,891 @@
 
 <file path=ppt/slides/slide10.xml><?xml version="1.0" encoding="utf-8"?>
 <p:sld xmlns:a="http://schemas.openxmlformats.org/drawingml/2006/main" xmlns:r="http://schemas.openxmlformats.org/officeDocument/2006/relationships" xmlns:p="http://schemas.openxmlformats.org/presentationml/2006/main">
+  <p:cSld name="Slide 9">
+    <p:bg>
+      <p:bgPr>
+        <a:solidFill>
+          <a:srgbClr val="F7F9FC"/>
+        </a:solidFill>
+      </p:bgPr>
+    </p:bg>
+    <p:spTree>
+      <p:nvGrpSpPr>
+        <p:cNvPr id="1" name=""/>
+        <p:cNvGrpSpPr/>
+        <p:nvPr/>
+      </p:nvGrpSpPr>
+      <p:grpSpPr>
+        <a:xfrm>
+          <a:off x="0" y="0"/>
+          <a:ext cx="0" cy="0"/>
+          <a:chOff x="0" y="0"/>
+          <a:chExt cx="0" cy="0"/>
+        </a:xfrm>
+      </p:grpSpPr>
+      <p:sp>
+        <p:nvSpPr>
+          <p:cNvPr id="2" name="Text 0"/>
+          <p:cNvSpPr/>
+          <p:nvPr/>
+        </p:nvSpPr>
+        <p:spPr>
+          <a:xfrm>
+            <a:off x="640080" y="310896"/>
+            <a:ext cx="9144000" cy="219456"/>
+          </a:xfrm>
+          <a:prstGeom prst="rect">
+            <a:avLst/>
+          </a:prstGeom>
+          <a:noFill/>
+          <a:ln/>
+        </p:spPr>
+        <p:txBody>
+          <a:bodyPr wrap="square" lIns="254" tIns="254" rIns="254" bIns="254" rtlCol="0" anchor="ctr">
+            <a:normAutofit/>
+          </a:bodyPr>
+          <a:lstStyle/>
+          <a:p>
+            <a:pPr algn="l" indent="0" marL="0">
+              <a:buNone/>
+            </a:pPr>
+            <a:r>
+              <a:rPr lang="en-US" sz="1050" b="1" spc="240" kern="0" dirty="0">
+                <a:solidFill>
+                  <a:srgbClr val="06AFA5"/>
+                </a:solidFill>
+                <a:latin typeface="Aptos" pitchFamily="34" charset="0"/>
+                <a:ea typeface="Aptos" pitchFamily="34" charset="-122"/>
+                <a:cs typeface="Aptos" pitchFamily="34" charset="-120"/>
+              </a:rPr>
+              <a:t>06 / QUALITY + COST MEASURED HERE</a:t>
+            </a:r>
+            <a:endParaRPr lang="en-US" sz="1050" dirty="0"/>
+          </a:p>
+        </p:txBody>
+      </p:sp>
+      <p:sp>
+        <p:nvSpPr>
+          <p:cNvPr id="3" name="Text 1"/>
+          <p:cNvSpPr/>
+          <p:nvPr/>
+        </p:nvSpPr>
+        <p:spPr>
+          <a:xfrm>
+            <a:off x="10972800" y="292608"/>
+            <a:ext cx="576072" cy="219456"/>
+          </a:xfrm>
+          <a:prstGeom prst="rect">
+            <a:avLst/>
+          </a:prstGeom>
+          <a:noFill/>
+          <a:ln/>
+        </p:spPr>
+        <p:txBody>
+          <a:bodyPr wrap="square" lIns="254" tIns="254" rIns="254" bIns="254" rtlCol="0" anchor="ctr">
+            <a:normAutofit/>
+          </a:bodyPr>
+          <a:lstStyle/>
+          <a:p>
+            <a:pPr algn="r" indent="0" marL="0">
+              <a:buNone/>
+            </a:pPr>
+            <a:r>
+              <a:rPr lang="en-US" sz="1000" dirty="0">
+                <a:solidFill>
+                  <a:srgbClr val="536579"/>
+                </a:solidFill>
+                <a:latin typeface="Aptos" pitchFamily="34" charset="0"/>
+                <a:ea typeface="Aptos" pitchFamily="34" charset="-122"/>
+                <a:cs typeface="Aptos" pitchFamily="34" charset="-120"/>
+              </a:rPr>
+              <a:t>09 / 12</a:t>
+            </a:r>
+            <a:endParaRPr lang="en-US" sz="1000" dirty="0"/>
+          </a:p>
+        </p:txBody>
+      </p:sp>
+      <p:sp>
+        <p:nvSpPr>
+          <p:cNvPr id="4" name="Text 2"/>
+          <p:cNvSpPr/>
+          <p:nvPr/>
+        </p:nvSpPr>
+        <p:spPr>
+          <a:xfrm>
+            <a:off x="640080" y="777240"/>
+            <a:ext cx="10927080" cy="932688"/>
+          </a:xfrm>
+          <a:prstGeom prst="rect">
+            <a:avLst/>
+          </a:prstGeom>
+          <a:noFill/>
+          <a:ln/>
+        </p:spPr>
+        <p:txBody>
+          <a:bodyPr wrap="square" lIns="254" tIns="254" rIns="254" bIns="254" rtlCol="0" anchor="t">
+            <a:normAutofit/>
+          </a:bodyPr>
+          <a:lstStyle/>
+          <a:p>
+            <a:pPr algn="l" indent="0" marL="0">
+              <a:buNone/>
+            </a:pPr>
+            <a:r>
+              <a:rPr lang="en-US" sz="3150" b="1" dirty="0">
+                <a:solidFill>
+                  <a:srgbClr val="132438"/>
+                </a:solidFill>
+                <a:latin typeface="Aptos" pitchFamily="34" charset="0"/>
+                <a:ea typeface="Aptos" pitchFamily="34" charset="-122"/>
+                <a:cs typeface="Aptos" pitchFamily="34" charset="-120"/>
+              </a:rPr>
+              <a:t>A completed run is not a correct run.</a:t>
+            </a:r>
+            <a:endParaRPr lang="en-US" sz="3150" dirty="0"/>
+          </a:p>
+        </p:txBody>
+      </p:sp>
+      <p:sp>
+        <p:nvSpPr>
+          <p:cNvPr id="5" name="Shape 3"/>
+          <p:cNvSpPr/>
+          <p:nvPr/>
+        </p:nvSpPr>
+        <p:spPr>
+          <a:xfrm>
+            <a:off x="640080" y="6327648"/>
+            <a:ext cx="10927080" cy="0"/>
+          </a:xfrm>
+          <a:prstGeom prst="line">
+            <a:avLst/>
+          </a:prstGeom>
+          <a:noFill/>
+          <a:ln w="11430">
+            <a:solidFill>
+              <a:srgbClr val="DCE5ED"/>
+            </a:solidFill>
+            <a:prstDash val="solid"/>
+          </a:ln>
+        </p:spPr>
+        <p:txBody>
+          <a:bodyPr/>
+          <a:p/>
+        </p:txBody>
+      </p:sp>
+      <p:sp>
+        <p:nvSpPr>
+          <p:cNvPr id="6" name="Text 4"/>
+          <p:cNvSpPr/>
+          <p:nvPr/>
+        </p:nvSpPr>
+        <p:spPr>
+          <a:xfrm>
+            <a:off x="640080" y="6419088"/>
+            <a:ext cx="5486400" cy="155448"/>
+          </a:xfrm>
+          <a:prstGeom prst="rect">
+            <a:avLst/>
+          </a:prstGeom>
+          <a:noFill/>
+          <a:ln/>
+        </p:spPr>
+        <p:txBody>
+          <a:bodyPr wrap="square" lIns="254" tIns="254" rIns="254" bIns="254" rtlCol="0" anchor="ctr">
+            <a:normAutofit/>
+          </a:bodyPr>
+          <a:lstStyle/>
+          <a:p>
+            <a:pPr algn="l" indent="0" marL="0">
+              <a:buNone/>
+            </a:pPr>
+            <a:r>
+              <a:rPr lang="en-US" sz="900" spc="120" kern="0" dirty="0">
+                <a:solidFill>
+                  <a:srgbClr val="536579"/>
+                </a:solidFill>
+                <a:latin typeface="Aptos" pitchFamily="34" charset="0"/>
+                <a:ea typeface="Aptos" pitchFamily="34" charset="-122"/>
+                <a:cs typeface="Aptos" pitchFamily="34" charset="-120"/>
+              </a:rPr>
+              <a:t>KAOP  /  CUSTOMER DISCUSSION</a:t>
+            </a:r>
+            <a:endParaRPr lang="en-US" sz="900" dirty="0"/>
+          </a:p>
+        </p:txBody>
+      </p:sp>
+      <p:sp>
+        <p:nvSpPr>
+          <p:cNvPr id="8" name="Shape 6"/>
+          <p:cNvSpPr/>
+          <p:nvPr/>
+        </p:nvSpPr>
+        <p:spPr>
+          <a:xfrm>
+            <a:off x="694944" y="1874520"/>
+            <a:ext cx="5486400" cy="3419856"/>
+          </a:xfrm>
+          <a:prstGeom prst="roundRect">
+            <a:avLst>
+              <a:gd name="adj" fmla="val 5615"/>
+            </a:avLst>
+          </a:prstGeom>
+          <a:solidFill>
+            <a:srgbClr val="FFFFFF"/>
+          </a:solidFill>
+          <a:ln w="10160">
+            <a:solidFill>
+              <a:srgbClr val="DCE5ED"/>
+            </a:solidFill>
+            <a:prstDash val="solid"/>
+          </a:ln>
+        </p:spPr>
+        <p:txBody>
+          <a:bodyPr/>
+          <a:p/>
+        </p:txBody>
+      </p:sp>
+      <p:sp>
+        <p:nvSpPr>
+          <p:cNvPr id="9" name="Text 7"/>
+          <p:cNvSpPr/>
+          <p:nvPr/>
+        </p:nvSpPr>
+        <p:spPr>
+          <a:xfrm>
+            <a:off x="914400" y="2157984"/>
+            <a:ext cx="5029200" cy="228600"/>
+          </a:xfrm>
+          <a:prstGeom prst="rect">
+            <a:avLst/>
+          </a:prstGeom>
+          <a:noFill/>
+          <a:ln/>
+        </p:spPr>
+        <p:txBody>
+          <a:bodyPr wrap="square" lIns="254" tIns="254" rIns="254" bIns="254" rtlCol="0" anchor="ctr">
+            <a:normAutofit/>
+          </a:bodyPr>
+          <a:lstStyle/>
+          <a:p>
+            <a:pPr algn="l" indent="0" marL="0">
+              <a:buNone/>
+            </a:pPr>
+            <a:r>
+              <a:rPr lang="en-US" sz="1200" b="1" spc="130" kern="0" dirty="0">
+                <a:solidFill>
+                  <a:srgbClr val="536579"/>
+                </a:solidFill>
+                <a:latin typeface="Aptos" pitchFamily="34" charset="0"/>
+                <a:ea typeface="Aptos" pitchFamily="34" charset="-122"/>
+                <a:cs typeface="Aptos" pitchFamily="34" charset="-120"/>
+              </a:rPr>
+              <a:t>ANSWER QUALITY</a:t>
+            </a:r>
+            <a:endParaRPr lang="en-US" sz="1200" dirty="0"/>
+          </a:p>
+        </p:txBody>
+      </p:sp>
+      <p:sp>
+        <p:nvSpPr>
+          <p:cNvPr id="10" name="Text 8"/>
+          <p:cNvSpPr/>
+          <p:nvPr/>
+        </p:nvSpPr>
+        <p:spPr>
+          <a:xfrm>
+            <a:off x="923544" y="2706624"/>
+            <a:ext cx="2103120" cy="585216"/>
+          </a:xfrm>
+          <a:prstGeom prst="rect">
+            <a:avLst/>
+          </a:prstGeom>
+          <a:noFill/>
+          <a:ln/>
+        </p:spPr>
+        <p:txBody>
+          <a:bodyPr wrap="square" lIns="254" tIns="254" rIns="254" bIns="254" rtlCol="0" anchor="ctr">
+            <a:normAutofit/>
+          </a:bodyPr>
+          <a:lstStyle/>
+          <a:p>
+            <a:pPr algn="l" indent="0" marL="0">
+              <a:buNone/>
+            </a:pPr>
+            <a:r>
+              <a:rPr lang="en-US" sz="3400" b="1" dirty="0">
+                <a:solidFill>
+                  <a:srgbClr val="C66765"/>
+                </a:solidFill>
+                <a:latin typeface="Aptos" pitchFamily="34" charset="0"/>
+                <a:ea typeface="Aptos" pitchFamily="34" charset="-122"/>
+                <a:cs typeface="Aptos" pitchFamily="34" charset="-120"/>
+              </a:rPr>
+              <a:t>1 of 5</a:t>
+            </a:r>
+            <a:endParaRPr lang="en-US" sz="3400" dirty="0"/>
+          </a:p>
+        </p:txBody>
+      </p:sp>
+      <p:sp>
+        <p:nvSpPr>
+          <p:cNvPr id="11" name="Text 9"/>
+          <p:cNvSpPr/>
+          <p:nvPr/>
+        </p:nvSpPr>
+        <p:spPr>
+          <a:xfrm>
+            <a:off x="2953512" y="2834640"/>
+            <a:ext cx="448056" cy="365760"/>
+          </a:xfrm>
+          <a:prstGeom prst="rect">
+            <a:avLst/>
+          </a:prstGeom>
+          <a:noFill/>
+          <a:ln/>
+        </p:spPr>
+        <p:txBody>
+          <a:bodyPr wrap="square" lIns="254" tIns="254" rIns="254" bIns="254" rtlCol="0" anchor="ctr">
+            <a:normAutofit/>
+          </a:bodyPr>
+          <a:lstStyle/>
+          <a:p>
+            <a:pPr algn="ctr" indent="0" marL="0">
+              <a:buNone/>
+            </a:pPr>
+            <a:r>
+              <a:rPr lang="en-US" sz="2700" b="1" dirty="0">
+                <a:solidFill>
+                  <a:srgbClr val="06AFA5"/>
+                </a:solidFill>
+                <a:latin typeface="Aptos" pitchFamily="34" charset="0"/>
+                <a:ea typeface="Aptos" pitchFamily="34" charset="-122"/>
+                <a:cs typeface="Aptos" pitchFamily="34" charset="-120"/>
+              </a:rPr>
+              <a:t>→</a:t>
+            </a:r>
+            <a:endParaRPr lang="en-US" sz="2700" dirty="0"/>
+          </a:p>
+        </p:txBody>
+      </p:sp>
+      <p:sp>
+        <p:nvSpPr>
+          <p:cNvPr id="12" name="Text 10"/>
+          <p:cNvSpPr/>
+          <p:nvPr/>
+        </p:nvSpPr>
+        <p:spPr>
+          <a:xfrm>
+            <a:off x="3483864" y="2706624"/>
+            <a:ext cx="2377440" cy="585216"/>
+          </a:xfrm>
+          <a:prstGeom prst="rect">
+            <a:avLst/>
+          </a:prstGeom>
+          <a:noFill/>
+          <a:ln/>
+        </p:spPr>
+        <p:txBody>
+          <a:bodyPr wrap="square" lIns="254" tIns="254" rIns="254" bIns="254" rtlCol="0" anchor="ctr">
+            <a:normAutofit/>
+          </a:bodyPr>
+          <a:lstStyle/>
+          <a:p>
+            <a:pPr algn="l" indent="0" marL="0">
+              <a:buNone/>
+            </a:pPr>
+            <a:r>
+              <a:rPr lang="en-US" sz="3400" b="1" dirty="0">
+                <a:solidFill>
+                  <a:srgbClr val="06AFA5"/>
+                </a:solidFill>
+                <a:latin typeface="Aptos" pitchFamily="34" charset="0"/>
+                <a:ea typeface="Aptos" pitchFamily="34" charset="-122"/>
+                <a:cs typeface="Aptos" pitchFamily="34" charset="-120"/>
+              </a:rPr>
+              <a:t>10 of 10</a:t>
+            </a:r>
+            <a:endParaRPr lang="en-US" sz="3400" dirty="0"/>
+          </a:p>
+        </p:txBody>
+      </p:sp>
+      <p:sp>
+        <p:nvSpPr>
+          <p:cNvPr id="13" name="Text 11"/>
+          <p:cNvSpPr/>
+          <p:nvPr/>
+        </p:nvSpPr>
+        <p:spPr>
+          <a:xfrm>
+            <a:off x="914400" y="3456432"/>
+            <a:ext cx="5029200" cy="292608"/>
+          </a:xfrm>
+          <a:prstGeom prst="rect">
+            <a:avLst/>
+          </a:prstGeom>
+          <a:noFill/>
+          <a:ln/>
+        </p:spPr>
+        <p:txBody>
+          <a:bodyPr wrap="square" lIns="254" tIns="254" rIns="254" bIns="254" rtlCol="0" anchor="ctr">
+            <a:normAutofit/>
+          </a:bodyPr>
+          <a:lstStyle/>
+          <a:p>
+            <a:pPr algn="l" indent="0" marL="0">
+              <a:buNone/>
+            </a:pPr>
+            <a:r>
+              <a:rPr lang="en-US" sz="1710" b="1" dirty="0">
+                <a:solidFill>
+                  <a:srgbClr val="132438"/>
+                </a:solidFill>
+                <a:latin typeface="Aptos" pitchFamily="34" charset="0"/>
+                <a:ea typeface="Aptos" pitchFamily="34" charset="-122"/>
+                <a:cs typeface="Aptos" pitchFamily="34" charset="-120"/>
+              </a:rPr>
+              <a:t>Agent found the actual cause</a:t>
+            </a:r>
+            <a:endParaRPr lang="en-US" sz="1710" dirty="0"/>
+          </a:p>
+        </p:txBody>
+      </p:sp>
+      <p:sp>
+        <p:nvSpPr>
+          <p:cNvPr id="14" name="Text 12"/>
+          <p:cNvSpPr/>
+          <p:nvPr/>
+        </p:nvSpPr>
+        <p:spPr>
+          <a:xfrm>
+            <a:off x="914400" y="3959352"/>
+            <a:ext cx="4937760" cy="868680"/>
+          </a:xfrm>
+          <a:prstGeom prst="rect">
+            <a:avLst/>
+          </a:prstGeom>
+          <a:noFill/>
+          <a:ln/>
+        </p:spPr>
+        <p:txBody>
+          <a:bodyPr wrap="square" lIns="254" tIns="254" rIns="254" bIns="254" rtlCol="0" anchor="t">
+            <a:normAutofit/>
+          </a:bodyPr>
+          <a:lstStyle/>
+          <a:p>
+            <a:pPr algn="l" indent="0" marL="0">
+              <a:buNone/>
+            </a:pPr>
+            <a:r>
+              <a:rPr lang="en-US" sz="1460" dirty="0">
+                <a:solidFill>
+                  <a:srgbClr val="536579"/>
+                </a:solidFill>
+                <a:latin typeface="Aptos" pitchFamily="34" charset="0"/>
+                <a:ea typeface="Aptos" pitchFamily="34" charset="-122"/>
+                <a:cs typeface="Aptos" pitchFamily="34" charset="-120"/>
+              </a:rPr>
+              <a:t>Without / with one documented probe standard.</a:t>
+            </a:r>
+            <a:endParaRPr lang="en-US" sz="1460" dirty="0"/>
+          </a:p>
+          <a:p>
+            <a:pPr algn="l" indent="0" marL="0">
+              <a:buNone/>
+            </a:pPr>
+            <a:r>
+              <a:rPr lang="en-US" sz="1460" dirty="0">
+                <a:solidFill>
+                  <a:srgbClr val="536579"/>
+                </a:solidFill>
+                <a:latin typeface="Aptos" pitchFamily="34" charset="0"/>
+                <a:ea typeface="Aptos" pitchFamily="34" charset="-122"/>
+                <a:cs typeface="Aptos" pitchFamily="34" charset="-120"/>
+              </a:rPr>
+              <a:t>Same investigation input; small lab samples.</a:t>
+            </a:r>
+            <a:endParaRPr lang="en-US" sz="1460" dirty="0"/>
+          </a:p>
+        </p:txBody>
+      </p:sp>
+      <p:sp>
+        <p:nvSpPr>
+          <p:cNvPr id="15" name="Shape 13"/>
+          <p:cNvSpPr/>
+          <p:nvPr/>
+        </p:nvSpPr>
+        <p:spPr>
+          <a:xfrm>
+            <a:off x="6391656" y="1874520"/>
+            <a:ext cx="5093208" cy="3419856"/>
+          </a:xfrm>
+          <a:prstGeom prst="roundRect">
+            <a:avLst>
+              <a:gd name="adj" fmla="val 5615"/>
+            </a:avLst>
+          </a:prstGeom>
+          <a:solidFill>
+            <a:srgbClr val="FFFFFF"/>
+          </a:solidFill>
+          <a:ln w="10160">
+            <a:solidFill>
+              <a:srgbClr val="DCE5ED"/>
+            </a:solidFill>
+            <a:prstDash val="solid"/>
+          </a:ln>
+        </p:spPr>
+        <p:txBody>
+          <a:bodyPr/>
+          <a:p/>
+        </p:txBody>
+      </p:sp>
+      <p:sp>
+        <p:nvSpPr>
+          <p:cNvPr id="16" name="Text 14"/>
+          <p:cNvSpPr/>
+          <p:nvPr/>
+        </p:nvSpPr>
+        <p:spPr>
+          <a:xfrm>
+            <a:off x="6601968" y="2157984"/>
+            <a:ext cx="4663440" cy="228600"/>
+          </a:xfrm>
+          <a:prstGeom prst="rect">
+            <a:avLst/>
+          </a:prstGeom>
+          <a:noFill/>
+          <a:ln/>
+        </p:spPr>
+        <p:txBody>
+          <a:bodyPr wrap="square" lIns="254" tIns="254" rIns="254" bIns="254" rtlCol="0" anchor="ctr">
+            <a:normAutofit/>
+          </a:bodyPr>
+          <a:lstStyle/>
+          <a:p>
+            <a:pPr algn="l" indent="0" marL="0">
+              <a:buNone/>
+            </a:pPr>
+            <a:r>
+              <a:rPr lang="en-US" sz="1200" b="1" spc="100" kern="0" dirty="0">
+                <a:solidFill>
+                  <a:srgbClr val="536579"/>
+                </a:solidFill>
+                <a:latin typeface="Aptos" pitchFamily="34" charset="0"/>
+                <a:ea typeface="Aptos" pitchFamily="34" charset="-122"/>
+                <a:cs typeface="Aptos" pitchFamily="34" charset="-120"/>
+              </a:rPr>
+              <a:t>COST OF THE GRAFANA INVESTIGATOR</a:t>
+            </a:r>
+            <a:endParaRPr lang="en-US" sz="1200" dirty="0"/>
+          </a:p>
+        </p:txBody>
+      </p:sp>
+      <p:sp>
+        <p:nvSpPr>
+          <p:cNvPr id="17" name="Text 15"/>
+          <p:cNvSpPr/>
+          <p:nvPr/>
+        </p:nvSpPr>
+        <p:spPr>
+          <a:xfrm>
+            <a:off x="6620256" y="2706624"/>
+            <a:ext cx="1792224" cy="585216"/>
+          </a:xfrm>
+          <a:prstGeom prst="rect">
+            <a:avLst/>
+          </a:prstGeom>
+          <a:noFill/>
+          <a:ln/>
+        </p:spPr>
+        <p:txBody>
+          <a:bodyPr wrap="square" lIns="254" tIns="254" rIns="254" bIns="254" rtlCol="0" anchor="ctr">
+            <a:normAutofit/>
+          </a:bodyPr>
+          <a:lstStyle/>
+          <a:p>
+            <a:pPr algn="l" indent="0" marL="0">
+              <a:buNone/>
+            </a:pPr>
+            <a:r>
+              <a:rPr lang="en-US" sz="3400" b="1" dirty="0">
+                <a:solidFill>
+                  <a:srgbClr val="132438"/>
+                </a:solidFill>
+                <a:latin typeface="Aptos" pitchFamily="34" charset="0"/>
+                <a:ea typeface="Aptos" pitchFamily="34" charset="-122"/>
+                <a:cs typeface="Aptos" pitchFamily="34" charset="-120"/>
+              </a:rPr>
+              <a:t>$0.68</a:t>
+            </a:r>
+            <a:endParaRPr lang="en-US" sz="3400" dirty="0"/>
+          </a:p>
+        </p:txBody>
+      </p:sp>
+      <p:sp>
+        <p:nvSpPr>
+          <p:cNvPr id="18" name="Text 16"/>
+          <p:cNvSpPr/>
+          <p:nvPr/>
+        </p:nvSpPr>
+        <p:spPr>
+          <a:xfrm>
+            <a:off x="8430768" y="2834640"/>
+            <a:ext cx="448056" cy="365760"/>
+          </a:xfrm>
+          <a:prstGeom prst="rect">
+            <a:avLst/>
+          </a:prstGeom>
+          <a:noFill/>
+          <a:ln/>
+        </p:spPr>
+        <p:txBody>
+          <a:bodyPr wrap="square" lIns="254" tIns="254" rIns="254" bIns="254" rtlCol="0" anchor="ctr">
+            <a:normAutofit/>
+          </a:bodyPr>
+          <a:lstStyle/>
+          <a:p>
+            <a:pPr algn="ctr" indent="0" marL="0">
+              <a:buNone/>
+            </a:pPr>
+            <a:r>
+              <a:rPr lang="en-US" sz="2700" b="1" dirty="0">
+                <a:solidFill>
+                  <a:srgbClr val="06AFA5"/>
+                </a:solidFill>
+                <a:latin typeface="Aptos" pitchFamily="34" charset="0"/>
+                <a:ea typeface="Aptos" pitchFamily="34" charset="-122"/>
+                <a:cs typeface="Aptos" pitchFamily="34" charset="-120"/>
+              </a:rPr>
+              <a:t>→</a:t>
+            </a:r>
+            <a:endParaRPr lang="en-US" sz="2700" dirty="0"/>
+          </a:p>
+        </p:txBody>
+      </p:sp>
+      <p:sp>
+        <p:nvSpPr>
+          <p:cNvPr id="19" name="Text 17"/>
+          <p:cNvSpPr/>
+          <p:nvPr/>
+        </p:nvSpPr>
+        <p:spPr>
+          <a:xfrm>
+            <a:off x="8924544" y="2706624"/>
+            <a:ext cx="2103120" cy="585216"/>
+          </a:xfrm>
+          <a:prstGeom prst="rect">
+            <a:avLst/>
+          </a:prstGeom>
+          <a:noFill/>
+          <a:ln/>
+        </p:spPr>
+        <p:txBody>
+          <a:bodyPr wrap="square" lIns="254" tIns="254" rIns="254" bIns="254" rtlCol="0" anchor="ctr">
+            <a:normAutofit/>
+          </a:bodyPr>
+          <a:lstStyle/>
+          <a:p>
+            <a:pPr algn="l" indent="0" marL="0">
+              <a:buNone/>
+            </a:pPr>
+            <a:r>
+              <a:rPr lang="en-US" sz="3400" b="1" dirty="0">
+                <a:solidFill>
+                  <a:srgbClr val="06AFA5"/>
+                </a:solidFill>
+                <a:latin typeface="Aptos" pitchFamily="34" charset="0"/>
+                <a:ea typeface="Aptos" pitchFamily="34" charset="-122"/>
+                <a:cs typeface="Aptos" pitchFamily="34" charset="-120"/>
+              </a:rPr>
+              <a:t>$0.53</a:t>
+            </a:r>
+            <a:endParaRPr lang="en-US" sz="3400" dirty="0"/>
+          </a:p>
+        </p:txBody>
+      </p:sp>
+      <p:sp>
+        <p:nvSpPr>
+          <p:cNvPr id="20" name="Text 18"/>
+          <p:cNvSpPr/>
+          <p:nvPr/>
+        </p:nvSpPr>
+        <p:spPr>
+          <a:xfrm>
+            <a:off x="6611112" y="3456432"/>
+            <a:ext cx="4663440" cy="292608"/>
+          </a:xfrm>
+          <a:prstGeom prst="rect">
+            <a:avLst/>
+          </a:prstGeom>
+          <a:noFill/>
+          <a:ln/>
+        </p:spPr>
+        <p:txBody>
+          <a:bodyPr wrap="square" lIns="254" tIns="254" rIns="254" bIns="254" rtlCol="0" anchor="ctr">
+            <a:normAutofit/>
+          </a:bodyPr>
+          <a:lstStyle/>
+          <a:p>
+            <a:pPr algn="l" indent="0" marL="0">
+              <a:buNone/>
+            </a:pPr>
+            <a:r>
+              <a:rPr lang="en-US" sz="1710" b="1" dirty="0">
+                <a:solidFill>
+                  <a:srgbClr val="132438"/>
+                </a:solidFill>
+                <a:latin typeface="Aptos" pitchFamily="34" charset="0"/>
+                <a:ea typeface="Aptos" pitchFamily="34" charset="-122"/>
+                <a:cs typeface="Aptos" pitchFamily="34" charset="-120"/>
+              </a:rPr>
+              <a:t>Reported average per run</a:t>
+            </a:r>
+            <a:endParaRPr lang="en-US" sz="1710" dirty="0"/>
+          </a:p>
+        </p:txBody>
+      </p:sp>
+      <p:sp>
+        <p:nvSpPr>
+          <p:cNvPr id="21" name="Text 19"/>
+          <p:cNvSpPr/>
+          <p:nvPr/>
+        </p:nvSpPr>
+        <p:spPr>
+          <a:xfrm>
+            <a:off x="6611112" y="3959352"/>
+            <a:ext cx="4572000" cy="868680"/>
+          </a:xfrm>
+          <a:prstGeom prst="rect">
+            <a:avLst/>
+          </a:prstGeom>
+          <a:noFill/>
+          <a:ln/>
+        </p:spPr>
+        <p:txBody>
+          <a:bodyPr wrap="square" lIns="254" tIns="254" rIns="254" bIns="254" rtlCol="0" anchor="t">
+            <a:normAutofit/>
+          </a:bodyPr>
+          <a:lstStyle/>
+          <a:p>
+            <a:pPr algn="l" indent="0" marL="0">
+              <a:buNone/>
+            </a:pPr>
+            <a:r>
+              <a:rPr lang="en-US" sz="1460" dirty="0">
+                <a:solidFill>
+                  <a:srgbClr val="536579"/>
+                </a:solidFill>
+                <a:latin typeface="Aptos" pitchFamily="34" charset="0"/>
+                <a:ea typeface="Aptos" pitchFamily="34" charset="-122"/>
+                <a:cs typeface="Aptos" pitchFamily="34" charset="-120"/>
+              </a:rPr>
+              <a:t>28 read tools versus a broader toolset.</a:t>
+            </a:r>
+            <a:endParaRPr lang="en-US" sz="1460" dirty="0"/>
+          </a:p>
+          <a:p>
+            <a:pPr algn="l" indent="0" marL="0">
+              <a:buNone/>
+            </a:pPr>
+            <a:r>
+              <a:rPr lang="en-US" sz="1460" dirty="0">
+                <a:solidFill>
+                  <a:srgbClr val="536579"/>
+                </a:solidFill>
+                <a:latin typeface="Aptos" pitchFamily="34" charset="0"/>
+                <a:ea typeface="Aptos" pitchFamily="34" charset="-122"/>
+                <a:cs typeface="Aptos" pitchFamily="34" charset="-120"/>
+              </a:rPr>
+              <a:t>Five runs per setup; identical cases vary.</a:t>
+            </a:r>
+            <a:endParaRPr lang="en-US" sz="1460" dirty="0"/>
+          </a:p>
+        </p:txBody>
+      </p:sp>
+      <p:sp>
+        <p:nvSpPr>
+          <p:cNvPr id="22" name="Shape 20"/>
+          <p:cNvSpPr/>
+          <p:nvPr/>
+        </p:nvSpPr>
+        <p:spPr>
+          <a:xfrm>
+            <a:off x="694944" y="5495544"/>
+            <a:ext cx="10789920" cy="438912"/>
+          </a:xfrm>
+          <a:prstGeom prst="roundRect">
+            <a:avLst>
+              <a:gd name="adj" fmla="val 22917"/>
+            </a:avLst>
+          </a:prstGeom>
+          <a:solidFill>
+            <a:srgbClr val="EAF0F5"/>
+          </a:solidFill>
+          <a:ln w="12700">
+            <a:solidFill>
+              <a:srgbClr val="EAF0F5">
+                <a:alpha val="0"/>
+              </a:srgbClr>
+            </a:solidFill>
+            <a:prstDash val="solid"/>
+          </a:ln>
+        </p:spPr>
+        <p:txBody>
+          <a:bodyPr/>
+          <a:p/>
+        </p:txBody>
+      </p:sp>
+      <p:sp>
+        <p:nvSpPr>
+          <p:cNvPr id="23" name="Text 21"/>
+          <p:cNvSpPr/>
+          <p:nvPr/>
+        </p:nvSpPr>
+        <p:spPr>
+          <a:xfrm>
+            <a:off x="914400" y="5614416"/>
+            <a:ext cx="10378440" cy="164592"/>
+          </a:xfrm>
+          <a:prstGeom prst="rect">
+            <a:avLst/>
+          </a:prstGeom>
+          <a:noFill/>
+          <a:ln/>
+        </p:spPr>
+        <p:txBody>
+          <a:bodyPr wrap="square" lIns="254" tIns="254" rIns="254" bIns="254" rtlCol="0" anchor="ctr">
+            <a:normAutofit/>
+          </a:bodyPr>
+          <a:lstStyle/>
+          <a:p>
+            <a:pPr algn="ctr" indent="0" marL="0">
+              <a:buNone/>
+            </a:pPr>
+            <a:r>
+              <a:rPr lang="en-US" sz="1190" dirty="0">
+                <a:solidFill>
+                  <a:srgbClr val="536579"/>
+                </a:solidFill>
+                <a:latin typeface="Aptos" pitchFamily="34" charset="0"/>
+                <a:ea typeface="Aptos" pitchFamily="34" charset="-122"/>
+                <a:cs typeface="Aptos" pitchFamily="34" charset="-120"/>
+              </a:rPr>
+              <a:t>NOT A BENCHMARK: Hosted agent changed version during tests; evaluation must be repeated in the customer environment.</a:t>
+            </a:r>
+            <a:endParaRPr lang="en-US" sz="1190" dirty="0"/>
+          </a:p>
+        </p:txBody>
+      </p:sp>
+    </p:spTree>
+  </p:cSld>
+  <p:clrMapOvr>
+    <a:masterClrMapping/>
+  </p:clrMapOvr>
+</p:sld>
+</file>
+
+<file path=ppt/slides/slide11.xml><?xml version="1.0" encoding="utf-8"?>
+<p:sld xmlns:a="http://schemas.openxmlformats.org/drawingml/2006/main" xmlns:r="http://schemas.openxmlformats.org/officeDocument/2006/relationships" xmlns:p="http://schemas.openxmlformats.org/presentationml/2006/main">
   <p:cSld name="Slide 10">
     <p:bg>
       <p:bgPr>
@@ -3187,7 +4073,7 @@
 </p:sld>
 </file>
 
-<file path=ppt/slides/slide11.xml><?xml version="1.0" encoding="utf-8"?>
+<file path=ppt/slides/slide12.xml><?xml version="1.0" encoding="utf-8"?>
 <p:sld xmlns:a="http://schemas.openxmlformats.org/drawingml/2006/main" xmlns:r="http://schemas.openxmlformats.org/officeDocument/2006/relationships" xmlns:p="http://schemas.openxmlformats.org/presentationml/2006/main">
   <p:cSld name="Slide 11">
     <p:bg>
@@ -3918,7 +4804,7 @@
 </p:sld>
 </file>
 
-<file path=ppt/slides/slide12.xml><?xml version="1.0" encoding="utf-8"?>
+<file path=ppt/slides/slide13.xml><?xml version="1.0" encoding="utf-8"?>
 <p:sld xmlns:a="http://schemas.openxmlformats.org/drawingml/2006/main" xmlns:r="http://schemas.openxmlformats.org/officeDocument/2006/relationships" xmlns:p="http://schemas.openxmlformats.org/presentationml/2006/main">
   <p:cSld name="Slide 12">
     <p:bg>
@@ -4430,7 +5316,7 @@
 </p:sld>
 </file>
 
-<file path=ppt/slides/slide13.xml><?xml version="1.0" encoding="utf-8"?>
+<file path=ppt/slides/slide14.xml><?xml version="1.0" encoding="utf-8"?>
 <p:sld xmlns:a="http://schemas.openxmlformats.org/drawingml/2006/main" xmlns:r="http://schemas.openxmlformats.org/officeDocument/2006/relationships" xmlns:p="http://schemas.openxmlformats.org/presentationml/2006/main">
   <p:cSld name="Slide 13">
     <p:bg>
@@ -5343,7 +6229,7 @@
 </p:sld>
 </file>
 
-<file path=ppt/slides/slide14.xml><?xml version="1.0" encoding="utf-8"?>
+<file path=ppt/slides/slide15.xml><?xml version="1.0" encoding="utf-8"?>
 <p:sld xmlns:a="http://schemas.openxmlformats.org/drawingml/2006/main" xmlns:r="http://schemas.openxmlformats.org/officeDocument/2006/relationships" xmlns:p="http://schemas.openxmlformats.org/presentationml/2006/main">
   <p:cSld name="Slide 14">
     <p:bg>
@@ -6464,6 +7350,1010 @@
 </file>
 
 <file path=ppt/slides/slide2.xml><?xml version="1.0" encoding="utf-8"?>
+<p:sld xmlns:a="http://schemas.openxmlformats.org/drawingml/2006/main" xmlns:p="http://schemas.openxmlformats.org/presentationml/2006/main" xmlns:r="http://schemas.openxmlformats.org/officeDocument/2006/relationships">
+  <p:cSld>
+    <p:bg>
+      <p:bgPr>
+        <a:solidFill>
+          <a:srgbClr val="F7F9FC"/>
+        </a:solidFill>
+      </p:bgPr>
+    </p:bg>
+    <p:spTree>
+      <p:nvGrpSpPr>
+        <p:cNvPr id="1" name=""/>
+        <p:cNvGrpSpPr/>
+        <p:nvPr/>
+      </p:nvGrpSpPr>
+      <p:grpSpPr/>
+      <p:sp>
+        <p:nvSpPr>
+          <p:cNvPr id="2" name="Text 0"/>
+          <p:cNvSpPr/>
+          <p:nvPr/>
+        </p:nvSpPr>
+        <p:spPr>
+          <a:xfrm>
+            <a:off x="640080" y="310896"/>
+            <a:ext cx="9144000" cy="219456"/>
+          </a:xfrm>
+          <a:prstGeom prst="rect">
+            <a:avLst/>
+          </a:prstGeom>
+          <a:noFill/>
+          <a:ln/>
+        </p:spPr>
+        <p:txBody>
+          <a:bodyPr wrap="square" lIns="254" tIns="254" rIns="254" bIns="254" rtlCol="0" anchor="ctr">
+            <a:normAutofit/>
+          </a:bodyPr>
+          <a:lstStyle/>
+          <a:p>
+            <a:pPr algn="l" indent="0" marL="0">
+              <a:buNone/>
+            </a:pPr>
+            <a:r>
+              <a:rPr lang="en-US" sz="1050" b="1" spc="240" kern="0" dirty="0">
+                <a:solidFill>
+                  <a:srgbClr val="06AFA5"/>
+                </a:solidFill>
+                <a:latin typeface="Aptos" pitchFamily="34" charset="0"/>
+                <a:ea typeface="Aptos" pitchFamily="34" charset="-122"/>
+                <a:cs typeface="Aptos" pitchFamily="34" charset="-120"/>
+              </a:rPr>
+              <a:t>INTRODUCTION  /  AGENDA</a:t>
+            </a:r>
+            <a:endParaRPr lang="en-US" sz="1050" dirty="0"/>
+          </a:p>
+        </p:txBody>
+      </p:sp>
+      <p:sp>
+        <p:nvSpPr>
+          <p:cNvPr id="4" name="Text 2"/>
+          <p:cNvSpPr/>
+          <p:nvPr/>
+        </p:nvSpPr>
+        <p:spPr>
+          <a:xfrm>
+            <a:off x="640080" y="777240"/>
+            <a:ext cx="10927080" cy="932688"/>
+          </a:xfrm>
+          <a:prstGeom prst="rect">
+            <a:avLst/>
+          </a:prstGeom>
+          <a:noFill/>
+          <a:ln/>
+        </p:spPr>
+        <p:txBody>
+          <a:bodyPr wrap="square" lIns="254" tIns="254" rIns="254" bIns="254" rtlCol="0" anchor="t">
+            <a:normAutofit/>
+          </a:bodyPr>
+          <a:lstStyle/>
+          <a:p>
+            <a:pPr algn="l" indent="0" marL="0">
+              <a:buNone/>
+            </a:pPr>
+            <a:r>
+              <a:rPr lang="en-US" sz="3150" b="1" dirty="0">
+                <a:solidFill>
+                  <a:srgbClr val="132438"/>
+                </a:solidFill>
+                <a:latin typeface="Aptos" pitchFamily="34" charset="0"/>
+                <a:ea typeface="Aptos" pitchFamily="34" charset="-122"/>
+                <a:cs typeface="Aptos" pitchFamily="34" charset="-120"/>
+              </a:rPr>
+              <a:t>Today: one real incident and a first step.</a:t>
+            </a:r>
+            <a:endParaRPr lang="en-US" sz="3150" dirty="0"/>
+          </a:p>
+        </p:txBody>
+      </p:sp>
+      <p:sp>
+        <p:nvSpPr>
+          <p:cNvPr id="5" name="Shape 3"/>
+          <p:cNvSpPr/>
+          <p:nvPr/>
+        </p:nvSpPr>
+        <p:spPr>
+          <a:xfrm>
+            <a:off x="640080" y="6327648"/>
+            <a:ext cx="10927080" cy="0"/>
+          </a:xfrm>
+          <a:prstGeom prst="line">
+            <a:avLst/>
+          </a:prstGeom>
+          <a:noFill/>
+          <a:ln w="11430">
+            <a:solidFill>
+              <a:srgbClr val="DCE5ED"/>
+            </a:solidFill>
+            <a:prstDash val="solid"/>
+          </a:ln>
+        </p:spPr>
+        <p:txBody>
+          <a:bodyPr/>
+          <a:p/>
+        </p:txBody>
+      </p:sp>
+      <p:sp>
+        <p:nvSpPr>
+          <p:cNvPr id="6" name="Text 4"/>
+          <p:cNvSpPr/>
+          <p:nvPr/>
+        </p:nvSpPr>
+        <p:spPr>
+          <a:xfrm>
+            <a:off x="640080" y="6419088"/>
+            <a:ext cx="5486400" cy="155448"/>
+          </a:xfrm>
+          <a:prstGeom prst="rect">
+            <a:avLst/>
+          </a:prstGeom>
+          <a:noFill/>
+          <a:ln/>
+        </p:spPr>
+        <p:txBody>
+          <a:bodyPr wrap="square" lIns="254" tIns="254" rIns="254" bIns="254" rtlCol="0" anchor="ctr">
+            <a:normAutofit/>
+          </a:bodyPr>
+          <a:lstStyle/>
+          <a:p>
+            <a:pPr algn="l" indent="0" marL="0">
+              <a:buNone/>
+            </a:pPr>
+            <a:r>
+              <a:rPr lang="en-US" sz="900" spc="120" kern="0" dirty="0">
+                <a:solidFill>
+                  <a:srgbClr val="536579"/>
+                </a:solidFill>
+                <a:latin typeface="Aptos" pitchFamily="34" charset="0"/>
+                <a:ea typeface="Aptos" pitchFamily="34" charset="-122"/>
+                <a:cs typeface="Aptos" pitchFamily="34" charset="-120"/>
+              </a:rPr>
+              <a:t>KAOP  /  CUSTOMER DISCUSSION</a:t>
+            </a:r>
+            <a:endParaRPr lang="en-US" sz="900" dirty="0"/>
+          </a:p>
+        </p:txBody>
+      </p:sp>
+      <p:sp>
+        <p:nvSpPr>
+          <p:cNvPr id="7" name="Rounded Rectangle 6"/>
+          <p:cNvSpPr/>
+          <p:nvPr/>
+        </p:nvSpPr>
+        <p:spPr>
+          <a:xfrm>
+            <a:off x="673100" y="1905000"/>
+            <a:ext cx="3683000" cy="3683000"/>
+          </a:xfrm>
+          <a:prstGeom prst="roundRect">
+            <a:avLst>
+              <a:gd name="adj" fmla="val 8000"/>
+            </a:avLst>
+          </a:prstGeom>
+          <a:solidFill>
+            <a:srgbClr val="0C1423"/>
+          </a:solidFill>
+          <a:ln>
+            <a:solidFill>
+              <a:srgbClr val="0C1423"/>
+            </a:solidFill>
+          </a:ln>
+          <a:effectLst/>
+        </p:spPr>
+        <p:style>
+          <a:lnRef idx="1">
+            <a:schemeClr val="accent1"/>
+          </a:lnRef>
+          <a:fillRef idx="3">
+            <a:schemeClr val="accent1"/>
+          </a:fillRef>
+          <a:effectRef idx="2">
+            <a:schemeClr val="accent1"/>
+          </a:effectRef>
+          <a:fontRef idx="minor">
+            <a:schemeClr val="lt1"/>
+          </a:fontRef>
+        </p:style>
+        <p:txBody>
+          <a:bodyPr rtlCol="0" anchor="ctr"/>
+          <a:lstStyle/>
+          <a:p>
+            <a:pPr algn="ctr"/>
+          </a:p>
+        </p:txBody>
+      </p:sp>
+      <p:sp>
+        <p:nvSpPr>
+          <p:cNvPr id="8" name="TextBox 7"/>
+          <p:cNvSpPr txBox="1"/>
+          <p:nvPr/>
+        </p:nvSpPr>
+        <p:spPr>
+          <a:xfrm>
+            <a:off x="952500" y="2184400"/>
+            <a:ext cx="3175000" cy="3175000"/>
+          </a:xfrm>
+          <a:prstGeom prst="rect">
+            <a:avLst/>
+          </a:prstGeom>
+          <a:noFill/>
+        </p:spPr>
+        <p:txBody>
+          <a:bodyPr wrap="square" lIns="0" rIns="0" tIns="0" bIns="0">
+            <a:spAutoFit/>
+          </a:bodyPr>
+          <a:lstStyle/>
+          <a:p>
+            <a:r>
+              <a:rPr sz="1100" b="1">
+                <a:solidFill>
+                  <a:srgbClr val="C6F783"/>
+                </a:solidFill>
+                <a:latin typeface="Aptos"/>
+              </a:rPr>
+              <a:t>YOUR PRESENTER</a:t>
+            </a:r>
+          </a:p>
+          <a:p>
+            <a:pPr>
+              <a:spcBef>
+                <a:spcPts val="600"/>
+              </a:spcBef>
+            </a:pPr>
+            <a:r>
+              <a:rPr sz="2400" b="1">
+                <a:solidFill>
+                  <a:srgbClr val="FFFFFF"/>
+                </a:solidFill>
+                <a:latin typeface="Aptos"/>
+              </a:rPr>
+              <a:t>Echizeni Ikpah</a:t>
+            </a:r>
+          </a:p>
+          <a:p>
+            <a:pPr>
+              <a:spcBef>
+                <a:spcPts val="600"/>
+              </a:spcBef>
+            </a:pPr>
+            <a:r>
+              <a:rPr sz="1400" b="0">
+                <a:solidFill>
+                  <a:srgbClr val="B8C4D6"/>
+                </a:solidFill>
+                <a:latin typeface="Aptos"/>
+              </a:rPr>
+              <a:t>Product Engineer, Komodor</a:t>
+            </a:r>
+          </a:p>
+          <a:p>
+            <a:pPr>
+              <a:spcBef>
+                <a:spcPts val="600"/>
+              </a:spcBef>
+            </a:pPr>
+            <a:r>
+              <a:rPr sz="1400" b="0">
+                <a:solidFill>
+                  <a:srgbClr val="E6ECF4"/>
+                </a:solidFill>
+                <a:latin typeface="Aptos"/>
+              </a:rPr>
+              <a:t>I help teams adopt KAOP: get the first workflow running, measure the results with you, and bring your feedback to our product team.</a:t>
+            </a:r>
+          </a:p>
+        </p:txBody>
+      </p:sp>
+      <p:sp>
+        <p:nvSpPr>
+          <p:cNvPr id="9" name="TextBox 8"/>
+          <p:cNvSpPr txBox="1"/>
+          <p:nvPr/>
+        </p:nvSpPr>
+        <p:spPr>
+          <a:xfrm>
+            <a:off x="952500" y="4978400"/>
+            <a:ext cx="3175000" cy="457200"/>
+          </a:xfrm>
+          <a:prstGeom prst="rect">
+            <a:avLst/>
+          </a:prstGeom>
+          <a:noFill/>
+        </p:spPr>
+        <p:txBody>
+          <a:bodyPr wrap="square" lIns="0" rIns="0" tIns="0" bIns="0">
+            <a:spAutoFit/>
+          </a:bodyPr>
+          <a:lstStyle/>
+          <a:p>
+            <a:r>
+              <a:rPr sz="1300" b="1">
+                <a:solidFill>
+                  <a:srgbClr val="C6F783"/>
+                </a:solidFill>
+                <a:latin typeface="Aptos"/>
+              </a:rPr>
+              <a:t>Please ask questions any time. This is a conversation.</a:t>
+            </a:r>
+          </a:p>
+        </p:txBody>
+      </p:sp>
+      <p:sp>
+        <p:nvSpPr>
+          <p:cNvPr id="10" name="Rounded Rectangle 9"/>
+          <p:cNvSpPr/>
+          <p:nvPr/>
+        </p:nvSpPr>
+        <p:spPr>
+          <a:xfrm>
+            <a:off x="4699000" y="1955800"/>
+            <a:ext cx="406400" cy="406400"/>
+          </a:xfrm>
+          <a:prstGeom prst="roundRect">
+            <a:avLst>
+              <a:gd name="adj" fmla="val 8000"/>
+            </a:avLst>
+          </a:prstGeom>
+          <a:solidFill>
+            <a:srgbClr val="06AFA5"/>
+          </a:solidFill>
+          <a:ln>
+            <a:solidFill>
+              <a:srgbClr val="06AFA5"/>
+            </a:solidFill>
+          </a:ln>
+          <a:effectLst/>
+        </p:spPr>
+        <p:style>
+          <a:lnRef idx="1">
+            <a:schemeClr val="accent1"/>
+          </a:lnRef>
+          <a:fillRef idx="3">
+            <a:schemeClr val="accent1"/>
+          </a:fillRef>
+          <a:effectRef idx="2">
+            <a:schemeClr val="accent1"/>
+          </a:effectRef>
+          <a:fontRef idx="minor">
+            <a:schemeClr val="lt1"/>
+          </a:fontRef>
+        </p:style>
+        <p:txBody>
+          <a:bodyPr rtlCol="0" anchor="ctr"/>
+          <a:lstStyle/>
+          <a:p>
+            <a:pPr algn="ctr"/>
+          </a:p>
+        </p:txBody>
+      </p:sp>
+      <p:sp>
+        <p:nvSpPr>
+          <p:cNvPr id="11" name="TextBox 10"/>
+          <p:cNvSpPr txBox="1"/>
+          <p:nvPr/>
+        </p:nvSpPr>
+        <p:spPr>
+          <a:xfrm>
+            <a:off x="4699000" y="2057400"/>
+            <a:ext cx="406400" cy="228600"/>
+          </a:xfrm>
+          <a:prstGeom prst="rect">
+            <a:avLst/>
+          </a:prstGeom>
+          <a:noFill/>
+        </p:spPr>
+        <p:txBody>
+          <a:bodyPr wrap="square" lIns="0" rIns="0" tIns="0" bIns="0">
+            <a:spAutoFit/>
+          </a:bodyPr>
+          <a:lstStyle/>
+          <a:p>
+            <a:pPr algn="ctr"/>
+            <a:r>
+              <a:rPr sz="1100" b="1">
+                <a:solidFill>
+                  <a:srgbClr val="FFFFFF"/>
+                </a:solidFill>
+                <a:latin typeface="Aptos"/>
+              </a:rPr>
+              <a:t>01</a:t>
+            </a:r>
+          </a:p>
+        </p:txBody>
+      </p:sp>
+      <p:sp>
+        <p:nvSpPr>
+          <p:cNvPr id="12" name="TextBox 11"/>
+          <p:cNvSpPr txBox="1"/>
+          <p:nvPr/>
+        </p:nvSpPr>
+        <p:spPr>
+          <a:xfrm>
+            <a:off x="5308600" y="1905000"/>
+            <a:ext cx="6172200" cy="635000"/>
+          </a:xfrm>
+          <a:prstGeom prst="rect">
+            <a:avLst/>
+          </a:prstGeom>
+          <a:noFill/>
+        </p:spPr>
+        <p:txBody>
+          <a:bodyPr wrap="square" lIns="0" rIns="0" tIns="0" bIns="0">
+            <a:spAutoFit/>
+          </a:bodyPr>
+          <a:lstStyle/>
+          <a:p>
+            <a:r>
+              <a:rPr sz="1700" b="1">
+                <a:solidFill>
+                  <a:srgbClr val="132438"/>
+                </a:solidFill>
+                <a:latin typeface="Aptos"/>
+              </a:rPr>
+              <a:t>Your environment</a:t>
+            </a:r>
+          </a:p>
+          <a:p>
+            <a:pPr>
+              <a:spcBef>
+                <a:spcPts val="600"/>
+              </a:spcBef>
+            </a:pPr>
+            <a:r>
+              <a:rPr sz="1350" b="0">
+                <a:solidFill>
+                  <a:srgbClr val="536579"/>
+                </a:solidFill>
+                <a:latin typeface="Aptos"/>
+              </a:rPr>
+              <a:t>Where agent sprawl would hurt first</a:t>
+            </a:r>
+          </a:p>
+        </p:txBody>
+      </p:sp>
+      <p:sp>
+        <p:nvSpPr>
+          <p:cNvPr id="13" name="Rounded Rectangle 12"/>
+          <p:cNvSpPr/>
+          <p:nvPr/>
+        </p:nvSpPr>
+        <p:spPr>
+          <a:xfrm>
+            <a:off x="4699000" y="2692400"/>
+            <a:ext cx="406400" cy="406400"/>
+          </a:xfrm>
+          <a:prstGeom prst="roundRect">
+            <a:avLst>
+              <a:gd name="adj" fmla="val 8000"/>
+            </a:avLst>
+          </a:prstGeom>
+          <a:solidFill>
+            <a:srgbClr val="06AFA5"/>
+          </a:solidFill>
+          <a:ln>
+            <a:solidFill>
+              <a:srgbClr val="06AFA5"/>
+            </a:solidFill>
+          </a:ln>
+          <a:effectLst/>
+        </p:spPr>
+        <p:style>
+          <a:lnRef idx="1">
+            <a:schemeClr val="accent1"/>
+          </a:lnRef>
+          <a:fillRef idx="3">
+            <a:schemeClr val="accent1"/>
+          </a:fillRef>
+          <a:effectRef idx="2">
+            <a:schemeClr val="accent1"/>
+          </a:effectRef>
+          <a:fontRef idx="minor">
+            <a:schemeClr val="lt1"/>
+          </a:fontRef>
+        </p:style>
+        <p:txBody>
+          <a:bodyPr rtlCol="0" anchor="ctr"/>
+          <a:lstStyle/>
+          <a:p>
+            <a:pPr algn="ctr"/>
+          </a:p>
+        </p:txBody>
+      </p:sp>
+      <p:sp>
+        <p:nvSpPr>
+          <p:cNvPr id="14" name="TextBox 13"/>
+          <p:cNvSpPr txBox="1"/>
+          <p:nvPr/>
+        </p:nvSpPr>
+        <p:spPr>
+          <a:xfrm>
+            <a:off x="4699000" y="2794000"/>
+            <a:ext cx="406400" cy="228600"/>
+          </a:xfrm>
+          <a:prstGeom prst="rect">
+            <a:avLst/>
+          </a:prstGeom>
+          <a:noFill/>
+        </p:spPr>
+        <p:txBody>
+          <a:bodyPr wrap="square" lIns="0" rIns="0" tIns="0" bIns="0">
+            <a:spAutoFit/>
+          </a:bodyPr>
+          <a:lstStyle/>
+          <a:p>
+            <a:pPr algn="ctr"/>
+            <a:r>
+              <a:rPr sz="1100" b="1">
+                <a:solidFill>
+                  <a:srgbClr val="FFFFFF"/>
+                </a:solidFill>
+                <a:latin typeface="Aptos"/>
+              </a:rPr>
+              <a:t>02</a:t>
+            </a:r>
+          </a:p>
+        </p:txBody>
+      </p:sp>
+      <p:sp>
+        <p:nvSpPr>
+          <p:cNvPr id="15" name="TextBox 14"/>
+          <p:cNvSpPr txBox="1"/>
+          <p:nvPr/>
+        </p:nvSpPr>
+        <p:spPr>
+          <a:xfrm>
+            <a:off x="5308600" y="2641600"/>
+            <a:ext cx="6172200" cy="635000"/>
+          </a:xfrm>
+          <a:prstGeom prst="rect">
+            <a:avLst/>
+          </a:prstGeom>
+          <a:noFill/>
+        </p:spPr>
+        <p:txBody>
+          <a:bodyPr wrap="square" lIns="0" rIns="0" tIns="0" bIns="0">
+            <a:spAutoFit/>
+          </a:bodyPr>
+          <a:lstStyle/>
+          <a:p>
+            <a:r>
+              <a:rPr sz="1700" b="1">
+                <a:solidFill>
+                  <a:srgbClr val="132438"/>
+                </a:solidFill>
+                <a:latin typeface="Aptos"/>
+              </a:rPr>
+              <a:t>Why KAOP</a:t>
+            </a:r>
+          </a:p>
+          <a:p>
+            <a:pPr>
+              <a:spcBef>
+                <a:spcPts val="600"/>
+              </a:spcBef>
+            </a:pPr>
+            <a:r>
+              <a:rPr sz="1350" b="0">
+                <a:solidFill>
+                  <a:srgbClr val="536579"/>
+                </a:solidFill>
+                <a:latin typeface="Aptos"/>
+              </a:rPr>
+              <a:t>One view, real limits, work that closes</a:t>
+            </a:r>
+          </a:p>
+        </p:txBody>
+      </p:sp>
+      <p:sp>
+        <p:nvSpPr>
+          <p:cNvPr id="16" name="Rounded Rectangle 15"/>
+          <p:cNvSpPr/>
+          <p:nvPr/>
+        </p:nvSpPr>
+        <p:spPr>
+          <a:xfrm>
+            <a:off x="4699000" y="3429000"/>
+            <a:ext cx="406400" cy="406400"/>
+          </a:xfrm>
+          <a:prstGeom prst="roundRect">
+            <a:avLst>
+              <a:gd name="adj" fmla="val 8000"/>
+            </a:avLst>
+          </a:prstGeom>
+          <a:solidFill>
+            <a:srgbClr val="06AFA5"/>
+          </a:solidFill>
+          <a:ln>
+            <a:solidFill>
+              <a:srgbClr val="06AFA5"/>
+            </a:solidFill>
+          </a:ln>
+          <a:effectLst/>
+        </p:spPr>
+        <p:style>
+          <a:lnRef idx="1">
+            <a:schemeClr val="accent1"/>
+          </a:lnRef>
+          <a:fillRef idx="3">
+            <a:schemeClr val="accent1"/>
+          </a:fillRef>
+          <a:effectRef idx="2">
+            <a:schemeClr val="accent1"/>
+          </a:effectRef>
+          <a:fontRef idx="minor">
+            <a:schemeClr val="lt1"/>
+          </a:fontRef>
+        </p:style>
+        <p:txBody>
+          <a:bodyPr rtlCol="0" anchor="ctr"/>
+          <a:lstStyle/>
+          <a:p>
+            <a:pPr algn="ctr"/>
+          </a:p>
+        </p:txBody>
+      </p:sp>
+      <p:sp>
+        <p:nvSpPr>
+          <p:cNvPr id="17" name="TextBox 16"/>
+          <p:cNvSpPr txBox="1"/>
+          <p:nvPr/>
+        </p:nvSpPr>
+        <p:spPr>
+          <a:xfrm>
+            <a:off x="4699000" y="3530600"/>
+            <a:ext cx="406400" cy="228600"/>
+          </a:xfrm>
+          <a:prstGeom prst="rect">
+            <a:avLst/>
+          </a:prstGeom>
+          <a:noFill/>
+        </p:spPr>
+        <p:txBody>
+          <a:bodyPr wrap="square" lIns="0" rIns="0" tIns="0" bIns="0">
+            <a:spAutoFit/>
+          </a:bodyPr>
+          <a:lstStyle/>
+          <a:p>
+            <a:pPr algn="ctr"/>
+            <a:r>
+              <a:rPr sz="1100" b="1">
+                <a:solidFill>
+                  <a:srgbClr val="FFFFFF"/>
+                </a:solidFill>
+                <a:latin typeface="Aptos"/>
+              </a:rPr>
+              <a:t>03</a:t>
+            </a:r>
+          </a:p>
+        </p:txBody>
+      </p:sp>
+      <p:sp>
+        <p:nvSpPr>
+          <p:cNvPr id="18" name="TextBox 17"/>
+          <p:cNvSpPr txBox="1"/>
+          <p:nvPr/>
+        </p:nvSpPr>
+        <p:spPr>
+          <a:xfrm>
+            <a:off x="5308600" y="3378200"/>
+            <a:ext cx="6172200" cy="635000"/>
+          </a:xfrm>
+          <a:prstGeom prst="rect">
+            <a:avLst/>
+          </a:prstGeom>
+          <a:noFill/>
+        </p:spPr>
+        <p:txBody>
+          <a:bodyPr wrap="square" lIns="0" rIns="0" tIns="0" bIns="0">
+            <a:spAutoFit/>
+          </a:bodyPr>
+          <a:lstStyle/>
+          <a:p>
+            <a:r>
+              <a:rPr sz="1700" b="1">
+                <a:solidFill>
+                  <a:srgbClr val="132438"/>
+                </a:solidFill>
+                <a:latin typeface="Aptos"/>
+              </a:rPr>
+              <a:t>A live incident</a:t>
+            </a:r>
+          </a:p>
+          <a:p>
+            <a:pPr>
+              <a:spcBef>
+                <a:spcPts val="600"/>
+              </a:spcBef>
+            </a:pPr>
+            <a:r>
+              <a:rPr sz="1350" b="0">
+                <a:solidFill>
+                  <a:srgbClr val="536579"/>
+                </a:solidFill>
+                <a:latin typeface="Aptos"/>
+              </a:rPr>
+              <a:t>A real alert, the evidence, a human decision</a:t>
+            </a:r>
+          </a:p>
+        </p:txBody>
+      </p:sp>
+      <p:sp>
+        <p:nvSpPr>
+          <p:cNvPr id="19" name="Rounded Rectangle 18"/>
+          <p:cNvSpPr/>
+          <p:nvPr/>
+        </p:nvSpPr>
+        <p:spPr>
+          <a:xfrm>
+            <a:off x="4699000" y="4165600"/>
+            <a:ext cx="406400" cy="406400"/>
+          </a:xfrm>
+          <a:prstGeom prst="roundRect">
+            <a:avLst>
+              <a:gd name="adj" fmla="val 8000"/>
+            </a:avLst>
+          </a:prstGeom>
+          <a:solidFill>
+            <a:srgbClr val="06AFA5"/>
+          </a:solidFill>
+          <a:ln>
+            <a:solidFill>
+              <a:srgbClr val="06AFA5"/>
+            </a:solidFill>
+          </a:ln>
+          <a:effectLst/>
+        </p:spPr>
+        <p:style>
+          <a:lnRef idx="1">
+            <a:schemeClr val="accent1"/>
+          </a:lnRef>
+          <a:fillRef idx="3">
+            <a:schemeClr val="accent1"/>
+          </a:fillRef>
+          <a:effectRef idx="2">
+            <a:schemeClr val="accent1"/>
+          </a:effectRef>
+          <a:fontRef idx="minor">
+            <a:schemeClr val="lt1"/>
+          </a:fontRef>
+        </p:style>
+        <p:txBody>
+          <a:bodyPr rtlCol="0" anchor="ctr"/>
+          <a:lstStyle/>
+          <a:p>
+            <a:pPr algn="ctr"/>
+          </a:p>
+        </p:txBody>
+      </p:sp>
+      <p:sp>
+        <p:nvSpPr>
+          <p:cNvPr id="20" name="TextBox 19"/>
+          <p:cNvSpPr txBox="1"/>
+          <p:nvPr/>
+        </p:nvSpPr>
+        <p:spPr>
+          <a:xfrm>
+            <a:off x="4699000" y="4267200"/>
+            <a:ext cx="406400" cy="228600"/>
+          </a:xfrm>
+          <a:prstGeom prst="rect">
+            <a:avLst/>
+          </a:prstGeom>
+          <a:noFill/>
+        </p:spPr>
+        <p:txBody>
+          <a:bodyPr wrap="square" lIns="0" rIns="0" tIns="0" bIns="0">
+            <a:spAutoFit/>
+          </a:bodyPr>
+          <a:lstStyle/>
+          <a:p>
+            <a:pPr algn="ctr"/>
+            <a:r>
+              <a:rPr sz="1100" b="1">
+                <a:solidFill>
+                  <a:srgbClr val="FFFFFF"/>
+                </a:solidFill>
+                <a:latin typeface="Aptos"/>
+              </a:rPr>
+              <a:t>04</a:t>
+            </a:r>
+          </a:p>
+        </p:txBody>
+      </p:sp>
+      <p:sp>
+        <p:nvSpPr>
+          <p:cNvPr id="21" name="TextBox 20"/>
+          <p:cNvSpPr txBox="1"/>
+          <p:nvPr/>
+        </p:nvSpPr>
+        <p:spPr>
+          <a:xfrm>
+            <a:off x="5308600" y="4114800"/>
+            <a:ext cx="6172200" cy="635000"/>
+          </a:xfrm>
+          <a:prstGeom prst="rect">
+            <a:avLst/>
+          </a:prstGeom>
+          <a:noFill/>
+        </p:spPr>
+        <p:txBody>
+          <a:bodyPr wrap="square" lIns="0" rIns="0" tIns="0" bIns="0">
+            <a:spAutoFit/>
+          </a:bodyPr>
+          <a:lstStyle/>
+          <a:p>
+            <a:r>
+              <a:rPr sz="1700" b="1">
+                <a:solidFill>
+                  <a:srgbClr val="132438"/>
+                </a:solidFill>
+                <a:latin typeface="Aptos"/>
+              </a:rPr>
+              <a:t>A reviewed fix</a:t>
+            </a:r>
+          </a:p>
+          <a:p>
+            <a:pPr>
+              <a:spcBef>
+                <a:spcPts val="600"/>
+              </a:spcBef>
+            </a:pPr>
+            <a:r>
+              <a:rPr sz="1350" b="0">
+                <a:solidFill>
+                  <a:srgbClr val="536579"/>
+                </a:solidFill>
+                <a:latin typeface="Aptos"/>
+              </a:rPr>
+              <a:t>A separate code reviewer on a real pull request</a:t>
+            </a:r>
+          </a:p>
+        </p:txBody>
+      </p:sp>
+      <p:sp>
+        <p:nvSpPr>
+          <p:cNvPr id="22" name="Rounded Rectangle 21"/>
+          <p:cNvSpPr/>
+          <p:nvPr/>
+        </p:nvSpPr>
+        <p:spPr>
+          <a:xfrm>
+            <a:off x="4699000" y="4902200"/>
+            <a:ext cx="406400" cy="406400"/>
+          </a:xfrm>
+          <a:prstGeom prst="roundRect">
+            <a:avLst>
+              <a:gd name="adj" fmla="val 8000"/>
+            </a:avLst>
+          </a:prstGeom>
+          <a:solidFill>
+            <a:srgbClr val="06AFA5"/>
+          </a:solidFill>
+          <a:ln>
+            <a:solidFill>
+              <a:srgbClr val="06AFA5"/>
+            </a:solidFill>
+          </a:ln>
+          <a:effectLst/>
+        </p:spPr>
+        <p:style>
+          <a:lnRef idx="1">
+            <a:schemeClr val="accent1"/>
+          </a:lnRef>
+          <a:fillRef idx="3">
+            <a:schemeClr val="accent1"/>
+          </a:fillRef>
+          <a:effectRef idx="2">
+            <a:schemeClr val="accent1"/>
+          </a:effectRef>
+          <a:fontRef idx="minor">
+            <a:schemeClr val="lt1"/>
+          </a:fontRef>
+        </p:style>
+        <p:txBody>
+          <a:bodyPr rtlCol="0" anchor="ctr"/>
+          <a:lstStyle/>
+          <a:p>
+            <a:pPr algn="ctr"/>
+          </a:p>
+        </p:txBody>
+      </p:sp>
+      <p:sp>
+        <p:nvSpPr>
+          <p:cNvPr id="23" name="TextBox 22"/>
+          <p:cNvSpPr txBox="1"/>
+          <p:nvPr/>
+        </p:nvSpPr>
+        <p:spPr>
+          <a:xfrm>
+            <a:off x="4699000" y="5003800"/>
+            <a:ext cx="406400" cy="228600"/>
+          </a:xfrm>
+          <a:prstGeom prst="rect">
+            <a:avLst/>
+          </a:prstGeom>
+          <a:noFill/>
+        </p:spPr>
+        <p:txBody>
+          <a:bodyPr wrap="square" lIns="0" rIns="0" tIns="0" bIns="0">
+            <a:spAutoFit/>
+          </a:bodyPr>
+          <a:lstStyle/>
+          <a:p>
+            <a:pPr algn="ctr"/>
+            <a:r>
+              <a:rPr sz="1100" b="1">
+                <a:solidFill>
+                  <a:srgbClr val="FFFFFF"/>
+                </a:solidFill>
+                <a:latin typeface="Aptos"/>
+              </a:rPr>
+              <a:t>05</a:t>
+            </a:r>
+          </a:p>
+        </p:txBody>
+      </p:sp>
+      <p:sp>
+        <p:nvSpPr>
+          <p:cNvPr id="24" name="TextBox 23"/>
+          <p:cNvSpPr txBox="1"/>
+          <p:nvPr/>
+        </p:nvSpPr>
+        <p:spPr>
+          <a:xfrm>
+            <a:off x="5308600" y="4851400"/>
+            <a:ext cx="6172200" cy="635000"/>
+          </a:xfrm>
+          <a:prstGeom prst="rect">
+            <a:avLst/>
+          </a:prstGeom>
+          <a:noFill/>
+        </p:spPr>
+        <p:txBody>
+          <a:bodyPr wrap="square" lIns="0" rIns="0" tIns="0" bIns="0">
+            <a:spAutoFit/>
+          </a:bodyPr>
+          <a:lstStyle/>
+          <a:p>
+            <a:r>
+              <a:rPr sz="1700" b="1">
+                <a:solidFill>
+                  <a:srgbClr val="132438"/>
+                </a:solidFill>
+                <a:latin typeface="Aptos"/>
+              </a:rPr>
+              <a:t>Results and a first step</a:t>
+            </a:r>
+          </a:p>
+          <a:p>
+            <a:pPr>
+              <a:spcBef>
+                <a:spcPts val="600"/>
+              </a:spcBef>
+            </a:pPr>
+            <a:r>
+              <a:rPr sz="1350" b="0">
+                <a:solidFill>
+                  <a:srgbClr val="536579"/>
+                </a:solidFill>
+                <a:latin typeface="Aptos"/>
+              </a:rPr>
+              <a:t>What I measured, and a pilot that fits your team</a:t>
+            </a:r>
+          </a:p>
+        </p:txBody>
+      </p:sp>
+    </p:spTree>
+  </p:cSld>
+  <p:clrMapOvr>
+    <a:masterClrMapping/>
+  </p:clrMapOvr>
+</p:sld>
+</file>
+
+<file path=ppt/slides/slide3.xml><?xml version="1.0" encoding="utf-8"?>
 <p:sld xmlns:a="http://schemas.openxmlformats.org/drawingml/2006/main" xmlns:r="http://schemas.openxmlformats.org/officeDocument/2006/relationships" xmlns:p="http://schemas.openxmlformats.org/presentationml/2006/main">
   <p:cSld name="Slide 2">
     <p:bg>
@@ -7485,7 +9375,7 @@
 </p:sld>
 </file>
 
-<file path=ppt/slides/slide3.xml><?xml version="1.0" encoding="utf-8"?>
+<file path=ppt/slides/slide4.xml><?xml version="1.0" encoding="utf-8"?>
 <p:sld xmlns:a="http://schemas.openxmlformats.org/drawingml/2006/main" xmlns:r="http://schemas.openxmlformats.org/officeDocument/2006/relationships" xmlns:p="http://schemas.openxmlformats.org/presentationml/2006/main">
   <p:cSld name="Slide 3">
     <p:bg>
@@ -8558,7 +10448,7 @@
 </p:sld>
 </file>
 
-<file path=ppt/slides/slide4.xml><?xml version="1.0" encoding="utf-8"?>
+<file path=ppt/slides/slide5.xml><?xml version="1.0" encoding="utf-8"?>
 <p:sld xmlns:a="http://schemas.openxmlformats.org/drawingml/2006/main" xmlns:r="http://schemas.openxmlformats.org/officeDocument/2006/relationships" xmlns:p="http://schemas.openxmlformats.org/presentationml/2006/main">
   <p:cSld name="Slide 4">
     <p:bg>
@@ -10300,7 +12190,7 @@
 </p:sld>
 </file>
 
-<file path=ppt/slides/slide5.xml><?xml version="1.0" encoding="utf-8"?>
+<file path=ppt/slides/slide6.xml><?xml version="1.0" encoding="utf-8"?>
 <p:sld xmlns:a="http://schemas.openxmlformats.org/drawingml/2006/main" xmlns:r="http://schemas.openxmlformats.org/officeDocument/2006/relationships" xmlns:p="http://schemas.openxmlformats.org/presentationml/2006/main">
   <p:cSld name="Slide 5">
     <p:bg>
@@ -11510,7 +13400,7 @@
 </p:sld>
 </file>
 
-<file path=ppt/slides/slide6.xml><?xml version="1.0" encoding="utf-8"?>
+<file path=ppt/slides/slide7.xml><?xml version="1.0" encoding="utf-8"?>
 <p:sld xmlns:a="http://schemas.openxmlformats.org/drawingml/2006/main" xmlns:r="http://schemas.openxmlformats.org/officeDocument/2006/relationships" xmlns:p="http://schemas.openxmlformats.org/presentationml/2006/main">
   <p:cSld name="Slide 6">
     <p:bg>
@@ -13085,7 +14975,7 @@
 </p:sld>
 </file>
 
-<file path=ppt/slides/slide7.xml><?xml version="1.0" encoding="utf-8"?>
+<file path=ppt/slides/slide8.xml><?xml version="1.0" encoding="utf-8"?>
 <p:sld xmlns:a="http://schemas.openxmlformats.org/drawingml/2006/main" xmlns:r="http://schemas.openxmlformats.org/officeDocument/2006/relationships" xmlns:p="http://schemas.openxmlformats.org/presentationml/2006/main">
   <p:cSld name="Slide 7">
     <p:bg>
@@ -14274,7 +16164,7 @@
 </p:sld>
 </file>
 
-<file path=ppt/slides/slide8.xml><?xml version="1.0" encoding="utf-8"?>
+<file path=ppt/slides/slide9.xml><?xml version="1.0" encoding="utf-8"?>
 <p:sld xmlns:a="http://schemas.openxmlformats.org/drawingml/2006/main" xmlns:r="http://schemas.openxmlformats.org/officeDocument/2006/relationships" xmlns:p="http://schemas.openxmlformats.org/presentationml/2006/main">
   <p:cSld name="Slide 8">
     <p:bg>
@@ -15626,891 +17516,6 @@
               <a:t>Fix tested on the same outage: 5 liveness kills in 5 minutes before, 0 after.</a:t>
             </a:r>
             <a:endParaRPr lang="en-US" sz="1420" dirty="0"/>
-          </a:p>
-        </p:txBody>
-      </p:sp>
-    </p:spTree>
-  </p:cSld>
-  <p:clrMapOvr>
-    <a:masterClrMapping/>
-  </p:clrMapOvr>
-</p:sld>
-</file>
-
-<file path=ppt/slides/slide9.xml><?xml version="1.0" encoding="utf-8"?>
-<p:sld xmlns:a="http://schemas.openxmlformats.org/drawingml/2006/main" xmlns:r="http://schemas.openxmlformats.org/officeDocument/2006/relationships" xmlns:p="http://schemas.openxmlformats.org/presentationml/2006/main">
-  <p:cSld name="Slide 9">
-    <p:bg>
-      <p:bgPr>
-        <a:solidFill>
-          <a:srgbClr val="F7F9FC"/>
-        </a:solidFill>
-      </p:bgPr>
-    </p:bg>
-    <p:spTree>
-      <p:nvGrpSpPr>
-        <p:cNvPr id="1" name=""/>
-        <p:cNvGrpSpPr/>
-        <p:nvPr/>
-      </p:nvGrpSpPr>
-      <p:grpSpPr>
-        <a:xfrm>
-          <a:off x="0" y="0"/>
-          <a:ext cx="0" cy="0"/>
-          <a:chOff x="0" y="0"/>
-          <a:chExt cx="0" cy="0"/>
-        </a:xfrm>
-      </p:grpSpPr>
-      <p:sp>
-        <p:nvSpPr>
-          <p:cNvPr id="2" name="Text 0"/>
-          <p:cNvSpPr/>
-          <p:nvPr/>
-        </p:nvSpPr>
-        <p:spPr>
-          <a:xfrm>
-            <a:off x="640080" y="310896"/>
-            <a:ext cx="9144000" cy="219456"/>
-          </a:xfrm>
-          <a:prstGeom prst="rect">
-            <a:avLst/>
-          </a:prstGeom>
-          <a:noFill/>
-          <a:ln/>
-        </p:spPr>
-        <p:txBody>
-          <a:bodyPr wrap="square" lIns="254" tIns="254" rIns="254" bIns="254" rtlCol="0" anchor="ctr">
-            <a:normAutofit/>
-          </a:bodyPr>
-          <a:lstStyle/>
-          <a:p>
-            <a:pPr algn="l" indent="0" marL="0">
-              <a:buNone/>
-            </a:pPr>
-            <a:r>
-              <a:rPr lang="en-US" sz="1050" b="1" spc="240" kern="0" dirty="0">
-                <a:solidFill>
-                  <a:srgbClr val="06AFA5"/>
-                </a:solidFill>
-                <a:latin typeface="Aptos" pitchFamily="34" charset="0"/>
-                <a:ea typeface="Aptos" pitchFamily="34" charset="-122"/>
-                <a:cs typeface="Aptos" pitchFamily="34" charset="-120"/>
-              </a:rPr>
-              <a:t>06 / QUALITY + COST MEASURED HERE</a:t>
-            </a:r>
-            <a:endParaRPr lang="en-US" sz="1050" dirty="0"/>
-          </a:p>
-        </p:txBody>
-      </p:sp>
-      <p:sp>
-        <p:nvSpPr>
-          <p:cNvPr id="3" name="Text 1"/>
-          <p:cNvSpPr/>
-          <p:nvPr/>
-        </p:nvSpPr>
-        <p:spPr>
-          <a:xfrm>
-            <a:off x="10972800" y="292608"/>
-            <a:ext cx="576072" cy="219456"/>
-          </a:xfrm>
-          <a:prstGeom prst="rect">
-            <a:avLst/>
-          </a:prstGeom>
-          <a:noFill/>
-          <a:ln/>
-        </p:spPr>
-        <p:txBody>
-          <a:bodyPr wrap="square" lIns="254" tIns="254" rIns="254" bIns="254" rtlCol="0" anchor="ctr">
-            <a:normAutofit/>
-          </a:bodyPr>
-          <a:lstStyle/>
-          <a:p>
-            <a:pPr algn="r" indent="0" marL="0">
-              <a:buNone/>
-            </a:pPr>
-            <a:r>
-              <a:rPr lang="en-US" sz="1000" dirty="0">
-                <a:solidFill>
-                  <a:srgbClr val="536579"/>
-                </a:solidFill>
-                <a:latin typeface="Aptos" pitchFamily="34" charset="0"/>
-                <a:ea typeface="Aptos" pitchFamily="34" charset="-122"/>
-                <a:cs typeface="Aptos" pitchFamily="34" charset="-120"/>
-              </a:rPr>
-              <a:t>09 / 12</a:t>
-            </a:r>
-            <a:endParaRPr lang="en-US" sz="1000" dirty="0"/>
-          </a:p>
-        </p:txBody>
-      </p:sp>
-      <p:sp>
-        <p:nvSpPr>
-          <p:cNvPr id="4" name="Text 2"/>
-          <p:cNvSpPr/>
-          <p:nvPr/>
-        </p:nvSpPr>
-        <p:spPr>
-          <a:xfrm>
-            <a:off x="640080" y="777240"/>
-            <a:ext cx="10927080" cy="932688"/>
-          </a:xfrm>
-          <a:prstGeom prst="rect">
-            <a:avLst/>
-          </a:prstGeom>
-          <a:noFill/>
-          <a:ln/>
-        </p:spPr>
-        <p:txBody>
-          <a:bodyPr wrap="square" lIns="254" tIns="254" rIns="254" bIns="254" rtlCol="0" anchor="t">
-            <a:normAutofit/>
-          </a:bodyPr>
-          <a:lstStyle/>
-          <a:p>
-            <a:pPr algn="l" indent="0" marL="0">
-              <a:buNone/>
-            </a:pPr>
-            <a:r>
-              <a:rPr lang="en-US" sz="3150" b="1" dirty="0">
-                <a:solidFill>
-                  <a:srgbClr val="132438"/>
-                </a:solidFill>
-                <a:latin typeface="Aptos" pitchFamily="34" charset="0"/>
-                <a:ea typeface="Aptos" pitchFamily="34" charset="-122"/>
-                <a:cs typeface="Aptos" pitchFamily="34" charset="-120"/>
-              </a:rPr>
-              <a:t>A completed run is not a correct run.</a:t>
-            </a:r>
-            <a:endParaRPr lang="en-US" sz="3150" dirty="0"/>
-          </a:p>
-        </p:txBody>
-      </p:sp>
-      <p:sp>
-        <p:nvSpPr>
-          <p:cNvPr id="5" name="Shape 3"/>
-          <p:cNvSpPr/>
-          <p:nvPr/>
-        </p:nvSpPr>
-        <p:spPr>
-          <a:xfrm>
-            <a:off x="640080" y="6327648"/>
-            <a:ext cx="10927080" cy="0"/>
-          </a:xfrm>
-          <a:prstGeom prst="line">
-            <a:avLst/>
-          </a:prstGeom>
-          <a:noFill/>
-          <a:ln w="11430">
-            <a:solidFill>
-              <a:srgbClr val="DCE5ED"/>
-            </a:solidFill>
-            <a:prstDash val="solid"/>
-          </a:ln>
-        </p:spPr>
-        <p:txBody>
-          <a:bodyPr/>
-          <a:p/>
-        </p:txBody>
-      </p:sp>
-      <p:sp>
-        <p:nvSpPr>
-          <p:cNvPr id="6" name="Text 4"/>
-          <p:cNvSpPr/>
-          <p:nvPr/>
-        </p:nvSpPr>
-        <p:spPr>
-          <a:xfrm>
-            <a:off x="640080" y="6419088"/>
-            <a:ext cx="5486400" cy="155448"/>
-          </a:xfrm>
-          <a:prstGeom prst="rect">
-            <a:avLst/>
-          </a:prstGeom>
-          <a:noFill/>
-          <a:ln/>
-        </p:spPr>
-        <p:txBody>
-          <a:bodyPr wrap="square" lIns="254" tIns="254" rIns="254" bIns="254" rtlCol="0" anchor="ctr">
-            <a:normAutofit/>
-          </a:bodyPr>
-          <a:lstStyle/>
-          <a:p>
-            <a:pPr algn="l" indent="0" marL="0">
-              <a:buNone/>
-            </a:pPr>
-            <a:r>
-              <a:rPr lang="en-US" sz="900" spc="120" kern="0" dirty="0">
-                <a:solidFill>
-                  <a:srgbClr val="536579"/>
-                </a:solidFill>
-                <a:latin typeface="Aptos" pitchFamily="34" charset="0"/>
-                <a:ea typeface="Aptos" pitchFamily="34" charset="-122"/>
-                <a:cs typeface="Aptos" pitchFamily="34" charset="-120"/>
-              </a:rPr>
-              <a:t>KAOP  /  CUSTOMER DISCUSSION</a:t>
-            </a:r>
-            <a:endParaRPr lang="en-US" sz="900" dirty="0"/>
-          </a:p>
-        </p:txBody>
-      </p:sp>
-      <p:sp>
-        <p:nvSpPr>
-          <p:cNvPr id="8" name="Shape 6"/>
-          <p:cNvSpPr/>
-          <p:nvPr/>
-        </p:nvSpPr>
-        <p:spPr>
-          <a:xfrm>
-            <a:off x="694944" y="1874520"/>
-            <a:ext cx="5486400" cy="3419856"/>
-          </a:xfrm>
-          <a:prstGeom prst="roundRect">
-            <a:avLst>
-              <a:gd name="adj" fmla="val 5615"/>
-            </a:avLst>
-          </a:prstGeom>
-          <a:solidFill>
-            <a:srgbClr val="FFFFFF"/>
-          </a:solidFill>
-          <a:ln w="10160">
-            <a:solidFill>
-              <a:srgbClr val="DCE5ED"/>
-            </a:solidFill>
-            <a:prstDash val="solid"/>
-          </a:ln>
-        </p:spPr>
-        <p:txBody>
-          <a:bodyPr/>
-          <a:p/>
-        </p:txBody>
-      </p:sp>
-      <p:sp>
-        <p:nvSpPr>
-          <p:cNvPr id="9" name="Text 7"/>
-          <p:cNvSpPr/>
-          <p:nvPr/>
-        </p:nvSpPr>
-        <p:spPr>
-          <a:xfrm>
-            <a:off x="914400" y="2157984"/>
-            <a:ext cx="5029200" cy="228600"/>
-          </a:xfrm>
-          <a:prstGeom prst="rect">
-            <a:avLst/>
-          </a:prstGeom>
-          <a:noFill/>
-          <a:ln/>
-        </p:spPr>
-        <p:txBody>
-          <a:bodyPr wrap="square" lIns="254" tIns="254" rIns="254" bIns="254" rtlCol="0" anchor="ctr">
-            <a:normAutofit/>
-          </a:bodyPr>
-          <a:lstStyle/>
-          <a:p>
-            <a:pPr algn="l" indent="0" marL="0">
-              <a:buNone/>
-            </a:pPr>
-            <a:r>
-              <a:rPr lang="en-US" sz="1200" b="1" spc="130" kern="0" dirty="0">
-                <a:solidFill>
-                  <a:srgbClr val="536579"/>
-                </a:solidFill>
-                <a:latin typeface="Aptos" pitchFamily="34" charset="0"/>
-                <a:ea typeface="Aptos" pitchFamily="34" charset="-122"/>
-                <a:cs typeface="Aptos" pitchFamily="34" charset="-120"/>
-              </a:rPr>
-              <a:t>ANSWER QUALITY</a:t>
-            </a:r>
-            <a:endParaRPr lang="en-US" sz="1200" dirty="0"/>
-          </a:p>
-        </p:txBody>
-      </p:sp>
-      <p:sp>
-        <p:nvSpPr>
-          <p:cNvPr id="10" name="Text 8"/>
-          <p:cNvSpPr/>
-          <p:nvPr/>
-        </p:nvSpPr>
-        <p:spPr>
-          <a:xfrm>
-            <a:off x="923544" y="2706624"/>
-            <a:ext cx="2103120" cy="585216"/>
-          </a:xfrm>
-          <a:prstGeom prst="rect">
-            <a:avLst/>
-          </a:prstGeom>
-          <a:noFill/>
-          <a:ln/>
-        </p:spPr>
-        <p:txBody>
-          <a:bodyPr wrap="square" lIns="254" tIns="254" rIns="254" bIns="254" rtlCol="0" anchor="ctr">
-            <a:normAutofit/>
-          </a:bodyPr>
-          <a:lstStyle/>
-          <a:p>
-            <a:pPr algn="l" indent="0" marL="0">
-              <a:buNone/>
-            </a:pPr>
-            <a:r>
-              <a:rPr lang="en-US" sz="3400" b="1" dirty="0">
-                <a:solidFill>
-                  <a:srgbClr val="C66765"/>
-                </a:solidFill>
-                <a:latin typeface="Aptos" pitchFamily="34" charset="0"/>
-                <a:ea typeface="Aptos" pitchFamily="34" charset="-122"/>
-                <a:cs typeface="Aptos" pitchFamily="34" charset="-120"/>
-              </a:rPr>
-              <a:t>1 of 5</a:t>
-            </a:r>
-            <a:endParaRPr lang="en-US" sz="3400" dirty="0"/>
-          </a:p>
-        </p:txBody>
-      </p:sp>
-      <p:sp>
-        <p:nvSpPr>
-          <p:cNvPr id="11" name="Text 9"/>
-          <p:cNvSpPr/>
-          <p:nvPr/>
-        </p:nvSpPr>
-        <p:spPr>
-          <a:xfrm>
-            <a:off x="2953512" y="2834640"/>
-            <a:ext cx="448056" cy="365760"/>
-          </a:xfrm>
-          <a:prstGeom prst="rect">
-            <a:avLst/>
-          </a:prstGeom>
-          <a:noFill/>
-          <a:ln/>
-        </p:spPr>
-        <p:txBody>
-          <a:bodyPr wrap="square" lIns="254" tIns="254" rIns="254" bIns="254" rtlCol="0" anchor="ctr">
-            <a:normAutofit/>
-          </a:bodyPr>
-          <a:lstStyle/>
-          <a:p>
-            <a:pPr algn="ctr" indent="0" marL="0">
-              <a:buNone/>
-            </a:pPr>
-            <a:r>
-              <a:rPr lang="en-US" sz="2700" b="1" dirty="0">
-                <a:solidFill>
-                  <a:srgbClr val="06AFA5"/>
-                </a:solidFill>
-                <a:latin typeface="Aptos" pitchFamily="34" charset="0"/>
-                <a:ea typeface="Aptos" pitchFamily="34" charset="-122"/>
-                <a:cs typeface="Aptos" pitchFamily="34" charset="-120"/>
-              </a:rPr>
-              <a:t>→</a:t>
-            </a:r>
-            <a:endParaRPr lang="en-US" sz="2700" dirty="0"/>
-          </a:p>
-        </p:txBody>
-      </p:sp>
-      <p:sp>
-        <p:nvSpPr>
-          <p:cNvPr id="12" name="Text 10"/>
-          <p:cNvSpPr/>
-          <p:nvPr/>
-        </p:nvSpPr>
-        <p:spPr>
-          <a:xfrm>
-            <a:off x="3483864" y="2706624"/>
-            <a:ext cx="2377440" cy="585216"/>
-          </a:xfrm>
-          <a:prstGeom prst="rect">
-            <a:avLst/>
-          </a:prstGeom>
-          <a:noFill/>
-          <a:ln/>
-        </p:spPr>
-        <p:txBody>
-          <a:bodyPr wrap="square" lIns="254" tIns="254" rIns="254" bIns="254" rtlCol="0" anchor="ctr">
-            <a:normAutofit/>
-          </a:bodyPr>
-          <a:lstStyle/>
-          <a:p>
-            <a:pPr algn="l" indent="0" marL="0">
-              <a:buNone/>
-            </a:pPr>
-            <a:r>
-              <a:rPr lang="en-US" sz="3400" b="1" dirty="0">
-                <a:solidFill>
-                  <a:srgbClr val="06AFA5"/>
-                </a:solidFill>
-                <a:latin typeface="Aptos" pitchFamily="34" charset="0"/>
-                <a:ea typeface="Aptos" pitchFamily="34" charset="-122"/>
-                <a:cs typeface="Aptos" pitchFamily="34" charset="-120"/>
-              </a:rPr>
-              <a:t>10 of 10</a:t>
-            </a:r>
-            <a:endParaRPr lang="en-US" sz="3400" dirty="0"/>
-          </a:p>
-        </p:txBody>
-      </p:sp>
-      <p:sp>
-        <p:nvSpPr>
-          <p:cNvPr id="13" name="Text 11"/>
-          <p:cNvSpPr/>
-          <p:nvPr/>
-        </p:nvSpPr>
-        <p:spPr>
-          <a:xfrm>
-            <a:off x="914400" y="3456432"/>
-            <a:ext cx="5029200" cy="292608"/>
-          </a:xfrm>
-          <a:prstGeom prst="rect">
-            <a:avLst/>
-          </a:prstGeom>
-          <a:noFill/>
-          <a:ln/>
-        </p:spPr>
-        <p:txBody>
-          <a:bodyPr wrap="square" lIns="254" tIns="254" rIns="254" bIns="254" rtlCol="0" anchor="ctr">
-            <a:normAutofit/>
-          </a:bodyPr>
-          <a:lstStyle/>
-          <a:p>
-            <a:pPr algn="l" indent="0" marL="0">
-              <a:buNone/>
-            </a:pPr>
-            <a:r>
-              <a:rPr lang="en-US" sz="1710" b="1" dirty="0">
-                <a:solidFill>
-                  <a:srgbClr val="132438"/>
-                </a:solidFill>
-                <a:latin typeface="Aptos" pitchFamily="34" charset="0"/>
-                <a:ea typeface="Aptos" pitchFamily="34" charset="-122"/>
-                <a:cs typeface="Aptos" pitchFamily="34" charset="-120"/>
-              </a:rPr>
-              <a:t>Agent found the actual cause</a:t>
-            </a:r>
-            <a:endParaRPr lang="en-US" sz="1710" dirty="0"/>
-          </a:p>
-        </p:txBody>
-      </p:sp>
-      <p:sp>
-        <p:nvSpPr>
-          <p:cNvPr id="14" name="Text 12"/>
-          <p:cNvSpPr/>
-          <p:nvPr/>
-        </p:nvSpPr>
-        <p:spPr>
-          <a:xfrm>
-            <a:off x="914400" y="3959352"/>
-            <a:ext cx="4937760" cy="868680"/>
-          </a:xfrm>
-          <a:prstGeom prst="rect">
-            <a:avLst/>
-          </a:prstGeom>
-          <a:noFill/>
-          <a:ln/>
-        </p:spPr>
-        <p:txBody>
-          <a:bodyPr wrap="square" lIns="254" tIns="254" rIns="254" bIns="254" rtlCol="0" anchor="t">
-            <a:normAutofit/>
-          </a:bodyPr>
-          <a:lstStyle/>
-          <a:p>
-            <a:pPr algn="l" indent="0" marL="0">
-              <a:buNone/>
-            </a:pPr>
-            <a:r>
-              <a:rPr lang="en-US" sz="1460" dirty="0">
-                <a:solidFill>
-                  <a:srgbClr val="536579"/>
-                </a:solidFill>
-                <a:latin typeface="Aptos" pitchFamily="34" charset="0"/>
-                <a:ea typeface="Aptos" pitchFamily="34" charset="-122"/>
-                <a:cs typeface="Aptos" pitchFamily="34" charset="-120"/>
-              </a:rPr>
-              <a:t>Without / with one documented probe standard.</a:t>
-            </a:r>
-            <a:endParaRPr lang="en-US" sz="1460" dirty="0"/>
-          </a:p>
-          <a:p>
-            <a:pPr algn="l" indent="0" marL="0">
-              <a:buNone/>
-            </a:pPr>
-            <a:r>
-              <a:rPr lang="en-US" sz="1460" dirty="0">
-                <a:solidFill>
-                  <a:srgbClr val="536579"/>
-                </a:solidFill>
-                <a:latin typeface="Aptos" pitchFamily="34" charset="0"/>
-                <a:ea typeface="Aptos" pitchFamily="34" charset="-122"/>
-                <a:cs typeface="Aptos" pitchFamily="34" charset="-120"/>
-              </a:rPr>
-              <a:t>Same investigation input; small lab samples.</a:t>
-            </a:r>
-            <a:endParaRPr lang="en-US" sz="1460" dirty="0"/>
-          </a:p>
-        </p:txBody>
-      </p:sp>
-      <p:sp>
-        <p:nvSpPr>
-          <p:cNvPr id="15" name="Shape 13"/>
-          <p:cNvSpPr/>
-          <p:nvPr/>
-        </p:nvSpPr>
-        <p:spPr>
-          <a:xfrm>
-            <a:off x="6391656" y="1874520"/>
-            <a:ext cx="5093208" cy="3419856"/>
-          </a:xfrm>
-          <a:prstGeom prst="roundRect">
-            <a:avLst>
-              <a:gd name="adj" fmla="val 5615"/>
-            </a:avLst>
-          </a:prstGeom>
-          <a:solidFill>
-            <a:srgbClr val="FFFFFF"/>
-          </a:solidFill>
-          <a:ln w="10160">
-            <a:solidFill>
-              <a:srgbClr val="DCE5ED"/>
-            </a:solidFill>
-            <a:prstDash val="solid"/>
-          </a:ln>
-        </p:spPr>
-        <p:txBody>
-          <a:bodyPr/>
-          <a:p/>
-        </p:txBody>
-      </p:sp>
-      <p:sp>
-        <p:nvSpPr>
-          <p:cNvPr id="16" name="Text 14"/>
-          <p:cNvSpPr/>
-          <p:nvPr/>
-        </p:nvSpPr>
-        <p:spPr>
-          <a:xfrm>
-            <a:off x="6601968" y="2157984"/>
-            <a:ext cx="4663440" cy="228600"/>
-          </a:xfrm>
-          <a:prstGeom prst="rect">
-            <a:avLst/>
-          </a:prstGeom>
-          <a:noFill/>
-          <a:ln/>
-        </p:spPr>
-        <p:txBody>
-          <a:bodyPr wrap="square" lIns="254" tIns="254" rIns="254" bIns="254" rtlCol="0" anchor="ctr">
-            <a:normAutofit/>
-          </a:bodyPr>
-          <a:lstStyle/>
-          <a:p>
-            <a:pPr algn="l" indent="0" marL="0">
-              <a:buNone/>
-            </a:pPr>
-            <a:r>
-              <a:rPr lang="en-US" sz="1200" b="1" spc="100" kern="0" dirty="0">
-                <a:solidFill>
-                  <a:srgbClr val="536579"/>
-                </a:solidFill>
-                <a:latin typeface="Aptos" pitchFamily="34" charset="0"/>
-                <a:ea typeface="Aptos" pitchFamily="34" charset="-122"/>
-                <a:cs typeface="Aptos" pitchFamily="34" charset="-120"/>
-              </a:rPr>
-              <a:t>COST OF THE GRAFANA INVESTIGATOR</a:t>
-            </a:r>
-            <a:endParaRPr lang="en-US" sz="1200" dirty="0"/>
-          </a:p>
-        </p:txBody>
-      </p:sp>
-      <p:sp>
-        <p:nvSpPr>
-          <p:cNvPr id="17" name="Text 15"/>
-          <p:cNvSpPr/>
-          <p:nvPr/>
-        </p:nvSpPr>
-        <p:spPr>
-          <a:xfrm>
-            <a:off x="6620256" y="2706624"/>
-            <a:ext cx="1792224" cy="585216"/>
-          </a:xfrm>
-          <a:prstGeom prst="rect">
-            <a:avLst/>
-          </a:prstGeom>
-          <a:noFill/>
-          <a:ln/>
-        </p:spPr>
-        <p:txBody>
-          <a:bodyPr wrap="square" lIns="254" tIns="254" rIns="254" bIns="254" rtlCol="0" anchor="ctr">
-            <a:normAutofit/>
-          </a:bodyPr>
-          <a:lstStyle/>
-          <a:p>
-            <a:pPr algn="l" indent="0" marL="0">
-              <a:buNone/>
-            </a:pPr>
-            <a:r>
-              <a:rPr lang="en-US" sz="3400" b="1" dirty="0">
-                <a:solidFill>
-                  <a:srgbClr val="132438"/>
-                </a:solidFill>
-                <a:latin typeface="Aptos" pitchFamily="34" charset="0"/>
-                <a:ea typeface="Aptos" pitchFamily="34" charset="-122"/>
-                <a:cs typeface="Aptos" pitchFamily="34" charset="-120"/>
-              </a:rPr>
-              <a:t>$0.68</a:t>
-            </a:r>
-            <a:endParaRPr lang="en-US" sz="3400" dirty="0"/>
-          </a:p>
-        </p:txBody>
-      </p:sp>
-      <p:sp>
-        <p:nvSpPr>
-          <p:cNvPr id="18" name="Text 16"/>
-          <p:cNvSpPr/>
-          <p:nvPr/>
-        </p:nvSpPr>
-        <p:spPr>
-          <a:xfrm>
-            <a:off x="8430768" y="2834640"/>
-            <a:ext cx="448056" cy="365760"/>
-          </a:xfrm>
-          <a:prstGeom prst="rect">
-            <a:avLst/>
-          </a:prstGeom>
-          <a:noFill/>
-          <a:ln/>
-        </p:spPr>
-        <p:txBody>
-          <a:bodyPr wrap="square" lIns="254" tIns="254" rIns="254" bIns="254" rtlCol="0" anchor="ctr">
-            <a:normAutofit/>
-          </a:bodyPr>
-          <a:lstStyle/>
-          <a:p>
-            <a:pPr algn="ctr" indent="0" marL="0">
-              <a:buNone/>
-            </a:pPr>
-            <a:r>
-              <a:rPr lang="en-US" sz="2700" b="1" dirty="0">
-                <a:solidFill>
-                  <a:srgbClr val="06AFA5"/>
-                </a:solidFill>
-                <a:latin typeface="Aptos" pitchFamily="34" charset="0"/>
-                <a:ea typeface="Aptos" pitchFamily="34" charset="-122"/>
-                <a:cs typeface="Aptos" pitchFamily="34" charset="-120"/>
-              </a:rPr>
-              <a:t>→</a:t>
-            </a:r>
-            <a:endParaRPr lang="en-US" sz="2700" dirty="0"/>
-          </a:p>
-        </p:txBody>
-      </p:sp>
-      <p:sp>
-        <p:nvSpPr>
-          <p:cNvPr id="19" name="Text 17"/>
-          <p:cNvSpPr/>
-          <p:nvPr/>
-        </p:nvSpPr>
-        <p:spPr>
-          <a:xfrm>
-            <a:off x="8924544" y="2706624"/>
-            <a:ext cx="2103120" cy="585216"/>
-          </a:xfrm>
-          <a:prstGeom prst="rect">
-            <a:avLst/>
-          </a:prstGeom>
-          <a:noFill/>
-          <a:ln/>
-        </p:spPr>
-        <p:txBody>
-          <a:bodyPr wrap="square" lIns="254" tIns="254" rIns="254" bIns="254" rtlCol="0" anchor="ctr">
-            <a:normAutofit/>
-          </a:bodyPr>
-          <a:lstStyle/>
-          <a:p>
-            <a:pPr algn="l" indent="0" marL="0">
-              <a:buNone/>
-            </a:pPr>
-            <a:r>
-              <a:rPr lang="en-US" sz="3400" b="1" dirty="0">
-                <a:solidFill>
-                  <a:srgbClr val="06AFA5"/>
-                </a:solidFill>
-                <a:latin typeface="Aptos" pitchFamily="34" charset="0"/>
-                <a:ea typeface="Aptos" pitchFamily="34" charset="-122"/>
-                <a:cs typeface="Aptos" pitchFamily="34" charset="-120"/>
-              </a:rPr>
-              <a:t>$0.53</a:t>
-            </a:r>
-            <a:endParaRPr lang="en-US" sz="3400" dirty="0"/>
-          </a:p>
-        </p:txBody>
-      </p:sp>
-      <p:sp>
-        <p:nvSpPr>
-          <p:cNvPr id="20" name="Text 18"/>
-          <p:cNvSpPr/>
-          <p:nvPr/>
-        </p:nvSpPr>
-        <p:spPr>
-          <a:xfrm>
-            <a:off x="6611112" y="3456432"/>
-            <a:ext cx="4663440" cy="292608"/>
-          </a:xfrm>
-          <a:prstGeom prst="rect">
-            <a:avLst/>
-          </a:prstGeom>
-          <a:noFill/>
-          <a:ln/>
-        </p:spPr>
-        <p:txBody>
-          <a:bodyPr wrap="square" lIns="254" tIns="254" rIns="254" bIns="254" rtlCol="0" anchor="ctr">
-            <a:normAutofit/>
-          </a:bodyPr>
-          <a:lstStyle/>
-          <a:p>
-            <a:pPr algn="l" indent="0" marL="0">
-              <a:buNone/>
-            </a:pPr>
-            <a:r>
-              <a:rPr lang="en-US" sz="1710" b="1" dirty="0">
-                <a:solidFill>
-                  <a:srgbClr val="132438"/>
-                </a:solidFill>
-                <a:latin typeface="Aptos" pitchFamily="34" charset="0"/>
-                <a:ea typeface="Aptos" pitchFamily="34" charset="-122"/>
-                <a:cs typeface="Aptos" pitchFamily="34" charset="-120"/>
-              </a:rPr>
-              <a:t>Reported average per run</a:t>
-            </a:r>
-            <a:endParaRPr lang="en-US" sz="1710" dirty="0"/>
-          </a:p>
-        </p:txBody>
-      </p:sp>
-      <p:sp>
-        <p:nvSpPr>
-          <p:cNvPr id="21" name="Text 19"/>
-          <p:cNvSpPr/>
-          <p:nvPr/>
-        </p:nvSpPr>
-        <p:spPr>
-          <a:xfrm>
-            <a:off x="6611112" y="3959352"/>
-            <a:ext cx="4572000" cy="868680"/>
-          </a:xfrm>
-          <a:prstGeom prst="rect">
-            <a:avLst/>
-          </a:prstGeom>
-          <a:noFill/>
-          <a:ln/>
-        </p:spPr>
-        <p:txBody>
-          <a:bodyPr wrap="square" lIns="254" tIns="254" rIns="254" bIns="254" rtlCol="0" anchor="t">
-            <a:normAutofit/>
-          </a:bodyPr>
-          <a:lstStyle/>
-          <a:p>
-            <a:pPr algn="l" indent="0" marL="0">
-              <a:buNone/>
-            </a:pPr>
-            <a:r>
-              <a:rPr lang="en-US" sz="1460" dirty="0">
-                <a:solidFill>
-                  <a:srgbClr val="536579"/>
-                </a:solidFill>
-                <a:latin typeface="Aptos" pitchFamily="34" charset="0"/>
-                <a:ea typeface="Aptos" pitchFamily="34" charset="-122"/>
-                <a:cs typeface="Aptos" pitchFamily="34" charset="-120"/>
-              </a:rPr>
-              <a:t>28 read tools versus a broader toolset.</a:t>
-            </a:r>
-            <a:endParaRPr lang="en-US" sz="1460" dirty="0"/>
-          </a:p>
-          <a:p>
-            <a:pPr algn="l" indent="0" marL="0">
-              <a:buNone/>
-            </a:pPr>
-            <a:r>
-              <a:rPr lang="en-US" sz="1460" dirty="0">
-                <a:solidFill>
-                  <a:srgbClr val="536579"/>
-                </a:solidFill>
-                <a:latin typeface="Aptos" pitchFamily="34" charset="0"/>
-                <a:ea typeface="Aptos" pitchFamily="34" charset="-122"/>
-                <a:cs typeface="Aptos" pitchFamily="34" charset="-120"/>
-              </a:rPr>
-              <a:t>Five runs per setup; identical cases vary.</a:t>
-            </a:r>
-            <a:endParaRPr lang="en-US" sz="1460" dirty="0"/>
-          </a:p>
-        </p:txBody>
-      </p:sp>
-      <p:sp>
-        <p:nvSpPr>
-          <p:cNvPr id="22" name="Shape 20"/>
-          <p:cNvSpPr/>
-          <p:nvPr/>
-        </p:nvSpPr>
-        <p:spPr>
-          <a:xfrm>
-            <a:off x="694944" y="5495544"/>
-            <a:ext cx="10789920" cy="438912"/>
-          </a:xfrm>
-          <a:prstGeom prst="roundRect">
-            <a:avLst>
-              <a:gd name="adj" fmla="val 22917"/>
-            </a:avLst>
-          </a:prstGeom>
-          <a:solidFill>
-            <a:srgbClr val="EAF0F5"/>
-          </a:solidFill>
-          <a:ln w="12700">
-            <a:solidFill>
-              <a:srgbClr val="EAF0F5">
-                <a:alpha val="0"/>
-              </a:srgbClr>
-            </a:solidFill>
-            <a:prstDash val="solid"/>
-          </a:ln>
-        </p:spPr>
-        <p:txBody>
-          <a:bodyPr/>
-          <a:p/>
-        </p:txBody>
-      </p:sp>
-      <p:sp>
-        <p:nvSpPr>
-          <p:cNvPr id="23" name="Text 21"/>
-          <p:cNvSpPr/>
-          <p:nvPr/>
-        </p:nvSpPr>
-        <p:spPr>
-          <a:xfrm>
-            <a:off x="914400" y="5614416"/>
-            <a:ext cx="10378440" cy="164592"/>
-          </a:xfrm>
-          <a:prstGeom prst="rect">
-            <a:avLst/>
-          </a:prstGeom>
-          <a:noFill/>
-          <a:ln/>
-        </p:spPr>
-        <p:txBody>
-          <a:bodyPr wrap="square" lIns="254" tIns="254" rIns="254" bIns="254" rtlCol="0" anchor="ctr">
-            <a:normAutofit/>
-          </a:bodyPr>
-          <a:lstStyle/>
-          <a:p>
-            <a:pPr algn="ctr" indent="0" marL="0">
-              <a:buNone/>
-            </a:pPr>
-            <a:r>
-              <a:rPr lang="en-US" sz="1190" dirty="0">
-                <a:solidFill>
-                  <a:srgbClr val="536579"/>
-                </a:solidFill>
-                <a:latin typeface="Aptos" pitchFamily="34" charset="0"/>
-                <a:ea typeface="Aptos" pitchFamily="34" charset="-122"/>
-                <a:cs typeface="Aptos" pitchFamily="34" charset="-120"/>
-              </a:rPr>
-              <a:t>NOT A BENCHMARK: Hosted agent changed version during tests; evaluation must be repeated in the customer environment.</a:t>
-            </a:r>
-            <a:endParaRPr lang="en-US" sz="1190" dirty="0"/>
           </a:p>
         </p:txBody>
       </p:sp>

</xml_diff>

<commit_message>
Deck: presenter goals as bullet points on the agenda slide
Co-Authored-By: Claude Opus 5.5 <noreply@anthropic.com>
Claude-Session: https://claude.ai/code/session_01DptoPaaj14X3TGztKApoPN
</commit_message>
<xml_diff>
--- a/docs/presentation/KAOP_Customer_Pitch.pptx
+++ b/docs/presentation/KAOP_Customer_Pitch.pptx
@@ -7635,13 +7635,61 @@
               </a:spcBef>
             </a:pPr>
             <a:r>
+              <a:rPr sz="1400" b="1">
+                <a:solidFill>
+                  <a:srgbClr val="E6ECF4"/>
+                </a:solidFill>
+                <a:latin typeface="Aptos"/>
+              </a:rPr>
+              <a:t>I help teams adopt KAOP:</a:t>
+            </a:r>
+          </a:p>
+          <a:p>
+            <a:pPr>
+              <a:spcBef>
+                <a:spcPts val="600"/>
+              </a:spcBef>
+            </a:pPr>
+            <a:r>
               <a:rPr sz="1400" b="0">
                 <a:solidFill>
                   <a:srgbClr val="E6ECF4"/>
                 </a:solidFill>
                 <a:latin typeface="Aptos"/>
               </a:rPr>
-              <a:t>I help teams adopt KAOP: get the first workflow running, measure the results with you, and bring your feedback to our product team.</a:t>
+              <a:t>•  Get the first workflow running</a:t>
+            </a:r>
+          </a:p>
+          <a:p>
+            <a:pPr>
+              <a:spcBef>
+                <a:spcPts val="600"/>
+              </a:spcBef>
+            </a:pPr>
+            <a:r>
+              <a:rPr sz="1400" b="0">
+                <a:solidFill>
+                  <a:srgbClr val="E6ECF4"/>
+                </a:solidFill>
+                <a:latin typeface="Aptos"/>
+              </a:rPr>
+              <a:t>•  Measure the results with you</a:t>
+            </a:r>
+          </a:p>
+          <a:p>
+            <a:pPr>
+              <a:spcBef>
+                <a:spcPts val="600"/>
+              </a:spcBef>
+            </a:pPr>
+            <a:r>
+              <a:rPr sz="1400" b="0">
+                <a:solidFill>
+                  <a:srgbClr val="E6ECF4"/>
+                </a:solidFill>
+                <a:latin typeface="Aptos"/>
+              </a:rPr>
+              <a:t>•  Bring your feedback to Product</a:t>
             </a:r>
           </a:p>
         </p:txBody>

</xml_diff>

<commit_message>
Deck: tag each workflow step on slide 5 with where it runs
Co-Authored-By: Claude Opus 5.5 <noreply@anthropic.com>
Claude-Session: https://claude.ai/code/session_01DptoPaaj14X3TGztKApoPN
</commit_message>
<xml_diff>
--- a/docs/presentation/KAOP_Customer_Pitch.pptx
+++ b/docs/presentation/KAOP_Customer_Pitch.pptx
@@ -10720,7 +10720,7 @@
         <p:spPr>
           <a:xfrm>
             <a:off x="658368" y="1856232"/>
-            <a:ext cx="10863072" cy="1536192"/>
+            <a:ext cx="10863072" cy="1676400"/>
           </a:xfrm>
           <a:prstGeom prst="roundRect">
             <a:avLst>
@@ -11458,8 +11458,8 @@
         </p:nvSpPr>
         <p:spPr>
           <a:xfrm>
-            <a:off x="658368" y="3675888"/>
-            <a:ext cx="10863072" cy="1508760"/>
+            <a:off x="658368" y="3853688"/>
+            <a:ext cx="10863072" cy="1676400"/>
           </a:xfrm>
           <a:prstGeom prst="roundRect">
             <a:avLst>
@@ -11489,7 +11489,7 @@
         </p:nvSpPr>
         <p:spPr>
           <a:xfrm>
-            <a:off x="877824" y="3849624"/>
+            <a:off x="877824" y="4027424"/>
             <a:ext cx="2980944" cy="292608"/>
           </a:xfrm>
           <a:prstGeom prst="roundRect">
@@ -11522,7 +11522,7 @@
         </p:nvSpPr>
         <p:spPr>
           <a:xfrm>
-            <a:off x="969264" y="3904488"/>
+            <a:off x="969264" y="4082288"/>
             <a:ext cx="2798064" cy="173736"/>
           </a:xfrm>
           <a:prstGeom prst="rect">
@@ -11563,7 +11563,7 @@
         </p:nvSpPr>
         <p:spPr>
           <a:xfrm>
-            <a:off x="950976" y="4315968"/>
+            <a:off x="950976" y="4493768"/>
             <a:ext cx="2194560" cy="630936"/>
           </a:xfrm>
           <a:prstGeom prst="roundRect">
@@ -11596,7 +11596,7 @@
         </p:nvSpPr>
         <p:spPr>
           <a:xfrm>
-            <a:off x="1042416" y="4434840"/>
+            <a:off x="1042416" y="4612640"/>
             <a:ext cx="2011680" cy="210312"/>
           </a:xfrm>
           <a:prstGeom prst="rect">
@@ -11637,7 +11637,7 @@
         </p:nvSpPr>
         <p:spPr>
           <a:xfrm>
-            <a:off x="1042416" y="4690872"/>
+            <a:off x="1042416" y="4868672"/>
             <a:ext cx="2020824" cy="146304"/>
           </a:xfrm>
           <a:prstGeom prst="rect">
@@ -11678,7 +11678,7 @@
         </p:nvSpPr>
         <p:spPr>
           <a:xfrm>
-            <a:off x="3172968" y="4617720"/>
+            <a:off x="3172968" y="4795520"/>
             <a:ext cx="256032" cy="0"/>
           </a:xfrm>
           <a:prstGeom prst="line">
@@ -11705,7 +11705,7 @@
         </p:nvSpPr>
         <p:spPr>
           <a:xfrm>
-            <a:off x="3319272" y="4530852"/>
+            <a:off x="3319272" y="4708652"/>
             <a:ext cx="146304" cy="173736"/>
           </a:xfrm>
           <a:prstGeom prst="chevron">
@@ -11736,7 +11736,7 @@
         </p:nvSpPr>
         <p:spPr>
           <a:xfrm>
-            <a:off x="3547872" y="4315968"/>
+            <a:off x="3547872" y="4493768"/>
             <a:ext cx="2194560" cy="630936"/>
           </a:xfrm>
           <a:prstGeom prst="roundRect">
@@ -11769,7 +11769,7 @@
         </p:nvSpPr>
         <p:spPr>
           <a:xfrm>
-            <a:off x="3639312" y="4434840"/>
+            <a:off x="3639312" y="4612640"/>
             <a:ext cx="2011680" cy="210312"/>
           </a:xfrm>
           <a:prstGeom prst="rect">
@@ -11810,7 +11810,7 @@
         </p:nvSpPr>
         <p:spPr>
           <a:xfrm>
-            <a:off x="3639312" y="4690872"/>
+            <a:off x="3639312" y="4868672"/>
             <a:ext cx="2020824" cy="146304"/>
           </a:xfrm>
           <a:prstGeom prst="rect">
@@ -11851,7 +11851,7 @@
         </p:nvSpPr>
         <p:spPr>
           <a:xfrm>
-            <a:off x="5769864" y="4617720"/>
+            <a:off x="5769864" y="4795520"/>
             <a:ext cx="256032" cy="0"/>
           </a:xfrm>
           <a:prstGeom prst="line">
@@ -11878,7 +11878,7 @@
         </p:nvSpPr>
         <p:spPr>
           <a:xfrm>
-            <a:off x="5916168" y="4530852"/>
+            <a:off x="5916168" y="4708652"/>
             <a:ext cx="146304" cy="173736"/>
           </a:xfrm>
           <a:prstGeom prst="chevron">
@@ -11909,7 +11909,7 @@
         </p:nvSpPr>
         <p:spPr>
           <a:xfrm>
-            <a:off x="6144768" y="4315968"/>
+            <a:off x="6144768" y="4493768"/>
             <a:ext cx="2194560" cy="630936"/>
           </a:xfrm>
           <a:prstGeom prst="roundRect">
@@ -11942,7 +11942,7 @@
         </p:nvSpPr>
         <p:spPr>
           <a:xfrm>
-            <a:off x="6236208" y="4434840"/>
+            <a:off x="6236208" y="4612640"/>
             <a:ext cx="2011680" cy="210312"/>
           </a:xfrm>
           <a:prstGeom prst="rect">
@@ -11983,7 +11983,7 @@
         </p:nvSpPr>
         <p:spPr>
           <a:xfrm>
-            <a:off x="6236208" y="4690872"/>
+            <a:off x="6236208" y="4868672"/>
             <a:ext cx="2020824" cy="146304"/>
           </a:xfrm>
           <a:prstGeom prst="rect">
@@ -12024,7 +12024,7 @@
         </p:nvSpPr>
         <p:spPr>
           <a:xfrm>
-            <a:off x="8366760" y="4617720"/>
+            <a:off x="8366760" y="4795520"/>
             <a:ext cx="256032" cy="0"/>
           </a:xfrm>
           <a:prstGeom prst="line">
@@ -12051,7 +12051,7 @@
         </p:nvSpPr>
         <p:spPr>
           <a:xfrm>
-            <a:off x="8513064" y="4530852"/>
+            <a:off x="8513064" y="4708652"/>
             <a:ext cx="146304" cy="173736"/>
           </a:xfrm>
           <a:prstGeom prst="chevron">
@@ -12082,7 +12082,7 @@
         </p:nvSpPr>
         <p:spPr>
           <a:xfrm>
-            <a:off x="8741664" y="4315968"/>
+            <a:off x="8741664" y="4493768"/>
             <a:ext cx="2194560" cy="630936"/>
           </a:xfrm>
           <a:prstGeom prst="roundRect">
@@ -12115,7 +12115,7 @@
         </p:nvSpPr>
         <p:spPr>
           <a:xfrm>
-            <a:off x="8833104" y="4434840"/>
+            <a:off x="8833104" y="4612640"/>
             <a:ext cx="2011680" cy="210312"/>
           </a:xfrm>
           <a:prstGeom prst="rect">
@@ -12156,7 +12156,7 @@
         </p:nvSpPr>
         <p:spPr>
           <a:xfrm>
-            <a:off x="8833104" y="4690872"/>
+            <a:off x="8833104" y="4868672"/>
             <a:ext cx="2020824" cy="146304"/>
           </a:xfrm>
           <a:prstGeom prst="rect">
@@ -12197,7 +12197,7 @@
         </p:nvSpPr>
         <p:spPr>
           <a:xfrm>
-            <a:off x="722376" y="5614416"/>
+            <a:off x="722376" y="5867400"/>
             <a:ext cx="10607040" cy="320040"/>
           </a:xfrm>
           <a:prstGeom prst="rect">
@@ -12227,6 +12227,1085 @@
               <a:t>The PR review does not auto-start from the incident. The two workflows have separate triggers and privileges.</a:t>
             </a:r>
             <a:endParaRPr lang="en-US" sz="1420" dirty="0"/>
+          </a:p>
+        </p:txBody>
+      </p:sp>
+      <p:sp>
+        <p:nvSpPr>
+          <p:cNvPr id="51" name="Rounded Rectangle 50"/>
+          <p:cNvSpPr/>
+          <p:nvPr/>
+        </p:nvSpPr>
+        <p:spPr>
+          <a:xfrm>
+            <a:off x="952500" y="3200400"/>
+            <a:ext cx="1137920" cy="203200"/>
+          </a:xfrm>
+          <a:prstGeom prst="roundRect">
+            <a:avLst>
+              <a:gd name="adj" fmla="val 50000"/>
+            </a:avLst>
+          </a:prstGeom>
+          <a:solidFill>
+            <a:srgbClr val="FDF1DE"/>
+          </a:solidFill>
+          <a:ln>
+            <a:solidFill>
+              <a:srgbClr val="FDF1DE"/>
+            </a:solidFill>
+          </a:ln>
+          <a:effectLst/>
+        </p:spPr>
+        <p:style>
+          <a:lnRef idx="1">
+            <a:schemeClr val="accent1"/>
+          </a:lnRef>
+          <a:fillRef idx="3">
+            <a:schemeClr val="accent1"/>
+          </a:fillRef>
+          <a:effectRef idx="2">
+            <a:schemeClr val="accent1"/>
+          </a:effectRef>
+          <a:fontRef idx="minor">
+            <a:schemeClr val="lt1"/>
+          </a:fontRef>
+        </p:style>
+        <p:txBody>
+          <a:bodyPr rtlCol="0" anchor="ctr"/>
+          <a:lstStyle/>
+          <a:p>
+            <a:pPr algn="ctr"/>
+          </a:p>
+        </p:txBody>
+      </p:sp>
+      <p:sp>
+        <p:nvSpPr>
+          <p:cNvPr id="52" name="TextBox 51"/>
+          <p:cNvSpPr txBox="1"/>
+          <p:nvPr/>
+        </p:nvSpPr>
+        <p:spPr>
+          <a:xfrm>
+            <a:off x="952500" y="3232150"/>
+            <a:ext cx="1137920" cy="152400"/>
+          </a:xfrm>
+          <a:prstGeom prst="rect">
+            <a:avLst/>
+          </a:prstGeom>
+          <a:noFill/>
+        </p:spPr>
+        <p:txBody>
+          <a:bodyPr wrap="square" lIns="0" rIns="0" tIns="0" bIns="0">
+            <a:spAutoFit/>
+          </a:bodyPr>
+          <a:lstStyle/>
+          <a:p>
+            <a:pPr algn="ctr"/>
+            <a:r>
+              <a:rPr sz="850" b="1">
+                <a:solidFill>
+                  <a:srgbClr val="B7791F"/>
+                </a:solidFill>
+                <a:latin typeface="Aptos"/>
+              </a:rPr>
+              <a:t>Grafana Cloud</a:t>
+            </a:r>
+          </a:p>
+        </p:txBody>
+      </p:sp>
+      <p:sp>
+        <p:nvSpPr>
+          <p:cNvPr id="53" name="Rounded Rectangle 52"/>
+          <p:cNvSpPr/>
+          <p:nvPr/>
+        </p:nvSpPr>
+        <p:spPr>
+          <a:xfrm>
+            <a:off x="3543300" y="3200400"/>
+            <a:ext cx="429259" cy="203200"/>
+          </a:xfrm>
+          <a:prstGeom prst="roundRect">
+            <a:avLst>
+              <a:gd name="adj" fmla="val 50000"/>
+            </a:avLst>
+          </a:prstGeom>
+          <a:solidFill>
+            <a:srgbClr val="E3F6F4"/>
+          </a:solidFill>
+          <a:ln>
+            <a:solidFill>
+              <a:srgbClr val="E3F6F4"/>
+            </a:solidFill>
+          </a:ln>
+          <a:effectLst/>
+        </p:spPr>
+        <p:style>
+          <a:lnRef idx="1">
+            <a:schemeClr val="accent1"/>
+          </a:lnRef>
+          <a:fillRef idx="3">
+            <a:schemeClr val="accent1"/>
+          </a:fillRef>
+          <a:effectRef idx="2">
+            <a:schemeClr val="accent1"/>
+          </a:effectRef>
+          <a:fontRef idx="minor">
+            <a:schemeClr val="lt1"/>
+          </a:fontRef>
+        </p:style>
+        <p:txBody>
+          <a:bodyPr rtlCol="0" anchor="ctr"/>
+          <a:lstStyle/>
+          <a:p>
+            <a:pPr algn="ctr"/>
+          </a:p>
+        </p:txBody>
+      </p:sp>
+      <p:sp>
+        <p:nvSpPr>
+          <p:cNvPr id="54" name="TextBox 53"/>
+          <p:cNvSpPr txBox="1"/>
+          <p:nvPr/>
+        </p:nvSpPr>
+        <p:spPr>
+          <a:xfrm>
+            <a:off x="3543300" y="3232150"/>
+            <a:ext cx="429259" cy="152400"/>
+          </a:xfrm>
+          <a:prstGeom prst="rect">
+            <a:avLst/>
+          </a:prstGeom>
+          <a:noFill/>
+        </p:spPr>
+        <p:txBody>
+          <a:bodyPr wrap="square" lIns="0" rIns="0" tIns="0" bIns="0">
+            <a:spAutoFit/>
+          </a:bodyPr>
+          <a:lstStyle/>
+          <a:p>
+            <a:pPr algn="ctr"/>
+            <a:r>
+              <a:rPr sz="850" b="1">
+                <a:solidFill>
+                  <a:srgbClr val="05867E"/>
+                </a:solidFill>
+                <a:latin typeface="Aptos"/>
+              </a:rPr>
+              <a:t>KAOP</a:t>
+            </a:r>
+          </a:p>
+        </p:txBody>
+      </p:sp>
+      <p:sp>
+        <p:nvSpPr>
+          <p:cNvPr id="55" name="Rounded Rectangle 54"/>
+          <p:cNvSpPr/>
+          <p:nvPr/>
+        </p:nvSpPr>
+        <p:spPr>
+          <a:xfrm>
+            <a:off x="4036060" y="3200400"/>
+            <a:ext cx="1059180" cy="203200"/>
+          </a:xfrm>
+          <a:prstGeom prst="roundRect">
+            <a:avLst>
+              <a:gd name="adj" fmla="val 50000"/>
+            </a:avLst>
+          </a:prstGeom>
+          <a:solidFill>
+            <a:srgbClr val="E8EFFD"/>
+          </a:solidFill>
+          <a:ln>
+            <a:solidFill>
+              <a:srgbClr val="E8EFFD"/>
+            </a:solidFill>
+          </a:ln>
+          <a:effectLst/>
+        </p:spPr>
+        <p:style>
+          <a:lnRef idx="1">
+            <a:schemeClr val="accent1"/>
+          </a:lnRef>
+          <a:fillRef idx="3">
+            <a:schemeClr val="accent1"/>
+          </a:fillRef>
+          <a:effectRef idx="2">
+            <a:schemeClr val="accent1"/>
+          </a:effectRef>
+          <a:fontRef idx="minor">
+            <a:schemeClr val="lt1"/>
+          </a:fontRef>
+        </p:style>
+        <p:txBody>
+          <a:bodyPr rtlCol="0" anchor="ctr"/>
+          <a:lstStyle/>
+          <a:p>
+            <a:pPr algn="ctr"/>
+          </a:p>
+        </p:txBody>
+      </p:sp>
+      <p:sp>
+        <p:nvSpPr>
+          <p:cNvPr id="56" name="TextBox 55"/>
+          <p:cNvSpPr txBox="1"/>
+          <p:nvPr/>
+        </p:nvSpPr>
+        <p:spPr>
+          <a:xfrm>
+            <a:off x="4036060" y="3232150"/>
+            <a:ext cx="1059180" cy="152400"/>
+          </a:xfrm>
+          <a:prstGeom prst="rect">
+            <a:avLst/>
+          </a:prstGeom>
+          <a:noFill/>
+        </p:spPr>
+        <p:txBody>
+          <a:bodyPr wrap="square" lIns="0" rIns="0" tIns="0" bIns="0">
+            <a:spAutoFit/>
+          </a:bodyPr>
+          <a:lstStyle/>
+          <a:p>
+            <a:pPr algn="ctr"/>
+            <a:r>
+              <a:rPr sz="850" b="1">
+                <a:solidFill>
+                  <a:srgbClr val="2F62C4"/>
+                </a:solidFill>
+                <a:latin typeface="Aptos"/>
+              </a:rPr>
+              <a:t>Your cluster</a:t>
+            </a:r>
+          </a:p>
+        </p:txBody>
+      </p:sp>
+      <p:sp>
+        <p:nvSpPr>
+          <p:cNvPr id="57" name="Rounded Rectangle 56"/>
+          <p:cNvSpPr/>
+          <p:nvPr/>
+        </p:nvSpPr>
+        <p:spPr>
+          <a:xfrm>
+            <a:off x="6146800" y="3200400"/>
+            <a:ext cx="429259" cy="203200"/>
+          </a:xfrm>
+          <a:prstGeom prst="roundRect">
+            <a:avLst>
+              <a:gd name="adj" fmla="val 50000"/>
+            </a:avLst>
+          </a:prstGeom>
+          <a:solidFill>
+            <a:srgbClr val="E3F6F4"/>
+          </a:solidFill>
+          <a:ln>
+            <a:solidFill>
+              <a:srgbClr val="E3F6F4"/>
+            </a:solidFill>
+          </a:ln>
+          <a:effectLst/>
+        </p:spPr>
+        <p:style>
+          <a:lnRef idx="1">
+            <a:schemeClr val="accent1"/>
+          </a:lnRef>
+          <a:fillRef idx="3">
+            <a:schemeClr val="accent1"/>
+          </a:fillRef>
+          <a:effectRef idx="2">
+            <a:schemeClr val="accent1"/>
+          </a:effectRef>
+          <a:fontRef idx="minor">
+            <a:schemeClr val="lt1"/>
+          </a:fontRef>
+        </p:style>
+        <p:txBody>
+          <a:bodyPr rtlCol="0" anchor="ctr"/>
+          <a:lstStyle/>
+          <a:p>
+            <a:pPr algn="ctr"/>
+          </a:p>
+        </p:txBody>
+      </p:sp>
+      <p:sp>
+        <p:nvSpPr>
+          <p:cNvPr id="58" name="TextBox 57"/>
+          <p:cNvSpPr txBox="1"/>
+          <p:nvPr/>
+        </p:nvSpPr>
+        <p:spPr>
+          <a:xfrm>
+            <a:off x="6146800" y="3232150"/>
+            <a:ext cx="429259" cy="152400"/>
+          </a:xfrm>
+          <a:prstGeom prst="rect">
+            <a:avLst/>
+          </a:prstGeom>
+          <a:noFill/>
+        </p:spPr>
+        <p:txBody>
+          <a:bodyPr wrap="square" lIns="0" rIns="0" tIns="0" bIns="0">
+            <a:spAutoFit/>
+          </a:bodyPr>
+          <a:lstStyle/>
+          <a:p>
+            <a:pPr algn="ctr"/>
+            <a:r>
+              <a:rPr sz="850" b="1">
+                <a:solidFill>
+                  <a:srgbClr val="05867E"/>
+                </a:solidFill>
+                <a:latin typeface="Aptos"/>
+              </a:rPr>
+              <a:t>KAOP</a:t>
+            </a:r>
+          </a:p>
+        </p:txBody>
+      </p:sp>
+      <p:sp>
+        <p:nvSpPr>
+          <p:cNvPr id="59" name="Rounded Rectangle 58"/>
+          <p:cNvSpPr/>
+          <p:nvPr/>
+        </p:nvSpPr>
+        <p:spPr>
+          <a:xfrm>
+            <a:off x="8737600" y="3200400"/>
+            <a:ext cx="350520" cy="203200"/>
+          </a:xfrm>
+          <a:prstGeom prst="roundRect">
+            <a:avLst>
+              <a:gd name="adj" fmla="val 50000"/>
+            </a:avLst>
+          </a:prstGeom>
+          <a:solidFill>
+            <a:srgbClr val="F3EAFB"/>
+          </a:solidFill>
+          <a:ln>
+            <a:solidFill>
+              <a:srgbClr val="F3EAFB"/>
+            </a:solidFill>
+          </a:ln>
+          <a:effectLst/>
+        </p:spPr>
+        <p:style>
+          <a:lnRef idx="1">
+            <a:schemeClr val="accent1"/>
+          </a:lnRef>
+          <a:fillRef idx="3">
+            <a:schemeClr val="accent1"/>
+          </a:fillRef>
+          <a:effectRef idx="2">
+            <a:schemeClr val="accent1"/>
+          </a:effectRef>
+          <a:fontRef idx="minor">
+            <a:schemeClr val="lt1"/>
+          </a:fontRef>
+        </p:style>
+        <p:txBody>
+          <a:bodyPr rtlCol="0" anchor="ctr"/>
+          <a:lstStyle/>
+          <a:p>
+            <a:pPr algn="ctr"/>
+          </a:p>
+        </p:txBody>
+      </p:sp>
+      <p:sp>
+        <p:nvSpPr>
+          <p:cNvPr id="60" name="TextBox 59"/>
+          <p:cNvSpPr txBox="1"/>
+          <p:nvPr/>
+        </p:nvSpPr>
+        <p:spPr>
+          <a:xfrm>
+            <a:off x="8737600" y="3232150"/>
+            <a:ext cx="350520" cy="152400"/>
+          </a:xfrm>
+          <a:prstGeom prst="rect">
+            <a:avLst/>
+          </a:prstGeom>
+          <a:noFill/>
+        </p:spPr>
+        <p:txBody>
+          <a:bodyPr wrap="square" lIns="0" rIns="0" tIns="0" bIns="0">
+            <a:spAutoFit/>
+          </a:bodyPr>
+          <a:lstStyle/>
+          <a:p>
+            <a:pPr algn="ctr"/>
+            <a:r>
+              <a:rPr sz="850" b="1">
+                <a:solidFill>
+                  <a:srgbClr val="7A3FB0"/>
+                </a:solidFill>
+                <a:latin typeface="Aptos"/>
+              </a:rPr>
+              <a:t>You</a:t>
+            </a:r>
+          </a:p>
+        </p:txBody>
+      </p:sp>
+      <p:sp>
+        <p:nvSpPr>
+          <p:cNvPr id="61" name="Rounded Rectangle 60"/>
+          <p:cNvSpPr/>
+          <p:nvPr/>
+        </p:nvSpPr>
+        <p:spPr>
+          <a:xfrm>
+            <a:off x="9151620" y="3200400"/>
+            <a:ext cx="429259" cy="203200"/>
+          </a:xfrm>
+          <a:prstGeom prst="roundRect">
+            <a:avLst>
+              <a:gd name="adj" fmla="val 50000"/>
+            </a:avLst>
+          </a:prstGeom>
+          <a:solidFill>
+            <a:srgbClr val="E3F6F4"/>
+          </a:solidFill>
+          <a:ln>
+            <a:solidFill>
+              <a:srgbClr val="E3F6F4"/>
+            </a:solidFill>
+          </a:ln>
+          <a:effectLst/>
+        </p:spPr>
+        <p:style>
+          <a:lnRef idx="1">
+            <a:schemeClr val="accent1"/>
+          </a:lnRef>
+          <a:fillRef idx="3">
+            <a:schemeClr val="accent1"/>
+          </a:fillRef>
+          <a:effectRef idx="2">
+            <a:schemeClr val="accent1"/>
+          </a:effectRef>
+          <a:fontRef idx="minor">
+            <a:schemeClr val="lt1"/>
+          </a:fontRef>
+        </p:style>
+        <p:txBody>
+          <a:bodyPr rtlCol="0" anchor="ctr"/>
+          <a:lstStyle/>
+          <a:p>
+            <a:pPr algn="ctr"/>
+          </a:p>
+        </p:txBody>
+      </p:sp>
+      <p:sp>
+        <p:nvSpPr>
+          <p:cNvPr id="62" name="TextBox 61"/>
+          <p:cNvSpPr txBox="1"/>
+          <p:nvPr/>
+        </p:nvSpPr>
+        <p:spPr>
+          <a:xfrm>
+            <a:off x="9151620" y="3232150"/>
+            <a:ext cx="429259" cy="152400"/>
+          </a:xfrm>
+          <a:prstGeom prst="rect">
+            <a:avLst/>
+          </a:prstGeom>
+          <a:noFill/>
+        </p:spPr>
+        <p:txBody>
+          <a:bodyPr wrap="square" lIns="0" rIns="0" tIns="0" bIns="0">
+            <a:spAutoFit/>
+          </a:bodyPr>
+          <a:lstStyle/>
+          <a:p>
+            <a:pPr algn="ctr"/>
+            <a:r>
+              <a:rPr sz="850" b="1">
+                <a:solidFill>
+                  <a:srgbClr val="05867E"/>
+                </a:solidFill>
+                <a:latin typeface="Aptos"/>
+              </a:rPr>
+              <a:t>KAOP</a:t>
+            </a:r>
+          </a:p>
+        </p:txBody>
+      </p:sp>
+      <p:sp>
+        <p:nvSpPr>
+          <p:cNvPr id="63" name="Rounded Rectangle 62"/>
+          <p:cNvSpPr/>
+          <p:nvPr/>
+        </p:nvSpPr>
+        <p:spPr>
+          <a:xfrm>
+            <a:off x="952500" y="5207000"/>
+            <a:ext cx="350520" cy="203200"/>
+          </a:xfrm>
+          <a:prstGeom prst="roundRect">
+            <a:avLst>
+              <a:gd name="adj" fmla="val 50000"/>
+            </a:avLst>
+          </a:prstGeom>
+          <a:solidFill>
+            <a:srgbClr val="F3EAFB"/>
+          </a:solidFill>
+          <a:ln>
+            <a:solidFill>
+              <a:srgbClr val="F3EAFB"/>
+            </a:solidFill>
+          </a:ln>
+          <a:effectLst/>
+        </p:spPr>
+        <p:style>
+          <a:lnRef idx="1">
+            <a:schemeClr val="accent1"/>
+          </a:lnRef>
+          <a:fillRef idx="3">
+            <a:schemeClr val="accent1"/>
+          </a:fillRef>
+          <a:effectRef idx="2">
+            <a:schemeClr val="accent1"/>
+          </a:effectRef>
+          <a:fontRef idx="minor">
+            <a:schemeClr val="lt1"/>
+          </a:fontRef>
+        </p:style>
+        <p:txBody>
+          <a:bodyPr rtlCol="0" anchor="ctr"/>
+          <a:lstStyle/>
+          <a:p>
+            <a:pPr algn="ctr"/>
+          </a:p>
+        </p:txBody>
+      </p:sp>
+      <p:sp>
+        <p:nvSpPr>
+          <p:cNvPr id="64" name="TextBox 63"/>
+          <p:cNvSpPr txBox="1"/>
+          <p:nvPr/>
+        </p:nvSpPr>
+        <p:spPr>
+          <a:xfrm>
+            <a:off x="952500" y="5238750"/>
+            <a:ext cx="350520" cy="152400"/>
+          </a:xfrm>
+          <a:prstGeom prst="rect">
+            <a:avLst/>
+          </a:prstGeom>
+          <a:noFill/>
+        </p:spPr>
+        <p:txBody>
+          <a:bodyPr wrap="square" lIns="0" rIns="0" tIns="0" bIns="0">
+            <a:spAutoFit/>
+          </a:bodyPr>
+          <a:lstStyle/>
+          <a:p>
+            <a:pPr algn="ctr"/>
+            <a:r>
+              <a:rPr sz="850" b="1">
+                <a:solidFill>
+                  <a:srgbClr val="7A3FB0"/>
+                </a:solidFill>
+                <a:latin typeface="Aptos"/>
+              </a:rPr>
+              <a:t>You</a:t>
+            </a:r>
+          </a:p>
+        </p:txBody>
+      </p:sp>
+      <p:sp>
+        <p:nvSpPr>
+          <p:cNvPr id="65" name="Rounded Rectangle 64"/>
+          <p:cNvSpPr/>
+          <p:nvPr/>
+        </p:nvSpPr>
+        <p:spPr>
+          <a:xfrm>
+            <a:off x="1366520" y="5207000"/>
+            <a:ext cx="586740" cy="203200"/>
+          </a:xfrm>
+          <a:prstGeom prst="roundRect">
+            <a:avLst>
+              <a:gd name="adj" fmla="val 50000"/>
+            </a:avLst>
+          </a:prstGeom>
+          <a:solidFill>
+            <a:srgbClr val="EEF0F3"/>
+          </a:solidFill>
+          <a:ln>
+            <a:solidFill>
+              <a:srgbClr val="EEF0F3"/>
+            </a:solidFill>
+          </a:ln>
+          <a:effectLst/>
+        </p:spPr>
+        <p:style>
+          <a:lnRef idx="1">
+            <a:schemeClr val="accent1"/>
+          </a:lnRef>
+          <a:fillRef idx="3">
+            <a:schemeClr val="accent1"/>
+          </a:fillRef>
+          <a:effectRef idx="2">
+            <a:schemeClr val="accent1"/>
+          </a:effectRef>
+          <a:fontRef idx="minor">
+            <a:schemeClr val="lt1"/>
+          </a:fontRef>
+        </p:style>
+        <p:txBody>
+          <a:bodyPr rtlCol="0" anchor="ctr"/>
+          <a:lstStyle/>
+          <a:p>
+            <a:pPr algn="ctr"/>
+          </a:p>
+        </p:txBody>
+      </p:sp>
+      <p:sp>
+        <p:nvSpPr>
+          <p:cNvPr id="66" name="TextBox 65"/>
+          <p:cNvSpPr txBox="1"/>
+          <p:nvPr/>
+        </p:nvSpPr>
+        <p:spPr>
+          <a:xfrm>
+            <a:off x="1366520" y="5238750"/>
+            <a:ext cx="586740" cy="152400"/>
+          </a:xfrm>
+          <a:prstGeom prst="rect">
+            <a:avLst/>
+          </a:prstGeom>
+          <a:noFill/>
+        </p:spPr>
+        <p:txBody>
+          <a:bodyPr wrap="square" lIns="0" rIns="0" tIns="0" bIns="0">
+            <a:spAutoFit/>
+          </a:bodyPr>
+          <a:lstStyle/>
+          <a:p>
+            <a:pPr algn="ctr"/>
+            <a:r>
+              <a:rPr sz="850" b="1">
+                <a:solidFill>
+                  <a:srgbClr val="3D4A5C"/>
+                </a:solidFill>
+                <a:latin typeface="Aptos"/>
+              </a:rPr>
+              <a:t>GitHub</a:t>
+            </a:r>
+          </a:p>
+        </p:txBody>
+      </p:sp>
+      <p:sp>
+        <p:nvSpPr>
+          <p:cNvPr id="67" name="Rounded Rectangle 66"/>
+          <p:cNvSpPr/>
+          <p:nvPr/>
+        </p:nvSpPr>
+        <p:spPr>
+          <a:xfrm>
+            <a:off x="3543300" y="5207000"/>
+            <a:ext cx="429259" cy="203200"/>
+          </a:xfrm>
+          <a:prstGeom prst="roundRect">
+            <a:avLst>
+              <a:gd name="adj" fmla="val 50000"/>
+            </a:avLst>
+          </a:prstGeom>
+          <a:solidFill>
+            <a:srgbClr val="E3F6F4"/>
+          </a:solidFill>
+          <a:ln>
+            <a:solidFill>
+              <a:srgbClr val="E3F6F4"/>
+            </a:solidFill>
+          </a:ln>
+          <a:effectLst/>
+        </p:spPr>
+        <p:style>
+          <a:lnRef idx="1">
+            <a:schemeClr val="accent1"/>
+          </a:lnRef>
+          <a:fillRef idx="3">
+            <a:schemeClr val="accent1"/>
+          </a:fillRef>
+          <a:effectRef idx="2">
+            <a:schemeClr val="accent1"/>
+          </a:effectRef>
+          <a:fontRef idx="minor">
+            <a:schemeClr val="lt1"/>
+          </a:fontRef>
+        </p:style>
+        <p:txBody>
+          <a:bodyPr rtlCol="0" anchor="ctr"/>
+          <a:lstStyle/>
+          <a:p>
+            <a:pPr algn="ctr"/>
+          </a:p>
+        </p:txBody>
+      </p:sp>
+      <p:sp>
+        <p:nvSpPr>
+          <p:cNvPr id="68" name="TextBox 67"/>
+          <p:cNvSpPr txBox="1"/>
+          <p:nvPr/>
+        </p:nvSpPr>
+        <p:spPr>
+          <a:xfrm>
+            <a:off x="3543300" y="5238750"/>
+            <a:ext cx="429259" cy="152400"/>
+          </a:xfrm>
+          <a:prstGeom prst="rect">
+            <a:avLst/>
+          </a:prstGeom>
+          <a:noFill/>
+        </p:spPr>
+        <p:txBody>
+          <a:bodyPr wrap="square" lIns="0" rIns="0" tIns="0" bIns="0">
+            <a:spAutoFit/>
+          </a:bodyPr>
+          <a:lstStyle/>
+          <a:p>
+            <a:pPr algn="ctr"/>
+            <a:r>
+              <a:rPr sz="850" b="1">
+                <a:solidFill>
+                  <a:srgbClr val="05867E"/>
+                </a:solidFill>
+                <a:latin typeface="Aptos"/>
+              </a:rPr>
+              <a:t>KAOP</a:t>
+            </a:r>
+          </a:p>
+        </p:txBody>
+      </p:sp>
+      <p:sp>
+        <p:nvSpPr>
+          <p:cNvPr id="69" name="Rounded Rectangle 68"/>
+          <p:cNvSpPr/>
+          <p:nvPr/>
+        </p:nvSpPr>
+        <p:spPr>
+          <a:xfrm>
+            <a:off x="4036060" y="5207000"/>
+            <a:ext cx="586740" cy="203200"/>
+          </a:xfrm>
+          <a:prstGeom prst="roundRect">
+            <a:avLst>
+              <a:gd name="adj" fmla="val 50000"/>
+            </a:avLst>
+          </a:prstGeom>
+          <a:solidFill>
+            <a:srgbClr val="EEF0F3"/>
+          </a:solidFill>
+          <a:ln>
+            <a:solidFill>
+              <a:srgbClr val="EEF0F3"/>
+            </a:solidFill>
+          </a:ln>
+          <a:effectLst/>
+        </p:spPr>
+        <p:style>
+          <a:lnRef idx="1">
+            <a:schemeClr val="accent1"/>
+          </a:lnRef>
+          <a:fillRef idx="3">
+            <a:schemeClr val="accent1"/>
+          </a:fillRef>
+          <a:effectRef idx="2">
+            <a:schemeClr val="accent1"/>
+          </a:effectRef>
+          <a:fontRef idx="minor">
+            <a:schemeClr val="lt1"/>
+          </a:fontRef>
+        </p:style>
+        <p:txBody>
+          <a:bodyPr rtlCol="0" anchor="ctr"/>
+          <a:lstStyle/>
+          <a:p>
+            <a:pPr algn="ctr"/>
+          </a:p>
+        </p:txBody>
+      </p:sp>
+      <p:sp>
+        <p:nvSpPr>
+          <p:cNvPr id="70" name="TextBox 69"/>
+          <p:cNvSpPr txBox="1"/>
+          <p:nvPr/>
+        </p:nvSpPr>
+        <p:spPr>
+          <a:xfrm>
+            <a:off x="4036060" y="5238750"/>
+            <a:ext cx="586740" cy="152400"/>
+          </a:xfrm>
+          <a:prstGeom prst="rect">
+            <a:avLst/>
+          </a:prstGeom>
+          <a:noFill/>
+        </p:spPr>
+        <p:txBody>
+          <a:bodyPr wrap="square" lIns="0" rIns="0" tIns="0" bIns="0">
+            <a:spAutoFit/>
+          </a:bodyPr>
+          <a:lstStyle/>
+          <a:p>
+            <a:pPr algn="ctr"/>
+            <a:r>
+              <a:rPr sz="850" b="1">
+                <a:solidFill>
+                  <a:srgbClr val="3D4A5C"/>
+                </a:solidFill>
+                <a:latin typeface="Aptos"/>
+              </a:rPr>
+              <a:t>GitHub</a:t>
+            </a:r>
+          </a:p>
+        </p:txBody>
+      </p:sp>
+      <p:sp>
+        <p:nvSpPr>
+          <p:cNvPr id="71" name="Rounded Rectangle 70"/>
+          <p:cNvSpPr/>
+          <p:nvPr/>
+        </p:nvSpPr>
+        <p:spPr>
+          <a:xfrm>
+            <a:off x="6146800" y="5207000"/>
+            <a:ext cx="350520" cy="203200"/>
+          </a:xfrm>
+          <a:prstGeom prst="roundRect">
+            <a:avLst>
+              <a:gd name="adj" fmla="val 50000"/>
+            </a:avLst>
+          </a:prstGeom>
+          <a:solidFill>
+            <a:srgbClr val="F3EAFB"/>
+          </a:solidFill>
+          <a:ln>
+            <a:solidFill>
+              <a:srgbClr val="F3EAFB"/>
+            </a:solidFill>
+          </a:ln>
+          <a:effectLst/>
+        </p:spPr>
+        <p:style>
+          <a:lnRef idx="1">
+            <a:schemeClr val="accent1"/>
+          </a:lnRef>
+          <a:fillRef idx="3">
+            <a:schemeClr val="accent1"/>
+          </a:fillRef>
+          <a:effectRef idx="2">
+            <a:schemeClr val="accent1"/>
+          </a:effectRef>
+          <a:fontRef idx="minor">
+            <a:schemeClr val="lt1"/>
+          </a:fontRef>
+        </p:style>
+        <p:txBody>
+          <a:bodyPr rtlCol="0" anchor="ctr"/>
+          <a:lstStyle/>
+          <a:p>
+            <a:pPr algn="ctr"/>
+          </a:p>
+        </p:txBody>
+      </p:sp>
+      <p:sp>
+        <p:nvSpPr>
+          <p:cNvPr id="72" name="TextBox 71"/>
+          <p:cNvSpPr txBox="1"/>
+          <p:nvPr/>
+        </p:nvSpPr>
+        <p:spPr>
+          <a:xfrm>
+            <a:off x="6146800" y="5238750"/>
+            <a:ext cx="350520" cy="152400"/>
+          </a:xfrm>
+          <a:prstGeom prst="rect">
+            <a:avLst/>
+          </a:prstGeom>
+          <a:noFill/>
+        </p:spPr>
+        <p:txBody>
+          <a:bodyPr wrap="square" lIns="0" rIns="0" tIns="0" bIns="0">
+            <a:spAutoFit/>
+          </a:bodyPr>
+          <a:lstStyle/>
+          <a:p>
+            <a:pPr algn="ctr"/>
+            <a:r>
+              <a:rPr sz="850" b="1">
+                <a:solidFill>
+                  <a:srgbClr val="7A3FB0"/>
+                </a:solidFill>
+                <a:latin typeface="Aptos"/>
+              </a:rPr>
+              <a:t>You</a:t>
+            </a:r>
+          </a:p>
+        </p:txBody>
+      </p:sp>
+      <p:sp>
+        <p:nvSpPr>
+          <p:cNvPr id="73" name="Rounded Rectangle 72"/>
+          <p:cNvSpPr/>
+          <p:nvPr/>
+        </p:nvSpPr>
+        <p:spPr>
+          <a:xfrm>
+            <a:off x="6560820" y="5207000"/>
+            <a:ext cx="586740" cy="203200"/>
+          </a:xfrm>
+          <a:prstGeom prst="roundRect">
+            <a:avLst>
+              <a:gd name="adj" fmla="val 50000"/>
+            </a:avLst>
+          </a:prstGeom>
+          <a:solidFill>
+            <a:srgbClr val="EEF0F3"/>
+          </a:solidFill>
+          <a:ln>
+            <a:solidFill>
+              <a:srgbClr val="EEF0F3"/>
+            </a:solidFill>
+          </a:ln>
+          <a:effectLst/>
+        </p:spPr>
+        <p:style>
+          <a:lnRef idx="1">
+            <a:schemeClr val="accent1"/>
+          </a:lnRef>
+          <a:fillRef idx="3">
+            <a:schemeClr val="accent1"/>
+          </a:fillRef>
+          <a:effectRef idx="2">
+            <a:schemeClr val="accent1"/>
+          </a:effectRef>
+          <a:fontRef idx="minor">
+            <a:schemeClr val="lt1"/>
+          </a:fontRef>
+        </p:style>
+        <p:txBody>
+          <a:bodyPr rtlCol="0" anchor="ctr"/>
+          <a:lstStyle/>
+          <a:p>
+            <a:pPr algn="ctr"/>
+          </a:p>
+        </p:txBody>
+      </p:sp>
+      <p:sp>
+        <p:nvSpPr>
+          <p:cNvPr id="74" name="TextBox 73"/>
+          <p:cNvSpPr txBox="1"/>
+          <p:nvPr/>
+        </p:nvSpPr>
+        <p:spPr>
+          <a:xfrm>
+            <a:off x="6560820" y="5238750"/>
+            <a:ext cx="586740" cy="152400"/>
+          </a:xfrm>
+          <a:prstGeom prst="rect">
+            <a:avLst/>
+          </a:prstGeom>
+          <a:noFill/>
+        </p:spPr>
+        <p:txBody>
+          <a:bodyPr wrap="square" lIns="0" rIns="0" tIns="0" bIns="0">
+            <a:spAutoFit/>
+          </a:bodyPr>
+          <a:lstStyle/>
+          <a:p>
+            <a:pPr algn="ctr"/>
+            <a:r>
+              <a:rPr sz="850" b="1">
+                <a:solidFill>
+                  <a:srgbClr val="3D4A5C"/>
+                </a:solidFill>
+                <a:latin typeface="Aptos"/>
+              </a:rPr>
+              <a:t>GitHub</a:t>
+            </a:r>
+          </a:p>
+        </p:txBody>
+      </p:sp>
+      <p:sp>
+        <p:nvSpPr>
+          <p:cNvPr id="75" name="Rounded Rectangle 74"/>
+          <p:cNvSpPr/>
+          <p:nvPr/>
+        </p:nvSpPr>
+        <p:spPr>
+          <a:xfrm>
+            <a:off x="8737600" y="5207000"/>
+            <a:ext cx="1059180" cy="203200"/>
+          </a:xfrm>
+          <a:prstGeom prst="roundRect">
+            <a:avLst>
+              <a:gd name="adj" fmla="val 50000"/>
+            </a:avLst>
+          </a:prstGeom>
+          <a:solidFill>
+            <a:srgbClr val="E8EFFD"/>
+          </a:solidFill>
+          <a:ln>
+            <a:solidFill>
+              <a:srgbClr val="E8EFFD"/>
+            </a:solidFill>
+          </a:ln>
+          <a:effectLst/>
+        </p:spPr>
+        <p:style>
+          <a:lnRef idx="1">
+            <a:schemeClr val="accent1"/>
+          </a:lnRef>
+          <a:fillRef idx="3">
+            <a:schemeClr val="accent1"/>
+          </a:fillRef>
+          <a:effectRef idx="2">
+            <a:schemeClr val="accent1"/>
+          </a:effectRef>
+          <a:fontRef idx="minor">
+            <a:schemeClr val="lt1"/>
+          </a:fontRef>
+        </p:style>
+        <p:txBody>
+          <a:bodyPr rtlCol="0" anchor="ctr"/>
+          <a:lstStyle/>
+          <a:p>
+            <a:pPr algn="ctr"/>
+          </a:p>
+        </p:txBody>
+      </p:sp>
+      <p:sp>
+        <p:nvSpPr>
+          <p:cNvPr id="76" name="TextBox 75"/>
+          <p:cNvSpPr txBox="1"/>
+          <p:nvPr/>
+        </p:nvSpPr>
+        <p:spPr>
+          <a:xfrm>
+            <a:off x="8737600" y="5238750"/>
+            <a:ext cx="1059180" cy="152400"/>
+          </a:xfrm>
+          <a:prstGeom prst="rect">
+            <a:avLst/>
+          </a:prstGeom>
+          <a:noFill/>
+        </p:spPr>
+        <p:txBody>
+          <a:bodyPr wrap="square" lIns="0" rIns="0" tIns="0" bIns="0">
+            <a:spAutoFit/>
+          </a:bodyPr>
+          <a:lstStyle/>
+          <a:p>
+            <a:pPr algn="ctr"/>
+            <a:r>
+              <a:rPr sz="850" b="1">
+                <a:solidFill>
+                  <a:srgbClr val="2F62C4"/>
+                </a:solidFill>
+                <a:latin typeface="Aptos"/>
+              </a:rPr>
+              <a:t>Your cluster</a:t>
+            </a:r>
           </a:p>
         </p:txBody>
       </p:sp>

</xml_diff>

<commit_message>
Deck: slide 3 shows KAOP's operating model as the foundation under the three outcomes
Co-Authored-By: Claude Opus 5.5 <noreply@anthropic.com>
Claude-Session: https://claude.ai/code/session_01DptoPaaj14X3TGztKApoPN
</commit_message>
<xml_diff>
--- a/docs/presentation/KAOP_Customer_Pitch.pptx
+++ b/docs/presentation/KAOP_Customer_Pitch.pptx
@@ -9646,8 +9646,8 @@
         </p:nvSpPr>
         <p:spPr>
           <a:xfrm>
-            <a:off x="694944" y="1984248"/>
-            <a:ext cx="3529584" cy="2715768"/>
+            <a:off x="635000" y="1984248"/>
+            <a:ext cx="3454400" cy="2260600"/>
           </a:xfrm>
           <a:prstGeom prst="roundRect">
             <a:avLst>
@@ -9677,8 +9677,8 @@
         </p:nvSpPr>
         <p:spPr>
           <a:xfrm>
-            <a:off x="914400" y="2212848"/>
-            <a:ext cx="1280160" cy="466344"/>
+            <a:off x="854456" y="2212848"/>
+            <a:ext cx="3022600" cy="466344"/>
           </a:xfrm>
           <a:prstGeom prst="rect">
             <a:avLst/>
@@ -9718,8 +9718,8 @@
         </p:nvSpPr>
         <p:spPr>
           <a:xfrm>
-            <a:off x="914400" y="2843784"/>
-            <a:ext cx="3108960" cy="356616"/>
+            <a:off x="854456" y="2843784"/>
+            <a:ext cx="3022600" cy="356616"/>
           </a:xfrm>
           <a:prstGeom prst="rect">
             <a:avLst/>
@@ -9759,8 +9759,8 @@
         </p:nvSpPr>
         <p:spPr>
           <a:xfrm>
-            <a:off x="914400" y="3493008"/>
-            <a:ext cx="2999232" cy="786384"/>
+            <a:off x="854456" y="3493008"/>
+            <a:ext cx="3022600" cy="786384"/>
           </a:xfrm>
           <a:prstGeom prst="rect">
             <a:avLst/>
@@ -9817,8 +9817,8 @@
         </p:nvSpPr>
         <p:spPr>
           <a:xfrm>
-            <a:off x="4535424" y="1984248"/>
-            <a:ext cx="3529584" cy="2715768"/>
+            <a:off x="4368800" y="1984248"/>
+            <a:ext cx="3454400" cy="2260600"/>
           </a:xfrm>
           <a:prstGeom prst="roundRect">
             <a:avLst>
@@ -9848,8 +9848,8 @@
         </p:nvSpPr>
         <p:spPr>
           <a:xfrm>
-            <a:off x="4754880" y="2212848"/>
-            <a:ext cx="1280160" cy="466344"/>
+            <a:off x="4588256" y="2212848"/>
+            <a:ext cx="3022600" cy="466344"/>
           </a:xfrm>
           <a:prstGeom prst="rect">
             <a:avLst/>
@@ -9889,8 +9889,8 @@
         </p:nvSpPr>
         <p:spPr>
           <a:xfrm>
-            <a:off x="4754880" y="2843784"/>
-            <a:ext cx="3108960" cy="356616"/>
+            <a:off x="4588256" y="2843784"/>
+            <a:ext cx="3022600" cy="356616"/>
           </a:xfrm>
           <a:prstGeom prst="rect">
             <a:avLst/>
@@ -9930,8 +9930,8 @@
         </p:nvSpPr>
         <p:spPr>
           <a:xfrm>
-            <a:off x="4754880" y="3493008"/>
-            <a:ext cx="2999232" cy="786384"/>
+            <a:off x="4588256" y="3493008"/>
+            <a:ext cx="3022600" cy="786384"/>
           </a:xfrm>
           <a:prstGeom prst="rect">
             <a:avLst/>
@@ -9988,8 +9988,8 @@
         </p:nvSpPr>
         <p:spPr>
           <a:xfrm>
-            <a:off x="8375904" y="1984248"/>
-            <a:ext cx="3529584" cy="2715768"/>
+            <a:off x="8102600" y="1984248"/>
+            <a:ext cx="3454400" cy="2260600"/>
           </a:xfrm>
           <a:prstGeom prst="roundRect">
             <a:avLst>
@@ -10019,8 +10019,8 @@
         </p:nvSpPr>
         <p:spPr>
           <a:xfrm>
-            <a:off x="8595360" y="2212848"/>
-            <a:ext cx="1280160" cy="466344"/>
+            <a:off x="8322056" y="2212848"/>
+            <a:ext cx="3022600" cy="466344"/>
           </a:xfrm>
           <a:prstGeom prst="rect">
             <a:avLst/>
@@ -10060,8 +10060,8 @@
         </p:nvSpPr>
         <p:spPr>
           <a:xfrm>
-            <a:off x="8595360" y="2843784"/>
-            <a:ext cx="3108960" cy="356616"/>
+            <a:off x="8322056" y="2843784"/>
+            <a:ext cx="3022600" cy="356616"/>
           </a:xfrm>
           <a:prstGeom prst="rect">
             <a:avLst/>
@@ -10101,8 +10101,8 @@
         </p:nvSpPr>
         <p:spPr>
           <a:xfrm>
-            <a:off x="8595360" y="3493008"/>
-            <a:ext cx="2999232" cy="786384"/>
+            <a:off x="8322056" y="3493008"/>
+            <a:ext cx="3022600" cy="786384"/>
           </a:xfrm>
           <a:prstGeom prst="rect">
             <a:avLst/>
@@ -10153,338 +10153,388 @@
       </p:sp>
       <p:sp>
         <p:nvSpPr>
-          <p:cNvPr id="20" name="Text 18"/>
-          <p:cNvSpPr/>
-          <p:nvPr/>
-        </p:nvSpPr>
-        <p:spPr>
-          <a:xfrm>
-            <a:off x="777240" y="5056632"/>
-            <a:ext cx="5157216" cy="274320"/>
-          </a:xfrm>
-          <a:prstGeom prst="rect">
-            <a:avLst/>
-          </a:prstGeom>
-          <a:noFill/>
-          <a:ln/>
-        </p:spPr>
-        <p:txBody>
-          <a:bodyPr wrap="square" lIns="254" tIns="254" rIns="254" bIns="254" rtlCol="0" anchor="ctr">
-            <a:normAutofit/>
-          </a:bodyPr>
-          <a:lstStyle/>
-          <a:p>
-            <a:pPr algn="l" indent="0" marL="0">
-              <a:buNone/>
-            </a:pPr>
-            <a:r>
-              <a:rPr lang="en-US" sz="1640" b="1" dirty="0">
-                <a:solidFill>
-                  <a:srgbClr val="132438"/>
-                </a:solidFill>
-                <a:latin typeface="Aptos" pitchFamily="34" charset="0"/>
-                <a:ea typeface="Aptos" pitchFamily="34" charset="-122"/>
-                <a:cs typeface="Aptos" pitchFamily="34" charset="-120"/>
-              </a:rPr>
-              <a:t>Built on KAOP’s shared operating model</a:t>
-            </a:r>
-            <a:endParaRPr lang="en-US" sz="1640" dirty="0"/>
-          </a:p>
-        </p:txBody>
-      </p:sp>
-      <p:sp>
-        <p:nvSpPr>
-          <p:cNvPr id="21" name="Shape 19"/>
-          <p:cNvSpPr/>
-          <p:nvPr/>
-        </p:nvSpPr>
-        <p:spPr>
-          <a:xfrm>
-            <a:off x="5760720" y="4965192"/>
-            <a:ext cx="1298448" cy="347472"/>
+          <p:cNvPr id="20" name="Rounded Rectangle 19"/>
+          <p:cNvSpPr/>
+          <p:nvPr/>
+        </p:nvSpPr>
+        <p:spPr>
+          <a:xfrm>
+            <a:off x="635000" y="4470400"/>
+            <a:ext cx="10922000" cy="1625600"/>
           </a:xfrm>
           <a:prstGeom prst="roundRect">
             <a:avLst>
-              <a:gd name="adj" fmla="val 39474"/>
+              <a:gd name="adj" fmla="val 8000"/>
             </a:avLst>
           </a:prstGeom>
           <a:solidFill>
-            <a:srgbClr val="EAF0F5"/>
+            <a:srgbClr val="0C1423"/>
           </a:solidFill>
-          <a:ln w="12700">
+          <a:ln>
             <a:solidFill>
-              <a:srgbClr val="EAF0F5">
-                <a:alpha val="0"/>
-              </a:srgbClr>
+              <a:srgbClr val="0C1423"/>
             </a:solidFill>
-            <a:prstDash val="solid"/>
           </a:ln>
-        </p:spPr>
-        <p:txBody>
-          <a:bodyPr/>
-          <a:p/>
-        </p:txBody>
-      </p:sp>
-      <p:sp>
-        <p:nvSpPr>
-          <p:cNvPr id="22" name="Text 20"/>
-          <p:cNvSpPr/>
-          <p:nvPr/>
-        </p:nvSpPr>
-        <p:spPr>
-          <a:xfrm>
-            <a:off x="5870448" y="5038344"/>
-            <a:ext cx="1078992" cy="173736"/>
-          </a:xfrm>
-          <a:prstGeom prst="rect">
-            <a:avLst/>
-          </a:prstGeom>
-          <a:noFill/>
-          <a:ln/>
-        </p:spPr>
-        <p:txBody>
-          <a:bodyPr wrap="square" lIns="254" tIns="254" rIns="254" bIns="254" rtlCol="0" anchor="ctr">
-            <a:normAutofit/>
-          </a:bodyPr>
-          <a:lstStyle/>
-          <a:p>
-            <a:pPr algn="ctr" indent="0" marL="0">
-              <a:buNone/>
-            </a:pPr>
-            <a:r>
-              <a:rPr lang="en-US" sz="1130" b="1" dirty="0">
-                <a:solidFill>
-                  <a:srgbClr val="132438"/>
-                </a:solidFill>
-                <a:latin typeface="Aptos" pitchFamily="34" charset="0"/>
-                <a:ea typeface="Aptos" pitchFamily="34" charset="-122"/>
-                <a:cs typeface="Aptos" pitchFamily="34" charset="-120"/>
+          <a:effectLst/>
+        </p:spPr>
+        <p:style>
+          <a:lnRef idx="1">
+            <a:schemeClr val="accent1"/>
+          </a:lnRef>
+          <a:fillRef idx="3">
+            <a:schemeClr val="accent1"/>
+          </a:fillRef>
+          <a:effectRef idx="2">
+            <a:schemeClr val="accent1"/>
+          </a:effectRef>
+          <a:fontRef idx="minor">
+            <a:schemeClr val="lt1"/>
+          </a:fontRef>
+        </p:style>
+        <p:txBody>
+          <a:bodyPr rtlCol="0" anchor="ctr"/>
+          <a:lstStyle/>
+          <a:p>
+            <a:pPr algn="ctr"/>
+          </a:p>
+        </p:txBody>
+      </p:sp>
+      <p:sp>
+        <p:nvSpPr>
+          <p:cNvPr id="21" name="TextBox 20"/>
+          <p:cNvSpPr txBox="1"/>
+          <p:nvPr/>
+        </p:nvSpPr>
+        <p:spPr>
+          <a:xfrm>
+            <a:off x="914400" y="4648200"/>
+            <a:ext cx="6350000" cy="203200"/>
+          </a:xfrm>
+          <a:prstGeom prst="rect">
+            <a:avLst/>
+          </a:prstGeom>
+          <a:noFill/>
+        </p:spPr>
+        <p:txBody>
+          <a:bodyPr wrap="square" lIns="0" rIns="0" tIns="0" bIns="0">
+            <a:spAutoFit/>
+          </a:bodyPr>
+          <a:lstStyle/>
+          <a:p>
+            <a:r>
+              <a:rPr sz="1050" b="1">
+                <a:solidFill>
+                  <a:srgbClr val="C6F783"/>
+                </a:solidFill>
+                <a:latin typeface="Aptos"/>
+              </a:rPr>
+              <a:t>THE FOUNDATION: KAOP'S OPERATING MODEL</a:t>
+            </a:r>
+          </a:p>
+        </p:txBody>
+      </p:sp>
+      <p:sp>
+        <p:nvSpPr>
+          <p:cNvPr id="22" name="TextBox 21"/>
+          <p:cNvSpPr txBox="1"/>
+          <p:nvPr/>
+        </p:nvSpPr>
+        <p:spPr>
+          <a:xfrm>
+            <a:off x="914400" y="5029200"/>
+            <a:ext cx="2286000" cy="889000"/>
+          </a:xfrm>
+          <a:prstGeom prst="rect">
+            <a:avLst/>
+          </a:prstGeom>
+          <a:noFill/>
+        </p:spPr>
+        <p:txBody>
+          <a:bodyPr wrap="square" lIns="0" rIns="0" tIns="0" bIns="0">
+            <a:spAutoFit/>
+          </a:bodyPr>
+          <a:lstStyle/>
+          <a:p>
+            <a:r>
+              <a:rPr sz="2200" b="1">
+                <a:solidFill>
+                  <a:srgbClr val="FFFFFF"/>
+                </a:solidFill>
+                <a:latin typeface="Aptos"/>
               </a:rPr>
               <a:t>BUILD</a:t>
             </a:r>
-            <a:endParaRPr lang="en-US" sz="1130" dirty="0"/>
-          </a:p>
-        </p:txBody>
-      </p:sp>
-      <p:sp>
-        <p:nvSpPr>
-          <p:cNvPr id="23" name="Shape 21"/>
-          <p:cNvSpPr/>
-          <p:nvPr/>
-        </p:nvSpPr>
-        <p:spPr>
-          <a:xfrm>
-            <a:off x="7168896" y="4965192"/>
-            <a:ext cx="1298448" cy="347472"/>
-          </a:xfrm>
-          <a:prstGeom prst="roundRect">
-            <a:avLst>
-              <a:gd name="adj" fmla="val 39474"/>
-            </a:avLst>
-          </a:prstGeom>
-          <a:solidFill>
-            <a:srgbClr val="EAF0F5"/>
-          </a:solidFill>
-          <a:ln w="12700">
-            <a:solidFill>
-              <a:srgbClr val="EAF0F5">
-                <a:alpha val="0"/>
-              </a:srgbClr>
-            </a:solidFill>
-            <a:prstDash val="solid"/>
-          </a:ln>
-        </p:spPr>
-        <p:txBody>
-          <a:bodyPr/>
-          <a:p/>
-        </p:txBody>
-      </p:sp>
-      <p:sp>
-        <p:nvSpPr>
-          <p:cNvPr id="24" name="Text 22"/>
-          <p:cNvSpPr/>
-          <p:nvPr/>
-        </p:nvSpPr>
-        <p:spPr>
-          <a:xfrm>
-            <a:off x="7278624" y="5038344"/>
-            <a:ext cx="1078992" cy="173736"/>
-          </a:xfrm>
-          <a:prstGeom prst="rect">
-            <a:avLst/>
-          </a:prstGeom>
-          <a:noFill/>
-          <a:ln/>
-        </p:spPr>
-        <p:txBody>
-          <a:bodyPr wrap="square" lIns="254" tIns="254" rIns="254" bIns="254" rtlCol="0" anchor="ctr">
-            <a:normAutofit/>
-          </a:bodyPr>
-          <a:lstStyle/>
-          <a:p>
-            <a:pPr algn="ctr" indent="0" marL="0">
-              <a:buNone/>
-            </a:pPr>
-            <a:r>
-              <a:rPr lang="en-US" sz="1130" b="1" dirty="0">
-                <a:solidFill>
-                  <a:srgbClr val="132438"/>
-                </a:solidFill>
-                <a:latin typeface="Aptos" pitchFamily="34" charset="0"/>
-                <a:ea typeface="Aptos" pitchFamily="34" charset="-122"/>
-                <a:cs typeface="Aptos" pitchFamily="34" charset="-120"/>
+          </a:p>
+          <a:p>
+            <a:pPr>
+              <a:spcBef>
+                <a:spcPts val="600"/>
+              </a:spcBef>
+            </a:pPr>
+            <a:r>
+              <a:rPr sz="1200" b="0">
+                <a:solidFill>
+                  <a:srgbClr val="B8C4D6"/>
+                </a:solidFill>
+                <a:latin typeface="Aptos"/>
+              </a:rPr>
+              <a:t>Catalog agents, imports, or your own</a:t>
+            </a:r>
+          </a:p>
+        </p:txBody>
+      </p:sp>
+      <p:sp>
+        <p:nvSpPr>
+          <p:cNvPr id="23" name="TextBox 22"/>
+          <p:cNvSpPr txBox="1"/>
+          <p:nvPr/>
+        </p:nvSpPr>
+        <p:spPr>
+          <a:xfrm>
+            <a:off x="3505200" y="5029200"/>
+            <a:ext cx="2286000" cy="889000"/>
+          </a:xfrm>
+          <a:prstGeom prst="rect">
+            <a:avLst/>
+          </a:prstGeom>
+          <a:noFill/>
+        </p:spPr>
+        <p:txBody>
+          <a:bodyPr wrap="square" lIns="0" rIns="0" tIns="0" bIns="0">
+            <a:spAutoFit/>
+          </a:bodyPr>
+          <a:lstStyle/>
+          <a:p>
+            <a:r>
+              <a:rPr sz="2200" b="1">
+                <a:solidFill>
+                  <a:srgbClr val="FFFFFF"/>
+                </a:solidFill>
+                <a:latin typeface="Aptos"/>
               </a:rPr>
               <a:t>RUN</a:t>
             </a:r>
-            <a:endParaRPr lang="en-US" sz="1130" dirty="0"/>
-          </a:p>
-        </p:txBody>
-      </p:sp>
-      <p:sp>
-        <p:nvSpPr>
-          <p:cNvPr id="25" name="Shape 23"/>
-          <p:cNvSpPr/>
-          <p:nvPr/>
-        </p:nvSpPr>
-        <p:spPr>
-          <a:xfrm>
-            <a:off x="8577072" y="4965192"/>
-            <a:ext cx="1298448" cy="347472"/>
-          </a:xfrm>
-          <a:prstGeom prst="roundRect">
-            <a:avLst>
-              <a:gd name="adj" fmla="val 39474"/>
-            </a:avLst>
-          </a:prstGeom>
-          <a:solidFill>
-            <a:srgbClr val="06AFA5"/>
-          </a:solidFill>
-          <a:ln w="12700">
-            <a:solidFill>
-              <a:srgbClr val="06AFA5">
-                <a:alpha val="0"/>
-              </a:srgbClr>
-            </a:solidFill>
-            <a:prstDash val="solid"/>
-          </a:ln>
-        </p:spPr>
-        <p:txBody>
-          <a:bodyPr/>
-          <a:p/>
-        </p:txBody>
-      </p:sp>
-      <p:sp>
-        <p:nvSpPr>
-          <p:cNvPr id="26" name="Text 24"/>
-          <p:cNvSpPr/>
-          <p:nvPr/>
-        </p:nvSpPr>
-        <p:spPr>
-          <a:xfrm>
-            <a:off x="8686800" y="5038344"/>
-            <a:ext cx="1078992" cy="173736"/>
-          </a:xfrm>
-          <a:prstGeom prst="rect">
-            <a:avLst/>
-          </a:prstGeom>
-          <a:noFill/>
-          <a:ln/>
-        </p:spPr>
-        <p:txBody>
-          <a:bodyPr wrap="square" lIns="254" tIns="254" rIns="254" bIns="254" rtlCol="0" anchor="ctr">
-            <a:normAutofit/>
-          </a:bodyPr>
-          <a:lstStyle/>
-          <a:p>
-            <a:pPr algn="ctr" indent="0" marL="0">
-              <a:buNone/>
-            </a:pPr>
-            <a:r>
-              <a:rPr lang="en-US" sz="1130" b="1" dirty="0">
+          </a:p>
+          <a:p>
+            <a:pPr>
+              <a:spcBef>
+                <a:spcPts val="600"/>
+              </a:spcBef>
+            </a:pPr>
+            <a:r>
+              <a:rPr sz="1200" b="0">
+                <a:solidFill>
+                  <a:srgbClr val="B8C4D6"/>
+                </a:solidFill>
+                <a:latin typeface="Aptos"/>
+              </a:rPr>
+              <a:t>Workflows, triggers, approvals</a:t>
+            </a:r>
+          </a:p>
+        </p:txBody>
+      </p:sp>
+      <p:sp>
+        <p:nvSpPr>
+          <p:cNvPr id="24" name="TextBox 23"/>
+          <p:cNvSpPr txBox="1"/>
+          <p:nvPr/>
+        </p:nvSpPr>
+        <p:spPr>
+          <a:xfrm>
+            <a:off x="3175000" y="5080000"/>
+            <a:ext cx="254000" cy="304800"/>
+          </a:xfrm>
+          <a:prstGeom prst="rect">
+            <a:avLst/>
+          </a:prstGeom>
+          <a:noFill/>
+        </p:spPr>
+        <p:txBody>
+          <a:bodyPr wrap="square" lIns="0" rIns="0" tIns="0" bIns="0">
+            <a:spAutoFit/>
+          </a:bodyPr>
+          <a:lstStyle/>
+          <a:p>
+            <a:pPr algn="ctr"/>
+            <a:r>
+              <a:rPr sz="2200" b="1">
+                <a:solidFill>
+                  <a:srgbClr val="06AFA5"/>
+                </a:solidFill>
+                <a:latin typeface="Aptos"/>
+              </a:rPr>
+              <a:t>›</a:t>
+            </a:r>
+          </a:p>
+        </p:txBody>
+      </p:sp>
+      <p:sp>
+        <p:nvSpPr>
+          <p:cNvPr id="25" name="TextBox 24"/>
+          <p:cNvSpPr txBox="1"/>
+          <p:nvPr/>
+        </p:nvSpPr>
+        <p:spPr>
+          <a:xfrm>
+            <a:off x="6096000" y="5029200"/>
+            <a:ext cx="2286000" cy="889000"/>
+          </a:xfrm>
+          <a:prstGeom prst="rect">
+            <a:avLst/>
+          </a:prstGeom>
+          <a:noFill/>
+        </p:spPr>
+        <p:txBody>
+          <a:bodyPr wrap="square" lIns="0" rIns="0" tIns="0" bIns="0">
+            <a:spAutoFit/>
+          </a:bodyPr>
+          <a:lstStyle/>
+          <a:p>
+            <a:r>
+              <a:rPr sz="2200" b="1">
                 <a:solidFill>
                   <a:srgbClr val="FFFFFF"/>
                 </a:solidFill>
-                <a:latin typeface="Aptos" pitchFamily="34" charset="0"/>
-                <a:ea typeface="Aptos" pitchFamily="34" charset="-122"/>
-                <a:cs typeface="Aptos" pitchFamily="34" charset="-120"/>
+                <a:latin typeface="Aptos"/>
               </a:rPr>
               <a:t>GOVERN</a:t>
             </a:r>
-            <a:endParaRPr lang="en-US" sz="1130" dirty="0"/>
-          </a:p>
-        </p:txBody>
-      </p:sp>
-      <p:sp>
-        <p:nvSpPr>
-          <p:cNvPr id="27" name="Shape 25"/>
-          <p:cNvSpPr/>
-          <p:nvPr/>
-        </p:nvSpPr>
-        <p:spPr>
-          <a:xfrm>
-            <a:off x="9985248" y="4965192"/>
-            <a:ext cx="1298448" cy="347472"/>
-          </a:xfrm>
-          <a:prstGeom prst="roundRect">
-            <a:avLst>
-              <a:gd name="adj" fmla="val 39474"/>
-            </a:avLst>
-          </a:prstGeom>
-          <a:solidFill>
-            <a:srgbClr val="EAF0F5"/>
-          </a:solidFill>
-          <a:ln w="12700">
-            <a:solidFill>
-              <a:srgbClr val="EAF0F5">
-                <a:alpha val="0"/>
-              </a:srgbClr>
-            </a:solidFill>
-            <a:prstDash val="solid"/>
-          </a:ln>
-        </p:spPr>
-        <p:txBody>
-          <a:bodyPr/>
-          <a:p/>
-        </p:txBody>
-      </p:sp>
-      <p:sp>
-        <p:nvSpPr>
-          <p:cNvPr id="28" name="Text 26"/>
-          <p:cNvSpPr/>
-          <p:nvPr/>
-        </p:nvSpPr>
-        <p:spPr>
-          <a:xfrm>
-            <a:off x="10094976" y="5038344"/>
-            <a:ext cx="1078992" cy="173736"/>
-          </a:xfrm>
-          <a:prstGeom prst="rect">
-            <a:avLst/>
-          </a:prstGeom>
-          <a:noFill/>
-          <a:ln/>
-        </p:spPr>
-        <p:txBody>
-          <a:bodyPr wrap="square" lIns="254" tIns="254" rIns="254" bIns="254" rtlCol="0" anchor="ctr">
-            <a:normAutofit/>
-          </a:bodyPr>
-          <a:lstStyle/>
-          <a:p>
-            <a:pPr algn="ctr" indent="0" marL="0">
-              <a:buNone/>
-            </a:pPr>
-            <a:r>
-              <a:rPr lang="en-US" sz="1130" b="1" dirty="0">
-                <a:solidFill>
-                  <a:srgbClr val="132438"/>
-                </a:solidFill>
-                <a:latin typeface="Aptos" pitchFamily="34" charset="0"/>
-                <a:ea typeface="Aptos" pitchFamily="34" charset="-122"/>
-                <a:cs typeface="Aptos" pitchFamily="34" charset="-120"/>
+          </a:p>
+          <a:p>
+            <a:pPr>
+              <a:spcBef>
+                <a:spcPts val="600"/>
+              </a:spcBef>
+            </a:pPr>
+            <a:r>
+              <a:rPr sz="1200" b="0">
+                <a:solidFill>
+                  <a:srgbClr val="B8C4D6"/>
+                </a:solidFill>
+                <a:latin typeface="Aptos"/>
+              </a:rPr>
+              <a:t>Identity, limits, audit trail</a:t>
+            </a:r>
+          </a:p>
+        </p:txBody>
+      </p:sp>
+      <p:sp>
+        <p:nvSpPr>
+          <p:cNvPr id="26" name="TextBox 25"/>
+          <p:cNvSpPr txBox="1"/>
+          <p:nvPr/>
+        </p:nvSpPr>
+        <p:spPr>
+          <a:xfrm>
+            <a:off x="5765800" y="5080000"/>
+            <a:ext cx="254000" cy="304800"/>
+          </a:xfrm>
+          <a:prstGeom prst="rect">
+            <a:avLst/>
+          </a:prstGeom>
+          <a:noFill/>
+        </p:spPr>
+        <p:txBody>
+          <a:bodyPr wrap="square" lIns="0" rIns="0" tIns="0" bIns="0">
+            <a:spAutoFit/>
+          </a:bodyPr>
+          <a:lstStyle/>
+          <a:p>
+            <a:pPr algn="ctr"/>
+            <a:r>
+              <a:rPr sz="2200" b="1">
+                <a:solidFill>
+                  <a:srgbClr val="06AFA5"/>
+                </a:solidFill>
+                <a:latin typeface="Aptos"/>
+              </a:rPr>
+              <a:t>›</a:t>
+            </a:r>
+          </a:p>
+        </p:txBody>
+      </p:sp>
+      <p:sp>
+        <p:nvSpPr>
+          <p:cNvPr id="27" name="TextBox 26"/>
+          <p:cNvSpPr txBox="1"/>
+          <p:nvPr/>
+        </p:nvSpPr>
+        <p:spPr>
+          <a:xfrm>
+            <a:off x="8686800" y="5029200"/>
+            <a:ext cx="2286000" cy="889000"/>
+          </a:xfrm>
+          <a:prstGeom prst="rect">
+            <a:avLst/>
+          </a:prstGeom>
+          <a:noFill/>
+        </p:spPr>
+        <p:txBody>
+          <a:bodyPr wrap="square" lIns="0" rIns="0" tIns="0" bIns="0">
+            <a:spAutoFit/>
+          </a:bodyPr>
+          <a:lstStyle/>
+          <a:p>
+            <a:r>
+              <a:rPr sz="2200" b="1">
+                <a:solidFill>
+                  <a:srgbClr val="FFFFFF"/>
+                </a:solidFill>
+                <a:latin typeface="Aptos"/>
               </a:rPr>
               <a:t>OPTIMIZE</a:t>
             </a:r>
-            <a:endParaRPr lang="en-US" sz="1130" dirty="0"/>
+          </a:p>
+          <a:p>
+            <a:pPr>
+              <a:spcBef>
+                <a:spcPts val="600"/>
+              </a:spcBef>
+            </a:pPr>
+            <a:r>
+              <a:rPr sz="1200" b="0">
+                <a:solidFill>
+                  <a:srgbClr val="B8C4D6"/>
+                </a:solidFill>
+                <a:latin typeface="Aptos"/>
+              </a:rPr>
+              <a:t>Cost, quality, evaluations</a:t>
+            </a:r>
+          </a:p>
+        </p:txBody>
+      </p:sp>
+      <p:sp>
+        <p:nvSpPr>
+          <p:cNvPr id="28" name="TextBox 27"/>
+          <p:cNvSpPr txBox="1"/>
+          <p:nvPr/>
+        </p:nvSpPr>
+        <p:spPr>
+          <a:xfrm>
+            <a:off x="8356600" y="5080000"/>
+            <a:ext cx="254000" cy="304800"/>
+          </a:xfrm>
+          <a:prstGeom prst="rect">
+            <a:avLst/>
+          </a:prstGeom>
+          <a:noFill/>
+        </p:spPr>
+        <p:txBody>
+          <a:bodyPr wrap="square" lIns="0" rIns="0" tIns="0" bIns="0">
+            <a:spAutoFit/>
+          </a:bodyPr>
+          <a:lstStyle/>
+          <a:p>
+            <a:pPr algn="ctr"/>
+            <a:r>
+              <a:rPr sz="2200" b="1">
+                <a:solidFill>
+                  <a:srgbClr val="06AFA5"/>
+                </a:solidFill>
+                <a:latin typeface="Aptos"/>
+              </a:rPr>
+              <a:t>›</a:t>
+            </a:r>
           </a:p>
         </p:txBody>
       </p:sp>

</xml_diff>